<commit_message>
docs: update README files to highlight out-of-the-box functionality
</commit_message>
<xml_diff>
--- a/img/example-marked.pptx
+++ b/img/example-marked.pptx
@@ -4,6 +4,9 @@
   <p:sldMasterIdLst>
     <p:sldMasterId id="2147483648" r:id="rId1"/>
   </p:sldMasterIdLst>
+  <p:notesMasterIdLst>
+    <p:notesMasterId r:id="rId4"/>
+  </p:notesMasterIdLst>
   <p:sldIdLst>
     <p:sldId id="256" r:id="rId2"/>
     <p:sldId id="258" r:id="rId3"/>
@@ -116,7 +119,7 @@
 <file path=ppt/revisionInfo.xml><?xml version="1.0" encoding="utf-8"?>
 <p1510:revInfo xmlns:a="http://schemas.openxmlformats.org/drawingml/2006/main" xmlns:r="http://schemas.openxmlformats.org/officeDocument/2006/relationships" xmlns:p1510="http://schemas.microsoft.com/office/powerpoint/2015/10/main">
   <p1510:revLst>
-    <p1510:client id="{21B15FB9-1BA0-F247-8406-2C9EAB55C849}" v="196" dt="2026-05-30T16:57:14.013"/>
+    <p1510:client id="{21B15FB9-1BA0-F247-8406-2C9EAB55C849}" v="200" dt="2026-05-31T06:40:34.248"/>
   </p1510:revLst>
 </p1510:revInfo>
 </file>
@@ -125,19 +128,19 @@
 <pc:chgInfo xmlns:a="http://schemas.openxmlformats.org/drawingml/2006/main" xmlns:r="http://schemas.openxmlformats.org/officeDocument/2006/relationships" xmlns:ac="http://schemas.microsoft.com/office/drawing/2013/main/command" xmlns:pc="http://schemas.microsoft.com/office/powerpoint/2013/main/command">
   <pc:docChgLst>
     <pc:chgData name="Zihao Viston Wang" userId="bb38f0bb24686ff5" providerId="LiveId" clId="{624A8E29-C0AB-51FB-8E4A-8A86974DAEAD}"/>
-    <pc:docChg chg="modSld">
-      <pc:chgData name="Zihao Viston Wang" userId="bb38f0bb24686ff5" providerId="LiveId" clId="{624A8E29-C0AB-51FB-8E4A-8A86974DAEAD}" dt="2026-05-30T17:07:53.522" v="4" actId="113"/>
+    <pc:docChg chg="undo custSel modSld">
+      <pc:chgData name="Zihao Viston Wang" userId="bb38f0bb24686ff5" providerId="LiveId" clId="{624A8E29-C0AB-51FB-8E4A-8A86974DAEAD}" dt="2026-05-31T06:45:12.503" v="231" actId="14838"/>
       <pc:docMkLst>
         <pc:docMk/>
       </pc:docMkLst>
-      <pc:sldChg chg="modSp mod">
-        <pc:chgData name="Zihao Viston Wang" userId="bb38f0bb24686ff5" providerId="LiveId" clId="{624A8E29-C0AB-51FB-8E4A-8A86974DAEAD}" dt="2026-05-30T17:07:53.522" v="4" actId="113"/>
+      <pc:sldChg chg="addSp delSp modSp mod">
+        <pc:chgData name="Zihao Viston Wang" userId="bb38f0bb24686ff5" providerId="LiveId" clId="{624A8E29-C0AB-51FB-8E4A-8A86974DAEAD}" dt="2026-05-31T06:44:22.157" v="154" actId="14838"/>
         <pc:sldMkLst>
           <pc:docMk/>
           <pc:sldMk cId="333356922" sldId="256"/>
         </pc:sldMkLst>
-        <pc:spChg chg="mod">
-          <ac:chgData name="Zihao Viston Wang" userId="bb38f0bb24686ff5" providerId="LiveId" clId="{624A8E29-C0AB-51FB-8E4A-8A86974DAEAD}" dt="2026-05-30T17:07:53.522" v="4" actId="113"/>
+        <pc:spChg chg="mod topLvl">
+          <ac:chgData name="Zihao Viston Wang" userId="bb38f0bb24686ff5" providerId="LiveId" clId="{624A8E29-C0AB-51FB-8E4A-8A86974DAEAD}" dt="2026-05-31T06:40:34.248" v="47" actId="164"/>
           <ac:spMkLst>
             <pc:docMk/>
             <pc:sldMk cId="333356922" sldId="256"/>
@@ -145,7 +148,23 @@
           </ac:spMkLst>
         </pc:spChg>
         <pc:spChg chg="mod">
-          <ac:chgData name="Zihao Viston Wang" userId="bb38f0bb24686ff5" providerId="LiveId" clId="{624A8E29-C0AB-51FB-8E4A-8A86974DAEAD}" dt="2026-05-30T17:07:53.522" v="4" actId="113"/>
+          <ac:chgData name="Zihao Viston Wang" userId="bb38f0bb24686ff5" providerId="LiveId" clId="{624A8E29-C0AB-51FB-8E4A-8A86974DAEAD}" dt="2026-05-31T06:37:28.331" v="13" actId="207"/>
+          <ac:spMkLst>
+            <pc:docMk/>
+            <pc:sldMk cId="333356922" sldId="256"/>
+            <ac:spMk id="40" creationId="{601AD2E7-C370-1028-90AB-D59B286CABEE}"/>
+          </ac:spMkLst>
+        </pc:spChg>
+        <pc:spChg chg="mod">
+          <ac:chgData name="Zihao Viston Wang" userId="bb38f0bb24686ff5" providerId="LiveId" clId="{624A8E29-C0AB-51FB-8E4A-8A86974DAEAD}" dt="2026-05-31T06:44:22.157" v="154" actId="14838"/>
+          <ac:spMkLst>
+            <pc:docMk/>
+            <pc:sldMk cId="333356922" sldId="256"/>
+            <ac:spMk id="44" creationId="{DC3EDA75-0D47-93C9-5EC8-DA64F381C31F}"/>
+          </ac:spMkLst>
+        </pc:spChg>
+        <pc:spChg chg="mod topLvl">
+          <ac:chgData name="Zihao Viston Wang" userId="bb38f0bb24686ff5" providerId="LiveId" clId="{624A8E29-C0AB-51FB-8E4A-8A86974DAEAD}" dt="2026-05-31T06:44:22.157" v="154" actId="14838"/>
           <ac:spMkLst>
             <pc:docMk/>
             <pc:sldMk cId="333356922" sldId="256"/>
@@ -153,23 +172,39 @@
           </ac:spMkLst>
         </pc:spChg>
         <pc:spChg chg="mod">
-          <ac:chgData name="Zihao Viston Wang" userId="bb38f0bb24686ff5" providerId="LiveId" clId="{624A8E29-C0AB-51FB-8E4A-8A86974DAEAD}" dt="2026-05-30T17:07:53.522" v="4" actId="113"/>
+          <ac:chgData name="Zihao Viston Wang" userId="bb38f0bb24686ff5" providerId="LiveId" clId="{624A8E29-C0AB-51FB-8E4A-8A86974DAEAD}" dt="2026-05-31T06:44:22.157" v="154" actId="14838"/>
           <ac:spMkLst>
             <pc:docMk/>
             <pc:sldMk cId="333356922" sldId="256"/>
             <ac:spMk id="57" creationId="{F9168089-D3B4-DB4C-FC1A-55190DFA0F6C}"/>
           </ac:spMkLst>
         </pc:spChg>
-        <pc:spChg chg="mod">
-          <ac:chgData name="Zihao Viston Wang" userId="bb38f0bb24686ff5" providerId="LiveId" clId="{624A8E29-C0AB-51FB-8E4A-8A86974DAEAD}" dt="2026-05-30T17:07:53.522" v="4" actId="113"/>
+        <pc:spChg chg="mod topLvl">
+          <ac:chgData name="Zihao Viston Wang" userId="bb38f0bb24686ff5" providerId="LiveId" clId="{624A8E29-C0AB-51FB-8E4A-8A86974DAEAD}" dt="2026-05-31T06:44:22.157" v="154" actId="14838"/>
           <ac:spMkLst>
             <pc:docMk/>
             <pc:sldMk cId="333356922" sldId="256"/>
             <ac:spMk id="79" creationId="{34C26D17-51FC-CA83-4809-7A0BE4A4D938}"/>
           </ac:spMkLst>
         </pc:spChg>
-        <pc:spChg chg="mod">
-          <ac:chgData name="Zihao Viston Wang" userId="bb38f0bb24686ff5" providerId="LiveId" clId="{624A8E29-C0AB-51FB-8E4A-8A86974DAEAD}" dt="2026-05-30T17:07:53.522" v="4" actId="113"/>
+        <pc:spChg chg="mod topLvl">
+          <ac:chgData name="Zihao Viston Wang" userId="bb38f0bb24686ff5" providerId="LiveId" clId="{624A8E29-C0AB-51FB-8E4A-8A86974DAEAD}" dt="2026-05-31T06:44:22.157" v="154" actId="14838"/>
+          <ac:spMkLst>
+            <pc:docMk/>
+            <pc:sldMk cId="333356922" sldId="256"/>
+            <ac:spMk id="95" creationId="{4FECC7F8-8DDD-E18F-F5C7-835C5D18917F}"/>
+          </ac:spMkLst>
+        </pc:spChg>
+        <pc:spChg chg="mod topLvl">
+          <ac:chgData name="Zihao Viston Wang" userId="bb38f0bb24686ff5" providerId="LiveId" clId="{624A8E29-C0AB-51FB-8E4A-8A86974DAEAD}" dt="2026-05-31T06:44:22.157" v="154" actId="14838"/>
+          <ac:spMkLst>
+            <pc:docMk/>
+            <pc:sldMk cId="333356922" sldId="256"/>
+            <ac:spMk id="100" creationId="{D36683D6-A59B-D771-AF19-29ECD329BD8B}"/>
+          </ac:spMkLst>
+        </pc:spChg>
+        <pc:spChg chg="mod topLvl">
+          <ac:chgData name="Zihao Viston Wang" userId="bb38f0bb24686ff5" providerId="LiveId" clId="{624A8E29-C0AB-51FB-8E4A-8A86974DAEAD}" dt="2026-05-31T06:40:34.248" v="47" actId="164"/>
           <ac:spMkLst>
             <pc:docMk/>
             <pc:sldMk cId="333356922" sldId="256"/>
@@ -177,15 +212,15 @@
           </ac:spMkLst>
         </pc:spChg>
         <pc:spChg chg="mod">
-          <ac:chgData name="Zihao Viston Wang" userId="bb38f0bb24686ff5" providerId="LiveId" clId="{624A8E29-C0AB-51FB-8E4A-8A86974DAEAD}" dt="2026-05-30T17:07:53.522" v="4" actId="113"/>
+          <ac:chgData name="Zihao Viston Wang" userId="bb38f0bb24686ff5" providerId="LiveId" clId="{624A8E29-C0AB-51FB-8E4A-8A86974DAEAD}" dt="2026-05-31T06:44:22.157" v="154" actId="14838"/>
           <ac:spMkLst>
             <pc:docMk/>
             <pc:sldMk cId="333356922" sldId="256"/>
             <ac:spMk id="121" creationId="{A4D1CBB8-43A6-ED88-98FE-49A141236F10}"/>
           </ac:spMkLst>
         </pc:spChg>
-        <pc:spChg chg="mod">
-          <ac:chgData name="Zihao Viston Wang" userId="bb38f0bb24686ff5" providerId="LiveId" clId="{624A8E29-C0AB-51FB-8E4A-8A86974DAEAD}" dt="2026-05-30T17:07:53.522" v="4" actId="113"/>
+        <pc:spChg chg="mod topLvl">
+          <ac:chgData name="Zihao Viston Wang" userId="bb38f0bb24686ff5" providerId="LiveId" clId="{624A8E29-C0AB-51FB-8E4A-8A86974DAEAD}" dt="2026-05-31T06:40:34.248" v="47" actId="164"/>
           <ac:spMkLst>
             <pc:docMk/>
             <pc:sldMk cId="333356922" sldId="256"/>
@@ -193,15 +228,15 @@
           </ac:spMkLst>
         </pc:spChg>
         <pc:spChg chg="mod">
-          <ac:chgData name="Zihao Viston Wang" userId="bb38f0bb24686ff5" providerId="LiveId" clId="{624A8E29-C0AB-51FB-8E4A-8A86974DAEAD}" dt="2026-05-30T17:07:53.522" v="4" actId="113"/>
+          <ac:chgData name="Zihao Viston Wang" userId="bb38f0bb24686ff5" providerId="LiveId" clId="{624A8E29-C0AB-51FB-8E4A-8A86974DAEAD}" dt="2026-05-31T06:44:22.157" v="154" actId="14838"/>
           <ac:spMkLst>
             <pc:docMk/>
             <pc:sldMk cId="333356922" sldId="256"/>
             <ac:spMk id="132" creationId="{0700A8A5-68E8-2038-FFF2-695F23534178}"/>
           </ac:spMkLst>
         </pc:spChg>
-        <pc:spChg chg="mod">
-          <ac:chgData name="Zihao Viston Wang" userId="bb38f0bb24686ff5" providerId="LiveId" clId="{624A8E29-C0AB-51FB-8E4A-8A86974DAEAD}" dt="2026-05-30T17:07:53.522" v="4" actId="113"/>
+        <pc:spChg chg="mod topLvl">
+          <ac:chgData name="Zihao Viston Wang" userId="bb38f0bb24686ff5" providerId="LiveId" clId="{624A8E29-C0AB-51FB-8E4A-8A86974DAEAD}" dt="2026-05-31T06:44:22.157" v="154" actId="14838"/>
           <ac:spMkLst>
             <pc:docMk/>
             <pc:sldMk cId="333356922" sldId="256"/>
@@ -209,38 +244,214 @@
           </ac:spMkLst>
         </pc:spChg>
         <pc:spChg chg="mod">
-          <ac:chgData name="Zihao Viston Wang" userId="bb38f0bb24686ff5" providerId="LiveId" clId="{624A8E29-C0AB-51FB-8E4A-8A86974DAEAD}" dt="2026-05-30T17:07:53.522" v="4" actId="113"/>
+          <ac:chgData name="Zihao Viston Wang" userId="bb38f0bb24686ff5" providerId="LiveId" clId="{624A8E29-C0AB-51FB-8E4A-8A86974DAEAD}" dt="2026-05-31T06:37:34.497" v="14" actId="207"/>
+          <ac:spMkLst>
+            <pc:docMk/>
+            <pc:sldMk cId="333356922" sldId="256"/>
+            <ac:spMk id="156" creationId="{402CD5BD-6929-0009-256C-CE11019254E0}"/>
+          </ac:spMkLst>
+        </pc:spChg>
+        <pc:spChg chg="mod topLvl">
+          <ac:chgData name="Zihao Viston Wang" userId="bb38f0bb24686ff5" providerId="LiveId" clId="{624A8E29-C0AB-51FB-8E4A-8A86974DAEAD}" dt="2026-05-31T06:44:22.157" v="154" actId="14838"/>
+          <ac:spMkLst>
+            <pc:docMk/>
+            <pc:sldMk cId="333356922" sldId="256"/>
+            <ac:spMk id="162" creationId="{6778955A-4814-046A-650F-24AC5D48E585}"/>
+          </ac:spMkLst>
+        </pc:spChg>
+        <pc:spChg chg="mod topLvl">
+          <ac:chgData name="Zihao Viston Wang" userId="bb38f0bb24686ff5" providerId="LiveId" clId="{624A8E29-C0AB-51FB-8E4A-8A86974DAEAD}" dt="2026-05-31T06:40:34.248" v="47" actId="164"/>
           <ac:spMkLst>
             <pc:docMk/>
             <pc:sldMk cId="333356922" sldId="256"/>
             <ac:spMk id="163" creationId="{0B26C5A9-9D90-3E00-BF36-6D4D5CB15F96}"/>
           </ac:spMkLst>
         </pc:spChg>
+        <pc:cxnChg chg="mod">
+          <ac:chgData name="Zihao Viston Wang" userId="bb38f0bb24686ff5" providerId="LiveId" clId="{624A8E29-C0AB-51FB-8E4A-8A86974DAEAD}" dt="2026-05-31T06:36:57.141" v="10" actId="692"/>
+          <ac:cxnSpMkLst>
+            <pc:docMk/>
+            <pc:sldMk cId="333356922" sldId="256"/>
+            <ac:cxnSpMk id="16" creationId="{702AFE14-0768-5BC0-CDBE-0B7982C4AF19}"/>
+          </ac:cxnSpMkLst>
+        </pc:cxnChg>
+        <pc:cxnChg chg="mod">
+          <ac:chgData name="Zihao Viston Wang" userId="bb38f0bb24686ff5" providerId="LiveId" clId="{624A8E29-C0AB-51FB-8E4A-8A86974DAEAD}" dt="2026-05-31T06:36:57.141" v="10" actId="692"/>
+          <ac:cxnSpMkLst>
+            <pc:docMk/>
+            <pc:sldMk cId="333356922" sldId="256"/>
+            <ac:cxnSpMk id="23" creationId="{7EFDCBCB-DF99-BE85-BEB3-4F7167972C43}"/>
+          </ac:cxnSpMkLst>
+        </pc:cxnChg>
+        <pc:cxnChg chg="mod">
+          <ac:chgData name="Zihao Viston Wang" userId="bb38f0bb24686ff5" providerId="LiveId" clId="{624A8E29-C0AB-51FB-8E4A-8A86974DAEAD}" dt="2026-05-31T06:36:57.141" v="10" actId="692"/>
+          <ac:cxnSpMkLst>
+            <pc:docMk/>
+            <pc:sldMk cId="333356922" sldId="256"/>
+            <ac:cxnSpMk id="34" creationId="{A2F30F7E-AE9D-14BB-D04B-32B336129E65}"/>
+          </ac:cxnSpMkLst>
+        </pc:cxnChg>
+        <pc:cxnChg chg="mod">
+          <ac:chgData name="Zihao Viston Wang" userId="bb38f0bb24686ff5" providerId="LiveId" clId="{624A8E29-C0AB-51FB-8E4A-8A86974DAEAD}" dt="2026-05-31T06:36:57.141" v="10" actId="692"/>
+          <ac:cxnSpMkLst>
+            <pc:docMk/>
+            <pc:sldMk cId="333356922" sldId="256"/>
+            <ac:cxnSpMk id="42" creationId="{2797FA0A-7840-BC28-A620-2BD60455E1F9}"/>
+          </ac:cxnSpMkLst>
+        </pc:cxnChg>
+        <pc:cxnChg chg="mod">
+          <ac:chgData name="Zihao Viston Wang" userId="bb38f0bb24686ff5" providerId="LiveId" clId="{624A8E29-C0AB-51FB-8E4A-8A86974DAEAD}" dt="2026-05-31T06:36:57.141" v="10" actId="692"/>
+          <ac:cxnSpMkLst>
+            <pc:docMk/>
+            <pc:sldMk cId="333356922" sldId="256"/>
+            <ac:cxnSpMk id="43" creationId="{9FA1B514-38FC-12B3-6103-1471C709E323}"/>
+          </ac:cxnSpMkLst>
+        </pc:cxnChg>
+        <pc:cxnChg chg="mod">
+          <ac:chgData name="Zihao Viston Wang" userId="bb38f0bb24686ff5" providerId="LiveId" clId="{624A8E29-C0AB-51FB-8E4A-8A86974DAEAD}" dt="2026-05-31T06:36:57.141" v="10" actId="692"/>
+          <ac:cxnSpMkLst>
+            <pc:docMk/>
+            <pc:sldMk cId="333356922" sldId="256"/>
+            <ac:cxnSpMk id="45" creationId="{6CFD0B21-EF17-0850-A16A-324451C208E9}"/>
+          </ac:cxnSpMkLst>
+        </pc:cxnChg>
+        <pc:cxnChg chg="mod">
+          <ac:chgData name="Zihao Viston Wang" userId="bb38f0bb24686ff5" providerId="LiveId" clId="{624A8E29-C0AB-51FB-8E4A-8A86974DAEAD}" dt="2026-05-31T06:36:57.141" v="10" actId="692"/>
+          <ac:cxnSpMkLst>
+            <pc:docMk/>
+            <pc:sldMk cId="333356922" sldId="256"/>
+            <ac:cxnSpMk id="49" creationId="{048963D1-C6DC-E7DF-EE81-AAFB21AFA728}"/>
+          </ac:cxnSpMkLst>
+        </pc:cxnChg>
+        <pc:cxnChg chg="mod">
+          <ac:chgData name="Zihao Viston Wang" userId="bb38f0bb24686ff5" providerId="LiveId" clId="{624A8E29-C0AB-51FB-8E4A-8A86974DAEAD}" dt="2026-05-31T06:36:57.141" v="10" actId="692"/>
+          <ac:cxnSpMkLst>
+            <pc:docMk/>
+            <pc:sldMk cId="333356922" sldId="256"/>
+            <ac:cxnSpMk id="50" creationId="{1F21ECC4-80A6-2A27-F117-AA80B885A977}"/>
+          </ac:cxnSpMkLst>
+        </pc:cxnChg>
+        <pc:cxnChg chg="mod">
+          <ac:chgData name="Zihao Viston Wang" userId="bb38f0bb24686ff5" providerId="LiveId" clId="{624A8E29-C0AB-51FB-8E4A-8A86974DAEAD}" dt="2026-05-31T06:36:57.141" v="10" actId="692"/>
+          <ac:cxnSpMkLst>
+            <pc:docMk/>
+            <pc:sldMk cId="333356922" sldId="256"/>
+            <ac:cxnSpMk id="71" creationId="{BDAADD49-104B-2EAB-FCA5-82DFB6326C8D}"/>
+          </ac:cxnSpMkLst>
+        </pc:cxnChg>
+        <pc:cxnChg chg="mod">
+          <ac:chgData name="Zihao Viston Wang" userId="bb38f0bb24686ff5" providerId="LiveId" clId="{624A8E29-C0AB-51FB-8E4A-8A86974DAEAD}" dt="2026-05-31T06:36:57.141" v="10" actId="692"/>
+          <ac:cxnSpMkLst>
+            <pc:docMk/>
+            <pc:sldMk cId="333356922" sldId="256"/>
+            <ac:cxnSpMk id="78" creationId="{32A2565B-36A2-B0EF-2FF4-BD8FD75511D3}"/>
+          </ac:cxnSpMkLst>
+        </pc:cxnChg>
+        <pc:cxnChg chg="mod">
+          <ac:chgData name="Zihao Viston Wang" userId="bb38f0bb24686ff5" providerId="LiveId" clId="{624A8E29-C0AB-51FB-8E4A-8A86974DAEAD}" dt="2026-05-31T06:37:57.269" v="16" actId="692"/>
+          <ac:cxnSpMkLst>
+            <pc:docMk/>
+            <pc:sldMk cId="333356922" sldId="256"/>
+            <ac:cxnSpMk id="91" creationId="{EF169605-6BCA-1228-A209-34E7F0B7503B}"/>
+          </ac:cxnSpMkLst>
+        </pc:cxnChg>
+        <pc:cxnChg chg="mod">
+          <ac:chgData name="Zihao Viston Wang" userId="bb38f0bb24686ff5" providerId="LiveId" clId="{624A8E29-C0AB-51FB-8E4A-8A86974DAEAD}" dt="2026-05-31T06:37:57.269" v="16" actId="692"/>
+          <ac:cxnSpMkLst>
+            <pc:docMk/>
+            <pc:sldMk cId="333356922" sldId="256"/>
+            <ac:cxnSpMk id="96" creationId="{2575A347-7589-F295-98B7-9C937F048683}"/>
+          </ac:cxnSpMkLst>
+        </pc:cxnChg>
+        <pc:cxnChg chg="mod">
+          <ac:chgData name="Zihao Viston Wang" userId="bb38f0bb24686ff5" providerId="LiveId" clId="{624A8E29-C0AB-51FB-8E4A-8A86974DAEAD}" dt="2026-05-31T06:37:57.269" v="16" actId="692"/>
+          <ac:cxnSpMkLst>
+            <pc:docMk/>
+            <pc:sldMk cId="333356922" sldId="256"/>
+            <ac:cxnSpMk id="101" creationId="{C584822C-6C04-38E6-6210-E4804744A63B}"/>
+          </ac:cxnSpMkLst>
+        </pc:cxnChg>
+        <pc:cxnChg chg="mod">
+          <ac:chgData name="Zihao Viston Wang" userId="bb38f0bb24686ff5" providerId="LiveId" clId="{624A8E29-C0AB-51FB-8E4A-8A86974DAEAD}" dt="2026-05-31T06:37:57.269" v="16" actId="692"/>
+          <ac:cxnSpMkLst>
+            <pc:docMk/>
+            <pc:sldMk cId="333356922" sldId="256"/>
+            <ac:cxnSpMk id="110" creationId="{FCDAB1CE-EFBB-AC0B-0DAF-18A0090F8B8D}"/>
+          </ac:cxnSpMkLst>
+        </pc:cxnChg>
+        <pc:cxnChg chg="mod">
+          <ac:chgData name="Zihao Viston Wang" userId="bb38f0bb24686ff5" providerId="LiveId" clId="{624A8E29-C0AB-51FB-8E4A-8A86974DAEAD}" dt="2026-05-31T06:37:57.269" v="16" actId="692"/>
+          <ac:cxnSpMkLst>
+            <pc:docMk/>
+            <pc:sldMk cId="333356922" sldId="256"/>
+            <ac:cxnSpMk id="116" creationId="{5CD7A262-30C5-F972-761C-1853E8EAD21B}"/>
+          </ac:cxnSpMkLst>
+        </pc:cxnChg>
+        <pc:cxnChg chg="mod">
+          <ac:chgData name="Zihao Viston Wang" userId="bb38f0bb24686ff5" providerId="LiveId" clId="{624A8E29-C0AB-51FB-8E4A-8A86974DAEAD}" dt="2026-05-31T06:37:57.269" v="16" actId="692"/>
+          <ac:cxnSpMkLst>
+            <pc:docMk/>
+            <pc:sldMk cId="333356922" sldId="256"/>
+            <ac:cxnSpMk id="123" creationId="{721BFE38-F56F-4ECB-C0E7-3AB53482FF50}"/>
+          </ac:cxnSpMkLst>
+        </pc:cxnChg>
+        <pc:cxnChg chg="mod">
+          <ac:chgData name="Zihao Viston Wang" userId="bb38f0bb24686ff5" providerId="LiveId" clId="{624A8E29-C0AB-51FB-8E4A-8A86974DAEAD}" dt="2026-05-31T06:37:57.269" v="16" actId="692"/>
+          <ac:cxnSpMkLst>
+            <pc:docMk/>
+            <pc:sldMk cId="333356922" sldId="256"/>
+            <ac:cxnSpMk id="131" creationId="{1F5057BC-2AFC-9E58-3C1E-B132DC0F3C77}"/>
+          </ac:cxnSpMkLst>
+        </pc:cxnChg>
+        <pc:cxnChg chg="mod">
+          <ac:chgData name="Zihao Viston Wang" userId="bb38f0bb24686ff5" providerId="LiveId" clId="{624A8E29-C0AB-51FB-8E4A-8A86974DAEAD}" dt="2026-05-31T06:37:57.269" v="16" actId="692"/>
+          <ac:cxnSpMkLst>
+            <pc:docMk/>
+            <pc:sldMk cId="333356922" sldId="256"/>
+            <ac:cxnSpMk id="138" creationId="{A2CB1E6F-2323-694D-A086-DBF6AB34038D}"/>
+          </ac:cxnSpMkLst>
+        </pc:cxnChg>
+        <pc:cxnChg chg="mod">
+          <ac:chgData name="Zihao Viston Wang" userId="bb38f0bb24686ff5" providerId="LiveId" clId="{624A8E29-C0AB-51FB-8E4A-8A86974DAEAD}" dt="2026-05-31T06:37:57.269" v="16" actId="692"/>
+          <ac:cxnSpMkLst>
+            <pc:docMk/>
+            <pc:sldMk cId="333356922" sldId="256"/>
+            <ac:cxnSpMk id="150" creationId="{45959344-B3E4-8FB8-7E82-C77C6E203DAD}"/>
+          </ac:cxnSpMkLst>
+        </pc:cxnChg>
+        <pc:cxnChg chg="mod">
+          <ac:chgData name="Zihao Viston Wang" userId="bb38f0bb24686ff5" providerId="LiveId" clId="{624A8E29-C0AB-51FB-8E4A-8A86974DAEAD}" dt="2026-05-31T06:37:57.269" v="16" actId="692"/>
+          <ac:cxnSpMkLst>
+            <pc:docMk/>
+            <pc:sldMk cId="333356922" sldId="256"/>
+            <ac:cxnSpMk id="155" creationId="{7FE0FC47-DEAE-C128-81F0-01167734F819}"/>
+          </ac:cxnSpMkLst>
+        </pc:cxnChg>
       </pc:sldChg>
-      <pc:sldChg chg="modSp mod">
-        <pc:chgData name="Zihao Viston Wang" userId="bb38f0bb24686ff5" providerId="LiveId" clId="{624A8E29-C0AB-51FB-8E4A-8A86974DAEAD}" dt="2026-05-30T17:01:55.572" v="3" actId="20577"/>
+      <pc:sldChg chg="addSp delSp modSp mod">
+        <pc:chgData name="Zihao Viston Wang" userId="bb38f0bb24686ff5" providerId="LiveId" clId="{624A8E29-C0AB-51FB-8E4A-8A86974DAEAD}" dt="2026-05-31T06:45:12.503" v="231" actId="14838"/>
         <pc:sldMkLst>
           <pc:docMk/>
           <pc:sldMk cId="1547542409" sldId="258"/>
         </pc:sldMkLst>
         <pc:spChg chg="mod">
-          <ac:chgData name="Zihao Viston Wang" userId="bb38f0bb24686ff5" providerId="LiveId" clId="{624A8E29-C0AB-51FB-8E4A-8A86974DAEAD}" dt="2026-05-30T16:59:50.520" v="2" actId="113"/>
+          <ac:chgData name="Zihao Viston Wang" userId="bb38f0bb24686ff5" providerId="LiveId" clId="{624A8E29-C0AB-51FB-8E4A-8A86974DAEAD}" dt="2026-05-31T06:45:12.503" v="231" actId="14838"/>
           <ac:spMkLst>
             <pc:docMk/>
             <pc:sldMk cId="1547542409" sldId="258"/>
             <ac:spMk id="21" creationId="{5C1BC332-1F69-6FFF-2FE9-E7C75526BF85}"/>
           </ac:spMkLst>
         </pc:spChg>
-        <pc:spChg chg="mod">
-          <ac:chgData name="Zihao Viston Wang" userId="bb38f0bb24686ff5" providerId="LiveId" clId="{624A8E29-C0AB-51FB-8E4A-8A86974DAEAD}" dt="2026-05-30T16:59:50.520" v="2" actId="113"/>
+        <pc:spChg chg="mod topLvl">
+          <ac:chgData name="Zihao Viston Wang" userId="bb38f0bb24686ff5" providerId="LiveId" clId="{624A8E29-C0AB-51FB-8E4A-8A86974DAEAD}" dt="2026-05-31T06:40:06.897" v="46" actId="164"/>
           <ac:spMkLst>
             <pc:docMk/>
             <pc:sldMk cId="1547542409" sldId="258"/>
             <ac:spMk id="40" creationId="{25378701-7E65-7E82-BBF4-727FE91491D0}"/>
           </ac:spMkLst>
         </pc:spChg>
-        <pc:spChg chg="mod">
-          <ac:chgData name="Zihao Viston Wang" userId="bb38f0bb24686ff5" providerId="LiveId" clId="{624A8E29-C0AB-51FB-8E4A-8A86974DAEAD}" dt="2026-05-30T17:01:55.572" v="3" actId="20577"/>
+        <pc:spChg chg="mod topLvl">
+          <ac:chgData name="Zihao Viston Wang" userId="bb38f0bb24686ff5" providerId="LiveId" clId="{624A8E29-C0AB-51FB-8E4A-8A86974DAEAD}" dt="2026-05-31T06:40:06.897" v="46" actId="164"/>
           <ac:spMkLst>
             <pc:docMk/>
             <pc:sldMk cId="1547542409" sldId="258"/>
@@ -248,23 +459,31 @@
           </ac:spMkLst>
         </pc:spChg>
         <pc:spChg chg="mod">
-          <ac:chgData name="Zihao Viston Wang" userId="bb38f0bb24686ff5" providerId="LiveId" clId="{624A8E29-C0AB-51FB-8E4A-8A86974DAEAD}" dt="2026-05-30T16:59:50.520" v="2" actId="113"/>
+          <ac:chgData name="Zihao Viston Wang" userId="bb38f0bb24686ff5" providerId="LiveId" clId="{624A8E29-C0AB-51FB-8E4A-8A86974DAEAD}" dt="2026-05-31T06:45:12.503" v="231" actId="14838"/>
+          <ac:spMkLst>
+            <pc:docMk/>
+            <pc:sldMk cId="1547542409" sldId="258"/>
+            <ac:spMk id="57" creationId="{917BA7E7-527B-DEB0-1F72-3982855C22CB}"/>
+          </ac:spMkLst>
+        </pc:spChg>
+        <pc:spChg chg="mod topLvl">
+          <ac:chgData name="Zihao Viston Wang" userId="bb38f0bb24686ff5" providerId="LiveId" clId="{624A8E29-C0AB-51FB-8E4A-8A86974DAEAD}" dt="2026-05-31T06:45:12.503" v="231" actId="14838"/>
           <ac:spMkLst>
             <pc:docMk/>
             <pc:sldMk cId="1547542409" sldId="258"/>
             <ac:spMk id="79" creationId="{911E7BB7-5502-050E-E833-CA3669D16C29}"/>
           </ac:spMkLst>
         </pc:spChg>
-        <pc:spChg chg="mod">
-          <ac:chgData name="Zihao Viston Wang" userId="bb38f0bb24686ff5" providerId="LiveId" clId="{624A8E29-C0AB-51FB-8E4A-8A86974DAEAD}" dt="2026-05-30T16:59:50.520" v="2" actId="113"/>
+        <pc:spChg chg="mod topLvl">
+          <ac:chgData name="Zihao Viston Wang" userId="bb38f0bb24686ff5" providerId="LiveId" clId="{624A8E29-C0AB-51FB-8E4A-8A86974DAEAD}" dt="2026-05-31T06:45:12.503" v="231" actId="14838"/>
           <ac:spMkLst>
             <pc:docMk/>
             <pc:sldMk cId="1547542409" sldId="258"/>
             <ac:spMk id="95" creationId="{2C45279F-D51D-A527-3A48-16E8971464D5}"/>
           </ac:spMkLst>
         </pc:spChg>
-        <pc:spChg chg="mod">
-          <ac:chgData name="Zihao Viston Wang" userId="bb38f0bb24686ff5" providerId="LiveId" clId="{624A8E29-C0AB-51FB-8E4A-8A86974DAEAD}" dt="2026-05-30T16:59:50.520" v="2" actId="113"/>
+        <pc:spChg chg="mod topLvl">
+          <ac:chgData name="Zihao Viston Wang" userId="bb38f0bb24686ff5" providerId="LiveId" clId="{624A8E29-C0AB-51FB-8E4A-8A86974DAEAD}" dt="2026-05-31T06:45:12.503" v="231" actId="14838"/>
           <ac:spMkLst>
             <pc:docMk/>
             <pc:sldMk cId="1547542409" sldId="258"/>
@@ -272,41 +491,658 @@
           </ac:spMkLst>
         </pc:spChg>
         <pc:spChg chg="mod">
-          <ac:chgData name="Zihao Viston Wang" userId="bb38f0bb24686ff5" providerId="LiveId" clId="{624A8E29-C0AB-51FB-8E4A-8A86974DAEAD}" dt="2026-05-30T16:59:50.520" v="2" actId="113"/>
+          <ac:chgData name="Zihao Viston Wang" userId="bb38f0bb24686ff5" providerId="LiveId" clId="{624A8E29-C0AB-51FB-8E4A-8A86974DAEAD}" dt="2026-05-31T06:45:12.503" v="231" actId="14838"/>
+          <ac:spMkLst>
+            <pc:docMk/>
+            <pc:sldMk cId="1547542409" sldId="258"/>
+            <ac:spMk id="114" creationId="{ABFC6FEA-1F5A-9C35-E3A8-F96E40C04DB8}"/>
+          </ac:spMkLst>
+        </pc:spChg>
+        <pc:spChg chg="mod topLvl">
+          <ac:chgData name="Zihao Viston Wang" userId="bb38f0bb24686ff5" providerId="LiveId" clId="{624A8E29-C0AB-51FB-8E4A-8A86974DAEAD}" dt="2026-05-31T06:45:12.503" v="231" actId="14838"/>
           <ac:spMkLst>
             <pc:docMk/>
             <pc:sldMk cId="1547542409" sldId="258"/>
             <ac:spMk id="121" creationId="{C86F10DA-B136-8EC8-D648-5DD9DE57FFCC}"/>
           </ac:spMkLst>
         </pc:spChg>
-        <pc:spChg chg="mod">
-          <ac:chgData name="Zihao Viston Wang" userId="bb38f0bb24686ff5" providerId="LiveId" clId="{624A8E29-C0AB-51FB-8E4A-8A86974DAEAD}" dt="2026-05-30T16:59:50.520" v="2" actId="113"/>
+        <pc:spChg chg="mod topLvl">
+          <ac:chgData name="Zihao Viston Wang" userId="bb38f0bb24686ff5" providerId="LiveId" clId="{624A8E29-C0AB-51FB-8E4A-8A86974DAEAD}" dt="2026-05-31T06:40:06.897" v="46" actId="164"/>
           <ac:spMkLst>
             <pc:docMk/>
             <pc:sldMk cId="1547542409" sldId="258"/>
             <ac:spMk id="130" creationId="{F60D0070-7A30-9D8B-3575-EFF11D913C75}"/>
           </ac:spMkLst>
         </pc:spChg>
+        <pc:spChg chg="mod topLvl">
+          <ac:chgData name="Zihao Viston Wang" userId="bb38f0bb24686ff5" providerId="LiveId" clId="{624A8E29-C0AB-51FB-8E4A-8A86974DAEAD}" dt="2026-05-31T06:40:06.897" v="46" actId="164"/>
+          <ac:spMkLst>
+            <pc:docMk/>
+            <pc:sldMk cId="1547542409" sldId="258"/>
+            <ac:spMk id="132" creationId="{D3DA2F39-3C0A-96BA-7808-EEA1D741A49C}"/>
+          </ac:spMkLst>
+        </pc:spChg>
         <pc:spChg chg="mod">
-          <ac:chgData name="Zihao Viston Wang" userId="bb38f0bb24686ff5" providerId="LiveId" clId="{624A8E29-C0AB-51FB-8E4A-8A86974DAEAD}" dt="2026-05-30T16:59:50.520" v="2" actId="113"/>
+          <ac:chgData name="Zihao Viston Wang" userId="bb38f0bb24686ff5" providerId="LiveId" clId="{624A8E29-C0AB-51FB-8E4A-8A86974DAEAD}" dt="2026-05-31T06:45:12.503" v="231" actId="14838"/>
+          <ac:spMkLst>
+            <pc:docMk/>
+            <pc:sldMk cId="1547542409" sldId="258"/>
+            <ac:spMk id="148" creationId="{7690AD36-6B22-977C-FC88-E798AA1DA8E3}"/>
+          </ac:spMkLst>
+        </pc:spChg>
+        <pc:spChg chg="mod topLvl">
+          <ac:chgData name="Zihao Viston Wang" userId="bb38f0bb24686ff5" providerId="LiveId" clId="{624A8E29-C0AB-51FB-8E4A-8A86974DAEAD}" dt="2026-05-31T06:45:12.503" v="231" actId="14838"/>
           <ac:spMkLst>
             <pc:docMk/>
             <pc:sldMk cId="1547542409" sldId="258"/>
             <ac:spMk id="156" creationId="{FFB5EE87-060B-090C-E46E-11B21CC35AC9}"/>
           </ac:spMkLst>
         </pc:spChg>
-        <pc:spChg chg="mod">
-          <ac:chgData name="Zihao Viston Wang" userId="bb38f0bb24686ff5" providerId="LiveId" clId="{624A8E29-C0AB-51FB-8E4A-8A86974DAEAD}" dt="2026-05-30T16:59:50.520" v="2" actId="113"/>
+        <pc:spChg chg="mod topLvl">
+          <ac:chgData name="Zihao Viston Wang" userId="bb38f0bb24686ff5" providerId="LiveId" clId="{624A8E29-C0AB-51FB-8E4A-8A86974DAEAD}" dt="2026-05-31T06:45:12.503" v="231" actId="14838"/>
           <ac:spMkLst>
             <pc:docMk/>
             <pc:sldMk cId="1547542409" sldId="258"/>
             <ac:spMk id="162" creationId="{1031C39A-5B31-AD31-751D-863FD8DBA28B}"/>
           </ac:spMkLst>
         </pc:spChg>
+        <pc:picChg chg="mod">
+          <ac:chgData name="Zihao Viston Wang" userId="bb38f0bb24686ff5" providerId="LiveId" clId="{624A8E29-C0AB-51FB-8E4A-8A86974DAEAD}" dt="2026-05-31T06:39:33.374" v="44" actId="692"/>
+          <ac:picMkLst>
+            <pc:docMk/>
+            <pc:sldMk cId="1547542409" sldId="258"/>
+            <ac:picMk id="70" creationId="{200E670D-C701-E2FD-C685-601E4C695041}"/>
+          </ac:picMkLst>
+        </pc:picChg>
+        <pc:cxnChg chg="mod">
+          <ac:chgData name="Zihao Viston Wang" userId="bb38f0bb24686ff5" providerId="LiveId" clId="{624A8E29-C0AB-51FB-8E4A-8A86974DAEAD}" dt="2026-05-31T06:39:33.374" v="44" actId="692"/>
+          <ac:cxnSpMkLst>
+            <pc:docMk/>
+            <pc:sldMk cId="1547542409" sldId="258"/>
+            <ac:cxnSpMk id="16" creationId="{33A52804-A982-32B9-98E1-23DCCAC42C93}"/>
+          </ac:cxnSpMkLst>
+        </pc:cxnChg>
+        <pc:cxnChg chg="mod">
+          <ac:chgData name="Zihao Viston Wang" userId="bb38f0bb24686ff5" providerId="LiveId" clId="{624A8E29-C0AB-51FB-8E4A-8A86974DAEAD}" dt="2026-05-31T06:39:33.374" v="44" actId="692"/>
+          <ac:cxnSpMkLst>
+            <pc:docMk/>
+            <pc:sldMk cId="1547542409" sldId="258"/>
+            <ac:cxnSpMk id="23" creationId="{09092759-02D4-0C63-6752-67DB83CA9452}"/>
+          </ac:cxnSpMkLst>
+        </pc:cxnChg>
+        <pc:cxnChg chg="mod">
+          <ac:chgData name="Zihao Viston Wang" userId="bb38f0bb24686ff5" providerId="LiveId" clId="{624A8E29-C0AB-51FB-8E4A-8A86974DAEAD}" dt="2026-05-31T06:39:33.374" v="44" actId="692"/>
+          <ac:cxnSpMkLst>
+            <pc:docMk/>
+            <pc:sldMk cId="1547542409" sldId="258"/>
+            <ac:cxnSpMk id="34" creationId="{FEF19E5D-A8BE-4251-A8A2-015F049B5255}"/>
+          </ac:cxnSpMkLst>
+        </pc:cxnChg>
+        <pc:cxnChg chg="mod">
+          <ac:chgData name="Zihao Viston Wang" userId="bb38f0bb24686ff5" providerId="LiveId" clId="{624A8E29-C0AB-51FB-8E4A-8A86974DAEAD}" dt="2026-05-31T06:39:33.374" v="44" actId="692"/>
+          <ac:cxnSpMkLst>
+            <pc:docMk/>
+            <pc:sldMk cId="1547542409" sldId="258"/>
+            <ac:cxnSpMk id="42" creationId="{02D1E283-6E5B-B0AF-51F7-547DBA8EFA51}"/>
+          </ac:cxnSpMkLst>
+        </pc:cxnChg>
+        <pc:cxnChg chg="mod">
+          <ac:chgData name="Zihao Viston Wang" userId="bb38f0bb24686ff5" providerId="LiveId" clId="{624A8E29-C0AB-51FB-8E4A-8A86974DAEAD}" dt="2026-05-31T06:39:33.374" v="44" actId="692"/>
+          <ac:cxnSpMkLst>
+            <pc:docMk/>
+            <pc:sldMk cId="1547542409" sldId="258"/>
+            <ac:cxnSpMk id="43" creationId="{E0011866-623F-0918-9882-4F1FD08AC2AB}"/>
+          </ac:cxnSpMkLst>
+        </pc:cxnChg>
+        <pc:cxnChg chg="mod">
+          <ac:chgData name="Zihao Viston Wang" userId="bb38f0bb24686ff5" providerId="LiveId" clId="{624A8E29-C0AB-51FB-8E4A-8A86974DAEAD}" dt="2026-05-31T06:39:33.374" v="44" actId="692"/>
+          <ac:cxnSpMkLst>
+            <pc:docMk/>
+            <pc:sldMk cId="1547542409" sldId="258"/>
+            <ac:cxnSpMk id="45" creationId="{C5648FE9-4F55-25B9-46FA-9F816C596E62}"/>
+          </ac:cxnSpMkLst>
+        </pc:cxnChg>
+        <pc:cxnChg chg="mod">
+          <ac:chgData name="Zihao Viston Wang" userId="bb38f0bb24686ff5" providerId="LiveId" clId="{624A8E29-C0AB-51FB-8E4A-8A86974DAEAD}" dt="2026-05-31T06:39:33.374" v="44" actId="692"/>
+          <ac:cxnSpMkLst>
+            <pc:docMk/>
+            <pc:sldMk cId="1547542409" sldId="258"/>
+            <ac:cxnSpMk id="50" creationId="{4877BB6D-056A-9C7F-54A3-571E4D88E199}"/>
+          </ac:cxnSpMkLst>
+        </pc:cxnChg>
+        <pc:cxnChg chg="mod">
+          <ac:chgData name="Zihao Viston Wang" userId="bb38f0bb24686ff5" providerId="LiveId" clId="{624A8E29-C0AB-51FB-8E4A-8A86974DAEAD}" dt="2026-05-31T06:39:33.374" v="44" actId="692"/>
+          <ac:cxnSpMkLst>
+            <pc:docMk/>
+            <pc:sldMk cId="1547542409" sldId="258"/>
+            <ac:cxnSpMk id="71" creationId="{32863922-AA86-D90D-C617-AA0C70EA8C94}"/>
+          </ac:cxnSpMkLst>
+        </pc:cxnChg>
+        <pc:cxnChg chg="mod">
+          <ac:chgData name="Zihao Viston Wang" userId="bb38f0bb24686ff5" providerId="LiveId" clId="{624A8E29-C0AB-51FB-8E4A-8A86974DAEAD}" dt="2026-05-31T06:39:33.374" v="44" actId="692"/>
+          <ac:cxnSpMkLst>
+            <pc:docMk/>
+            <pc:sldMk cId="1547542409" sldId="258"/>
+            <ac:cxnSpMk id="78" creationId="{DE1935D8-3055-6B05-FE2B-47988569AD20}"/>
+          </ac:cxnSpMkLst>
+        </pc:cxnChg>
+        <pc:cxnChg chg="mod">
+          <ac:chgData name="Zihao Viston Wang" userId="bb38f0bb24686ff5" providerId="LiveId" clId="{624A8E29-C0AB-51FB-8E4A-8A86974DAEAD}" dt="2026-05-31T06:39:54.006" v="45" actId="692"/>
+          <ac:cxnSpMkLst>
+            <pc:docMk/>
+            <pc:sldMk cId="1547542409" sldId="258"/>
+            <ac:cxnSpMk id="96" creationId="{2AEBE6DE-E151-02D5-F89C-8E0E9C9044F5}"/>
+          </ac:cxnSpMkLst>
+        </pc:cxnChg>
+        <pc:cxnChg chg="mod">
+          <ac:chgData name="Zihao Viston Wang" userId="bb38f0bb24686ff5" providerId="LiveId" clId="{624A8E29-C0AB-51FB-8E4A-8A86974DAEAD}" dt="2026-05-31T06:39:54.006" v="45" actId="692"/>
+          <ac:cxnSpMkLst>
+            <pc:docMk/>
+            <pc:sldMk cId="1547542409" sldId="258"/>
+            <ac:cxnSpMk id="99" creationId="{B07DE192-5861-4AA0-5922-4C2C30397BB4}"/>
+          </ac:cxnSpMkLst>
+        </pc:cxnChg>
+        <pc:cxnChg chg="mod">
+          <ac:chgData name="Zihao Viston Wang" userId="bb38f0bb24686ff5" providerId="LiveId" clId="{624A8E29-C0AB-51FB-8E4A-8A86974DAEAD}" dt="2026-05-31T06:39:54.006" v="45" actId="692"/>
+          <ac:cxnSpMkLst>
+            <pc:docMk/>
+            <pc:sldMk cId="1547542409" sldId="258"/>
+            <ac:cxnSpMk id="101" creationId="{FC7ED45F-D113-A117-C73A-89B5BCC8A86B}"/>
+          </ac:cxnSpMkLst>
+        </pc:cxnChg>
+        <pc:cxnChg chg="mod">
+          <ac:chgData name="Zihao Viston Wang" userId="bb38f0bb24686ff5" providerId="LiveId" clId="{624A8E29-C0AB-51FB-8E4A-8A86974DAEAD}" dt="2026-05-31T06:39:54.006" v="45" actId="692"/>
+          <ac:cxnSpMkLst>
+            <pc:docMk/>
+            <pc:sldMk cId="1547542409" sldId="258"/>
+            <ac:cxnSpMk id="110" creationId="{E9A3A1CC-0E03-23D0-1B6D-2A5996A5F20C}"/>
+          </ac:cxnSpMkLst>
+        </pc:cxnChg>
+        <pc:cxnChg chg="mod">
+          <ac:chgData name="Zihao Viston Wang" userId="bb38f0bb24686ff5" providerId="LiveId" clId="{624A8E29-C0AB-51FB-8E4A-8A86974DAEAD}" dt="2026-05-31T06:39:54.006" v="45" actId="692"/>
+          <ac:cxnSpMkLst>
+            <pc:docMk/>
+            <pc:sldMk cId="1547542409" sldId="258"/>
+            <ac:cxnSpMk id="117" creationId="{3D39A993-E931-2AC7-FA2C-448F52995C16}"/>
+          </ac:cxnSpMkLst>
+        </pc:cxnChg>
+        <pc:cxnChg chg="mod">
+          <ac:chgData name="Zihao Viston Wang" userId="bb38f0bb24686ff5" providerId="LiveId" clId="{624A8E29-C0AB-51FB-8E4A-8A86974DAEAD}" dt="2026-05-31T06:39:54.006" v="45" actId="692"/>
+          <ac:cxnSpMkLst>
+            <pc:docMk/>
+            <pc:sldMk cId="1547542409" sldId="258"/>
+            <ac:cxnSpMk id="123" creationId="{0AC23D31-00F6-8C3C-CCE5-B1CD5ADAC9DE}"/>
+          </ac:cxnSpMkLst>
+        </pc:cxnChg>
+        <pc:cxnChg chg="mod">
+          <ac:chgData name="Zihao Viston Wang" userId="bb38f0bb24686ff5" providerId="LiveId" clId="{624A8E29-C0AB-51FB-8E4A-8A86974DAEAD}" dt="2026-05-31T06:39:54.006" v="45" actId="692"/>
+          <ac:cxnSpMkLst>
+            <pc:docMk/>
+            <pc:sldMk cId="1547542409" sldId="258"/>
+            <ac:cxnSpMk id="125" creationId="{08E29C9F-2290-EC42-E9B6-85C85CFC804E}"/>
+          </ac:cxnSpMkLst>
+        </pc:cxnChg>
+        <pc:cxnChg chg="mod">
+          <ac:chgData name="Zihao Viston Wang" userId="bb38f0bb24686ff5" providerId="LiveId" clId="{624A8E29-C0AB-51FB-8E4A-8A86974DAEAD}" dt="2026-05-31T06:39:54.006" v="45" actId="692"/>
+          <ac:cxnSpMkLst>
+            <pc:docMk/>
+            <pc:sldMk cId="1547542409" sldId="258"/>
+            <ac:cxnSpMk id="133" creationId="{383399E7-0A8B-B5F3-8CAD-E4AB6C23D595}"/>
+          </ac:cxnSpMkLst>
+        </pc:cxnChg>
+        <pc:cxnChg chg="mod">
+          <ac:chgData name="Zihao Viston Wang" userId="bb38f0bb24686ff5" providerId="LiveId" clId="{624A8E29-C0AB-51FB-8E4A-8A86974DAEAD}" dt="2026-05-31T06:39:54.006" v="45" actId="692"/>
+          <ac:cxnSpMkLst>
+            <pc:docMk/>
+            <pc:sldMk cId="1547542409" sldId="258"/>
+            <ac:cxnSpMk id="155" creationId="{A117E8C1-02A9-5451-1830-01148D627210}"/>
+          </ac:cxnSpMkLst>
+        </pc:cxnChg>
+        <pc:cxnChg chg="mod">
+          <ac:chgData name="Zihao Viston Wang" userId="bb38f0bb24686ff5" providerId="LiveId" clId="{624A8E29-C0AB-51FB-8E4A-8A86974DAEAD}" dt="2026-05-31T06:39:54.006" v="45" actId="692"/>
+          <ac:cxnSpMkLst>
+            <pc:docMk/>
+            <pc:sldMk cId="1547542409" sldId="258"/>
+            <ac:cxnSpMk id="157" creationId="{A631FC9A-ECFB-9E48-30E2-99B11F5E6136}"/>
+          </ac:cxnSpMkLst>
+        </pc:cxnChg>
       </pc:sldChg>
     </pc:docChg>
   </pc:docChgLst>
 </pc:chgInfo>
+</file>
+
+<file path=ppt/notesMasters/notesMaster1.xml><?xml version="1.0" encoding="utf-8"?>
+<p:notesMaster xmlns:a="http://schemas.openxmlformats.org/drawingml/2006/main" xmlns:r="http://schemas.openxmlformats.org/officeDocument/2006/relationships" xmlns:p="http://schemas.openxmlformats.org/presentationml/2006/main">
+  <p:cSld>
+    <p:bg>
+      <p:bgRef idx="1001">
+        <a:schemeClr val="bg1"/>
+      </p:bgRef>
+    </p:bg>
+    <p:spTree>
+      <p:nvGrpSpPr>
+        <p:cNvPr id="1" name=""/>
+        <p:cNvGrpSpPr/>
+        <p:nvPr/>
+      </p:nvGrpSpPr>
+      <p:grpSpPr>
+        <a:xfrm>
+          <a:off x="0" y="0"/>
+          <a:ext cx="0" cy="0"/>
+          <a:chOff x="0" y="0"/>
+          <a:chExt cx="0" cy="0"/>
+        </a:xfrm>
+      </p:grpSpPr>
+      <p:sp>
+        <p:nvSpPr>
+          <p:cNvPr id="2" name="页眉占位符 1"/>
+          <p:cNvSpPr>
+            <a:spLocks noGrp="1"/>
+          </p:cNvSpPr>
+          <p:nvPr>
+            <p:ph type="hdr" sz="quarter"/>
+          </p:nvPr>
+        </p:nvSpPr>
+        <p:spPr>
+          <a:xfrm>
+            <a:off x="0" y="0"/>
+            <a:ext cx="2971800" cy="458788"/>
+          </a:xfrm>
+          <a:prstGeom prst="rect">
+            <a:avLst/>
+          </a:prstGeom>
+        </p:spPr>
+        <p:txBody>
+          <a:bodyPr vert="horz" lIns="91440" tIns="45720" rIns="91440" bIns="45720" rtlCol="0"/>
+          <a:lstStyle>
+            <a:lvl1pPr algn="l">
+              <a:defRPr sz="1200"/>
+            </a:lvl1pPr>
+          </a:lstStyle>
+          <a:p>
+            <a:endParaRPr kumimoji="1" lang="zh-CN" altLang="en-US"/>
+          </a:p>
+        </p:txBody>
+      </p:sp>
+      <p:sp>
+        <p:nvSpPr>
+          <p:cNvPr id="3" name="日期占位符 2"/>
+          <p:cNvSpPr>
+            <a:spLocks noGrp="1"/>
+          </p:cNvSpPr>
+          <p:nvPr>
+            <p:ph type="dt" idx="1"/>
+          </p:nvPr>
+        </p:nvSpPr>
+        <p:spPr>
+          <a:xfrm>
+            <a:off x="3884613" y="0"/>
+            <a:ext cx="2971800" cy="458788"/>
+          </a:xfrm>
+          <a:prstGeom prst="rect">
+            <a:avLst/>
+          </a:prstGeom>
+        </p:spPr>
+        <p:txBody>
+          <a:bodyPr vert="horz" lIns="91440" tIns="45720" rIns="91440" bIns="45720" rtlCol="0"/>
+          <a:lstStyle>
+            <a:lvl1pPr algn="r">
+              <a:defRPr sz="1200"/>
+            </a:lvl1pPr>
+          </a:lstStyle>
+          <a:p>
+            <a:fld id="{23656DED-251E-404A-A174-6D96B007F581}" type="datetimeFigureOut">
+              <a:rPr kumimoji="1" lang="zh-CN" altLang="en-US" smtClean="0"/>
+              <a:t>2026/5/31</a:t>
+            </a:fld>
+            <a:endParaRPr kumimoji="1" lang="zh-CN" altLang="en-US"/>
+          </a:p>
+        </p:txBody>
+      </p:sp>
+      <p:sp>
+        <p:nvSpPr>
+          <p:cNvPr id="4" name="幻灯片图像占位符 3"/>
+          <p:cNvSpPr>
+            <a:spLocks noGrp="1" noRot="1" noChangeAspect="1"/>
+          </p:cNvSpPr>
+          <p:nvPr>
+            <p:ph type="sldImg" idx="2"/>
+          </p:nvPr>
+        </p:nvSpPr>
+        <p:spPr>
+          <a:xfrm>
+            <a:off x="685800" y="1143000"/>
+            <a:ext cx="5486400" cy="3086100"/>
+          </a:xfrm>
+          <a:prstGeom prst="rect">
+            <a:avLst/>
+          </a:prstGeom>
+          <a:noFill/>
+          <a:ln w="12700">
+            <a:solidFill>
+              <a:prstClr val="black"/>
+            </a:solidFill>
+          </a:ln>
+        </p:spPr>
+        <p:txBody>
+          <a:bodyPr vert="horz" lIns="91440" tIns="45720" rIns="91440" bIns="45720" rtlCol="0" anchor="ctr"/>
+          <a:lstStyle/>
+          <a:p>
+            <a:endParaRPr lang="zh-CN" altLang="en-US"/>
+          </a:p>
+        </p:txBody>
+      </p:sp>
+      <p:sp>
+        <p:nvSpPr>
+          <p:cNvPr id="5" name="备注占位符 4"/>
+          <p:cNvSpPr>
+            <a:spLocks noGrp="1"/>
+          </p:cNvSpPr>
+          <p:nvPr>
+            <p:ph type="body" sz="quarter" idx="3"/>
+          </p:nvPr>
+        </p:nvSpPr>
+        <p:spPr>
+          <a:xfrm>
+            <a:off x="685800" y="4400550"/>
+            <a:ext cx="5486400" cy="3600450"/>
+          </a:xfrm>
+          <a:prstGeom prst="rect">
+            <a:avLst/>
+          </a:prstGeom>
+        </p:spPr>
+        <p:txBody>
+          <a:bodyPr vert="horz" lIns="91440" tIns="45720" rIns="91440" bIns="45720" rtlCol="0"/>
+          <a:lstStyle/>
+          <a:p>
+            <a:pPr lvl="0"/>
+            <a:r>
+              <a:rPr kumimoji="1" lang="zh-CN" altLang="en-US"/>
+              <a:t>单击此处编辑母版文本样式</a:t>
+            </a:r>
+          </a:p>
+          <a:p>
+            <a:pPr lvl="1"/>
+            <a:r>
+              <a:rPr kumimoji="1" lang="zh-CN" altLang="en-US"/>
+              <a:t>二级</a:t>
+            </a:r>
+          </a:p>
+          <a:p>
+            <a:pPr lvl="2"/>
+            <a:r>
+              <a:rPr kumimoji="1" lang="zh-CN" altLang="en-US"/>
+              <a:t>三级</a:t>
+            </a:r>
+          </a:p>
+          <a:p>
+            <a:pPr lvl="3"/>
+            <a:r>
+              <a:rPr kumimoji="1" lang="zh-CN" altLang="en-US"/>
+              <a:t>四级</a:t>
+            </a:r>
+          </a:p>
+          <a:p>
+            <a:pPr lvl="4"/>
+            <a:r>
+              <a:rPr kumimoji="1" lang="zh-CN" altLang="en-US"/>
+              <a:t>五级</a:t>
+            </a:r>
+          </a:p>
+        </p:txBody>
+      </p:sp>
+      <p:sp>
+        <p:nvSpPr>
+          <p:cNvPr id="6" name="页脚占位符 5"/>
+          <p:cNvSpPr>
+            <a:spLocks noGrp="1"/>
+          </p:cNvSpPr>
+          <p:nvPr>
+            <p:ph type="ftr" sz="quarter" idx="4"/>
+          </p:nvPr>
+        </p:nvSpPr>
+        <p:spPr>
+          <a:xfrm>
+            <a:off x="0" y="8685213"/>
+            <a:ext cx="2971800" cy="458787"/>
+          </a:xfrm>
+          <a:prstGeom prst="rect">
+            <a:avLst/>
+          </a:prstGeom>
+        </p:spPr>
+        <p:txBody>
+          <a:bodyPr vert="horz" lIns="91440" tIns="45720" rIns="91440" bIns="45720" rtlCol="0" anchor="b"/>
+          <a:lstStyle>
+            <a:lvl1pPr algn="l">
+              <a:defRPr sz="1200"/>
+            </a:lvl1pPr>
+          </a:lstStyle>
+          <a:p>
+            <a:endParaRPr kumimoji="1" lang="zh-CN" altLang="en-US"/>
+          </a:p>
+        </p:txBody>
+      </p:sp>
+      <p:sp>
+        <p:nvSpPr>
+          <p:cNvPr id="7" name="灯片编号占位符 6"/>
+          <p:cNvSpPr>
+            <a:spLocks noGrp="1"/>
+          </p:cNvSpPr>
+          <p:nvPr>
+            <p:ph type="sldNum" sz="quarter" idx="5"/>
+          </p:nvPr>
+        </p:nvSpPr>
+        <p:spPr>
+          <a:xfrm>
+            <a:off x="3884613" y="8685213"/>
+            <a:ext cx="2971800" cy="458787"/>
+          </a:xfrm>
+          <a:prstGeom prst="rect">
+            <a:avLst/>
+          </a:prstGeom>
+        </p:spPr>
+        <p:txBody>
+          <a:bodyPr vert="horz" lIns="91440" tIns="45720" rIns="91440" bIns="45720" rtlCol="0" anchor="b"/>
+          <a:lstStyle>
+            <a:lvl1pPr algn="r">
+              <a:defRPr sz="1200"/>
+            </a:lvl1pPr>
+          </a:lstStyle>
+          <a:p>
+            <a:fld id="{0B4A2B47-51C1-2F4A-990B-3D16120A9EA5}" type="slidenum">
+              <a:rPr kumimoji="1" lang="zh-CN" altLang="en-US" smtClean="0"/>
+              <a:t>‹#›</a:t>
+            </a:fld>
+            <a:endParaRPr kumimoji="1" lang="zh-CN" altLang="en-US"/>
+          </a:p>
+        </p:txBody>
+      </p:sp>
+    </p:spTree>
+    <p:extLst>
+      <p:ext uri="{BB962C8B-B14F-4D97-AF65-F5344CB8AC3E}">
+        <p14:creationId xmlns:p14="http://schemas.microsoft.com/office/powerpoint/2010/main" val="880462857"/>
+      </p:ext>
+    </p:extLst>
+  </p:cSld>
+  <p:clrMap bg1="lt1" tx1="dk1" bg2="lt2" tx2="dk2" accent1="accent1" accent2="accent2" accent3="accent3" accent4="accent4" accent5="accent5" accent6="accent6" hlink="hlink" folHlink="folHlink"/>
+  <p:notesStyle>
+    <a:lvl1pPr marL="0" algn="l" defTabSz="914400" rtl="0" eaLnBrk="1" latinLnBrk="0" hangingPunct="1">
+      <a:defRPr sz="1200" kern="1200">
+        <a:solidFill>
+          <a:schemeClr val="tx1"/>
+        </a:solidFill>
+        <a:latin typeface="+mn-lt"/>
+        <a:ea typeface="+mn-ea"/>
+        <a:cs typeface="+mn-cs"/>
+      </a:defRPr>
+    </a:lvl1pPr>
+    <a:lvl2pPr marL="457200" algn="l" defTabSz="914400" rtl="0" eaLnBrk="1" latinLnBrk="0" hangingPunct="1">
+      <a:defRPr sz="1200" kern="1200">
+        <a:solidFill>
+          <a:schemeClr val="tx1"/>
+        </a:solidFill>
+        <a:latin typeface="+mn-lt"/>
+        <a:ea typeface="+mn-ea"/>
+        <a:cs typeface="+mn-cs"/>
+      </a:defRPr>
+    </a:lvl2pPr>
+    <a:lvl3pPr marL="914400" algn="l" defTabSz="914400" rtl="0" eaLnBrk="1" latinLnBrk="0" hangingPunct="1">
+      <a:defRPr sz="1200" kern="1200">
+        <a:solidFill>
+          <a:schemeClr val="tx1"/>
+        </a:solidFill>
+        <a:latin typeface="+mn-lt"/>
+        <a:ea typeface="+mn-ea"/>
+        <a:cs typeface="+mn-cs"/>
+      </a:defRPr>
+    </a:lvl3pPr>
+    <a:lvl4pPr marL="1371600" algn="l" defTabSz="914400" rtl="0" eaLnBrk="1" latinLnBrk="0" hangingPunct="1">
+      <a:defRPr sz="1200" kern="1200">
+        <a:solidFill>
+          <a:schemeClr val="tx1"/>
+        </a:solidFill>
+        <a:latin typeface="+mn-lt"/>
+        <a:ea typeface="+mn-ea"/>
+        <a:cs typeface="+mn-cs"/>
+      </a:defRPr>
+    </a:lvl4pPr>
+    <a:lvl5pPr marL="1828800" algn="l" defTabSz="914400" rtl="0" eaLnBrk="1" latinLnBrk="0" hangingPunct="1">
+      <a:defRPr sz="1200" kern="1200">
+        <a:solidFill>
+          <a:schemeClr val="tx1"/>
+        </a:solidFill>
+        <a:latin typeface="+mn-lt"/>
+        <a:ea typeface="+mn-ea"/>
+        <a:cs typeface="+mn-cs"/>
+      </a:defRPr>
+    </a:lvl5pPr>
+    <a:lvl6pPr marL="2286000" algn="l" defTabSz="914400" rtl="0" eaLnBrk="1" latinLnBrk="0" hangingPunct="1">
+      <a:defRPr sz="1200" kern="1200">
+        <a:solidFill>
+          <a:schemeClr val="tx1"/>
+        </a:solidFill>
+        <a:latin typeface="+mn-lt"/>
+        <a:ea typeface="+mn-ea"/>
+        <a:cs typeface="+mn-cs"/>
+      </a:defRPr>
+    </a:lvl6pPr>
+    <a:lvl7pPr marL="2743200" algn="l" defTabSz="914400" rtl="0" eaLnBrk="1" latinLnBrk="0" hangingPunct="1">
+      <a:defRPr sz="1200" kern="1200">
+        <a:solidFill>
+          <a:schemeClr val="tx1"/>
+        </a:solidFill>
+        <a:latin typeface="+mn-lt"/>
+        <a:ea typeface="+mn-ea"/>
+        <a:cs typeface="+mn-cs"/>
+      </a:defRPr>
+    </a:lvl7pPr>
+    <a:lvl8pPr marL="3200400" algn="l" defTabSz="914400" rtl="0" eaLnBrk="1" latinLnBrk="0" hangingPunct="1">
+      <a:defRPr sz="1200" kern="1200">
+        <a:solidFill>
+          <a:schemeClr val="tx1"/>
+        </a:solidFill>
+        <a:latin typeface="+mn-lt"/>
+        <a:ea typeface="+mn-ea"/>
+        <a:cs typeface="+mn-cs"/>
+      </a:defRPr>
+    </a:lvl8pPr>
+    <a:lvl9pPr marL="3657600" algn="l" defTabSz="914400" rtl="0" eaLnBrk="1" latinLnBrk="0" hangingPunct="1">
+      <a:defRPr sz="1200" kern="1200">
+        <a:solidFill>
+          <a:schemeClr val="tx1"/>
+        </a:solidFill>
+        <a:latin typeface="+mn-lt"/>
+        <a:ea typeface="+mn-ea"/>
+        <a:cs typeface="+mn-cs"/>
+      </a:defRPr>
+    </a:lvl9pPr>
+  </p:notesStyle>
+</p:notesMaster>
+</file>
+
+<file path=ppt/notesSlides/notesSlide1.xml><?xml version="1.0" encoding="utf-8"?>
+<p:notes xmlns:a="http://schemas.openxmlformats.org/drawingml/2006/main" xmlns:r="http://schemas.openxmlformats.org/officeDocument/2006/relationships" xmlns:p="http://schemas.openxmlformats.org/presentationml/2006/main">
+  <p:cSld>
+    <p:spTree>
+      <p:nvGrpSpPr>
+        <p:cNvPr id="1" name=""/>
+        <p:cNvGrpSpPr/>
+        <p:nvPr/>
+      </p:nvGrpSpPr>
+      <p:grpSpPr>
+        <a:xfrm>
+          <a:off x="0" y="0"/>
+          <a:ext cx="0" cy="0"/>
+          <a:chOff x="0" y="0"/>
+          <a:chExt cx="0" cy="0"/>
+        </a:xfrm>
+      </p:grpSpPr>
+      <p:sp>
+        <p:nvSpPr>
+          <p:cNvPr id="2" name="幻灯片图像占位符 1"/>
+          <p:cNvSpPr>
+            <a:spLocks noGrp="1" noRot="1" noChangeAspect="1"/>
+          </p:cNvSpPr>
+          <p:nvPr>
+            <p:ph type="sldImg"/>
+          </p:nvPr>
+        </p:nvSpPr>
+        <p:spPr/>
+      </p:sp>
+      <p:sp>
+        <p:nvSpPr>
+          <p:cNvPr id="3" name="备注占位符 2"/>
+          <p:cNvSpPr>
+            <a:spLocks noGrp="1"/>
+          </p:cNvSpPr>
+          <p:nvPr>
+            <p:ph type="body" idx="1"/>
+          </p:nvPr>
+        </p:nvSpPr>
+        <p:spPr/>
+        <p:txBody>
+          <a:bodyPr/>
+          <a:lstStyle/>
+          <a:p>
+            <a:endParaRPr kumimoji="1" lang="zh-CN" altLang="en-US" dirty="0"/>
+          </a:p>
+        </p:txBody>
+      </p:sp>
+      <p:sp>
+        <p:nvSpPr>
+          <p:cNvPr id="4" name="灯片编号占位符 3"/>
+          <p:cNvSpPr>
+            <a:spLocks noGrp="1"/>
+          </p:cNvSpPr>
+          <p:nvPr>
+            <p:ph type="sldNum" sz="quarter" idx="5"/>
+          </p:nvPr>
+        </p:nvSpPr>
+        <p:spPr/>
+        <p:txBody>
+          <a:bodyPr/>
+          <a:lstStyle/>
+          <a:p>
+            <a:fld id="{0B4A2B47-51C1-2F4A-990B-3D16120A9EA5}" type="slidenum">
+              <a:rPr kumimoji="1" lang="zh-CN" altLang="en-US" smtClean="0"/>
+              <a:t>1</a:t>
+            </a:fld>
+            <a:endParaRPr kumimoji="1" lang="zh-CN" altLang="en-US"/>
+          </a:p>
+        </p:txBody>
+      </p:sp>
+    </p:spTree>
+    <p:extLst>
+      <p:ext uri="{BB962C8B-B14F-4D97-AF65-F5344CB8AC3E}">
+        <p14:creationId xmlns:p14="http://schemas.microsoft.com/office/powerpoint/2010/main" val="987216658"/>
+      </p:ext>
+    </p:extLst>
+  </p:cSld>
+  <p:clrMapOvr>
+    <a:masterClrMapping/>
+  </p:clrMapOvr>
+</p:notes>
 </file>
 
 <file path=ppt/slideLayouts/slideLayout1.xml><?xml version="1.0" encoding="utf-8"?>
@@ -3525,10 +4361,10 @@
       </p:grpSpPr>
       <p:grpSp>
         <p:nvGrpSpPr>
-          <p:cNvPr id="164" name="组合 163">
+          <p:cNvPr id="2" name="组合 1">
             <a:extLst>
               <a:ext uri="{FF2B5EF4-FFF2-40B4-BE49-F238E27FC236}">
-                <a16:creationId xmlns:a16="http://schemas.microsoft.com/office/drawing/2014/main" id="{79871770-D8C1-BD25-0A02-DF7024191208}"/>
+                <a16:creationId xmlns:a16="http://schemas.microsoft.com/office/drawing/2014/main" id="{858AFEE3-F4E9-BE9C-0E4B-3257FEAEE28C}"/>
               </a:ext>
             </a:extLst>
           </p:cNvPr>
@@ -3591,7 +4427,14 @@
             <a:lstStyle/>
             <a:p>
               <a:pPr algn="ctr"/>
-              <a:endParaRPr kumimoji="1" lang="zh-CN" altLang="en-US" b="1"/>
+              <a:endParaRPr kumimoji="1" lang="zh-CN" altLang="en-US" b="1">
+                <a:solidFill>
+                  <a:schemeClr val="accent1">
+                    <a:lumMod val="60000"/>
+                    <a:lumOff val="40000"/>
+                  </a:schemeClr>
+                </a:solidFill>
+              </a:endParaRPr>
             </a:p>
           </p:txBody>
         </p:sp>
@@ -3610,7 +4453,7 @@
             <p:nvPr/>
           </p:nvPicPr>
           <p:blipFill>
-            <a:blip r:embed="rId2"/>
+            <a:blip r:embed="rId3"/>
             <a:srcRect t="411"/>
             <a:stretch>
               <a:fillRect/>
@@ -3774,9 +4617,9 @@
             </a:prstGeom>
             <a:ln w="9525">
               <a:solidFill>
-                <a:schemeClr val="accent5">
-                  <a:lumMod val="60000"/>
-                  <a:lumOff val="40000"/>
+                <a:schemeClr val="tx2">
+                  <a:lumMod val="50000"/>
+                  <a:lumOff val="50000"/>
                 </a:schemeClr>
               </a:solidFill>
               <a:tailEnd type="oval" w="sm" len="sm"/>
@@ -3827,12 +4670,22 @@
             <a:p>
               <a:r>
                 <a:rPr kumimoji="1" lang="en" altLang="zh-CN" sz="700" b="1" i="1" dirty="0">
+                  <a:ln w="3175">
+                    <a:noFill/>
+                  </a:ln>
                   <a:solidFill>
-                    <a:schemeClr val="accent5">
-                      <a:lumMod val="60000"/>
-                      <a:lumOff val="40000"/>
+                    <a:schemeClr val="tx2">
+                      <a:lumMod val="50000"/>
+                      <a:lumOff val="50000"/>
                     </a:schemeClr>
                   </a:solidFill>
+                  <a:effectLst>
+                    <a:outerShdw blurRad="139700" dist="38100" dir="5400000" algn="t" rotWithShape="0">
+                      <a:prstClr val="black">
+                        <a:alpha val="25000"/>
+                      </a:prstClr>
+                    </a:outerShdw>
+                  </a:effectLst>
                   <a:latin typeface="Maple Mono" panose="020F0509060000000000" pitchFamily="49" charset="0"/>
                   <a:ea typeface="Maple Mono" panose="020F0509060000000000" pitchFamily="49" charset="0"/>
                 </a:rPr>
@@ -3840,12 +4693,22 @@
               </a:r>
               <a:r>
                 <a:rPr kumimoji="1" lang="en-US" altLang="zh-CN" sz="700" b="1" i="1" dirty="0">
+                  <a:ln w="3175">
+                    <a:noFill/>
+                  </a:ln>
                   <a:solidFill>
-                    <a:schemeClr val="accent5">
-                      <a:lumMod val="60000"/>
-                      <a:lumOff val="40000"/>
+                    <a:schemeClr val="tx2">
+                      <a:lumMod val="50000"/>
+                      <a:lumOff val="50000"/>
                     </a:schemeClr>
                   </a:solidFill>
+                  <a:effectLst>
+                    <a:outerShdw blurRad="139700" dist="38100" dir="5400000" algn="t" rotWithShape="0">
+                      <a:prstClr val="black">
+                        <a:alpha val="25000"/>
+                      </a:prstClr>
+                    </a:outerShdw>
+                  </a:effectLst>
                   <a:latin typeface="Maple Mono" panose="020F0509060000000000" pitchFamily="49" charset="0"/>
                   <a:ea typeface="Maple Mono" panose="020F0509060000000000" pitchFamily="49" charset="0"/>
                 </a:rPr>
@@ -3853,47 +4716,87 @@
               </a:r>
               <a:r>
                 <a:rPr kumimoji="1" lang="zh-CN" altLang="en-US" sz="700" b="1" i="1" dirty="0">
+                  <a:ln w="3175">
+                    <a:noFill/>
+                  </a:ln>
                   <a:solidFill>
-                    <a:schemeClr val="accent5">
-                      <a:lumMod val="60000"/>
-                      <a:lumOff val="40000"/>
+                    <a:schemeClr val="tx2">
+                      <a:lumMod val="50000"/>
+                      <a:lumOff val="50000"/>
                     </a:schemeClr>
                   </a:solidFill>
+                  <a:effectLst>
+                    <a:outerShdw blurRad="139700" dist="38100" dir="5400000" algn="t" rotWithShape="0">
+                      <a:prstClr val="black">
+                        <a:alpha val="25000"/>
+                      </a:prstClr>
+                    </a:outerShdw>
+                  </a:effectLst>
                   <a:latin typeface="Maple Mono" panose="020F0509060000000000" pitchFamily="49" charset="0"/>
                 </a:rPr>
                 <a:t> </a:t>
               </a:r>
               <a:endParaRPr kumimoji="1" lang="en-US" altLang="zh-CN" sz="700" b="1" i="1" dirty="0">
+                <a:ln w="3175">
+                  <a:noFill/>
+                </a:ln>
                 <a:solidFill>
-                  <a:schemeClr val="accent5">
-                    <a:lumMod val="60000"/>
-                    <a:lumOff val="40000"/>
+                  <a:schemeClr val="tx2">
+                    <a:lumMod val="50000"/>
+                    <a:lumOff val="50000"/>
                   </a:schemeClr>
                 </a:solidFill>
+                <a:effectLst>
+                  <a:outerShdw blurRad="139700" dist="38100" dir="5400000" algn="t" rotWithShape="0">
+                    <a:prstClr val="black">
+                      <a:alpha val="25000"/>
+                    </a:prstClr>
+                  </a:outerShdw>
+                </a:effectLst>
                 <a:latin typeface="Maple Mono" panose="020F0509060000000000" pitchFamily="49" charset="0"/>
               </a:endParaRPr>
             </a:p>
             <a:p>
               <a:r>
                 <a:rPr kumimoji="1" lang="en" altLang="zh-CN" sz="700" b="1" i="1" dirty="0">
+                  <a:ln w="3175">
+                    <a:noFill/>
+                  </a:ln>
                   <a:solidFill>
-                    <a:schemeClr val="accent5">
-                      <a:lumMod val="60000"/>
-                      <a:lumOff val="40000"/>
+                    <a:schemeClr val="tx2">
+                      <a:lumMod val="50000"/>
+                      <a:lumOff val="50000"/>
                     </a:schemeClr>
                   </a:solidFill>
+                  <a:effectLst>
+                    <a:outerShdw blurRad="139700" dist="38100" dir="5400000" algn="t" rotWithShape="0">
+                      <a:prstClr val="black">
+                        <a:alpha val="25000"/>
+                      </a:prstClr>
+                    </a:outerShdw>
+                  </a:effectLst>
                   <a:latin typeface="Maple Mono" panose="020F0509060000000000" pitchFamily="49" charset="0"/>
                   <a:ea typeface="Maple Mono" panose="020F0509060000000000" pitchFamily="49" charset="0"/>
                 </a:rPr>
                 <a:t>Structural Navigation</a:t>
               </a:r>
               <a:endParaRPr kumimoji="1" lang="zh-CN" altLang="en-US" sz="700" b="1" i="1" dirty="0">
+                <a:ln w="3175">
+                  <a:noFill/>
+                </a:ln>
                 <a:solidFill>
-                  <a:schemeClr val="accent5">
-                    <a:lumMod val="60000"/>
-                    <a:lumOff val="40000"/>
+                  <a:schemeClr val="tx2">
+                    <a:lumMod val="50000"/>
+                    <a:lumOff val="50000"/>
                   </a:schemeClr>
                 </a:solidFill>
+                <a:effectLst>
+                  <a:outerShdw blurRad="139700" dist="38100" dir="5400000" algn="t" rotWithShape="0">
+                    <a:prstClr val="black">
+                      <a:alpha val="25000"/>
+                    </a:prstClr>
+                  </a:outerShdw>
+                </a:effectLst>
                 <a:latin typeface="Maple Mono" panose="020F0509060000000000" pitchFamily="49" charset="0"/>
               </a:endParaRPr>
             </a:p>
@@ -3923,9 +4826,9 @@
             </a:prstGeom>
             <a:ln w="9525">
               <a:solidFill>
-                <a:schemeClr val="accent5">
-                  <a:lumMod val="60000"/>
-                  <a:lumOff val="40000"/>
+                <a:schemeClr val="tx2">
+                  <a:lumMod val="50000"/>
+                  <a:lumOff val="50000"/>
                 </a:schemeClr>
               </a:solidFill>
               <a:tailEnd type="oval" w="sm" len="sm"/>
@@ -3970,9 +4873,9 @@
             </a:prstGeom>
             <a:ln w="9525">
               <a:solidFill>
-                <a:schemeClr val="accent5">
-                  <a:lumMod val="60000"/>
-                  <a:lumOff val="40000"/>
+                <a:schemeClr val="tx2">
+                  <a:lumMod val="50000"/>
+                  <a:lumOff val="50000"/>
                 </a:schemeClr>
               </a:solidFill>
               <a:tailEnd type="none" w="sm" len="sm"/>
@@ -4023,12 +4926,22 @@
             <a:p>
               <a:r>
                 <a:rPr kumimoji="1" lang="en" altLang="zh-CN" sz="700" b="1" i="1" dirty="0">
+                  <a:ln w="3175">
+                    <a:noFill/>
+                  </a:ln>
                   <a:solidFill>
-                    <a:schemeClr val="accent5">
-                      <a:lumMod val="60000"/>
-                      <a:lumOff val="40000"/>
+                    <a:schemeClr val="tx2">
+                      <a:lumMod val="50000"/>
+                      <a:lumOff val="50000"/>
                     </a:schemeClr>
                   </a:solidFill>
+                  <a:effectLst>
+                    <a:outerShdw blurRad="139700" dist="38100" dir="5400000" algn="t" rotWithShape="0">
+                      <a:prstClr val="black">
+                        <a:alpha val="25000"/>
+                      </a:prstClr>
+                    </a:outerShdw>
+                  </a:effectLst>
                   <a:latin typeface="Maple Mono" panose="020F0509060000000000" pitchFamily="49" charset="0"/>
                   <a:ea typeface="Maple Mono" panose="020F0509060000000000" pitchFamily="49" charset="0"/>
                 </a:rPr>
@@ -4038,24 +4951,44 @@
             <a:p>
               <a:r>
                 <a:rPr kumimoji="1" lang="en" altLang="zh-CN" sz="700" b="1" i="1" dirty="0">
+                  <a:ln w="3175">
+                    <a:noFill/>
+                  </a:ln>
                   <a:solidFill>
-                    <a:schemeClr val="accent5">
-                      <a:lumMod val="60000"/>
-                      <a:lumOff val="40000"/>
+                    <a:schemeClr val="tx2">
+                      <a:lumMod val="50000"/>
+                      <a:lumOff val="50000"/>
                     </a:schemeClr>
                   </a:solidFill>
+                  <a:effectLst>
+                    <a:outerShdw blurRad="139700" dist="38100" dir="5400000" algn="t" rotWithShape="0">
+                      <a:prstClr val="black">
+                        <a:alpha val="25000"/>
+                      </a:prstClr>
+                    </a:outerShdw>
+                  </a:effectLst>
                   <a:latin typeface="Maple Mono" panose="020F0509060000000000" pitchFamily="49" charset="0"/>
                   <a:ea typeface="Maple Mono" panose="020F0509060000000000" pitchFamily="49" charset="0"/>
                 </a:rPr>
                 <a:t>Outline Recognition</a:t>
               </a:r>
               <a:endParaRPr kumimoji="1" lang="zh-CN" altLang="en-US" sz="700" b="1" i="1" dirty="0">
+                <a:ln w="3175">
+                  <a:noFill/>
+                </a:ln>
                 <a:solidFill>
-                  <a:schemeClr val="accent5">
-                    <a:lumMod val="60000"/>
-                    <a:lumOff val="40000"/>
+                  <a:schemeClr val="tx2">
+                    <a:lumMod val="50000"/>
+                    <a:lumOff val="50000"/>
                   </a:schemeClr>
                 </a:solidFill>
+                <a:effectLst>
+                  <a:outerShdw blurRad="139700" dist="38100" dir="5400000" algn="t" rotWithShape="0">
+                    <a:prstClr val="black">
+                      <a:alpha val="25000"/>
+                    </a:prstClr>
+                  </a:outerShdw>
+                </a:effectLst>
                 <a:latin typeface="Maple Mono" panose="020F0509060000000000" pitchFamily="49" charset="0"/>
               </a:endParaRPr>
             </a:p>
@@ -4085,9 +5018,9 @@
             </a:prstGeom>
             <a:ln w="9525" cap="rnd">
               <a:solidFill>
-                <a:schemeClr val="accent5">
-                  <a:lumMod val="60000"/>
-                  <a:lumOff val="40000"/>
+                <a:schemeClr val="tx2">
+                  <a:lumMod val="50000"/>
+                  <a:lumOff val="50000"/>
                 </a:schemeClr>
               </a:solidFill>
               <a:tailEnd type="none" w="sm" len="sm"/>
@@ -4132,9 +5065,9 @@
             </a:prstGeom>
             <a:ln w="9525" cap="rnd">
               <a:solidFill>
-                <a:schemeClr val="accent5">
-                  <a:lumMod val="60000"/>
-                  <a:lumOff val="40000"/>
+                <a:schemeClr val="tx2">
+                  <a:lumMod val="50000"/>
+                  <a:lumOff val="50000"/>
                 </a:schemeClr>
               </a:solidFill>
               <a:tailEnd type="oval" w="sm" len="sm"/>
@@ -4185,24 +5118,44 @@
             <a:p>
               <a:r>
                 <a:rPr kumimoji="1" lang="en" altLang="zh-CN" sz="700" b="1" i="1" dirty="0">
+                  <a:ln w="3175">
+                    <a:noFill/>
+                  </a:ln>
                   <a:solidFill>
-                    <a:schemeClr val="accent5">
-                      <a:lumMod val="60000"/>
-                      <a:lumOff val="40000"/>
+                    <a:schemeClr val="tx2">
+                      <a:lumMod val="50000"/>
+                      <a:lumOff val="50000"/>
                     </a:schemeClr>
                   </a:solidFill>
+                  <a:effectLst>
+                    <a:outerShdw blurRad="139700" dist="38100" dir="5400000" algn="t" rotWithShape="0">
+                      <a:prstClr val="black">
+                        <a:alpha val="25000"/>
+                      </a:prstClr>
+                    </a:outerShdw>
+                  </a:effectLst>
                   <a:latin typeface="Maple Mono" panose="020F0509060000000000" pitchFamily="49" charset="0"/>
                   <a:ea typeface="Maple Mono" panose="020F0509060000000000" pitchFamily="49" charset="0"/>
                 </a:rPr>
                 <a:t>Syntax Highlighting</a:t>
               </a:r>
               <a:endParaRPr kumimoji="1" lang="zh-CN" altLang="en-US" sz="700" b="1" i="1" dirty="0">
+                <a:ln w="3175">
+                  <a:noFill/>
+                </a:ln>
                 <a:solidFill>
-                  <a:schemeClr val="accent5">
-                    <a:lumMod val="60000"/>
-                    <a:lumOff val="40000"/>
+                  <a:schemeClr val="tx2">
+                    <a:lumMod val="50000"/>
+                    <a:lumOff val="50000"/>
                   </a:schemeClr>
                 </a:solidFill>
+                <a:effectLst>
+                  <a:outerShdw blurRad="139700" dist="38100" dir="5400000" algn="t" rotWithShape="0">
+                    <a:prstClr val="black">
+                      <a:alpha val="25000"/>
+                    </a:prstClr>
+                  </a:outerShdw>
+                </a:effectLst>
                 <a:latin typeface="Maple Mono" panose="020F0509060000000000" pitchFamily="49" charset="0"/>
               </a:endParaRPr>
             </a:p>
@@ -4232,9 +5185,9 @@
             </a:prstGeom>
             <a:ln w="9525">
               <a:solidFill>
-                <a:schemeClr val="accent5">
-                  <a:lumMod val="60000"/>
-                  <a:lumOff val="40000"/>
+                <a:schemeClr val="tx2">
+                  <a:lumMod val="50000"/>
+                  <a:lumOff val="50000"/>
                 </a:schemeClr>
               </a:solidFill>
               <a:tailEnd type="oval" w="sm" len="sm"/>
@@ -4285,12 +5238,22 @@
             <a:p>
               <a:r>
                 <a:rPr kumimoji="1" lang="en" altLang="zh-CN" sz="700" b="1" i="1" dirty="0">
+                  <a:ln w="3175">
+                    <a:noFill/>
+                  </a:ln>
                   <a:solidFill>
-                    <a:schemeClr val="accent5">
-                      <a:lumMod val="60000"/>
-                      <a:lumOff val="40000"/>
+                    <a:schemeClr val="tx2">
+                      <a:lumMod val="50000"/>
+                      <a:lumOff val="50000"/>
                     </a:schemeClr>
                   </a:solidFill>
+                  <a:effectLst>
+                    <a:outerShdw blurRad="139700" dist="38100" dir="5400000" algn="t" rotWithShape="0">
+                      <a:prstClr val="black">
+                        <a:alpha val="25000"/>
+                      </a:prstClr>
+                    </a:outerShdw>
+                  </a:effectLst>
                   <a:latin typeface="Maple Mono" panose="020F0509060000000000" pitchFamily="49" charset="0"/>
                   <a:ea typeface="Maple Mono" panose="020F0509060000000000" pitchFamily="49" charset="0"/>
                 </a:rPr>
@@ -4300,12 +5263,22 @@
             <a:p>
               <a:r>
                 <a:rPr kumimoji="1" lang="en" altLang="zh-CN" sz="700" b="1" i="1" dirty="0">
+                  <a:ln w="3175">
+                    <a:noFill/>
+                  </a:ln>
                   <a:solidFill>
-                    <a:schemeClr val="accent5">
-                      <a:lumMod val="60000"/>
-                      <a:lumOff val="40000"/>
+                    <a:schemeClr val="tx2">
+                      <a:lumMod val="50000"/>
+                      <a:lumOff val="50000"/>
                     </a:schemeClr>
                   </a:solidFill>
+                  <a:effectLst>
+                    <a:outerShdw blurRad="139700" dist="38100" dir="5400000" algn="t" rotWithShape="0">
+                      <a:prstClr val="black">
+                        <a:alpha val="25000"/>
+                      </a:prstClr>
+                    </a:outerShdw>
+                  </a:effectLst>
                   <a:latin typeface="Maple Mono" panose="020F0509060000000000" pitchFamily="49" charset="0"/>
                   <a:ea typeface="Maple Mono" panose="020F0509060000000000" pitchFamily="49" charset="0"/>
                 </a:rPr>
@@ -4313,12 +5286,22 @@
               </a:r>
               <a:r>
                 <a:rPr kumimoji="1" lang="en" altLang="zh-CN" sz="700" b="1" dirty="0" err="1">
+                  <a:ln w="3175">
+                    <a:noFill/>
+                  </a:ln>
                   <a:solidFill>
-                    <a:schemeClr val="accent5">
-                      <a:lumMod val="60000"/>
-                      <a:lumOff val="40000"/>
+                    <a:schemeClr val="tx2">
+                      <a:lumMod val="50000"/>
+                      <a:lumOff val="50000"/>
                     </a:schemeClr>
                   </a:solidFill>
+                  <a:effectLst>
+                    <a:outerShdw blurRad="139700" dist="38100" dir="5400000" algn="t" rotWithShape="0">
+                      <a:prstClr val="black">
+                        <a:alpha val="25000"/>
+                      </a:prstClr>
+                    </a:outerShdw>
+                  </a:effectLst>
                   <a:latin typeface="Maple Mono" panose="020F0509060000000000" pitchFamily="49" charset="0"/>
                   <a:ea typeface="Maple Mono" panose="020F0509060000000000" pitchFamily="49" charset="0"/>
                 </a:rPr>
@@ -4326,12 +5309,22 @@
               </a:r>
               <a:r>
                 <a:rPr kumimoji="1" lang="en" altLang="zh-CN" sz="700" b="1" i="1" dirty="0">
+                  <a:ln w="3175">
+                    <a:noFill/>
+                  </a:ln>
                   <a:solidFill>
-                    <a:schemeClr val="accent5">
-                      <a:lumMod val="60000"/>
-                      <a:lumOff val="40000"/>
+                    <a:schemeClr val="tx2">
+                      <a:lumMod val="50000"/>
+                      <a:lumOff val="50000"/>
                     </a:schemeClr>
                   </a:solidFill>
+                  <a:effectLst>
+                    <a:outerShdw blurRad="139700" dist="38100" dir="5400000" algn="t" rotWithShape="0">
+                      <a:prstClr val="black">
+                        <a:alpha val="25000"/>
+                      </a:prstClr>
+                    </a:outerShdw>
+                  </a:effectLst>
                   <a:latin typeface="Maple Mono" panose="020F0509060000000000" pitchFamily="49" charset="0"/>
                   <a:ea typeface="Maple Mono" panose="020F0509060000000000" pitchFamily="49" charset="0"/>
                 </a:rPr>
@@ -4341,24 +5334,44 @@
             <a:p>
               <a:r>
                 <a:rPr kumimoji="1" lang="en" altLang="zh-CN" sz="700" b="1" i="1" dirty="0">
+                  <a:ln w="3175">
+                    <a:noFill/>
+                  </a:ln>
                   <a:solidFill>
-                    <a:schemeClr val="accent5">
-                      <a:lumMod val="60000"/>
-                      <a:lumOff val="40000"/>
+                    <a:schemeClr val="tx2">
+                      <a:lumMod val="50000"/>
+                      <a:lumOff val="50000"/>
                     </a:schemeClr>
                   </a:solidFill>
+                  <a:effectLst>
+                    <a:outerShdw blurRad="139700" dist="38100" dir="5400000" algn="t" rotWithShape="0">
+                      <a:prstClr val="black">
+                        <a:alpha val="25000"/>
+                      </a:prstClr>
+                    </a:outerShdw>
+                  </a:effectLst>
                   <a:latin typeface="Maple Mono" panose="020F0509060000000000" pitchFamily="49" charset="0"/>
                   <a:ea typeface="Maple Mono" panose="020F0509060000000000" pitchFamily="49" charset="0"/>
                 </a:rPr>
                 <a:t>in the Data Viewer</a:t>
               </a:r>
               <a:endParaRPr kumimoji="1" lang="zh-CN" altLang="en-US" sz="700" b="1" i="1" dirty="0">
+                <a:ln w="3175">
+                  <a:noFill/>
+                </a:ln>
                 <a:solidFill>
-                  <a:schemeClr val="accent5">
-                    <a:lumMod val="60000"/>
-                    <a:lumOff val="40000"/>
+                  <a:schemeClr val="tx2">
+                    <a:lumMod val="50000"/>
+                    <a:lumOff val="50000"/>
                   </a:schemeClr>
                 </a:solidFill>
+                <a:effectLst>
+                  <a:outerShdw blurRad="139700" dist="38100" dir="5400000" algn="t" rotWithShape="0">
+                    <a:prstClr val="black">
+                      <a:alpha val="25000"/>
+                    </a:prstClr>
+                  </a:outerShdw>
+                </a:effectLst>
                 <a:latin typeface="Maple Mono" panose="020F0509060000000000" pitchFamily="49" charset="0"/>
               </a:endParaRPr>
             </a:p>
@@ -4388,9 +5401,9 @@
             </a:prstGeom>
             <a:ln w="9525" cap="rnd">
               <a:solidFill>
-                <a:schemeClr val="accent5">
-                  <a:lumMod val="60000"/>
-                  <a:lumOff val="40000"/>
+                <a:schemeClr val="tx2">
+                  <a:lumMod val="50000"/>
+                  <a:lumOff val="50000"/>
                 </a:schemeClr>
               </a:solidFill>
               <a:tailEnd type="none" w="sm" len="sm"/>
@@ -4435,9 +5448,9 @@
             </a:prstGeom>
             <a:ln w="9525" cap="rnd">
               <a:solidFill>
-                <a:schemeClr val="accent5">
-                  <a:lumMod val="60000"/>
-                  <a:lumOff val="40000"/>
+                <a:schemeClr val="tx2">
+                  <a:lumMod val="50000"/>
+                  <a:lumOff val="50000"/>
                 </a:schemeClr>
               </a:solidFill>
               <a:tailEnd type="oval" w="sm" len="sm"/>
@@ -4488,24 +5501,44 @@
             <a:p>
               <a:r>
                 <a:rPr kumimoji="1" lang="en" altLang="zh-CN" sz="700" b="1" i="1" dirty="0">
+                  <a:ln w="3175">
+                    <a:noFill/>
+                  </a:ln>
                   <a:solidFill>
-                    <a:schemeClr val="accent5">
-                      <a:lumMod val="60000"/>
-                      <a:lumOff val="40000"/>
+                    <a:schemeClr val="tx2">
+                      <a:lumMod val="50000"/>
+                      <a:lumOff val="50000"/>
                     </a:schemeClr>
                   </a:solidFill>
+                  <a:effectLst>
+                    <a:outerShdw blurRad="139700" dist="38100" dir="5400000" algn="t" rotWithShape="0">
+                      <a:prstClr val="black">
+                        <a:alpha val="25000"/>
+                      </a:prstClr>
+                    </a:outerShdw>
+                  </a:effectLst>
                   <a:latin typeface="Maple Mono" panose="020F0509060000000000" pitchFamily="49" charset="0"/>
                   <a:ea typeface="Maple Mono" panose="020F0509060000000000" pitchFamily="49" charset="0"/>
                 </a:rPr>
                 <a:t>Enhanced Commenting</a:t>
               </a:r>
               <a:endParaRPr kumimoji="1" lang="zh-CN" altLang="en-US" sz="700" b="1" i="1" dirty="0">
+                <a:ln w="3175">
+                  <a:noFill/>
+                </a:ln>
                 <a:solidFill>
-                  <a:schemeClr val="accent5">
-                    <a:lumMod val="60000"/>
-                    <a:lumOff val="40000"/>
+                  <a:schemeClr val="tx2">
+                    <a:lumMod val="50000"/>
+                    <a:lumOff val="50000"/>
                   </a:schemeClr>
                 </a:solidFill>
+                <a:effectLst>
+                  <a:outerShdw blurRad="139700" dist="38100" dir="5400000" algn="t" rotWithShape="0">
+                    <a:prstClr val="black">
+                      <a:alpha val="25000"/>
+                    </a:prstClr>
+                  </a:outerShdw>
+                </a:effectLst>
                 <a:latin typeface="Maple Mono" panose="020F0509060000000000" pitchFamily="49" charset="0"/>
               </a:endParaRPr>
             </a:p>
@@ -4526,7 +5559,7 @@
             <p:nvPr/>
           </p:nvPicPr>
           <p:blipFill>
-            <a:blip r:embed="rId3"/>
+            <a:blip r:embed="rId4"/>
             <a:srcRect/>
             <a:stretch/>
           </p:blipFill>
@@ -4670,9 +5703,9 @@
             </a:prstGeom>
             <a:ln w="9525">
               <a:solidFill>
-                <a:schemeClr val="accent5">
-                  <a:lumMod val="60000"/>
-                  <a:lumOff val="40000"/>
+                <a:schemeClr val="tx2">
+                  <a:lumMod val="50000"/>
+                  <a:lumOff val="50000"/>
                 </a:schemeClr>
               </a:solidFill>
               <a:tailEnd type="oval" w="sm" len="sm"/>
@@ -4717,9 +5750,9 @@
             </a:prstGeom>
             <a:ln w="9525">
               <a:solidFill>
-                <a:schemeClr val="accent5">
-                  <a:lumMod val="60000"/>
-                  <a:lumOff val="40000"/>
+                <a:schemeClr val="tx2">
+                  <a:lumMod val="50000"/>
+                  <a:lumOff val="50000"/>
                 </a:schemeClr>
               </a:solidFill>
               <a:headEnd type="oval" w="sm" len="sm"/>
@@ -4771,12 +5804,22 @@
             <a:p>
               <a:r>
                 <a:rPr kumimoji="1" lang="en" altLang="zh-CN" sz="700" b="1" i="1" dirty="0">
+                  <a:ln w="3175">
+                    <a:noFill/>
+                  </a:ln>
                   <a:solidFill>
-                    <a:schemeClr val="accent5">
-                      <a:lumMod val="60000"/>
-                      <a:lumOff val="40000"/>
+                    <a:schemeClr val="tx2">
+                      <a:lumMod val="50000"/>
+                      <a:lumOff val="50000"/>
                     </a:schemeClr>
                   </a:solidFill>
+                  <a:effectLst>
+                    <a:outerShdw blurRad="139700" dist="38100" dir="5400000" algn="t" rotWithShape="0">
+                      <a:prstClr val="black">
+                        <a:alpha val="25000"/>
+                      </a:prstClr>
+                    </a:outerShdw>
+                  </a:effectLst>
                   <a:latin typeface="Maple Mono" panose="020F0509060000000000" pitchFamily="49" charset="0"/>
                   <a:ea typeface="Maple Mono" panose="020F0509060000000000" pitchFamily="49" charset="0"/>
                 </a:rPr>
@@ -4809,9 +5852,9 @@
             </a:prstGeom>
             <a:ln w="9525" cap="rnd">
               <a:solidFill>
-                <a:schemeClr val="accent5">
-                  <a:lumMod val="60000"/>
-                  <a:lumOff val="40000"/>
+                <a:schemeClr val="tx2">
+                  <a:lumMod val="50000"/>
+                  <a:lumOff val="50000"/>
                 </a:schemeClr>
               </a:solidFill>
               <a:tailEnd type="oval" w="sm" len="sm"/>
@@ -4862,12 +5905,22 @@
             <a:p>
               <a:r>
                 <a:rPr kumimoji="1" lang="en" altLang="zh-CN" sz="700" b="1" i="1" dirty="0">
+                  <a:ln w="3175">
+                    <a:noFill/>
+                  </a:ln>
                   <a:solidFill>
-                    <a:schemeClr val="accent5">
-                      <a:lumMod val="60000"/>
-                      <a:lumOff val="40000"/>
+                    <a:schemeClr val="tx2">
+                      <a:lumMod val="50000"/>
+                      <a:lumOff val="50000"/>
                     </a:schemeClr>
                   </a:solidFill>
+                  <a:effectLst>
+                    <a:outerShdw blurRad="139700" dist="38100" dir="5400000" algn="t" rotWithShape="0">
+                      <a:prstClr val="black">
+                        <a:alpha val="25000"/>
+                      </a:prstClr>
+                    </a:outerShdw>
+                  </a:effectLst>
                   <a:latin typeface="Maple Mono" panose="020F0509060000000000" pitchFamily="49" charset="0"/>
                   <a:ea typeface="Maple Mono" panose="020F0509060000000000" pitchFamily="49" charset="0"/>
                 </a:rPr>
@@ -4875,12 +5928,22 @@
               </a:r>
               <a:r>
                 <a:rPr kumimoji="1" lang="zh-CN" altLang="en-US" sz="700" b="1" i="1" dirty="0">
+                  <a:ln w="3175">
+                    <a:noFill/>
+                  </a:ln>
                   <a:solidFill>
-                    <a:schemeClr val="accent5">
-                      <a:lumMod val="60000"/>
-                      <a:lumOff val="40000"/>
+                    <a:schemeClr val="tx2">
+                      <a:lumMod val="50000"/>
+                      <a:lumOff val="50000"/>
                     </a:schemeClr>
                   </a:solidFill>
+                  <a:effectLst>
+                    <a:outerShdw blurRad="139700" dist="38100" dir="5400000" algn="t" rotWithShape="0">
+                      <a:prstClr val="black">
+                        <a:alpha val="25000"/>
+                      </a:prstClr>
+                    </a:outerShdw>
+                  </a:effectLst>
                   <a:latin typeface="Maple Mono" panose="020F0509060000000000" pitchFamily="49" charset="0"/>
                   <a:ea typeface="Maple Mono" panose="020F0509060000000000" pitchFamily="49" charset="0"/>
                 </a:rPr>
@@ -4888,12 +5951,22 @@
               </a:r>
               <a:r>
                 <a:rPr kumimoji="1" lang="en-US" altLang="zh-CN" sz="700" b="1" i="1" dirty="0">
+                  <a:ln w="3175">
+                    <a:noFill/>
+                  </a:ln>
                   <a:solidFill>
-                    <a:schemeClr val="accent5">
-                      <a:lumMod val="60000"/>
-                      <a:lumOff val="40000"/>
+                    <a:schemeClr val="tx2">
+                      <a:lumMod val="50000"/>
+                      <a:lumOff val="50000"/>
                     </a:schemeClr>
                   </a:solidFill>
+                  <a:effectLst>
+                    <a:outerShdw blurRad="139700" dist="38100" dir="5400000" algn="t" rotWithShape="0">
+                      <a:prstClr val="black">
+                        <a:alpha val="25000"/>
+                      </a:prstClr>
+                    </a:outerShdw>
+                  </a:effectLst>
                   <a:latin typeface="Maple Mono" panose="020F0509060000000000" pitchFamily="49" charset="0"/>
                   <a:ea typeface="Maple Mono" panose="020F0509060000000000" pitchFamily="49" charset="0"/>
                 </a:rPr>
@@ -4901,12 +5974,22 @@
               </a:r>
               <a:r>
                 <a:rPr kumimoji="1" lang="zh-CN" altLang="en-US" sz="700" b="1" i="1" dirty="0">
+                  <a:ln w="3175">
+                    <a:noFill/>
+                  </a:ln>
                   <a:solidFill>
-                    <a:schemeClr val="accent5">
-                      <a:lumMod val="60000"/>
-                      <a:lumOff val="40000"/>
+                    <a:schemeClr val="tx2">
+                      <a:lumMod val="50000"/>
+                      <a:lumOff val="50000"/>
                     </a:schemeClr>
                   </a:solidFill>
+                  <a:effectLst>
+                    <a:outerShdw blurRad="139700" dist="38100" dir="5400000" algn="t" rotWithShape="0">
+                      <a:prstClr val="black">
+                        <a:alpha val="25000"/>
+                      </a:prstClr>
+                    </a:outerShdw>
+                  </a:effectLst>
                   <a:latin typeface="Maple Mono" panose="020F0509060000000000" pitchFamily="49" charset="0"/>
                   <a:ea typeface="Maple Mono" panose="020F0509060000000000" pitchFamily="49" charset="0"/>
                 </a:rPr>
@@ -4914,12 +5997,22 @@
               </a:r>
               <a:r>
                 <a:rPr kumimoji="1" lang="en-US" altLang="zh-CN" sz="700" b="1" i="1" dirty="0">
+                  <a:ln w="3175">
+                    <a:noFill/>
+                  </a:ln>
                   <a:solidFill>
-                    <a:schemeClr val="accent5">
-                      <a:lumMod val="60000"/>
-                      <a:lumOff val="40000"/>
+                    <a:schemeClr val="tx2">
+                      <a:lumMod val="50000"/>
+                      <a:lumOff val="50000"/>
                     </a:schemeClr>
                   </a:solidFill>
+                  <a:effectLst>
+                    <a:outerShdw blurRad="139700" dist="38100" dir="5400000" algn="t" rotWithShape="0">
+                      <a:prstClr val="black">
+                        <a:alpha val="25000"/>
+                      </a:prstClr>
+                    </a:outerShdw>
+                  </a:effectLst>
                   <a:latin typeface="Maple Mono" panose="020F0509060000000000" pitchFamily="49" charset="0"/>
                   <a:ea typeface="Maple Mono" panose="020F0509060000000000" pitchFamily="49" charset="0"/>
                 </a:rPr>
@@ -4927,12 +6020,22 @@
               </a:r>
               <a:r>
                 <a:rPr kumimoji="1" lang="zh-CN" altLang="en-US" sz="700" b="1" i="1" dirty="0">
+                  <a:ln w="3175">
+                    <a:noFill/>
+                  </a:ln>
                   <a:solidFill>
-                    <a:schemeClr val="accent5">
-                      <a:lumMod val="60000"/>
-                      <a:lumOff val="40000"/>
+                    <a:schemeClr val="tx2">
+                      <a:lumMod val="50000"/>
+                      <a:lumOff val="50000"/>
                     </a:schemeClr>
                   </a:solidFill>
+                  <a:effectLst>
+                    <a:outerShdw blurRad="139700" dist="38100" dir="5400000" algn="t" rotWithShape="0">
+                      <a:prstClr val="black">
+                        <a:alpha val="25000"/>
+                      </a:prstClr>
+                    </a:outerShdw>
+                  </a:effectLst>
                   <a:latin typeface="Maple Mono" panose="020F0509060000000000" pitchFamily="49" charset="0"/>
                   <a:ea typeface="Maple Mono" panose="020F0509060000000000" pitchFamily="49" charset="0"/>
                 </a:rPr>
@@ -4940,24 +6043,44 @@
               </a:r>
               <a:r>
                 <a:rPr kumimoji="1" lang="en-US" altLang="zh-CN" sz="700" b="1" i="1" dirty="0">
+                  <a:ln w="3175">
+                    <a:noFill/>
+                  </a:ln>
                   <a:solidFill>
-                    <a:schemeClr val="accent5">
-                      <a:lumMod val="60000"/>
-                      <a:lumOff val="40000"/>
+                    <a:schemeClr val="tx2">
+                      <a:lumMod val="50000"/>
+                      <a:lumOff val="50000"/>
                     </a:schemeClr>
                   </a:solidFill>
+                  <a:effectLst>
+                    <a:outerShdw blurRad="139700" dist="38100" dir="5400000" algn="t" rotWithShape="0">
+                      <a:prstClr val="black">
+                        <a:alpha val="25000"/>
+                      </a:prstClr>
+                    </a:outerShdw>
+                  </a:effectLst>
                   <a:latin typeface="Maple Mono" panose="020F0509060000000000" pitchFamily="49" charset="0"/>
                   <a:ea typeface="Maple Mono" panose="020F0509060000000000" pitchFamily="49" charset="0"/>
                 </a:rPr>
                 <a:t>Setup</a:t>
               </a:r>
               <a:endParaRPr kumimoji="1" lang="zh-CN" altLang="en-US" sz="700" b="1" i="1" dirty="0">
+                <a:ln w="3175">
+                  <a:noFill/>
+                </a:ln>
                 <a:solidFill>
-                  <a:schemeClr val="accent5">
-                    <a:lumMod val="60000"/>
-                    <a:lumOff val="40000"/>
+                  <a:schemeClr val="tx2">
+                    <a:lumMod val="50000"/>
+                    <a:lumOff val="50000"/>
                   </a:schemeClr>
                 </a:solidFill>
+                <a:effectLst>
+                  <a:outerShdw blurRad="139700" dist="38100" dir="5400000" algn="t" rotWithShape="0">
+                    <a:prstClr val="black">
+                      <a:alpha val="25000"/>
+                    </a:prstClr>
+                  </a:outerShdw>
+                </a:effectLst>
                 <a:latin typeface="Maple Mono" panose="020F0509060000000000" pitchFamily="49" charset="0"/>
               </a:endParaRPr>
             </a:p>
@@ -4987,9 +6110,9 @@
             </a:prstGeom>
             <a:ln w="9525" cap="rnd">
               <a:solidFill>
-                <a:schemeClr val="accent5">
-                  <a:lumMod val="60000"/>
-                  <a:lumOff val="40000"/>
+                <a:schemeClr val="tx2">
+                  <a:lumMod val="50000"/>
+                  <a:lumOff val="50000"/>
                 </a:schemeClr>
               </a:solidFill>
               <a:tailEnd type="none" w="sm" len="sm"/>
@@ -5034,9 +6157,9 @@
             </a:prstGeom>
             <a:ln w="9525" cap="rnd">
               <a:solidFill>
-                <a:schemeClr val="accent5">
-                  <a:lumMod val="60000"/>
-                  <a:lumOff val="40000"/>
+                <a:schemeClr val="tx2">
+                  <a:lumMod val="50000"/>
+                  <a:lumOff val="50000"/>
                 </a:schemeClr>
               </a:solidFill>
               <a:tailEnd type="oval" w="sm" len="sm"/>
@@ -5087,12 +6210,22 @@
             <a:p>
               <a:r>
                 <a:rPr kumimoji="1" lang="en-US" altLang="zh-CN" sz="700" b="1" i="1" dirty="0">
+                  <a:ln w="3175">
+                    <a:noFill/>
+                  </a:ln>
                   <a:solidFill>
-                    <a:schemeClr val="accent5">
-                      <a:lumMod val="60000"/>
-                      <a:lumOff val="40000"/>
+                    <a:schemeClr val="tx2">
+                      <a:lumMod val="50000"/>
+                      <a:lumOff val="50000"/>
                     </a:schemeClr>
                   </a:solidFill>
+                  <a:effectLst>
+                    <a:outerShdw blurRad="139700" dist="38100" dir="5400000" algn="t" rotWithShape="0">
+                      <a:prstClr val="black">
+                        <a:alpha val="25000"/>
+                      </a:prstClr>
+                    </a:outerShdw>
+                  </a:effectLst>
                   <a:latin typeface="Maple Mono" panose="020F0509060000000000" pitchFamily="49" charset="0"/>
                   <a:ea typeface="Maple Mono" panose="020F0509060000000000" pitchFamily="49" charset="0"/>
                 </a:rPr>
@@ -5100,12 +6233,22 @@
               </a:r>
               <a:r>
                 <a:rPr kumimoji="1" lang="zh-CN" altLang="en-US" sz="700" b="1" i="1" dirty="0">
+                  <a:ln w="3175">
+                    <a:noFill/>
+                  </a:ln>
                   <a:solidFill>
-                    <a:schemeClr val="accent5">
-                      <a:lumMod val="60000"/>
-                      <a:lumOff val="40000"/>
+                    <a:schemeClr val="tx2">
+                      <a:lumMod val="50000"/>
+                      <a:lumOff val="50000"/>
                     </a:schemeClr>
                   </a:solidFill>
+                  <a:effectLst>
+                    <a:outerShdw blurRad="139700" dist="38100" dir="5400000" algn="t" rotWithShape="0">
+                      <a:prstClr val="black">
+                        <a:alpha val="25000"/>
+                      </a:prstClr>
+                    </a:outerShdw>
+                  </a:effectLst>
                   <a:latin typeface="Maple Mono" panose="020F0509060000000000" pitchFamily="49" charset="0"/>
                   <a:ea typeface="Maple Mono" panose="020F0509060000000000" pitchFamily="49" charset="0"/>
                 </a:rPr>
@@ -5113,24 +6256,44 @@
               </a:r>
               <a:r>
                 <a:rPr kumimoji="1" lang="en-US" altLang="zh-CN" sz="700" b="1" i="1" dirty="0">
+                  <a:ln w="3175">
+                    <a:noFill/>
+                  </a:ln>
                   <a:solidFill>
-                    <a:schemeClr val="accent5">
-                      <a:lumMod val="60000"/>
-                      <a:lumOff val="40000"/>
+                    <a:schemeClr val="tx2">
+                      <a:lumMod val="50000"/>
+                      <a:lumOff val="50000"/>
                     </a:schemeClr>
                   </a:solidFill>
+                  <a:effectLst>
+                    <a:outerShdw blurRad="139700" dist="38100" dir="5400000" algn="t" rotWithShape="0">
+                      <a:prstClr val="black">
+                        <a:alpha val="25000"/>
+                      </a:prstClr>
+                    </a:outerShdw>
+                  </a:effectLst>
                   <a:latin typeface="Maple Mono" panose="020F0509060000000000" pitchFamily="49" charset="0"/>
                   <a:ea typeface="Maple Mono" panose="020F0509060000000000" pitchFamily="49" charset="0"/>
                 </a:rPr>
                 <a:t>Viewer</a:t>
               </a:r>
               <a:endParaRPr kumimoji="1" lang="zh-CN" altLang="en-US" sz="700" b="1" i="1" dirty="0">
+                <a:ln w="3175">
+                  <a:noFill/>
+                </a:ln>
                 <a:solidFill>
-                  <a:schemeClr val="accent5">
-                    <a:lumMod val="60000"/>
-                    <a:lumOff val="40000"/>
+                  <a:schemeClr val="tx2">
+                    <a:lumMod val="50000"/>
+                    <a:lumOff val="50000"/>
                   </a:schemeClr>
                 </a:solidFill>
+                <a:effectLst>
+                  <a:outerShdw blurRad="139700" dist="38100" dir="5400000" algn="t" rotWithShape="0">
+                    <a:prstClr val="black">
+                      <a:alpha val="25000"/>
+                    </a:prstClr>
+                  </a:outerShdw>
+                </a:effectLst>
                 <a:latin typeface="Maple Mono" panose="020F0509060000000000" pitchFamily="49" charset="0"/>
               </a:endParaRPr>
             </a:p>
@@ -5160,9 +6323,9 @@
             </a:prstGeom>
             <a:ln w="9525" cap="rnd">
               <a:solidFill>
-                <a:schemeClr val="accent5">
-                  <a:lumMod val="60000"/>
-                  <a:lumOff val="40000"/>
+                <a:schemeClr val="tx2">
+                  <a:lumMod val="50000"/>
+                  <a:lumOff val="50000"/>
                 </a:schemeClr>
               </a:solidFill>
               <a:tailEnd type="none" w="sm" len="sm"/>
@@ -5198,7 +6361,7 @@
             <p:nvPr/>
           </p:nvPicPr>
           <p:blipFill>
-            <a:blip r:embed="rId4"/>
+            <a:blip r:embed="rId5"/>
             <a:srcRect/>
             <a:stretch>
               <a:fillRect/>
@@ -5344,9 +6507,9 @@
             </a:prstGeom>
             <a:ln w="9525">
               <a:solidFill>
-                <a:schemeClr val="accent5">
-                  <a:lumMod val="60000"/>
-                  <a:lumOff val="40000"/>
+                <a:schemeClr val="tx2">
+                  <a:lumMod val="50000"/>
+                  <a:lumOff val="50000"/>
                 </a:schemeClr>
               </a:solidFill>
               <a:tailEnd type="oval" w="sm" len="sm"/>
@@ -5398,12 +6561,22 @@
               <a:pPr algn="r"/>
               <a:r>
                 <a:rPr kumimoji="1" lang="en-US" altLang="zh-CN" sz="700" b="1" i="1" dirty="0">
+                  <a:ln w="3175">
+                    <a:noFill/>
+                  </a:ln>
                   <a:solidFill>
-                    <a:schemeClr val="accent5">
-                      <a:lumMod val="60000"/>
-                      <a:lumOff val="40000"/>
+                    <a:schemeClr val="tx2">
+                      <a:lumMod val="50000"/>
+                      <a:lumOff val="50000"/>
                     </a:schemeClr>
                   </a:solidFill>
+                  <a:effectLst>
+                    <a:outerShdw blurRad="139700" dist="38100" dir="5400000" algn="t" rotWithShape="0">
+                      <a:prstClr val="black">
+                        <a:alpha val="25000"/>
+                      </a:prstClr>
+                    </a:outerShdw>
+                  </a:effectLst>
                   <a:latin typeface="Maple Mono" panose="020F0509060000000000" pitchFamily="49" charset="0"/>
                   <a:ea typeface="Maple Mono" panose="020F0509060000000000" pitchFamily="49" charset="0"/>
                 </a:rPr>
@@ -5411,12 +6584,22 @@
               </a:r>
               <a:r>
                 <a:rPr kumimoji="1" lang="zh-CN" altLang="en-US" sz="700" b="1" i="1" dirty="0">
+                  <a:ln w="3175">
+                    <a:noFill/>
+                  </a:ln>
                   <a:solidFill>
-                    <a:schemeClr val="accent5">
-                      <a:lumMod val="60000"/>
-                      <a:lumOff val="40000"/>
+                    <a:schemeClr val="tx2">
+                      <a:lumMod val="50000"/>
+                      <a:lumOff val="50000"/>
                     </a:schemeClr>
                   </a:solidFill>
+                  <a:effectLst>
+                    <a:outerShdw blurRad="139700" dist="38100" dir="5400000" algn="t" rotWithShape="0">
+                      <a:prstClr val="black">
+                        <a:alpha val="25000"/>
+                      </a:prstClr>
+                    </a:outerShdw>
+                  </a:effectLst>
                   <a:latin typeface="Maple Mono" panose="020F0509060000000000" pitchFamily="49" charset="0"/>
                   <a:ea typeface="Maple Mono" panose="020F0509060000000000" pitchFamily="49" charset="0"/>
                 </a:rPr>
@@ -5424,24 +6607,44 @@
               </a:r>
               <a:r>
                 <a:rPr kumimoji="1" lang="en" altLang="zh-CN" sz="700" b="1" i="1" dirty="0">
+                  <a:ln w="3175">
+                    <a:noFill/>
+                  </a:ln>
                   <a:solidFill>
-                    <a:schemeClr val="accent5">
-                      <a:lumMod val="60000"/>
-                      <a:lumOff val="40000"/>
+                    <a:schemeClr val="tx2">
+                      <a:lumMod val="50000"/>
+                      <a:lumOff val="50000"/>
                     </a:schemeClr>
                   </a:solidFill>
+                  <a:effectLst>
+                    <a:outerShdw blurRad="139700" dist="38100" dir="5400000" algn="t" rotWithShape="0">
+                      <a:prstClr val="black">
+                        <a:alpha val="25000"/>
+                      </a:prstClr>
+                    </a:outerShdw>
+                  </a:effectLst>
                   <a:latin typeface="Maple Mono" panose="020F0509060000000000" pitchFamily="49" charset="0"/>
                   <a:ea typeface="Maple Mono" panose="020F0509060000000000" pitchFamily="49" charset="0"/>
                 </a:rPr>
                 <a:t>Table</a:t>
               </a:r>
               <a:endParaRPr kumimoji="1" lang="zh-CN" altLang="en-US" sz="700" b="1" i="1" dirty="0">
+                <a:ln w="3175">
+                  <a:noFill/>
+                </a:ln>
                 <a:solidFill>
-                  <a:schemeClr val="accent5">
-                    <a:lumMod val="60000"/>
-                    <a:lumOff val="40000"/>
+                  <a:schemeClr val="tx2">
+                    <a:lumMod val="50000"/>
+                    <a:lumOff val="50000"/>
                   </a:schemeClr>
                 </a:solidFill>
+                <a:effectLst>
+                  <a:outerShdw blurRad="139700" dist="38100" dir="5400000" algn="t" rotWithShape="0">
+                    <a:prstClr val="black">
+                      <a:alpha val="25000"/>
+                    </a:prstClr>
+                  </a:outerShdw>
+                </a:effectLst>
                 <a:latin typeface="Maple Mono" panose="020F0509060000000000" pitchFamily="49" charset="0"/>
               </a:endParaRPr>
             </a:p>
@@ -5471,9 +6674,9 @@
             </a:prstGeom>
             <a:ln w="9525">
               <a:solidFill>
-                <a:schemeClr val="accent5">
-                  <a:lumMod val="60000"/>
-                  <a:lumOff val="40000"/>
+                <a:schemeClr val="tx2">
+                  <a:lumMod val="50000"/>
+                  <a:lumOff val="50000"/>
                 </a:schemeClr>
               </a:solidFill>
               <a:tailEnd type="none" w="sm" len="sm"/>
@@ -5518,9 +6721,9 @@
             </a:prstGeom>
             <a:ln w="9525" cap="rnd">
               <a:solidFill>
-                <a:schemeClr val="accent5">
-                  <a:lumMod val="60000"/>
-                  <a:lumOff val="40000"/>
+                <a:schemeClr val="tx2">
+                  <a:lumMod val="50000"/>
+                  <a:lumOff val="50000"/>
                 </a:schemeClr>
               </a:solidFill>
               <a:tailEnd type="oval" w="sm" len="sm"/>
@@ -5572,12 +6775,22 @@
               <a:pPr algn="r"/>
               <a:r>
                 <a:rPr kumimoji="1" lang="en-US" altLang="zh-CN" sz="700" b="1" i="1" dirty="0">
+                  <a:ln w="3175">
+                    <a:noFill/>
+                  </a:ln>
                   <a:solidFill>
-                    <a:schemeClr val="accent5">
-                      <a:lumMod val="60000"/>
-                      <a:lumOff val="40000"/>
+                    <a:schemeClr val="tx2">
+                      <a:lumMod val="50000"/>
+                      <a:lumOff val="50000"/>
                     </a:schemeClr>
                   </a:solidFill>
+                  <a:effectLst>
+                    <a:outerShdw blurRad="139700" dist="38100" dir="5400000" algn="t" rotWithShape="0">
+                      <a:prstClr val="black">
+                        <a:alpha val="25000"/>
+                      </a:prstClr>
+                    </a:outerShdw>
+                  </a:effectLst>
                   <a:latin typeface="Maple Mono" panose="020F0509060000000000" pitchFamily="49" charset="0"/>
                   <a:ea typeface="Maple Mono" panose="020F0509060000000000" pitchFamily="49" charset="0"/>
                 </a:rPr>
@@ -5585,12 +6798,22 @@
               </a:r>
               <a:r>
                 <a:rPr kumimoji="1" lang="zh-CN" altLang="en-US" sz="700" b="1" i="1" dirty="0">
+                  <a:ln w="3175">
+                    <a:noFill/>
+                  </a:ln>
                   <a:solidFill>
-                    <a:schemeClr val="accent5">
-                      <a:lumMod val="60000"/>
-                      <a:lumOff val="40000"/>
+                    <a:schemeClr val="tx2">
+                      <a:lumMod val="50000"/>
+                      <a:lumOff val="50000"/>
                     </a:schemeClr>
                   </a:solidFill>
+                  <a:effectLst>
+                    <a:outerShdw blurRad="139700" dist="38100" dir="5400000" algn="t" rotWithShape="0">
+                      <a:prstClr val="black">
+                        <a:alpha val="25000"/>
+                      </a:prstClr>
+                    </a:outerShdw>
+                  </a:effectLst>
                   <a:latin typeface="Maple Mono" panose="020F0509060000000000" pitchFamily="49" charset="0"/>
                   <a:ea typeface="Maple Mono" panose="020F0509060000000000" pitchFamily="49" charset="0"/>
                 </a:rPr>
@@ -5598,24 +6821,44 @@
               </a:r>
               <a:r>
                 <a:rPr kumimoji="1" lang="en-US" altLang="zh-CN" sz="700" b="1" i="1" dirty="0">
+                  <a:ln w="3175">
+                    <a:noFill/>
+                  </a:ln>
                   <a:solidFill>
-                    <a:schemeClr val="accent5">
-                      <a:lumMod val="60000"/>
-                      <a:lumOff val="40000"/>
+                    <a:schemeClr val="tx2">
+                      <a:lumMod val="50000"/>
+                      <a:lumOff val="50000"/>
                     </a:schemeClr>
                   </a:solidFill>
+                  <a:effectLst>
+                    <a:outerShdw blurRad="139700" dist="38100" dir="5400000" algn="t" rotWithShape="0">
+                      <a:prstClr val="black">
+                        <a:alpha val="25000"/>
+                      </a:prstClr>
+                    </a:outerShdw>
+                  </a:effectLst>
                   <a:latin typeface="Maple Mono" panose="020F0509060000000000" pitchFamily="49" charset="0"/>
                   <a:ea typeface="Maple Mono" panose="020F0509060000000000" pitchFamily="49" charset="0"/>
                 </a:rPr>
                 <a:t>Table</a:t>
               </a:r>
               <a:endParaRPr kumimoji="1" lang="zh-CN" altLang="en-US" sz="700" b="1" i="1" dirty="0">
+                <a:ln w="3175">
+                  <a:noFill/>
+                </a:ln>
                 <a:solidFill>
-                  <a:schemeClr val="accent5">
-                    <a:lumMod val="60000"/>
-                    <a:lumOff val="40000"/>
+                  <a:schemeClr val="tx2">
+                    <a:lumMod val="50000"/>
+                    <a:lumOff val="50000"/>
                   </a:schemeClr>
                 </a:solidFill>
+                <a:effectLst>
+                  <a:outerShdw blurRad="139700" dist="38100" dir="5400000" algn="t" rotWithShape="0">
+                    <a:prstClr val="black">
+                      <a:alpha val="25000"/>
+                    </a:prstClr>
+                  </a:outerShdw>
+                </a:effectLst>
                 <a:latin typeface="Maple Mono" panose="020F0509060000000000" pitchFamily="49" charset="0"/>
               </a:endParaRPr>
             </a:p>
@@ -5645,9 +6888,9 @@
             </a:prstGeom>
             <a:ln w="9525" cap="rnd">
               <a:solidFill>
-                <a:schemeClr val="accent5">
-                  <a:lumMod val="60000"/>
-                  <a:lumOff val="40000"/>
+                <a:schemeClr val="tx2">
+                  <a:lumMod val="50000"/>
+                  <a:lumOff val="50000"/>
                 </a:schemeClr>
               </a:solidFill>
               <a:tailEnd type="oval" w="sm" len="sm"/>
@@ -5692,9 +6935,9 @@
             </a:prstGeom>
             <a:ln w="9525">
               <a:solidFill>
-                <a:schemeClr val="accent5">
-                  <a:lumMod val="60000"/>
-                  <a:lumOff val="40000"/>
+                <a:schemeClr val="tx2">
+                  <a:lumMod val="50000"/>
+                  <a:lumOff val="50000"/>
                 </a:schemeClr>
               </a:solidFill>
               <a:tailEnd type="none" w="sm" len="sm"/>
@@ -5746,12 +6989,22 @@
               <a:pPr algn="r"/>
               <a:r>
                 <a:rPr kumimoji="1" lang="en" altLang="zh-CN" sz="700" b="1" i="1" dirty="0">
+                  <a:ln w="3175">
+                    <a:noFill/>
+                  </a:ln>
                   <a:solidFill>
-                    <a:schemeClr val="accent5">
-                      <a:lumMod val="60000"/>
-                      <a:lumOff val="40000"/>
+                    <a:schemeClr val="tx2">
+                      <a:lumMod val="50000"/>
+                      <a:lumOff val="50000"/>
                     </a:schemeClr>
                   </a:solidFill>
+                  <a:effectLst>
+                    <a:outerShdw blurRad="139700" dist="38100" dir="5400000" algn="t" rotWithShape="0">
+                      <a:prstClr val="black">
+                        <a:alpha val="25000"/>
+                      </a:prstClr>
+                    </a:outerShdw>
+                  </a:effectLst>
                   <a:latin typeface="Maple Mono" panose="020F0509060000000000" pitchFamily="49" charset="0"/>
                   <a:ea typeface="Maple Mono" panose="020F0509060000000000" pitchFamily="49" charset="0"/>
                 </a:rPr>
@@ -5762,12 +7015,22 @@
               <a:pPr algn="r"/>
               <a:r>
                 <a:rPr kumimoji="1" lang="en" altLang="zh-CN" sz="700" b="1" i="1" dirty="0">
+                  <a:ln w="3175">
+                    <a:noFill/>
+                  </a:ln>
                   <a:solidFill>
-                    <a:schemeClr val="accent5">
-                      <a:lumMod val="60000"/>
-                      <a:lumOff val="40000"/>
+                    <a:schemeClr val="tx2">
+                      <a:lumMod val="50000"/>
+                      <a:lumOff val="50000"/>
                     </a:schemeClr>
                   </a:solidFill>
+                  <a:effectLst>
+                    <a:outerShdw blurRad="139700" dist="38100" dir="5400000" algn="t" rotWithShape="0">
+                      <a:prstClr val="black">
+                        <a:alpha val="25000"/>
+                      </a:prstClr>
+                    </a:outerShdw>
+                  </a:effectLst>
                   <a:latin typeface="Maple Mono" panose="020F0509060000000000" pitchFamily="49" charset="0"/>
                   <a:ea typeface="Maple Mono" panose="020F0509060000000000" pitchFamily="49" charset="0"/>
                 </a:rPr>
@@ -5800,9 +7063,9 @@
             </a:prstGeom>
             <a:ln w="9525" cap="rnd">
               <a:solidFill>
-                <a:schemeClr val="accent5">
-                  <a:lumMod val="60000"/>
-                  <a:lumOff val="40000"/>
+                <a:schemeClr val="tx2">
+                  <a:lumMod val="50000"/>
+                  <a:lumOff val="50000"/>
                 </a:schemeClr>
               </a:solidFill>
               <a:tailEnd type="oval" w="sm" len="sm"/>
@@ -5853,12 +7116,22 @@
             <a:p>
               <a:r>
                 <a:rPr kumimoji="1" lang="en-US" altLang="zh-CN" sz="700" b="1" i="1" dirty="0">
+                  <a:ln w="3175">
+                    <a:noFill/>
+                  </a:ln>
                   <a:solidFill>
-                    <a:schemeClr val="accent5">
-                      <a:lumMod val="60000"/>
-                      <a:lumOff val="40000"/>
+                    <a:schemeClr val="tx2">
+                      <a:lumMod val="50000"/>
+                      <a:lumOff val="50000"/>
                     </a:schemeClr>
                   </a:solidFill>
+                  <a:effectLst>
+                    <a:outerShdw blurRad="139700" dist="38100" dir="5400000" algn="t" rotWithShape="0">
+                      <a:prstClr val="black">
+                        <a:alpha val="25000"/>
+                      </a:prstClr>
+                    </a:outerShdw>
+                  </a:effectLst>
                   <a:latin typeface="Maple Mono" panose="020F0509060000000000" pitchFamily="49" charset="0"/>
                   <a:ea typeface="Maple Mono" panose="020F0509060000000000" pitchFamily="49" charset="0"/>
                 </a:rPr>
@@ -5891,9 +7164,9 @@
             </a:prstGeom>
             <a:ln w="9525" cap="rnd">
               <a:solidFill>
-                <a:schemeClr val="accent5">
-                  <a:lumMod val="60000"/>
-                  <a:lumOff val="40000"/>
+                <a:schemeClr val="tx2">
+                  <a:lumMod val="50000"/>
+                  <a:lumOff val="50000"/>
                 </a:schemeClr>
               </a:solidFill>
               <a:tailEnd type="none" w="sm" len="sm"/>
@@ -5938,9 +7211,9 @@
             </a:prstGeom>
             <a:ln w="9525" cap="rnd">
               <a:solidFill>
-                <a:schemeClr val="accent5">
-                  <a:lumMod val="60000"/>
-                  <a:lumOff val="40000"/>
+                <a:schemeClr val="tx2">
+                  <a:lumMod val="50000"/>
+                  <a:lumOff val="50000"/>
                 </a:schemeClr>
               </a:solidFill>
               <a:tailEnd type="oval" w="sm" len="sm"/>
@@ -5985,9 +7258,9 @@
             </a:prstGeom>
             <a:ln w="9525" cap="rnd">
               <a:solidFill>
-                <a:schemeClr val="accent5">
-                  <a:lumMod val="60000"/>
-                  <a:lumOff val="40000"/>
+                <a:schemeClr val="tx2">
+                  <a:lumMod val="50000"/>
+                  <a:lumOff val="50000"/>
                 </a:schemeClr>
               </a:solidFill>
               <a:tailEnd type="none" w="sm" len="sm"/>
@@ -6038,24 +7311,44 @@
             <a:p>
               <a:r>
                 <a:rPr kumimoji="1" lang="en-US" altLang="zh-CN" sz="700" b="1" i="1" dirty="0">
+                  <a:ln w="3175">
+                    <a:noFill/>
+                  </a:ln>
                   <a:solidFill>
-                    <a:schemeClr val="accent5">
-                      <a:lumMod val="60000"/>
-                      <a:lumOff val="40000"/>
+                    <a:schemeClr val="tx2">
+                      <a:lumMod val="50000"/>
+                      <a:lumOff val="50000"/>
                     </a:schemeClr>
                   </a:solidFill>
+                  <a:effectLst>
+                    <a:outerShdw blurRad="139700" dist="38100" dir="5400000" algn="t" rotWithShape="0">
+                      <a:prstClr val="black">
+                        <a:alpha val="25000"/>
+                      </a:prstClr>
+                    </a:outerShdw>
+                  </a:effectLst>
                   <a:latin typeface="Maple Mono" panose="020F0509060000000000" pitchFamily="49" charset="0"/>
                   <a:ea typeface="Maple Mono" panose="020F0509060000000000" pitchFamily="49" charset="0"/>
                 </a:rPr>
                 <a:t>Display Stata Output </a:t>
               </a:r>
               <a:endParaRPr kumimoji="1" lang="zh-CN" altLang="en-US" sz="700" b="1" i="1" dirty="0">
+                <a:ln w="3175">
+                  <a:noFill/>
+                </a:ln>
                 <a:solidFill>
-                  <a:schemeClr val="accent5">
-                    <a:lumMod val="60000"/>
-                    <a:lumOff val="40000"/>
+                  <a:schemeClr val="tx2">
+                    <a:lumMod val="50000"/>
+                    <a:lumOff val="50000"/>
                   </a:schemeClr>
                 </a:solidFill>
+                <a:effectLst>
+                  <a:outerShdw blurRad="139700" dist="38100" dir="5400000" algn="t" rotWithShape="0">
+                    <a:prstClr val="black">
+                      <a:alpha val="25000"/>
+                    </a:prstClr>
+                  </a:outerShdw>
+                </a:effectLst>
                 <a:latin typeface="Maple Mono" panose="020F0509060000000000" pitchFamily="49" charset="0"/>
               </a:endParaRPr>
             </a:p>
@@ -6085,9 +7378,9 @@
             </a:prstGeom>
             <a:ln w="9525" cap="rnd">
               <a:solidFill>
-                <a:schemeClr val="accent5">
-                  <a:lumMod val="60000"/>
-                  <a:lumOff val="40000"/>
+                <a:schemeClr val="tx2">
+                  <a:lumMod val="50000"/>
+                  <a:lumOff val="50000"/>
                 </a:schemeClr>
               </a:solidFill>
               <a:tailEnd type="oval" w="sm" len="sm"/>
@@ -6132,9 +7425,9 @@
             </a:prstGeom>
             <a:ln w="9525">
               <a:solidFill>
-                <a:schemeClr val="accent5">
-                  <a:lumMod val="60000"/>
-                  <a:lumOff val="40000"/>
+                <a:schemeClr val="tx2">
+                  <a:lumMod val="50000"/>
+                  <a:lumOff val="50000"/>
                 </a:schemeClr>
               </a:solidFill>
               <a:tailEnd type="none" w="sm" len="sm"/>
@@ -6186,24 +7479,44 @@
               <a:pPr algn="r"/>
               <a:r>
                 <a:rPr kumimoji="1" lang="en-US" altLang="zh-CN" sz="700" b="1" i="1" dirty="0">
+                  <a:ln w="3175">
+                    <a:noFill/>
+                  </a:ln>
                   <a:solidFill>
-                    <a:schemeClr val="accent5">
-                      <a:lumMod val="60000"/>
-                      <a:lumOff val="40000"/>
+                    <a:schemeClr val="tx2">
+                      <a:lumMod val="50000"/>
+                      <a:lumOff val="50000"/>
                     </a:schemeClr>
                   </a:solidFill>
+                  <a:effectLst>
+                    <a:outerShdw blurRad="139700" dist="38100" dir="5400000" algn="t" rotWithShape="0">
+                      <a:prstClr val="black">
+                        <a:alpha val="25000"/>
+                      </a:prstClr>
+                    </a:outerShdw>
+                  </a:effectLst>
                   <a:latin typeface="Maple Mono" panose="020F0509060000000000" pitchFamily="49" charset="0"/>
                   <a:ea typeface="Maple Mono" panose="020F0509060000000000" pitchFamily="49" charset="0"/>
                 </a:rPr>
                 <a:t>Graph Output </a:t>
               </a:r>
               <a:endParaRPr kumimoji="1" lang="zh-CN" altLang="en-US" sz="700" b="1" i="1" dirty="0">
+                <a:ln w="3175">
+                  <a:noFill/>
+                </a:ln>
                 <a:solidFill>
-                  <a:schemeClr val="accent5">
-                    <a:lumMod val="60000"/>
-                    <a:lumOff val="40000"/>
+                  <a:schemeClr val="tx2">
+                    <a:lumMod val="50000"/>
+                    <a:lumOff val="50000"/>
                   </a:schemeClr>
                 </a:solidFill>
+                <a:effectLst>
+                  <a:outerShdw blurRad="139700" dist="38100" dir="5400000" algn="t" rotWithShape="0">
+                    <a:prstClr val="black">
+                      <a:alpha val="25000"/>
+                    </a:prstClr>
+                  </a:outerShdw>
+                </a:effectLst>
                 <a:latin typeface="Maple Mono" panose="020F0509060000000000" pitchFamily="49" charset="0"/>
               </a:endParaRPr>
             </a:p>
@@ -6233,9 +7546,9 @@
             </a:prstGeom>
             <a:ln w="9525" cap="rnd">
               <a:solidFill>
-                <a:schemeClr val="accent5">
-                  <a:lumMod val="60000"/>
-                  <a:lumOff val="40000"/>
+                <a:schemeClr val="tx2">
+                  <a:lumMod val="50000"/>
+                  <a:lumOff val="50000"/>
                 </a:schemeClr>
               </a:solidFill>
               <a:tailEnd type="oval" w="sm" len="sm"/>
@@ -6280,9 +7593,9 @@
             </a:prstGeom>
             <a:ln w="9525">
               <a:solidFill>
-                <a:schemeClr val="accent5">
-                  <a:lumMod val="60000"/>
-                  <a:lumOff val="40000"/>
+                <a:schemeClr val="tx2">
+                  <a:lumMod val="50000"/>
+                  <a:lumOff val="50000"/>
                 </a:schemeClr>
               </a:solidFill>
               <a:tailEnd type="none" w="sm" len="sm"/>
@@ -6334,12 +7647,22 @@
               <a:pPr algn="r"/>
               <a:r>
                 <a:rPr kumimoji="1" lang="en-US" altLang="zh-CN" sz="700" b="1" i="1" dirty="0">
+                  <a:ln w="3175">
+                    <a:noFill/>
+                  </a:ln>
                   <a:solidFill>
-                    <a:schemeClr val="accent5">
-                      <a:lumMod val="60000"/>
-                      <a:lumOff val="40000"/>
+                    <a:schemeClr val="tx2">
+                      <a:lumMod val="50000"/>
+                      <a:lumOff val="50000"/>
                     </a:schemeClr>
                   </a:solidFill>
+                  <a:effectLst>
+                    <a:outerShdw blurRad="139700" dist="38100" dir="5400000" algn="t" rotWithShape="0">
+                      <a:prstClr val="black">
+                        <a:alpha val="25000"/>
+                      </a:prstClr>
+                    </a:outerShdw>
+                  </a:effectLst>
                   <a:latin typeface="Maple Mono" panose="020F0509060000000000" pitchFamily="49" charset="0"/>
                   <a:ea typeface="Maple Mono" panose="020F0509060000000000" pitchFamily="49" charset="0"/>
                 </a:rPr>
@@ -6347,12 +7670,22 @@
               </a:r>
               <a:r>
                 <a:rPr kumimoji="1" lang="zh-CN" altLang="en-US" sz="700" b="1" i="1" dirty="0">
+                  <a:ln w="3175">
+                    <a:noFill/>
+                  </a:ln>
                   <a:solidFill>
-                    <a:schemeClr val="accent5">
-                      <a:lumMod val="60000"/>
-                      <a:lumOff val="40000"/>
+                    <a:schemeClr val="tx2">
+                      <a:lumMod val="50000"/>
+                      <a:lumOff val="50000"/>
                     </a:schemeClr>
                   </a:solidFill>
+                  <a:effectLst>
+                    <a:outerShdw blurRad="139700" dist="38100" dir="5400000" algn="t" rotWithShape="0">
+                      <a:prstClr val="black">
+                        <a:alpha val="25000"/>
+                      </a:prstClr>
+                    </a:outerShdw>
+                  </a:effectLst>
                   <a:latin typeface="Maple Mono" panose="020F0509060000000000" pitchFamily="49" charset="0"/>
                   <a:ea typeface="Maple Mono" panose="020F0509060000000000" pitchFamily="49" charset="0"/>
                 </a:rPr>
@@ -6360,24 +7693,44 @@
               </a:r>
               <a:r>
                 <a:rPr kumimoji="1" lang="en-US" altLang="zh-CN" sz="700" b="1" i="1" dirty="0">
+                  <a:ln w="3175">
+                    <a:noFill/>
+                  </a:ln>
                   <a:solidFill>
-                    <a:schemeClr val="accent5">
-                      <a:lumMod val="60000"/>
-                      <a:lumOff val="40000"/>
+                    <a:schemeClr val="tx2">
+                      <a:lumMod val="50000"/>
+                      <a:lumOff val="50000"/>
                     </a:schemeClr>
                   </a:solidFill>
+                  <a:effectLst>
+                    <a:outerShdw blurRad="139700" dist="38100" dir="5400000" algn="t" rotWithShape="0">
+                      <a:prstClr val="black">
+                        <a:alpha val="25000"/>
+                      </a:prstClr>
+                    </a:outerShdw>
+                  </a:effectLst>
                   <a:latin typeface="Maple Mono" panose="020F0509060000000000" pitchFamily="49" charset="0"/>
                   <a:ea typeface="Maple Mono" panose="020F0509060000000000" pitchFamily="49" charset="0"/>
                 </a:rPr>
                 <a:t>Line</a:t>
               </a:r>
               <a:endParaRPr kumimoji="1" lang="zh-CN" altLang="en-US" sz="700" b="1" i="1" dirty="0">
+                <a:ln w="3175">
+                  <a:noFill/>
+                </a:ln>
                 <a:solidFill>
-                  <a:schemeClr val="accent5">
-                    <a:lumMod val="60000"/>
-                    <a:lumOff val="40000"/>
+                  <a:schemeClr val="tx2">
+                    <a:lumMod val="50000"/>
+                    <a:lumOff val="50000"/>
                   </a:schemeClr>
                 </a:solidFill>
+                <a:effectLst>
+                  <a:outerShdw blurRad="139700" dist="38100" dir="5400000" algn="t" rotWithShape="0">
+                    <a:prstClr val="black">
+                      <a:alpha val="25000"/>
+                    </a:prstClr>
+                  </a:outerShdw>
+                </a:effectLst>
                 <a:latin typeface="Maple Mono" panose="020F0509060000000000" pitchFamily="49" charset="0"/>
               </a:endParaRPr>
             </a:p>
@@ -6422,10 +7775,10 @@
       </p:grpSpPr>
       <p:grpSp>
         <p:nvGrpSpPr>
-          <p:cNvPr id="18" name="组合 17">
+          <p:cNvPr id="2" name="组合 1">
             <a:extLst>
               <a:ext uri="{FF2B5EF4-FFF2-40B4-BE49-F238E27FC236}">
-                <a16:creationId xmlns:a16="http://schemas.microsoft.com/office/drawing/2014/main" id="{28D3F674-27C4-7D4A-713E-A80541FCABCC}"/>
+                <a16:creationId xmlns:a16="http://schemas.microsoft.com/office/drawing/2014/main" id="{D8674E0B-B4DE-1DF2-1A30-0462D7B6FFF7}"/>
               </a:ext>
             </a:extLst>
           </p:cNvPr>
@@ -6489,6 +7842,12 @@
             <a:p>
               <a:pPr algn="ctr"/>
               <a:endParaRPr kumimoji="1" lang="zh-CN" altLang="en-US" b="1">
+                <a:solidFill>
+                  <a:schemeClr val="tx2">
+                    <a:lumMod val="50000"/>
+                    <a:lumOff val="50000"/>
+                  </a:schemeClr>
+                </a:solidFill>
                 <a:latin typeface="Maple Mono NF CN" panose="020F0509060000000000" pitchFamily="49" charset="-128"/>
                 <a:ea typeface="Maple Mono NF CN" panose="020F0509060000000000" pitchFamily="49" charset="-128"/>
               </a:endParaRPr>
@@ -6674,9 +8033,9 @@
             </a:prstGeom>
             <a:ln w="9525">
               <a:solidFill>
-                <a:schemeClr val="accent5">
-                  <a:lumMod val="60000"/>
-                  <a:lumOff val="40000"/>
+                <a:schemeClr val="tx2">
+                  <a:lumMod val="50000"/>
+                  <a:lumOff val="50000"/>
                 </a:schemeClr>
               </a:solidFill>
               <a:tailEnd type="oval" w="sm" len="sm"/>
@@ -6728,11 +8087,18 @@
               <a:r>
                 <a:rPr kumimoji="1" lang="zh-CN" altLang="en-US" sz="700" b="1" dirty="0">
                   <a:solidFill>
-                    <a:schemeClr val="accent5">
-                      <a:lumMod val="60000"/>
-                      <a:lumOff val="40000"/>
+                    <a:schemeClr val="tx2">
+                      <a:lumMod val="50000"/>
+                      <a:lumOff val="50000"/>
                     </a:schemeClr>
                   </a:solidFill>
+                  <a:effectLst>
+                    <a:outerShdw blurRad="187198" dist="38100" dir="5400000" sx="99744" sy="99744" algn="t" rotWithShape="0">
+                      <a:prstClr val="black">
+                        <a:alpha val="40000"/>
+                      </a:prstClr>
+                    </a:outerShdw>
+                  </a:effectLst>
                   <a:latin typeface="Maple Mono NF CN" panose="020F0509060000000000" pitchFamily="49" charset="-128"/>
                   <a:ea typeface="Maple Mono NF CN" panose="020F0509060000000000" pitchFamily="49" charset="-128"/>
                 </a:rPr>
@@ -6765,9 +8131,9 @@
             </a:prstGeom>
             <a:ln w="9525">
               <a:solidFill>
-                <a:schemeClr val="accent5">
-                  <a:lumMod val="60000"/>
-                  <a:lumOff val="40000"/>
+                <a:schemeClr val="tx2">
+                  <a:lumMod val="50000"/>
+                  <a:lumOff val="50000"/>
                 </a:schemeClr>
               </a:solidFill>
               <a:tailEnd type="oval" w="sm" len="sm"/>
@@ -6812,9 +8178,9 @@
             </a:prstGeom>
             <a:ln w="9525">
               <a:solidFill>
-                <a:schemeClr val="accent5">
-                  <a:lumMod val="60000"/>
-                  <a:lumOff val="40000"/>
+                <a:schemeClr val="tx2">
+                  <a:lumMod val="50000"/>
+                  <a:lumOff val="50000"/>
                 </a:schemeClr>
               </a:solidFill>
               <a:tailEnd type="none" w="sm" len="sm"/>
@@ -6866,11 +8232,18 @@
               <a:r>
                 <a:rPr kumimoji="1" lang="zh-CN" altLang="en-US" sz="700" b="1" dirty="0">
                   <a:solidFill>
-                    <a:schemeClr val="accent5">
-                      <a:lumMod val="60000"/>
-                      <a:lumOff val="40000"/>
+                    <a:schemeClr val="tx2">
+                      <a:lumMod val="50000"/>
+                      <a:lumOff val="50000"/>
                     </a:schemeClr>
                   </a:solidFill>
+                  <a:effectLst>
+                    <a:outerShdw blurRad="187198" dist="38100" dir="5400000" sx="99744" sy="99744" algn="t" rotWithShape="0">
+                      <a:prstClr val="black">
+                        <a:alpha val="40000"/>
+                      </a:prstClr>
+                    </a:outerShdw>
+                  </a:effectLst>
                   <a:latin typeface="Maple Mono NF CN" panose="020F0509060000000000" pitchFamily="49" charset="-128"/>
                   <a:ea typeface="Maple Mono NF CN" panose="020F0509060000000000" pitchFamily="49" charset="-128"/>
                 </a:rPr>
@@ -6903,9 +8276,9 @@
             </a:prstGeom>
             <a:ln w="9525" cap="rnd">
               <a:solidFill>
-                <a:schemeClr val="accent5">
-                  <a:lumMod val="60000"/>
-                  <a:lumOff val="40000"/>
+                <a:schemeClr val="tx2">
+                  <a:lumMod val="50000"/>
+                  <a:lumOff val="50000"/>
                 </a:schemeClr>
               </a:solidFill>
               <a:tailEnd type="none" w="sm" len="sm"/>
@@ -6950,9 +8323,9 @@
             </a:prstGeom>
             <a:ln w="9525" cap="rnd">
               <a:solidFill>
-                <a:schemeClr val="accent5">
-                  <a:lumMod val="60000"/>
-                  <a:lumOff val="40000"/>
+                <a:schemeClr val="tx2">
+                  <a:lumMod val="50000"/>
+                  <a:lumOff val="50000"/>
                 </a:schemeClr>
               </a:solidFill>
               <a:tailEnd type="oval" w="sm" len="sm"/>
@@ -7004,11 +8377,18 @@
               <a:r>
                 <a:rPr kumimoji="1" lang="zh-CN" altLang="en-US" sz="700" b="1" dirty="0">
                   <a:solidFill>
-                    <a:schemeClr val="accent5">
-                      <a:lumMod val="60000"/>
-                      <a:lumOff val="40000"/>
+                    <a:schemeClr val="tx2">
+                      <a:lumMod val="50000"/>
+                      <a:lumOff val="50000"/>
                     </a:schemeClr>
                   </a:solidFill>
+                  <a:effectLst>
+                    <a:outerShdw blurRad="187198" dist="38100" dir="5400000" sx="99744" sy="99744" algn="t" rotWithShape="0">
+                      <a:prstClr val="black">
+                        <a:alpha val="40000"/>
+                      </a:prstClr>
+                    </a:outerShdw>
+                  </a:effectLst>
                   <a:latin typeface="Maple Mono NF CN" panose="020F0509060000000000" pitchFamily="49" charset="-128"/>
                   <a:ea typeface="Maple Mono NF CN" panose="020F0509060000000000" pitchFamily="49" charset="-128"/>
                 </a:rPr>
@@ -7041,9 +8421,9 @@
             </a:prstGeom>
             <a:ln w="9525">
               <a:solidFill>
-                <a:schemeClr val="accent5">
-                  <a:lumMod val="60000"/>
-                  <a:lumOff val="40000"/>
+                <a:schemeClr val="tx2">
+                  <a:lumMod val="50000"/>
+                  <a:lumOff val="50000"/>
                 </a:schemeClr>
               </a:solidFill>
               <a:tailEnd type="oval" w="sm" len="sm"/>
@@ -7095,11 +8475,18 @@
               <a:r>
                 <a:rPr kumimoji="1" lang="zh-CN" altLang="en-US" sz="700" b="1" dirty="0">
                   <a:solidFill>
-                    <a:schemeClr val="accent5">
-                      <a:lumMod val="60000"/>
-                      <a:lumOff val="40000"/>
+                    <a:schemeClr val="tx2">
+                      <a:lumMod val="50000"/>
+                      <a:lumOff val="50000"/>
                     </a:schemeClr>
                   </a:solidFill>
+                  <a:effectLst>
+                    <a:outerShdw blurRad="187198" dist="38100" dir="5400000" sx="99744" sy="99744" algn="t" rotWithShape="0">
+                      <a:prstClr val="black">
+                        <a:alpha val="40000"/>
+                      </a:prstClr>
+                    </a:outerShdw>
+                  </a:effectLst>
                   <a:latin typeface="Maple Mono NF CN" panose="020F0509060000000000" pitchFamily="49" charset="-128"/>
                   <a:ea typeface="Maple Mono NF CN" panose="020F0509060000000000" pitchFamily="49" charset="-128"/>
                 </a:rPr>
@@ -7107,11 +8494,18 @@
               </a:r>
               <a:endParaRPr kumimoji="1" lang="en-US" altLang="zh-CN" sz="700" b="1" dirty="0">
                 <a:solidFill>
-                  <a:schemeClr val="accent5">
-                    <a:lumMod val="60000"/>
-                    <a:lumOff val="40000"/>
+                  <a:schemeClr val="tx2">
+                    <a:lumMod val="50000"/>
+                    <a:lumOff val="50000"/>
                   </a:schemeClr>
                 </a:solidFill>
+                <a:effectLst>
+                  <a:outerShdw blurRad="187198" dist="38100" dir="5400000" sx="99744" sy="99744" algn="t" rotWithShape="0">
+                    <a:prstClr val="black">
+                      <a:alpha val="40000"/>
+                    </a:prstClr>
+                  </a:outerShdw>
+                </a:effectLst>
                 <a:latin typeface="Maple Mono NF CN" panose="020F0509060000000000" pitchFamily="49" charset="-128"/>
                 <a:ea typeface="Maple Mono NF CN" panose="020F0509060000000000" pitchFamily="49" charset="-128"/>
               </a:endParaRPr>
@@ -7120,11 +8514,18 @@
               <a:r>
                 <a:rPr kumimoji="1" lang="zh-CN" altLang="en-US" sz="700" b="1" dirty="0">
                   <a:solidFill>
-                    <a:schemeClr val="accent5">
-                      <a:lumMod val="60000"/>
-                      <a:lumOff val="40000"/>
+                    <a:schemeClr val="tx2">
+                      <a:lumMod val="50000"/>
+                      <a:lumOff val="50000"/>
                     </a:schemeClr>
                   </a:solidFill>
+                  <a:effectLst>
+                    <a:outerShdw blurRad="187198" dist="38100" dir="5400000" sx="99744" sy="99744" algn="t" rotWithShape="0">
+                      <a:prstClr val="black">
+                        <a:alpha val="40000"/>
+                      </a:prstClr>
+                    </a:outerShdw>
+                  </a:effectLst>
                   <a:latin typeface="Maple Mono NF CN" panose="020F0509060000000000" pitchFamily="49" charset="-128"/>
                   <a:ea typeface="Maple Mono NF CN" panose="020F0509060000000000" pitchFamily="49" charset="-128"/>
                 </a:rPr>
@@ -7133,11 +8534,18 @@
               <a:r>
                 <a:rPr kumimoji="1" lang="en-US" altLang="zh-CN" sz="700" b="1" dirty="0">
                   <a:solidFill>
-                    <a:schemeClr val="accent5">
-                      <a:lumMod val="60000"/>
-                      <a:lumOff val="40000"/>
+                    <a:schemeClr val="tx2">
+                      <a:lumMod val="50000"/>
+                      <a:lumOff val="50000"/>
                     </a:schemeClr>
                   </a:solidFill>
+                  <a:effectLst>
+                    <a:outerShdw blurRad="187198" dist="38100" dir="5400000" sx="99744" sy="99744" algn="t" rotWithShape="0">
+                      <a:prstClr val="black">
+                        <a:alpha val="40000"/>
+                      </a:prstClr>
+                    </a:outerShdw>
+                  </a:effectLst>
                   <a:latin typeface="Maple Mono NF CN" panose="020F0509060000000000" pitchFamily="49" charset="-128"/>
                   <a:ea typeface="Maple Mono NF CN" panose="020F0509060000000000" pitchFamily="49" charset="-128"/>
                 </a:rPr>
@@ -7146,11 +8554,18 @@
               <a:r>
                 <a:rPr kumimoji="1" lang="en" altLang="zh-CN" sz="700" b="1" dirty="0" err="1">
                   <a:solidFill>
-                    <a:schemeClr val="accent5">
-                      <a:lumMod val="60000"/>
-                      <a:lumOff val="40000"/>
+                    <a:schemeClr val="tx2">
+                      <a:lumMod val="50000"/>
+                      <a:lumOff val="50000"/>
                     </a:schemeClr>
                   </a:solidFill>
+                  <a:effectLst>
+                    <a:outerShdw blurRad="187198" dist="38100" dir="5400000" sx="99744" sy="99744" algn="t" rotWithShape="0">
+                      <a:prstClr val="black">
+                        <a:alpha val="40000"/>
+                      </a:prstClr>
+                    </a:outerShdw>
+                  </a:effectLst>
                   <a:latin typeface="Maple Mono NF CN" panose="020F0509060000000000" pitchFamily="49" charset="-128"/>
                   <a:ea typeface="Maple Mono NF CN" panose="020F0509060000000000" pitchFamily="49" charset="-128"/>
                 </a:rPr>
@@ -7159,11 +8574,18 @@
               <a:r>
                 <a:rPr kumimoji="1" lang="en-US" altLang="zh-CN" sz="700" b="1" dirty="0">
                   <a:solidFill>
-                    <a:schemeClr val="accent5">
-                      <a:lumMod val="60000"/>
-                      <a:lumOff val="40000"/>
+                    <a:schemeClr val="tx2">
+                      <a:lumMod val="50000"/>
+                      <a:lumOff val="50000"/>
                     </a:schemeClr>
                   </a:solidFill>
+                  <a:effectLst>
+                    <a:outerShdw blurRad="187198" dist="38100" dir="5400000" sx="99744" sy="99744" algn="t" rotWithShape="0">
+                      <a:prstClr val="black">
+                        <a:alpha val="40000"/>
+                      </a:prstClr>
+                    </a:outerShdw>
+                  </a:effectLst>
                   <a:latin typeface="Maple Mono NF CN" panose="020F0509060000000000" pitchFamily="49" charset="-128"/>
                   <a:ea typeface="Maple Mono NF CN" panose="020F0509060000000000" pitchFamily="49" charset="-128"/>
                 </a:rPr>
@@ -7172,11 +8594,18 @@
               <a:r>
                 <a:rPr kumimoji="1" lang="zh-CN" altLang="en-US" sz="700" b="1" dirty="0">
                   <a:solidFill>
-                    <a:schemeClr val="accent5">
-                      <a:lumMod val="60000"/>
-                      <a:lumOff val="40000"/>
+                    <a:schemeClr val="tx2">
+                      <a:lumMod val="50000"/>
+                      <a:lumOff val="50000"/>
                     </a:schemeClr>
                   </a:solidFill>
+                  <a:effectLst>
+                    <a:outerShdw blurRad="187198" dist="38100" dir="5400000" sx="99744" sy="99744" algn="t" rotWithShape="0">
+                      <a:prstClr val="black">
+                        <a:alpha val="40000"/>
+                      </a:prstClr>
+                    </a:outerShdw>
+                  </a:effectLst>
                   <a:latin typeface="Maple Mono NF CN" panose="020F0509060000000000" pitchFamily="49" charset="-128"/>
                   <a:ea typeface="Maple Mono NF CN" panose="020F0509060000000000" pitchFamily="49" charset="-128"/>
                 </a:rPr>
@@ -7209,9 +8638,9 @@
             </a:prstGeom>
             <a:ln w="9525" cap="rnd">
               <a:solidFill>
-                <a:schemeClr val="accent5">
-                  <a:lumMod val="60000"/>
-                  <a:lumOff val="40000"/>
+                <a:schemeClr val="tx2">
+                  <a:lumMod val="50000"/>
+                  <a:lumOff val="50000"/>
                 </a:schemeClr>
               </a:solidFill>
               <a:tailEnd type="none" w="sm" len="sm"/>
@@ -7256,9 +8685,9 @@
             </a:prstGeom>
             <a:ln w="9525" cap="rnd">
               <a:solidFill>
-                <a:schemeClr val="accent5">
-                  <a:lumMod val="60000"/>
-                  <a:lumOff val="40000"/>
+                <a:schemeClr val="tx2">
+                  <a:lumMod val="50000"/>
+                  <a:lumOff val="50000"/>
                 </a:schemeClr>
               </a:solidFill>
               <a:tailEnd type="oval" w="sm" len="sm"/>
@@ -7310,11 +8739,18 @@
               <a:r>
                 <a:rPr kumimoji="1" lang="zh-CN" altLang="en-US" sz="700" b="1" dirty="0">
                   <a:solidFill>
-                    <a:schemeClr val="accent5">
-                      <a:lumMod val="60000"/>
-                      <a:lumOff val="40000"/>
+                    <a:schemeClr val="tx2">
+                      <a:lumMod val="50000"/>
+                      <a:lumOff val="50000"/>
                     </a:schemeClr>
                   </a:solidFill>
+                  <a:effectLst>
+                    <a:outerShdw blurRad="187198" dist="38100" dir="5400000" sx="99744" sy="99744" algn="t" rotWithShape="0">
+                      <a:prstClr val="black">
+                        <a:alpha val="40000"/>
+                      </a:prstClr>
+                    </a:outerShdw>
+                  </a:effectLst>
                   <a:latin typeface="Maple Mono NF CN" panose="020F0509060000000000" pitchFamily="49" charset="-128"/>
                   <a:ea typeface="Maple Mono NF CN" panose="020F0509060000000000" pitchFamily="49" charset="-128"/>
                 </a:rPr>
@@ -7443,9 +8879,9 @@
             </a:custGeom>
             <a:ln>
               <a:solidFill>
-                <a:schemeClr val="accent5">
-                  <a:lumMod val="20000"/>
-                  <a:lumOff val="80000"/>
+                <a:schemeClr val="tx2">
+                  <a:lumMod val="50000"/>
+                  <a:lumOff val="50000"/>
                 </a:schemeClr>
               </a:solidFill>
             </a:ln>
@@ -7482,9 +8918,9 @@
             </a:prstGeom>
             <a:ln w="9525">
               <a:solidFill>
-                <a:schemeClr val="accent5">
-                  <a:lumMod val="60000"/>
-                  <a:lumOff val="40000"/>
+                <a:schemeClr val="tx2">
+                  <a:lumMod val="50000"/>
+                  <a:lumOff val="50000"/>
                 </a:schemeClr>
               </a:solidFill>
               <a:tailEnd type="oval" w="sm" len="sm"/>
@@ -7529,9 +8965,9 @@
             </a:prstGeom>
             <a:ln w="9525">
               <a:solidFill>
-                <a:schemeClr val="accent5">
-                  <a:lumMod val="60000"/>
-                  <a:lumOff val="40000"/>
+                <a:schemeClr val="tx2">
+                  <a:lumMod val="50000"/>
+                  <a:lumOff val="50000"/>
                 </a:schemeClr>
               </a:solidFill>
               <a:headEnd type="oval" w="sm" len="sm"/>
@@ -7584,11 +9020,18 @@
               <a:r>
                 <a:rPr kumimoji="1" lang="zh-CN" altLang="en" sz="700" b="1" dirty="0">
                   <a:solidFill>
-                    <a:schemeClr val="accent5">
-                      <a:lumMod val="60000"/>
-                      <a:lumOff val="40000"/>
+                    <a:schemeClr val="tx2">
+                      <a:lumMod val="50000"/>
+                      <a:lumOff val="50000"/>
                     </a:schemeClr>
                   </a:solidFill>
+                  <a:effectLst>
+                    <a:outerShdw blurRad="187198" dist="38100" dir="5400000" sx="99744" sy="99744" algn="t" rotWithShape="0">
+                      <a:prstClr val="black">
+                        <a:alpha val="40000"/>
+                      </a:prstClr>
+                    </a:outerShdw>
+                  </a:effectLst>
                   <a:latin typeface="Maple Mono NF CN" panose="020F0509060000000000" pitchFamily="49" charset="-128"/>
                   <a:ea typeface="Maple Mono NF CN" panose="020F0509060000000000" pitchFamily="49" charset="-128"/>
                 </a:rPr>
@@ -7597,11 +9040,18 @@
               <a:r>
                 <a:rPr kumimoji="1" lang="zh-CN" altLang="en-US" sz="700" b="1" dirty="0">
                   <a:solidFill>
-                    <a:schemeClr val="accent5">
-                      <a:lumMod val="60000"/>
-                      <a:lumOff val="40000"/>
+                    <a:schemeClr val="tx2">
+                      <a:lumMod val="50000"/>
+                      <a:lumOff val="50000"/>
                     </a:schemeClr>
                   </a:solidFill>
+                  <a:effectLst>
+                    <a:outerShdw blurRad="187198" dist="38100" dir="5400000" sx="99744" sy="99744" algn="t" rotWithShape="0">
+                      <a:prstClr val="black">
+                        <a:alpha val="40000"/>
+                      </a:prstClr>
+                    </a:outerShdw>
+                  </a:effectLst>
                   <a:latin typeface="Maple Mono NF CN" panose="020F0509060000000000" pitchFamily="49" charset="-128"/>
                   <a:ea typeface="Maple Mono NF CN" panose="020F0509060000000000" pitchFamily="49" charset="-128"/>
                 </a:rPr>
@@ -7609,11 +9059,18 @@
               </a:r>
               <a:endParaRPr kumimoji="1" lang="en" altLang="zh-CN" sz="700" b="1" dirty="0">
                 <a:solidFill>
-                  <a:schemeClr val="accent5">
-                    <a:lumMod val="60000"/>
-                    <a:lumOff val="40000"/>
+                  <a:schemeClr val="tx2">
+                    <a:lumMod val="50000"/>
+                    <a:lumOff val="50000"/>
                   </a:schemeClr>
                 </a:solidFill>
+                <a:effectLst>
+                  <a:outerShdw blurRad="187198" dist="38100" dir="5400000" sx="99744" sy="99744" algn="t" rotWithShape="0">
+                    <a:prstClr val="black">
+                      <a:alpha val="40000"/>
+                    </a:prstClr>
+                  </a:outerShdw>
+                </a:effectLst>
                 <a:latin typeface="Maple Mono NF CN" panose="020F0509060000000000" pitchFamily="49" charset="-128"/>
                 <a:ea typeface="Maple Mono NF CN" panose="020F0509060000000000" pitchFamily="49" charset="-128"/>
               </a:endParaRPr>
@@ -7644,9 +9101,9 @@
             </a:prstGeom>
             <a:ln w="9525" cap="rnd">
               <a:solidFill>
-                <a:schemeClr val="accent5">
-                  <a:lumMod val="60000"/>
-                  <a:lumOff val="40000"/>
+                <a:schemeClr val="tx2">
+                  <a:lumMod val="50000"/>
+                  <a:lumOff val="50000"/>
                 </a:schemeClr>
               </a:solidFill>
               <a:tailEnd type="oval" w="sm" len="sm"/>
@@ -7698,11 +9155,18 @@
               <a:r>
                 <a:rPr kumimoji="1" lang="zh-CN" altLang="en-US" sz="700" b="1" dirty="0">
                   <a:solidFill>
-                    <a:schemeClr val="accent5">
-                      <a:lumMod val="60000"/>
-                      <a:lumOff val="40000"/>
+                    <a:schemeClr val="tx2">
+                      <a:lumMod val="50000"/>
+                      <a:lumOff val="50000"/>
                     </a:schemeClr>
                   </a:solidFill>
+                  <a:effectLst>
+                    <a:outerShdw blurRad="187198" dist="38100" dir="5400000" sx="99744" sy="99744" algn="t" rotWithShape="0">
+                      <a:prstClr val="black">
+                        <a:alpha val="40000"/>
+                      </a:prstClr>
+                    </a:outerShdw>
+                  </a:effectLst>
                   <a:latin typeface="Maple Mono NF CN" panose="020F0509060000000000" pitchFamily="49" charset="-128"/>
                   <a:ea typeface="Maple Mono NF CN" panose="020F0509060000000000" pitchFamily="49" charset="-128"/>
                 </a:rPr>
@@ -7735,9 +9199,9 @@
             </a:prstGeom>
             <a:ln w="9525" cap="rnd">
               <a:solidFill>
-                <a:schemeClr val="accent5">
-                  <a:lumMod val="60000"/>
-                  <a:lumOff val="40000"/>
+                <a:schemeClr val="tx2">
+                  <a:lumMod val="50000"/>
+                  <a:lumOff val="50000"/>
                 </a:schemeClr>
               </a:solidFill>
               <a:tailEnd type="none" w="sm" len="sm"/>
@@ -7782,9 +9246,9 @@
             </a:prstGeom>
             <a:ln w="9525" cap="rnd">
               <a:solidFill>
-                <a:schemeClr val="accent5">
-                  <a:lumMod val="60000"/>
-                  <a:lumOff val="40000"/>
+                <a:schemeClr val="tx2">
+                  <a:lumMod val="50000"/>
+                  <a:lumOff val="50000"/>
                 </a:schemeClr>
               </a:solidFill>
               <a:tailEnd type="oval" w="sm" len="sm"/>
@@ -7836,11 +9300,18 @@
               <a:r>
                 <a:rPr kumimoji="1" lang="zh-CN" altLang="en-US" sz="700" b="1" dirty="0">
                   <a:solidFill>
-                    <a:schemeClr val="accent5">
-                      <a:lumMod val="60000"/>
-                      <a:lumOff val="40000"/>
+                    <a:schemeClr val="tx2">
+                      <a:lumMod val="50000"/>
+                      <a:lumOff val="50000"/>
                     </a:schemeClr>
                   </a:solidFill>
+                  <a:effectLst>
+                    <a:outerShdw blurRad="187198" dist="38100" dir="5400000" sx="99744" sy="99744" algn="t" rotWithShape="0">
+                      <a:prstClr val="black">
+                        <a:alpha val="40000"/>
+                      </a:prstClr>
+                    </a:outerShdw>
+                  </a:effectLst>
                   <a:latin typeface="Maple Mono NF CN" panose="020F0509060000000000" pitchFamily="49" charset="-128"/>
                   <a:ea typeface="Maple Mono NF CN" panose="020F0509060000000000" pitchFamily="49" charset="-128"/>
                 </a:rPr>
@@ -7873,9 +9344,9 @@
             </a:prstGeom>
             <a:ln w="9525" cap="rnd">
               <a:solidFill>
-                <a:schemeClr val="accent5">
-                  <a:lumMod val="60000"/>
-                  <a:lumOff val="40000"/>
+                <a:schemeClr val="tx2">
+                  <a:lumMod val="50000"/>
+                  <a:lumOff val="50000"/>
                 </a:schemeClr>
               </a:solidFill>
               <a:tailEnd type="none" w="sm" len="sm"/>
@@ -8057,9 +9528,9 @@
             </a:prstGeom>
             <a:ln w="9525">
               <a:solidFill>
-                <a:schemeClr val="accent5">
-                  <a:lumMod val="60000"/>
-                  <a:lumOff val="40000"/>
+                <a:schemeClr val="tx2">
+                  <a:lumMod val="50000"/>
+                  <a:lumOff val="50000"/>
                 </a:schemeClr>
               </a:solidFill>
               <a:tailEnd type="oval" w="sm" len="sm"/>
@@ -8112,11 +9583,18 @@
               <a:r>
                 <a:rPr kumimoji="1" lang="zh-CN" altLang="en-US" sz="700" b="1" dirty="0">
                   <a:solidFill>
-                    <a:schemeClr val="accent5">
-                      <a:lumMod val="60000"/>
-                      <a:lumOff val="40000"/>
+                    <a:schemeClr val="tx2">
+                      <a:lumMod val="50000"/>
+                      <a:lumOff val="50000"/>
                     </a:schemeClr>
                   </a:solidFill>
+                  <a:effectLst>
+                    <a:outerShdw blurRad="187198" dist="38100" dir="5400000" sx="99744" sy="99744" algn="t" rotWithShape="0">
+                      <a:prstClr val="black">
+                        <a:alpha val="40000"/>
+                      </a:prstClr>
+                    </a:outerShdw>
+                  </a:effectLst>
                   <a:latin typeface="Maple Mono NF CN" panose="020F0509060000000000" pitchFamily="49" charset="-128"/>
                   <a:ea typeface="Maple Mono NF CN" panose="020F0509060000000000" pitchFamily="49" charset="-128"/>
                 </a:rPr>
@@ -8149,9 +9627,9 @@
             </a:prstGeom>
             <a:ln w="9525">
               <a:solidFill>
-                <a:schemeClr val="accent5">
-                  <a:lumMod val="60000"/>
-                  <a:lumOff val="40000"/>
+                <a:schemeClr val="tx2">
+                  <a:lumMod val="50000"/>
+                  <a:lumOff val="50000"/>
                 </a:schemeClr>
               </a:solidFill>
               <a:tailEnd type="none" w="sm" len="sm"/>
@@ -8196,9 +9674,9 @@
             </a:prstGeom>
             <a:ln w="9525" cap="rnd">
               <a:solidFill>
-                <a:schemeClr val="accent5">
-                  <a:lumMod val="60000"/>
-                  <a:lumOff val="40000"/>
+                <a:schemeClr val="tx2">
+                  <a:lumMod val="50000"/>
+                  <a:lumOff val="50000"/>
                 </a:schemeClr>
               </a:solidFill>
               <a:tailEnd type="oval" w="sm" len="sm"/>
@@ -8251,11 +9729,18 @@
               <a:r>
                 <a:rPr kumimoji="1" lang="zh-CN" altLang="en-US" sz="700" b="1" dirty="0">
                   <a:solidFill>
-                    <a:schemeClr val="accent5">
-                      <a:lumMod val="60000"/>
-                      <a:lumOff val="40000"/>
+                    <a:schemeClr val="tx2">
+                      <a:lumMod val="50000"/>
+                      <a:lumOff val="50000"/>
                     </a:schemeClr>
                   </a:solidFill>
+                  <a:effectLst>
+                    <a:outerShdw blurRad="187198" dist="38100" dir="5400000" sx="99744" sy="99744" algn="t" rotWithShape="0">
+                      <a:prstClr val="black">
+                        <a:alpha val="40000"/>
+                      </a:prstClr>
+                    </a:outerShdw>
+                  </a:effectLst>
                   <a:latin typeface="Maple Mono NF CN" panose="020F0509060000000000" pitchFamily="49" charset="-128"/>
                   <a:ea typeface="Maple Mono NF CN" panose="020F0509060000000000" pitchFamily="49" charset="-128"/>
                 </a:rPr>
@@ -8288,9 +9773,9 @@
             </a:prstGeom>
             <a:ln w="9525" cap="rnd">
               <a:solidFill>
-                <a:schemeClr val="accent5">
-                  <a:lumMod val="60000"/>
-                  <a:lumOff val="40000"/>
+                <a:schemeClr val="tx2">
+                  <a:lumMod val="50000"/>
+                  <a:lumOff val="50000"/>
                 </a:schemeClr>
               </a:solidFill>
               <a:tailEnd type="oval" w="sm" len="sm"/>
@@ -8335,9 +9820,9 @@
             </a:prstGeom>
             <a:ln w="9525">
               <a:solidFill>
-                <a:schemeClr val="accent5">
-                  <a:lumMod val="60000"/>
-                  <a:lumOff val="40000"/>
+                <a:schemeClr val="tx2">
+                  <a:lumMod val="50000"/>
+                  <a:lumOff val="50000"/>
                 </a:schemeClr>
               </a:solidFill>
               <a:tailEnd type="none" w="sm" len="sm"/>
@@ -8372,8 +9857,8 @@
           </p:nvSpPr>
           <p:spPr>
             <a:xfrm>
-              <a:off x="10129450" y="3095697"/>
-              <a:ext cx="994183" cy="200055"/>
+              <a:off x="10288478" y="2995906"/>
+              <a:ext cx="829073" cy="307777"/>
             </a:xfrm>
             <a:prstGeom prst="rect">
               <a:avLst/>
@@ -8388,38 +9873,82 @@
             <a:p>
               <a:pPr algn="r"/>
               <a:r>
+                <a:rPr kumimoji="1" lang="zh-CN" altLang="en" sz="700" b="1" dirty="0">
+                  <a:solidFill>
+                    <a:schemeClr val="tx2">
+                      <a:lumMod val="50000"/>
+                      <a:lumOff val="50000"/>
+                    </a:schemeClr>
+                  </a:solidFill>
+                  <a:effectLst>
+                    <a:outerShdw blurRad="187198" dist="38100" dir="5400000" sx="99744" sy="99744" algn="t" rotWithShape="0">
+                      <a:prstClr val="black">
+                        <a:alpha val="40000"/>
+                      </a:prstClr>
+                    </a:outerShdw>
+                  </a:effectLst>
+                  <a:latin typeface="Maple Mono NF CN" panose="020F0509060000000000" pitchFamily="49" charset="-128"/>
+                  <a:ea typeface="Maple Mono NF CN" panose="020F0509060000000000" pitchFamily="49" charset="-128"/>
+                </a:rPr>
+                <a:t>使用</a:t>
+              </a:r>
+              <a:r>
                 <a:rPr kumimoji="1" lang="en" altLang="zh-CN" sz="700" b="1" dirty="0">
                   <a:solidFill>
-                    <a:schemeClr val="accent5">
-                      <a:lumMod val="60000"/>
-                      <a:lumOff val="40000"/>
+                    <a:schemeClr val="tx2">
+                      <a:lumMod val="50000"/>
+                      <a:lumOff val="50000"/>
                     </a:schemeClr>
                   </a:solidFill>
+                  <a:effectLst>
+                    <a:outerShdw blurRad="187198" dist="38100" dir="5400000" sx="99744" sy="99744" algn="t" rotWithShape="0">
+                      <a:prstClr val="black">
+                        <a:alpha val="40000"/>
+                      </a:prstClr>
+                    </a:outerShdw>
+                  </a:effectLst>
                   <a:latin typeface="Maple Mono NF CN" panose="020F0509060000000000" pitchFamily="49" charset="-128"/>
                   <a:ea typeface="Maple Mono NF CN" panose="020F0509060000000000" pitchFamily="49" charset="-128"/>
                 </a:rPr>
                 <a:t>Stata</a:t>
               </a:r>
+            </a:p>
+            <a:p>
+              <a:pPr algn="r"/>
               <a:r>
                 <a:rPr kumimoji="1" lang="zh-CN" altLang="en-US" sz="700" b="1" dirty="0">
                   <a:solidFill>
-                    <a:schemeClr val="accent5">
-                      <a:lumMod val="60000"/>
-                      <a:lumOff val="40000"/>
+                    <a:schemeClr val="tx2">
+                      <a:lumMod val="50000"/>
+                      <a:lumOff val="50000"/>
                     </a:schemeClr>
                   </a:solidFill>
+                  <a:effectLst>
+                    <a:outerShdw blurRad="187198" dist="38100" dir="5400000" sx="99744" sy="99744" algn="t" rotWithShape="0">
+                      <a:prstClr val="black">
+                        <a:alpha val="40000"/>
+                      </a:prstClr>
+                    </a:outerShdw>
+                  </a:effectLst>
                   <a:latin typeface="Maple Mono NF CN" panose="020F0509060000000000" pitchFamily="49" charset="-128"/>
                   <a:ea typeface="Maple Mono NF CN" panose="020F0509060000000000" pitchFamily="49" charset="-128"/>
                 </a:rPr>
-                <a:t>语法的筛选</a:t>
+                <a:t>语法筛选数据</a:t>
               </a:r>
               <a:endParaRPr kumimoji="1" lang="en" altLang="zh-CN" sz="700" b="1" dirty="0">
                 <a:solidFill>
-                  <a:schemeClr val="accent5">
-                    <a:lumMod val="60000"/>
-                    <a:lumOff val="40000"/>
+                  <a:schemeClr val="tx2">
+                    <a:lumMod val="50000"/>
+                    <a:lumOff val="50000"/>
                   </a:schemeClr>
                 </a:solidFill>
+                <a:effectLst>
+                  <a:outerShdw blurRad="187198" dist="38100" dir="5400000" sx="99744" sy="99744" algn="t" rotWithShape="0">
+                    <a:prstClr val="black">
+                      <a:alpha val="40000"/>
+                    </a:prstClr>
+                  </a:outerShdw>
+                </a:effectLst>
                 <a:latin typeface="Maple Mono NF CN" panose="020F0509060000000000" pitchFamily="49" charset="-128"/>
                 <a:ea typeface="Maple Mono NF CN" panose="020F0509060000000000" pitchFamily="49" charset="-128"/>
               </a:endParaRPr>
@@ -8450,9 +9979,9 @@
             </a:prstGeom>
             <a:ln w="9525" cap="rnd">
               <a:solidFill>
-                <a:schemeClr val="accent5">
-                  <a:lumMod val="60000"/>
-                  <a:lumOff val="40000"/>
+                <a:schemeClr val="tx2">
+                  <a:lumMod val="50000"/>
+                  <a:lumOff val="50000"/>
                 </a:schemeClr>
               </a:solidFill>
               <a:tailEnd type="oval" w="sm" len="sm"/>
@@ -8504,11 +10033,18 @@
               <a:r>
                 <a:rPr kumimoji="1" lang="zh-CN" altLang="en-US" sz="700" b="1" dirty="0">
                   <a:solidFill>
-                    <a:schemeClr val="accent5">
-                      <a:lumMod val="60000"/>
-                      <a:lumOff val="40000"/>
+                    <a:schemeClr val="tx2">
+                      <a:lumMod val="50000"/>
+                      <a:lumOff val="50000"/>
                     </a:schemeClr>
                   </a:solidFill>
+                  <a:effectLst>
+                    <a:outerShdw blurRad="187198" dist="38100" dir="5400000" sx="99744" sy="99744" algn="t" rotWithShape="0">
+                      <a:prstClr val="black">
+                        <a:alpha val="40000"/>
+                      </a:prstClr>
+                    </a:outerShdw>
+                  </a:effectLst>
                   <a:latin typeface="Maple Mono NF CN" panose="020F0509060000000000" pitchFamily="49" charset="-128"/>
                   <a:ea typeface="Maple Mono NF CN" panose="020F0509060000000000" pitchFamily="49" charset="-128"/>
                 </a:rPr>
@@ -8516,11 +10052,18 @@
               </a:r>
               <a:endParaRPr kumimoji="1" lang="en-US" altLang="zh-CN" sz="700" b="1" dirty="0">
                 <a:solidFill>
-                  <a:schemeClr val="accent5">
-                    <a:lumMod val="60000"/>
-                    <a:lumOff val="40000"/>
+                  <a:schemeClr val="tx2">
+                    <a:lumMod val="50000"/>
+                    <a:lumOff val="50000"/>
                   </a:schemeClr>
                 </a:solidFill>
+                <a:effectLst>
+                  <a:outerShdw blurRad="187198" dist="38100" dir="5400000" sx="99744" sy="99744" algn="t" rotWithShape="0">
+                    <a:prstClr val="black">
+                      <a:alpha val="40000"/>
+                    </a:prstClr>
+                  </a:outerShdw>
+                </a:effectLst>
                 <a:latin typeface="Maple Mono NF CN" panose="020F0509060000000000" pitchFamily="49" charset="-128"/>
                 <a:ea typeface="Maple Mono NF CN" panose="020F0509060000000000" pitchFamily="49" charset="-128"/>
               </a:endParaRPr>
@@ -8551,9 +10094,9 @@
             </a:prstGeom>
             <a:ln w="9525" cap="rnd">
               <a:solidFill>
-                <a:schemeClr val="accent5">
-                  <a:lumMod val="60000"/>
-                  <a:lumOff val="40000"/>
+                <a:schemeClr val="tx2">
+                  <a:lumMod val="50000"/>
+                  <a:lumOff val="50000"/>
                 </a:schemeClr>
               </a:solidFill>
               <a:tailEnd type="none" w="sm" len="sm"/>
@@ -8598,9 +10141,9 @@
             </a:prstGeom>
             <a:ln w="9525" cap="rnd">
               <a:solidFill>
-                <a:schemeClr val="accent5">
-                  <a:lumMod val="60000"/>
-                  <a:lumOff val="40000"/>
+                <a:schemeClr val="tx2">
+                  <a:lumMod val="50000"/>
+                  <a:lumOff val="50000"/>
                 </a:schemeClr>
               </a:solidFill>
               <a:tailEnd type="oval" w="sm" len="sm"/>
@@ -8645,9 +10188,9 @@
             </a:prstGeom>
             <a:ln w="9525" cap="rnd">
               <a:solidFill>
-                <a:schemeClr val="accent5">
-                  <a:lumMod val="60000"/>
-                  <a:lumOff val="40000"/>
+                <a:schemeClr val="tx2">
+                  <a:lumMod val="50000"/>
+                  <a:lumOff val="50000"/>
                 </a:schemeClr>
               </a:solidFill>
               <a:tailEnd type="none" w="sm" len="sm"/>
@@ -8682,8 +10225,8 @@
           </p:nvSpPr>
           <p:spPr>
             <a:xfrm>
-              <a:off x="7458434" y="874029"/>
-              <a:ext cx="824265" cy="307777"/>
+              <a:off x="7362450" y="866296"/>
+              <a:ext cx="954788" cy="200055"/>
             </a:xfrm>
             <a:prstGeom prst="rect">
               <a:avLst/>
@@ -8699,11 +10242,18 @@
               <a:r>
                 <a:rPr kumimoji="1" lang="en-US" altLang="zh-CN" sz="700" b="1" dirty="0">
                   <a:solidFill>
-                    <a:schemeClr val="accent5">
-                      <a:lumMod val="60000"/>
-                      <a:lumOff val="40000"/>
+                    <a:schemeClr val="tx2">
+                      <a:lumMod val="50000"/>
+                      <a:lumOff val="50000"/>
                     </a:schemeClr>
                   </a:solidFill>
+                  <a:effectLst>
+                    <a:outerShdw blurRad="187198" dist="38100" dir="5400000" sx="99744" sy="99744" algn="t" rotWithShape="0">
+                      <a:prstClr val="black">
+                        <a:alpha val="40000"/>
+                      </a:prstClr>
+                    </a:outerShdw>
+                  </a:effectLst>
                   <a:latin typeface="Maple Mono NF CN" panose="020F0509060000000000" pitchFamily="49" charset="-128"/>
                   <a:ea typeface="Maple Mono NF CN" panose="020F0509060000000000" pitchFamily="49" charset="-128"/>
                 </a:rPr>
@@ -8712,11 +10262,18 @@
               <a:r>
                 <a:rPr kumimoji="1" lang="zh-CN" altLang="en-US" sz="700" b="1" dirty="0">
                   <a:solidFill>
-                    <a:schemeClr val="accent5">
-                      <a:lumMod val="60000"/>
-                      <a:lumOff val="40000"/>
+                    <a:schemeClr val="tx2">
+                      <a:lumMod val="50000"/>
+                      <a:lumOff val="50000"/>
                     </a:schemeClr>
                   </a:solidFill>
+                  <a:effectLst>
+                    <a:outerShdw blurRad="187198" dist="38100" dir="5400000" sx="99744" sy="99744" algn="t" rotWithShape="0">
+                      <a:prstClr val="black">
+                        <a:alpha val="40000"/>
+                      </a:prstClr>
+                    </a:outerShdw>
+                  </a:effectLst>
                   <a:latin typeface="Maple Mono NF CN" panose="020F0509060000000000" pitchFamily="49" charset="-128"/>
                   <a:ea typeface="Maple Mono NF CN" panose="020F0509060000000000" pitchFamily="49" charset="-128"/>
                 </a:rPr>
@@ -8749,9 +10306,9 @@
             </a:prstGeom>
             <a:ln w="9525" cap="rnd">
               <a:solidFill>
-                <a:schemeClr val="accent5">
-                  <a:lumMod val="60000"/>
-                  <a:lumOff val="40000"/>
+                <a:schemeClr val="tx2">
+                  <a:lumMod val="50000"/>
+                  <a:lumOff val="50000"/>
                 </a:schemeClr>
               </a:solidFill>
               <a:tailEnd type="oval" w="sm" len="sm"/>
@@ -8796,9 +10353,9 @@
             </a:prstGeom>
             <a:ln w="9525">
               <a:solidFill>
-                <a:schemeClr val="accent5">
-                  <a:lumMod val="60000"/>
-                  <a:lumOff val="40000"/>
+                <a:schemeClr val="tx2">
+                  <a:lumMod val="50000"/>
+                  <a:lumOff val="50000"/>
                 </a:schemeClr>
               </a:solidFill>
               <a:tailEnd type="none" w="sm" len="sm"/>
@@ -8851,11 +10408,18 @@
               <a:r>
                 <a:rPr kumimoji="1" lang="zh-CN" altLang="en-US" sz="700" b="1" dirty="0">
                   <a:solidFill>
-                    <a:schemeClr val="accent5">
-                      <a:lumMod val="60000"/>
-                      <a:lumOff val="40000"/>
+                    <a:schemeClr val="tx2">
+                      <a:lumMod val="50000"/>
+                      <a:lumOff val="50000"/>
                     </a:schemeClr>
                   </a:solidFill>
+                  <a:effectLst>
+                    <a:outerShdw blurRad="187198" dist="38100" dir="5400000" sx="99744" sy="99744" algn="t" rotWithShape="0">
+                      <a:prstClr val="black">
+                        <a:alpha val="40000"/>
+                      </a:prstClr>
+                    </a:outerShdw>
+                  </a:effectLst>
                   <a:latin typeface="Maple Mono NF CN" panose="020F0509060000000000" pitchFamily="49" charset="-128"/>
                   <a:ea typeface="Maple Mono NF CN" panose="020F0509060000000000" pitchFamily="49" charset="-128"/>
                 </a:rPr>
@@ -8888,9 +10452,9 @@
             </a:prstGeom>
             <a:ln w="9525" cap="rnd">
               <a:solidFill>
-                <a:schemeClr val="accent5">
-                  <a:lumMod val="60000"/>
-                  <a:lumOff val="40000"/>
+                <a:schemeClr val="tx2">
+                  <a:lumMod val="50000"/>
+                  <a:lumOff val="50000"/>
                 </a:schemeClr>
               </a:solidFill>
               <a:tailEnd type="oval" w="sm" len="sm"/>
@@ -8935,9 +10499,9 @@
             </a:prstGeom>
             <a:ln w="9525">
               <a:solidFill>
-                <a:schemeClr val="accent5">
-                  <a:lumMod val="60000"/>
-                  <a:lumOff val="40000"/>
+                <a:schemeClr val="tx2">
+                  <a:lumMod val="50000"/>
+                  <a:lumOff val="50000"/>
                 </a:schemeClr>
               </a:solidFill>
               <a:tailEnd type="none" w="sm" len="sm"/>
@@ -8990,11 +10554,18 @@
               <a:r>
                 <a:rPr kumimoji="1" lang="zh-CN" altLang="en-US" sz="700" b="1" dirty="0">
                   <a:solidFill>
-                    <a:schemeClr val="accent5">
-                      <a:lumMod val="60000"/>
-                      <a:lumOff val="40000"/>
+                    <a:schemeClr val="tx2">
+                      <a:lumMod val="50000"/>
+                      <a:lumOff val="50000"/>
                     </a:schemeClr>
                   </a:solidFill>
+                  <a:effectLst>
+                    <a:outerShdw blurRad="187198" dist="38100" dir="5400000" sx="99744" sy="99744" algn="t" rotWithShape="0">
+                      <a:prstClr val="black">
+                        <a:alpha val="40000"/>
+                      </a:prstClr>
+                    </a:outerShdw>
+                  </a:effectLst>
                   <a:latin typeface="Maple Mono NF CN" panose="020F0509060000000000" pitchFamily="49" charset="-128"/>
                   <a:ea typeface="Maple Mono NF CN" panose="020F0509060000000000" pitchFamily="49" charset="-128"/>
                 </a:rPr>
@@ -9330,4 +10901,319 @@
     </a:ext>
   </a:extLst>
 </a:theme>
+</file>
+
+<file path=ppt/theme/theme2.xml><?xml version="1.0" encoding="utf-8"?>
+<a:theme xmlns:a="http://schemas.openxmlformats.org/drawingml/2006/main" name="Office 主题​​">
+  <a:themeElements>
+    <a:clrScheme name="Office">
+      <a:dk1>
+        <a:sysClr val="windowText" lastClr="000000"/>
+      </a:dk1>
+      <a:lt1>
+        <a:sysClr val="window" lastClr="FFFFFF"/>
+      </a:lt1>
+      <a:dk2>
+        <a:srgbClr val="0E2841"/>
+      </a:dk2>
+      <a:lt2>
+        <a:srgbClr val="E8E8E8"/>
+      </a:lt2>
+      <a:accent1>
+        <a:srgbClr val="156082"/>
+      </a:accent1>
+      <a:accent2>
+        <a:srgbClr val="E97132"/>
+      </a:accent2>
+      <a:accent3>
+        <a:srgbClr val="196B24"/>
+      </a:accent3>
+      <a:accent4>
+        <a:srgbClr val="0F9ED5"/>
+      </a:accent4>
+      <a:accent5>
+        <a:srgbClr val="A02B93"/>
+      </a:accent5>
+      <a:accent6>
+        <a:srgbClr val="4EA72E"/>
+      </a:accent6>
+      <a:hlink>
+        <a:srgbClr val="467886"/>
+      </a:hlink>
+      <a:folHlink>
+        <a:srgbClr val="96607D"/>
+      </a:folHlink>
+    </a:clrScheme>
+    <a:fontScheme name="Office">
+      <a:majorFont>
+        <a:latin typeface="等线 Light" panose="02110004020202020204"/>
+        <a:ea typeface=""/>
+        <a:cs typeface=""/>
+        <a:font script="Jpan" typeface="游ゴシック Light"/>
+        <a:font script="Hang" typeface="맑은 고딕"/>
+        <a:font script="Hans" typeface="等线 Light"/>
+        <a:font script="Hant" typeface="新細明體"/>
+        <a:font script="Arab" typeface="Times New Roman"/>
+        <a:font script="Hebr" typeface="Times New Roman"/>
+        <a:font script="Thai" typeface="Angsana New"/>
+        <a:font script="Ethi" typeface="Nyala"/>
+        <a:font script="Beng" typeface="Vrinda"/>
+        <a:font script="Gujr" typeface="Shruti"/>
+        <a:font script="Khmr" typeface="MoolBoran"/>
+        <a:font script="Knda" typeface="Tunga"/>
+        <a:font script="Guru" typeface="Raavi"/>
+        <a:font script="Cans" typeface="Euphemia"/>
+        <a:font script="Cher" typeface="Plantagenet Cherokee"/>
+        <a:font script="Yiii" typeface="Microsoft Yi Baiti"/>
+        <a:font script="Tibt" typeface="Microsoft Himalaya"/>
+        <a:font script="Thaa" typeface="MV Boli"/>
+        <a:font script="Deva" typeface="Mangal"/>
+        <a:font script="Telu" typeface="Gautami"/>
+        <a:font script="Taml" typeface="Latha"/>
+        <a:font script="Syrc" typeface="Estrangelo Edessa"/>
+        <a:font script="Orya" typeface="Kalinga"/>
+        <a:font script="Mlym" typeface="Kartika"/>
+        <a:font script="Laoo" typeface="DokChampa"/>
+        <a:font script="Sinh" typeface="Iskoola Pota"/>
+        <a:font script="Mong" typeface="Mongolian Baiti"/>
+        <a:font script="Viet" typeface="Times New Roman"/>
+        <a:font script="Uigh" typeface="Microsoft Uighur"/>
+        <a:font script="Geor" typeface="Sylfaen"/>
+        <a:font script="Armn" typeface="Arial"/>
+        <a:font script="Bugi" typeface="Leelawadee UI"/>
+        <a:font script="Bopo" typeface="Microsoft JhengHei"/>
+        <a:font script="Java" typeface="Javanese Text"/>
+        <a:font script="Lisu" typeface="Segoe UI"/>
+        <a:font script="Mymr" typeface="Myanmar Text"/>
+        <a:font script="Nkoo" typeface="Ebrima"/>
+        <a:font script="Olck" typeface="Nirmala UI"/>
+        <a:font script="Osma" typeface="Ebrima"/>
+        <a:font script="Phag" typeface="Phagspa"/>
+        <a:font script="Syrn" typeface="Estrangelo Edessa"/>
+        <a:font script="Syrj" typeface="Estrangelo Edessa"/>
+        <a:font script="Syre" typeface="Estrangelo Edessa"/>
+        <a:font script="Sora" typeface="Nirmala UI"/>
+        <a:font script="Tale" typeface="Microsoft Tai Le"/>
+        <a:font script="Talu" typeface="Microsoft New Tai Lue"/>
+        <a:font script="Tfng" typeface="Ebrima"/>
+      </a:majorFont>
+      <a:minorFont>
+        <a:latin typeface="等线" panose="02110004020202020204"/>
+        <a:ea typeface=""/>
+        <a:cs typeface=""/>
+        <a:font script="Jpan" typeface="游ゴシック"/>
+        <a:font script="Hang" typeface="맑은 고딕"/>
+        <a:font script="Hans" typeface="等线"/>
+        <a:font script="Hant" typeface="新細明體"/>
+        <a:font script="Arab" typeface="Arial"/>
+        <a:font script="Hebr" typeface="Arial"/>
+        <a:font script="Thai" typeface="Cordia New"/>
+        <a:font script="Ethi" typeface="Nyala"/>
+        <a:font script="Beng" typeface="Vrinda"/>
+        <a:font script="Gujr" typeface="Shruti"/>
+        <a:font script="Khmr" typeface="DaunPenh"/>
+        <a:font script="Knda" typeface="Tunga"/>
+        <a:font script="Guru" typeface="Raavi"/>
+        <a:font script="Cans" typeface="Euphemia"/>
+        <a:font script="Cher" typeface="Plantagenet Cherokee"/>
+        <a:font script="Yiii" typeface="Microsoft Yi Baiti"/>
+        <a:font script="Tibt" typeface="Microsoft Himalaya"/>
+        <a:font script="Thaa" typeface="MV Boli"/>
+        <a:font script="Deva" typeface="Mangal"/>
+        <a:font script="Telu" typeface="Gautami"/>
+        <a:font script="Taml" typeface="Latha"/>
+        <a:font script="Syrc" typeface="Estrangelo Edessa"/>
+        <a:font script="Orya" typeface="Kalinga"/>
+        <a:font script="Mlym" typeface="Kartika"/>
+        <a:font script="Laoo" typeface="DokChampa"/>
+        <a:font script="Sinh" typeface="Iskoola Pota"/>
+        <a:font script="Mong" typeface="Mongolian Baiti"/>
+        <a:font script="Viet" typeface="Arial"/>
+        <a:font script="Uigh" typeface="Microsoft Uighur"/>
+        <a:font script="Geor" typeface="Sylfaen"/>
+        <a:font script="Armn" typeface="Arial"/>
+        <a:font script="Bugi" typeface="Leelawadee UI"/>
+        <a:font script="Bopo" typeface="Microsoft JhengHei"/>
+        <a:font script="Java" typeface="Javanese Text"/>
+        <a:font script="Lisu" typeface="Segoe UI"/>
+        <a:font script="Mymr" typeface="Myanmar Text"/>
+        <a:font script="Nkoo" typeface="Ebrima"/>
+        <a:font script="Olck" typeface="Nirmala UI"/>
+        <a:font script="Osma" typeface="Ebrima"/>
+        <a:font script="Phag" typeface="Phagspa"/>
+        <a:font script="Syrn" typeface="Estrangelo Edessa"/>
+        <a:font script="Syrj" typeface="Estrangelo Edessa"/>
+        <a:font script="Syre" typeface="Estrangelo Edessa"/>
+        <a:font script="Sora" typeface="Nirmala UI"/>
+        <a:font script="Tale" typeface="Microsoft Tai Le"/>
+        <a:font script="Talu" typeface="Microsoft New Tai Lue"/>
+        <a:font script="Tfng" typeface="Ebrima"/>
+      </a:minorFont>
+    </a:fontScheme>
+    <a:fmtScheme name="Office">
+      <a:fillStyleLst>
+        <a:solidFill>
+          <a:schemeClr val="phClr"/>
+        </a:solidFill>
+        <a:gradFill rotWithShape="1">
+          <a:gsLst>
+            <a:gs pos="0">
+              <a:schemeClr val="phClr">
+                <a:lumMod val="110000"/>
+                <a:satMod val="105000"/>
+                <a:tint val="67000"/>
+              </a:schemeClr>
+            </a:gs>
+            <a:gs pos="50000">
+              <a:schemeClr val="phClr">
+                <a:lumMod val="105000"/>
+                <a:satMod val="103000"/>
+                <a:tint val="73000"/>
+              </a:schemeClr>
+            </a:gs>
+            <a:gs pos="100000">
+              <a:schemeClr val="phClr">
+                <a:lumMod val="105000"/>
+                <a:satMod val="109000"/>
+                <a:tint val="81000"/>
+              </a:schemeClr>
+            </a:gs>
+          </a:gsLst>
+          <a:lin ang="5400000" scaled="0"/>
+        </a:gradFill>
+        <a:gradFill rotWithShape="1">
+          <a:gsLst>
+            <a:gs pos="0">
+              <a:schemeClr val="phClr">
+                <a:satMod val="103000"/>
+                <a:lumMod val="102000"/>
+                <a:tint val="94000"/>
+              </a:schemeClr>
+            </a:gs>
+            <a:gs pos="50000">
+              <a:schemeClr val="phClr">
+                <a:satMod val="110000"/>
+                <a:lumMod val="100000"/>
+                <a:shade val="100000"/>
+              </a:schemeClr>
+            </a:gs>
+            <a:gs pos="100000">
+              <a:schemeClr val="phClr">
+                <a:lumMod val="99000"/>
+                <a:satMod val="120000"/>
+                <a:shade val="78000"/>
+              </a:schemeClr>
+            </a:gs>
+          </a:gsLst>
+          <a:lin ang="5400000" scaled="0"/>
+        </a:gradFill>
+      </a:fillStyleLst>
+      <a:lnStyleLst>
+        <a:ln w="12700" cap="flat" cmpd="sng" algn="ctr">
+          <a:solidFill>
+            <a:schemeClr val="phClr"/>
+          </a:solidFill>
+          <a:prstDash val="solid"/>
+          <a:miter lim="800000"/>
+        </a:ln>
+        <a:ln w="19050" cap="flat" cmpd="sng" algn="ctr">
+          <a:solidFill>
+            <a:schemeClr val="phClr"/>
+          </a:solidFill>
+          <a:prstDash val="solid"/>
+          <a:miter lim="800000"/>
+        </a:ln>
+        <a:ln w="25400" cap="flat" cmpd="sng" algn="ctr">
+          <a:solidFill>
+            <a:schemeClr val="phClr"/>
+          </a:solidFill>
+          <a:prstDash val="solid"/>
+          <a:miter lim="800000"/>
+        </a:ln>
+      </a:lnStyleLst>
+      <a:effectStyleLst>
+        <a:effectStyle>
+          <a:effectLst/>
+        </a:effectStyle>
+        <a:effectStyle>
+          <a:effectLst/>
+        </a:effectStyle>
+        <a:effectStyle>
+          <a:effectLst>
+            <a:outerShdw blurRad="57150" dist="19050" dir="5400000" algn="ctr" rotWithShape="0">
+              <a:srgbClr val="000000">
+                <a:alpha val="63000"/>
+              </a:srgbClr>
+            </a:outerShdw>
+          </a:effectLst>
+        </a:effectStyle>
+      </a:effectStyleLst>
+      <a:bgFillStyleLst>
+        <a:solidFill>
+          <a:schemeClr val="phClr"/>
+        </a:solidFill>
+        <a:solidFill>
+          <a:schemeClr val="phClr">
+            <a:tint val="95000"/>
+            <a:satMod val="170000"/>
+          </a:schemeClr>
+        </a:solidFill>
+        <a:gradFill rotWithShape="1">
+          <a:gsLst>
+            <a:gs pos="0">
+              <a:schemeClr val="phClr">
+                <a:tint val="93000"/>
+                <a:satMod val="150000"/>
+                <a:shade val="98000"/>
+                <a:lumMod val="102000"/>
+              </a:schemeClr>
+            </a:gs>
+            <a:gs pos="50000">
+              <a:schemeClr val="phClr">
+                <a:tint val="98000"/>
+                <a:satMod val="130000"/>
+                <a:shade val="90000"/>
+                <a:lumMod val="103000"/>
+              </a:schemeClr>
+            </a:gs>
+            <a:gs pos="100000">
+              <a:schemeClr val="phClr">
+                <a:shade val="63000"/>
+                <a:satMod val="120000"/>
+              </a:schemeClr>
+            </a:gs>
+          </a:gsLst>
+          <a:lin ang="5400000" scaled="0"/>
+        </a:gradFill>
+      </a:bgFillStyleLst>
+    </a:fmtScheme>
+  </a:themeElements>
+  <a:objectDefaults>
+    <a:lnDef>
+      <a:spPr/>
+      <a:bodyPr/>
+      <a:lstStyle/>
+      <a:style>
+        <a:lnRef idx="2">
+          <a:schemeClr val="accent1"/>
+        </a:lnRef>
+        <a:fillRef idx="0">
+          <a:schemeClr val="accent1"/>
+        </a:fillRef>
+        <a:effectRef idx="1">
+          <a:schemeClr val="accent1"/>
+        </a:effectRef>
+        <a:fontRef idx="minor">
+          <a:schemeClr val="tx1"/>
+        </a:fontRef>
+      </a:style>
+    </a:lnDef>
+  </a:objectDefaults>
+  <a:extraClrSchemeLst/>
+  <a:extLst>
+    <a:ext uri="{05A4C25C-085E-4340-85A3-A5531E510DB2}">
+      <thm15:themeFamily xmlns:thm15="http://schemas.microsoft.com/office/thememl/2012/main" name="Office Theme" id="{2E142A2C-CD16-42D6-873A-C26D2A0506FA}" vid="{1BDDFF52-6CD6-40A5-AB3C-68EB2F1E4D0A}"/>
+    </a:ext>
+  </a:extLst>
+</a:theme>
 </file>
</xml_diff>

<commit_message>
fix: update example images for improved clarity and presentation
</commit_message>
<xml_diff>
--- a/img/example-marked.pptx
+++ b/img/example-marked.pptx
@@ -119,7 +119,7 @@
 <file path=ppt/revisionInfo.xml><?xml version="1.0" encoding="utf-8"?>
 <p1510:revInfo xmlns:a="http://schemas.openxmlformats.org/drawingml/2006/main" xmlns:r="http://schemas.openxmlformats.org/officeDocument/2006/relationships" xmlns:p1510="http://schemas.microsoft.com/office/powerpoint/2015/10/main">
   <p1510:revLst>
-    <p1510:client id="{21B15FB9-1BA0-F247-8406-2C9EAB55C849}" v="200" dt="2026-05-31T06:40:34.248"/>
+    <p1510:client id="{21B15FB9-1BA0-F247-8406-2C9EAB55C849}" v="209" dt="2026-06-07T10:36:10.071"/>
   </p1510:revLst>
 </p1510:revInfo>
 </file>
@@ -129,18 +129,26 @@
   <pc:docChgLst>
     <pc:chgData name="Zihao Viston Wang" userId="bb38f0bb24686ff5" providerId="LiveId" clId="{624A8E29-C0AB-51FB-8E4A-8A86974DAEAD}"/>
     <pc:docChg chg="undo custSel modSld">
-      <pc:chgData name="Zihao Viston Wang" userId="bb38f0bb24686ff5" providerId="LiveId" clId="{624A8E29-C0AB-51FB-8E4A-8A86974DAEAD}" dt="2026-05-31T06:45:12.503" v="231" actId="14838"/>
+      <pc:chgData name="Zihao Viston Wang" userId="bb38f0bb24686ff5" providerId="LiveId" clId="{624A8E29-C0AB-51FB-8E4A-8A86974DAEAD}" dt="2026-06-07T10:36:10.071" v="832" actId="164"/>
       <pc:docMkLst>
         <pc:docMk/>
       </pc:docMkLst>
       <pc:sldChg chg="addSp delSp modSp mod">
-        <pc:chgData name="Zihao Viston Wang" userId="bb38f0bb24686ff5" providerId="LiveId" clId="{624A8E29-C0AB-51FB-8E4A-8A86974DAEAD}" dt="2026-05-31T06:44:22.157" v="154" actId="14838"/>
+        <pc:chgData name="Zihao Viston Wang" userId="bb38f0bb24686ff5" providerId="LiveId" clId="{624A8E29-C0AB-51FB-8E4A-8A86974DAEAD}" dt="2026-06-07T10:35:34.008" v="831" actId="164"/>
         <pc:sldMkLst>
           <pc:docMk/>
           <pc:sldMk cId="333356922" sldId="256"/>
         </pc:sldMkLst>
+        <pc:spChg chg="add mod">
+          <ac:chgData name="Zihao Viston Wang" userId="bb38f0bb24686ff5" providerId="LiveId" clId="{624A8E29-C0AB-51FB-8E4A-8A86974DAEAD}" dt="2026-06-07T10:22:06.617" v="277" actId="167"/>
+          <ac:spMkLst>
+            <pc:docMk/>
+            <pc:sldMk cId="333356922" sldId="256"/>
+            <ac:spMk id="3" creationId="{AFEAB8E9-8454-1FFC-BBF3-33F4CFF89C5B}"/>
+          </ac:spMkLst>
+        </pc:spChg>
         <pc:spChg chg="mod topLvl">
-          <ac:chgData name="Zihao Viston Wang" userId="bb38f0bb24686ff5" providerId="LiveId" clId="{624A8E29-C0AB-51FB-8E4A-8A86974DAEAD}" dt="2026-05-31T06:40:34.248" v="47" actId="164"/>
+          <ac:chgData name="Zihao Viston Wang" userId="bb38f0bb24686ff5" providerId="LiveId" clId="{624A8E29-C0AB-51FB-8E4A-8A86974DAEAD}" dt="2026-06-07T10:35:34.008" v="831" actId="164"/>
           <ac:spMkLst>
             <pc:docMk/>
             <pc:sldMk cId="333356922" sldId="256"/>
@@ -148,15 +156,15 @@
           </ac:spMkLst>
         </pc:spChg>
         <pc:spChg chg="mod">
-          <ac:chgData name="Zihao Viston Wang" userId="bb38f0bb24686ff5" providerId="LiveId" clId="{624A8E29-C0AB-51FB-8E4A-8A86974DAEAD}" dt="2026-05-31T06:37:28.331" v="13" actId="207"/>
+          <ac:chgData name="Zihao Viston Wang" userId="bb38f0bb24686ff5" providerId="LiveId" clId="{624A8E29-C0AB-51FB-8E4A-8A86974DAEAD}" dt="2026-06-07T10:32:58.414" v="643" actId="1035"/>
           <ac:spMkLst>
             <pc:docMk/>
             <pc:sldMk cId="333356922" sldId="256"/>
             <ac:spMk id="40" creationId="{601AD2E7-C370-1028-90AB-D59B286CABEE}"/>
           </ac:spMkLst>
         </pc:spChg>
-        <pc:spChg chg="mod">
-          <ac:chgData name="Zihao Viston Wang" userId="bb38f0bb24686ff5" providerId="LiveId" clId="{624A8E29-C0AB-51FB-8E4A-8A86974DAEAD}" dt="2026-05-31T06:44:22.157" v="154" actId="14838"/>
+        <pc:spChg chg="mod topLvl">
+          <ac:chgData name="Zihao Viston Wang" userId="bb38f0bb24686ff5" providerId="LiveId" clId="{624A8E29-C0AB-51FB-8E4A-8A86974DAEAD}" dt="2026-06-07T10:35:34.008" v="831" actId="164"/>
           <ac:spMkLst>
             <pc:docMk/>
             <pc:sldMk cId="333356922" sldId="256"/>
@@ -164,7 +172,7 @@
           </ac:spMkLst>
         </pc:spChg>
         <pc:spChg chg="mod topLvl">
-          <ac:chgData name="Zihao Viston Wang" userId="bb38f0bb24686ff5" providerId="LiveId" clId="{624A8E29-C0AB-51FB-8E4A-8A86974DAEAD}" dt="2026-05-31T06:44:22.157" v="154" actId="14838"/>
+          <ac:chgData name="Zihao Viston Wang" userId="bb38f0bb24686ff5" providerId="LiveId" clId="{624A8E29-C0AB-51FB-8E4A-8A86974DAEAD}" dt="2026-06-07T10:35:34.008" v="831" actId="164"/>
           <ac:spMkLst>
             <pc:docMk/>
             <pc:sldMk cId="333356922" sldId="256"/>
@@ -172,7 +180,7 @@
           </ac:spMkLst>
         </pc:spChg>
         <pc:spChg chg="mod">
-          <ac:chgData name="Zihao Viston Wang" userId="bb38f0bb24686ff5" providerId="LiveId" clId="{624A8E29-C0AB-51FB-8E4A-8A86974DAEAD}" dt="2026-05-31T06:44:22.157" v="154" actId="14838"/>
+          <ac:chgData name="Zihao Viston Wang" userId="bb38f0bb24686ff5" providerId="LiveId" clId="{624A8E29-C0AB-51FB-8E4A-8A86974DAEAD}" dt="2026-06-07T10:35:34.008" v="831" actId="164"/>
           <ac:spMkLst>
             <pc:docMk/>
             <pc:sldMk cId="333356922" sldId="256"/>
@@ -180,7 +188,7 @@
           </ac:spMkLst>
         </pc:spChg>
         <pc:spChg chg="mod topLvl">
-          <ac:chgData name="Zihao Viston Wang" userId="bb38f0bb24686ff5" providerId="LiveId" clId="{624A8E29-C0AB-51FB-8E4A-8A86974DAEAD}" dt="2026-05-31T06:44:22.157" v="154" actId="14838"/>
+          <ac:chgData name="Zihao Viston Wang" userId="bb38f0bb24686ff5" providerId="LiveId" clId="{624A8E29-C0AB-51FB-8E4A-8A86974DAEAD}" dt="2026-06-07T10:35:17.753" v="830" actId="1037"/>
           <ac:spMkLst>
             <pc:docMk/>
             <pc:sldMk cId="333356922" sldId="256"/>
@@ -188,7 +196,7 @@
           </ac:spMkLst>
         </pc:spChg>
         <pc:spChg chg="mod topLvl">
-          <ac:chgData name="Zihao Viston Wang" userId="bb38f0bb24686ff5" providerId="LiveId" clId="{624A8E29-C0AB-51FB-8E4A-8A86974DAEAD}" dt="2026-05-31T06:44:22.157" v="154" actId="14838"/>
+          <ac:chgData name="Zihao Viston Wang" userId="bb38f0bb24686ff5" providerId="LiveId" clId="{624A8E29-C0AB-51FB-8E4A-8A86974DAEAD}" dt="2026-06-07T10:33:33.568" v="724" actId="1037"/>
           <ac:spMkLst>
             <pc:docMk/>
             <pc:sldMk cId="333356922" sldId="256"/>
@@ -196,7 +204,7 @@
           </ac:spMkLst>
         </pc:spChg>
         <pc:spChg chg="mod topLvl">
-          <ac:chgData name="Zihao Viston Wang" userId="bb38f0bb24686ff5" providerId="LiveId" clId="{624A8E29-C0AB-51FB-8E4A-8A86974DAEAD}" dt="2026-05-31T06:44:22.157" v="154" actId="14838"/>
+          <ac:chgData name="Zihao Viston Wang" userId="bb38f0bb24686ff5" providerId="LiveId" clId="{624A8E29-C0AB-51FB-8E4A-8A86974DAEAD}" dt="2026-06-07T10:35:34.008" v="831" actId="164"/>
           <ac:spMkLst>
             <pc:docMk/>
             <pc:sldMk cId="333356922" sldId="256"/>
@@ -204,7 +212,7 @@
           </ac:spMkLst>
         </pc:spChg>
         <pc:spChg chg="mod topLvl">
-          <ac:chgData name="Zihao Viston Wang" userId="bb38f0bb24686ff5" providerId="LiveId" clId="{624A8E29-C0AB-51FB-8E4A-8A86974DAEAD}" dt="2026-05-31T06:40:34.248" v="47" actId="164"/>
+          <ac:chgData name="Zihao Viston Wang" userId="bb38f0bb24686ff5" providerId="LiveId" clId="{624A8E29-C0AB-51FB-8E4A-8A86974DAEAD}" dt="2026-06-07T10:34:59.461" v="811" actId="1037"/>
           <ac:spMkLst>
             <pc:docMk/>
             <pc:sldMk cId="333356922" sldId="256"/>
@@ -212,7 +220,7 @@
           </ac:spMkLst>
         </pc:spChg>
         <pc:spChg chg="mod">
-          <ac:chgData name="Zihao Viston Wang" userId="bb38f0bb24686ff5" providerId="LiveId" clId="{624A8E29-C0AB-51FB-8E4A-8A86974DAEAD}" dt="2026-05-31T06:44:22.157" v="154" actId="14838"/>
+          <ac:chgData name="Zihao Viston Wang" userId="bb38f0bb24686ff5" providerId="LiveId" clId="{624A8E29-C0AB-51FB-8E4A-8A86974DAEAD}" dt="2026-06-07T10:34:59.461" v="811" actId="1037"/>
           <ac:spMkLst>
             <pc:docMk/>
             <pc:sldMk cId="333356922" sldId="256"/>
@@ -220,15 +228,15 @@
           </ac:spMkLst>
         </pc:spChg>
         <pc:spChg chg="mod topLvl">
-          <ac:chgData name="Zihao Viston Wang" userId="bb38f0bb24686ff5" providerId="LiveId" clId="{624A8E29-C0AB-51FB-8E4A-8A86974DAEAD}" dt="2026-05-31T06:40:34.248" v="47" actId="164"/>
+          <ac:chgData name="Zihao Viston Wang" userId="bb38f0bb24686ff5" providerId="LiveId" clId="{624A8E29-C0AB-51FB-8E4A-8A86974DAEAD}" dt="2026-06-07T10:35:34.008" v="831" actId="164"/>
           <ac:spMkLst>
             <pc:docMk/>
             <pc:sldMk cId="333356922" sldId="256"/>
             <ac:spMk id="130" creationId="{D0A2469A-A542-07B2-1A72-9B6D92692F23}"/>
           </ac:spMkLst>
         </pc:spChg>
-        <pc:spChg chg="mod">
-          <ac:chgData name="Zihao Viston Wang" userId="bb38f0bb24686ff5" providerId="LiveId" clId="{624A8E29-C0AB-51FB-8E4A-8A86974DAEAD}" dt="2026-05-31T06:44:22.157" v="154" actId="14838"/>
+        <pc:spChg chg="mod topLvl">
+          <ac:chgData name="Zihao Viston Wang" userId="bb38f0bb24686ff5" providerId="LiveId" clId="{624A8E29-C0AB-51FB-8E4A-8A86974DAEAD}" dt="2026-06-07T10:35:34.008" v="831" actId="164"/>
           <ac:spMkLst>
             <pc:docMk/>
             <pc:sldMk cId="333356922" sldId="256"/>
@@ -236,15 +244,15 @@
           </ac:spMkLst>
         </pc:spChg>
         <pc:spChg chg="mod topLvl">
-          <ac:chgData name="Zihao Viston Wang" userId="bb38f0bb24686ff5" providerId="LiveId" clId="{624A8E29-C0AB-51FB-8E4A-8A86974DAEAD}" dt="2026-05-31T06:44:22.157" v="154" actId="14838"/>
+          <ac:chgData name="Zihao Viston Wang" userId="bb38f0bb24686ff5" providerId="LiveId" clId="{624A8E29-C0AB-51FB-8E4A-8A86974DAEAD}" dt="2026-06-07T10:35:34.008" v="831" actId="164"/>
           <ac:spMkLst>
             <pc:docMk/>
             <pc:sldMk cId="333356922" sldId="256"/>
             <ac:spMk id="148" creationId="{588CD81A-EBE5-F650-0647-CF07B883CE23}"/>
           </ac:spMkLst>
         </pc:spChg>
-        <pc:spChg chg="mod">
-          <ac:chgData name="Zihao Viston Wang" userId="bb38f0bb24686ff5" providerId="LiveId" clId="{624A8E29-C0AB-51FB-8E4A-8A86974DAEAD}" dt="2026-05-31T06:37:34.497" v="14" actId="207"/>
+        <pc:spChg chg="mod topLvl">
+          <ac:chgData name="Zihao Viston Wang" userId="bb38f0bb24686ff5" providerId="LiveId" clId="{624A8E29-C0AB-51FB-8E4A-8A86974DAEAD}" dt="2026-06-07T10:35:34.008" v="831" actId="164"/>
           <ac:spMkLst>
             <pc:docMk/>
             <pc:sldMk cId="333356922" sldId="256"/>
@@ -252,15 +260,15 @@
           </ac:spMkLst>
         </pc:spChg>
         <pc:spChg chg="mod topLvl">
-          <ac:chgData name="Zihao Viston Wang" userId="bb38f0bb24686ff5" providerId="LiveId" clId="{624A8E29-C0AB-51FB-8E4A-8A86974DAEAD}" dt="2026-05-31T06:44:22.157" v="154" actId="14838"/>
+          <ac:chgData name="Zihao Viston Wang" userId="bb38f0bb24686ff5" providerId="LiveId" clId="{624A8E29-C0AB-51FB-8E4A-8A86974DAEAD}" dt="2026-06-07T10:35:34.008" v="831" actId="164"/>
           <ac:spMkLst>
             <pc:docMk/>
             <pc:sldMk cId="333356922" sldId="256"/>
             <ac:spMk id="162" creationId="{6778955A-4814-046A-650F-24AC5D48E585}"/>
           </ac:spMkLst>
         </pc:spChg>
-        <pc:spChg chg="mod topLvl">
-          <ac:chgData name="Zihao Viston Wang" userId="bb38f0bb24686ff5" providerId="LiveId" clId="{624A8E29-C0AB-51FB-8E4A-8A86974DAEAD}" dt="2026-05-31T06:40:34.248" v="47" actId="164"/>
+        <pc:spChg chg="del mod topLvl">
+          <ac:chgData name="Zihao Viston Wang" userId="bb38f0bb24686ff5" providerId="LiveId" clId="{624A8E29-C0AB-51FB-8E4A-8A86974DAEAD}" dt="2026-06-07T10:21:25.332" v="270" actId="478"/>
           <ac:spMkLst>
             <pc:docMk/>
             <pc:sldMk cId="333356922" sldId="256"/>
@@ -356,7 +364,7 @@
           </ac:cxnSpMkLst>
         </pc:cxnChg>
         <pc:cxnChg chg="mod">
-          <ac:chgData name="Zihao Viston Wang" userId="bb38f0bb24686ff5" providerId="LiveId" clId="{624A8E29-C0AB-51FB-8E4A-8A86974DAEAD}" dt="2026-05-31T06:37:57.269" v="16" actId="692"/>
+          <ac:chgData name="Zihao Viston Wang" userId="bb38f0bb24686ff5" providerId="LiveId" clId="{624A8E29-C0AB-51FB-8E4A-8A86974DAEAD}" dt="2026-06-07T10:33:40.709" v="725" actId="14100"/>
           <ac:cxnSpMkLst>
             <pc:docMk/>
             <pc:sldMk cId="333356922" sldId="256"/>
@@ -364,7 +372,7 @@
           </ac:cxnSpMkLst>
         </pc:cxnChg>
         <pc:cxnChg chg="mod">
-          <ac:chgData name="Zihao Viston Wang" userId="bb38f0bb24686ff5" providerId="LiveId" clId="{624A8E29-C0AB-51FB-8E4A-8A86974DAEAD}" dt="2026-05-31T06:37:57.269" v="16" actId="692"/>
+          <ac:chgData name="Zihao Viston Wang" userId="bb38f0bb24686ff5" providerId="LiveId" clId="{624A8E29-C0AB-51FB-8E4A-8A86974DAEAD}" dt="2026-06-07T10:34:33.998" v="777" actId="14100"/>
           <ac:cxnSpMkLst>
             <pc:docMk/>
             <pc:sldMk cId="333356922" sldId="256"/>
@@ -404,7 +412,15 @@
           </ac:cxnSpMkLst>
         </pc:cxnChg>
         <pc:cxnChg chg="mod">
-          <ac:chgData name="Zihao Viston Wang" userId="bb38f0bb24686ff5" providerId="LiveId" clId="{624A8E29-C0AB-51FB-8E4A-8A86974DAEAD}" dt="2026-05-31T06:37:57.269" v="16" actId="692"/>
+          <ac:chgData name="Zihao Viston Wang" userId="bb38f0bb24686ff5" providerId="LiveId" clId="{624A8E29-C0AB-51FB-8E4A-8A86974DAEAD}" dt="2026-06-07T10:34:08.332" v="761" actId="14100"/>
+          <ac:cxnSpMkLst>
+            <pc:docMk/>
+            <pc:sldMk cId="333356922" sldId="256"/>
+            <ac:cxnSpMk id="133" creationId="{B4F80F3B-6B12-A477-80AF-BC2FCD302367}"/>
+          </ac:cxnSpMkLst>
+        </pc:cxnChg>
+        <pc:cxnChg chg="mod">
+          <ac:chgData name="Zihao Viston Wang" userId="bb38f0bb24686ff5" providerId="LiveId" clId="{624A8E29-C0AB-51FB-8E4A-8A86974DAEAD}" dt="2026-06-07T10:34:22.734" v="768" actId="14100"/>
           <ac:cxnSpMkLst>
             <pc:docMk/>
             <pc:sldMk cId="333356922" sldId="256"/>
@@ -428,14 +444,14 @@
           </ac:cxnSpMkLst>
         </pc:cxnChg>
       </pc:sldChg>
-      <pc:sldChg chg="addSp delSp modSp mod">
-        <pc:chgData name="Zihao Viston Wang" userId="bb38f0bb24686ff5" providerId="LiveId" clId="{624A8E29-C0AB-51FB-8E4A-8A86974DAEAD}" dt="2026-05-31T06:45:12.503" v="231" actId="14838"/>
+      <pc:sldChg chg="addSp delSp modSp mod setBg">
+        <pc:chgData name="Zihao Viston Wang" userId="bb38f0bb24686ff5" providerId="LiveId" clId="{624A8E29-C0AB-51FB-8E4A-8A86974DAEAD}" dt="2026-06-07T10:36:10.071" v="832" actId="164"/>
         <pc:sldMkLst>
           <pc:docMk/>
           <pc:sldMk cId="1547542409" sldId="258"/>
         </pc:sldMkLst>
-        <pc:spChg chg="mod">
-          <ac:chgData name="Zihao Viston Wang" userId="bb38f0bb24686ff5" providerId="LiveId" clId="{624A8E29-C0AB-51FB-8E4A-8A86974DAEAD}" dt="2026-05-31T06:45:12.503" v="231" actId="14838"/>
+        <pc:spChg chg="mod topLvl">
+          <ac:chgData name="Zihao Viston Wang" userId="bb38f0bb24686ff5" providerId="LiveId" clId="{624A8E29-C0AB-51FB-8E4A-8A86974DAEAD}" dt="2026-06-07T10:36:10.071" v="832" actId="164"/>
           <ac:spMkLst>
             <pc:docMk/>
             <pc:sldMk cId="1547542409" sldId="258"/>
@@ -443,7 +459,7 @@
           </ac:spMkLst>
         </pc:spChg>
         <pc:spChg chg="mod topLvl">
-          <ac:chgData name="Zihao Viston Wang" userId="bb38f0bb24686ff5" providerId="LiveId" clId="{624A8E29-C0AB-51FB-8E4A-8A86974DAEAD}" dt="2026-05-31T06:40:06.897" v="46" actId="164"/>
+          <ac:chgData name="Zihao Viston Wang" userId="bb38f0bb24686ff5" providerId="LiveId" clId="{624A8E29-C0AB-51FB-8E4A-8A86974DAEAD}" dt="2026-06-07T10:36:10.071" v="832" actId="164"/>
           <ac:spMkLst>
             <pc:docMk/>
             <pc:sldMk cId="1547542409" sldId="258"/>
@@ -451,7 +467,15 @@
           </ac:spMkLst>
         </pc:spChg>
         <pc:spChg chg="mod topLvl">
-          <ac:chgData name="Zihao Viston Wang" userId="bb38f0bb24686ff5" providerId="LiveId" clId="{624A8E29-C0AB-51FB-8E4A-8A86974DAEAD}" dt="2026-05-31T06:40:06.897" v="46" actId="164"/>
+          <ac:chgData name="Zihao Viston Wang" userId="bb38f0bb24686ff5" providerId="LiveId" clId="{624A8E29-C0AB-51FB-8E4A-8A86974DAEAD}" dt="2026-06-07T10:36:10.071" v="832" actId="164"/>
+          <ac:spMkLst>
+            <pc:docMk/>
+            <pc:sldMk cId="1547542409" sldId="258"/>
+            <ac:spMk id="44" creationId="{229C2A88-878E-31A0-D93F-B0E7A1CAEB54}"/>
+          </ac:spMkLst>
+        </pc:spChg>
+        <pc:spChg chg="mod topLvl">
+          <ac:chgData name="Zihao Viston Wang" userId="bb38f0bb24686ff5" providerId="LiveId" clId="{624A8E29-C0AB-51FB-8E4A-8A86974DAEAD}" dt="2026-06-07T10:36:10.071" v="832" actId="164"/>
           <ac:spMkLst>
             <pc:docMk/>
             <pc:sldMk cId="1547542409" sldId="258"/>
@@ -459,7 +483,7 @@
           </ac:spMkLst>
         </pc:spChg>
         <pc:spChg chg="mod">
-          <ac:chgData name="Zihao Viston Wang" userId="bb38f0bb24686ff5" providerId="LiveId" clId="{624A8E29-C0AB-51FB-8E4A-8A86974DAEAD}" dt="2026-05-31T06:45:12.503" v="231" actId="14838"/>
+          <ac:chgData name="Zihao Viston Wang" userId="bb38f0bb24686ff5" providerId="LiveId" clId="{624A8E29-C0AB-51FB-8E4A-8A86974DAEAD}" dt="2026-06-07T10:30:24.076" v="532" actId="1035"/>
           <ac:spMkLst>
             <pc:docMk/>
             <pc:sldMk cId="1547542409" sldId="258"/>
@@ -467,7 +491,7 @@
           </ac:spMkLst>
         </pc:spChg>
         <pc:spChg chg="mod topLvl">
-          <ac:chgData name="Zihao Viston Wang" userId="bb38f0bb24686ff5" providerId="LiveId" clId="{624A8E29-C0AB-51FB-8E4A-8A86974DAEAD}" dt="2026-05-31T06:45:12.503" v="231" actId="14838"/>
+          <ac:chgData name="Zihao Viston Wang" userId="bb38f0bb24686ff5" providerId="LiveId" clId="{624A8E29-C0AB-51FB-8E4A-8A86974DAEAD}" dt="2026-06-07T10:36:10.071" v="832" actId="164"/>
           <ac:spMkLst>
             <pc:docMk/>
             <pc:sldMk cId="1547542409" sldId="258"/>
@@ -475,7 +499,7 @@
           </ac:spMkLst>
         </pc:spChg>
         <pc:spChg chg="mod topLvl">
-          <ac:chgData name="Zihao Viston Wang" userId="bb38f0bb24686ff5" providerId="LiveId" clId="{624A8E29-C0AB-51FB-8E4A-8A86974DAEAD}" dt="2026-05-31T06:45:12.503" v="231" actId="14838"/>
+          <ac:chgData name="Zihao Viston Wang" userId="bb38f0bb24686ff5" providerId="LiveId" clId="{624A8E29-C0AB-51FB-8E4A-8A86974DAEAD}" dt="2026-06-07T10:30:24.076" v="532" actId="1035"/>
           <ac:spMkLst>
             <pc:docMk/>
             <pc:sldMk cId="1547542409" sldId="258"/>
@@ -483,7 +507,7 @@
           </ac:spMkLst>
         </pc:spChg>
         <pc:spChg chg="mod topLvl">
-          <ac:chgData name="Zihao Viston Wang" userId="bb38f0bb24686ff5" providerId="LiveId" clId="{624A8E29-C0AB-51FB-8E4A-8A86974DAEAD}" dt="2026-05-31T06:45:12.503" v="231" actId="14838"/>
+          <ac:chgData name="Zihao Viston Wang" userId="bb38f0bb24686ff5" providerId="LiveId" clId="{624A8E29-C0AB-51FB-8E4A-8A86974DAEAD}" dt="2026-06-07T10:36:10.071" v="832" actId="164"/>
           <ac:spMkLst>
             <pc:docMk/>
             <pc:sldMk cId="1547542409" sldId="258"/>
@@ -491,7 +515,7 @@
           </ac:spMkLst>
         </pc:spChg>
         <pc:spChg chg="mod">
-          <ac:chgData name="Zihao Viston Wang" userId="bb38f0bb24686ff5" providerId="LiveId" clId="{624A8E29-C0AB-51FB-8E4A-8A86974DAEAD}" dt="2026-05-31T06:45:12.503" v="231" actId="14838"/>
+          <ac:chgData name="Zihao Viston Wang" userId="bb38f0bb24686ff5" providerId="LiveId" clId="{624A8E29-C0AB-51FB-8E4A-8A86974DAEAD}" dt="2026-06-07T10:30:33.400" v="539" actId="1035"/>
           <ac:spMkLst>
             <pc:docMk/>
             <pc:sldMk cId="1547542409" sldId="258"/>
@@ -499,7 +523,7 @@
           </ac:spMkLst>
         </pc:spChg>
         <pc:spChg chg="mod topLvl">
-          <ac:chgData name="Zihao Viston Wang" userId="bb38f0bb24686ff5" providerId="LiveId" clId="{624A8E29-C0AB-51FB-8E4A-8A86974DAEAD}" dt="2026-05-31T06:45:12.503" v="231" actId="14838"/>
+          <ac:chgData name="Zihao Viston Wang" userId="bb38f0bb24686ff5" providerId="LiveId" clId="{624A8E29-C0AB-51FB-8E4A-8A86974DAEAD}" dt="2026-06-07T10:30:33.400" v="539" actId="1035"/>
           <ac:spMkLst>
             <pc:docMk/>
             <pc:sldMk cId="1547542409" sldId="258"/>
@@ -507,7 +531,7 @@
           </ac:spMkLst>
         </pc:spChg>
         <pc:spChg chg="mod topLvl">
-          <ac:chgData name="Zihao Viston Wang" userId="bb38f0bb24686ff5" providerId="LiveId" clId="{624A8E29-C0AB-51FB-8E4A-8A86974DAEAD}" dt="2026-05-31T06:40:06.897" v="46" actId="164"/>
+          <ac:chgData name="Zihao Viston Wang" userId="bb38f0bb24686ff5" providerId="LiveId" clId="{624A8E29-C0AB-51FB-8E4A-8A86974DAEAD}" dt="2026-06-07T10:36:10.071" v="832" actId="164"/>
           <ac:spMkLst>
             <pc:docMk/>
             <pc:sldMk cId="1547542409" sldId="258"/>
@@ -515,15 +539,15 @@
           </ac:spMkLst>
         </pc:spChg>
         <pc:spChg chg="mod topLvl">
-          <ac:chgData name="Zihao Viston Wang" userId="bb38f0bb24686ff5" providerId="LiveId" clId="{624A8E29-C0AB-51FB-8E4A-8A86974DAEAD}" dt="2026-05-31T06:40:06.897" v="46" actId="164"/>
+          <ac:chgData name="Zihao Viston Wang" userId="bb38f0bb24686ff5" providerId="LiveId" clId="{624A8E29-C0AB-51FB-8E4A-8A86974DAEAD}" dt="2026-06-07T10:36:10.071" v="832" actId="164"/>
           <ac:spMkLst>
             <pc:docMk/>
             <pc:sldMk cId="1547542409" sldId="258"/>
             <ac:spMk id="132" creationId="{D3DA2F39-3C0A-96BA-7808-EEA1D741A49C}"/>
           </ac:spMkLst>
         </pc:spChg>
-        <pc:spChg chg="mod">
-          <ac:chgData name="Zihao Viston Wang" userId="bb38f0bb24686ff5" providerId="LiveId" clId="{624A8E29-C0AB-51FB-8E4A-8A86974DAEAD}" dt="2026-05-31T06:45:12.503" v="231" actId="14838"/>
+        <pc:spChg chg="mod topLvl">
+          <ac:chgData name="Zihao Viston Wang" userId="bb38f0bb24686ff5" providerId="LiveId" clId="{624A8E29-C0AB-51FB-8E4A-8A86974DAEAD}" dt="2026-06-07T10:36:10.071" v="832" actId="164"/>
           <ac:spMkLst>
             <pc:docMk/>
             <pc:sldMk cId="1547542409" sldId="258"/>
@@ -531,7 +555,7 @@
           </ac:spMkLst>
         </pc:spChg>
         <pc:spChg chg="mod topLvl">
-          <ac:chgData name="Zihao Viston Wang" userId="bb38f0bb24686ff5" providerId="LiveId" clId="{624A8E29-C0AB-51FB-8E4A-8A86974DAEAD}" dt="2026-05-31T06:45:12.503" v="231" actId="14838"/>
+          <ac:chgData name="Zihao Viston Wang" userId="bb38f0bb24686ff5" providerId="LiveId" clId="{624A8E29-C0AB-51FB-8E4A-8A86974DAEAD}" dt="2026-06-07T10:30:53.862" v="560" actId="1038"/>
           <ac:spMkLst>
             <pc:docMk/>
             <pc:sldMk cId="1547542409" sldId="258"/>
@@ -539,15 +563,31 @@
           </ac:spMkLst>
         </pc:spChg>
         <pc:spChg chg="mod topLvl">
-          <ac:chgData name="Zihao Viston Wang" userId="bb38f0bb24686ff5" providerId="LiveId" clId="{624A8E29-C0AB-51FB-8E4A-8A86974DAEAD}" dt="2026-05-31T06:45:12.503" v="231" actId="14838"/>
+          <ac:chgData name="Zihao Viston Wang" userId="bb38f0bb24686ff5" providerId="LiveId" clId="{624A8E29-C0AB-51FB-8E4A-8A86974DAEAD}" dt="2026-06-07T10:30:53.862" v="560" actId="1038"/>
           <ac:spMkLst>
             <pc:docMk/>
             <pc:sldMk cId="1547542409" sldId="258"/>
             <ac:spMk id="162" creationId="{1031C39A-5B31-AD31-751D-863FD8DBA28B}"/>
           </ac:spMkLst>
         </pc:spChg>
-        <pc:picChg chg="mod">
-          <ac:chgData name="Zihao Viston Wang" userId="bb38f0bb24686ff5" providerId="LiveId" clId="{624A8E29-C0AB-51FB-8E4A-8A86974DAEAD}" dt="2026-05-31T06:39:33.374" v="44" actId="692"/>
+        <pc:spChg chg="mod topLvl">
+          <ac:chgData name="Zihao Viston Wang" userId="bb38f0bb24686ff5" providerId="LiveId" clId="{624A8E29-C0AB-51FB-8E4A-8A86974DAEAD}" dt="2026-06-07T10:36:10.071" v="832" actId="164"/>
+          <ac:spMkLst>
+            <pc:docMk/>
+            <pc:sldMk cId="1547542409" sldId="258"/>
+            <ac:spMk id="163" creationId="{66129CBA-1CCC-9DA7-573E-0AC281B7519C}"/>
+          </ac:spMkLst>
+        </pc:spChg>
+        <pc:picChg chg="add mod">
+          <ac:chgData name="Zihao Viston Wang" userId="bb38f0bb24686ff5" providerId="LiveId" clId="{624A8E29-C0AB-51FB-8E4A-8A86974DAEAD}" dt="2026-06-07T10:22:22.569" v="280"/>
+          <ac:picMkLst>
+            <pc:docMk/>
+            <pc:sldMk cId="1547542409" sldId="258"/>
+            <ac:picMk id="3" creationId="{EAAA91B4-518E-60CC-8033-ED0939B8D295}"/>
+          </ac:picMkLst>
+        </pc:picChg>
+        <pc:picChg chg="del mod">
+          <ac:chgData name="Zihao Viston Wang" userId="bb38f0bb24686ff5" providerId="LiveId" clId="{624A8E29-C0AB-51FB-8E4A-8A86974DAEAD}" dt="2026-06-07T10:22:22.062" v="279" actId="478"/>
           <ac:picMkLst>
             <pc:docMk/>
             <pc:sldMk cId="1547542409" sldId="258"/>
@@ -555,7 +595,7 @@
           </ac:picMkLst>
         </pc:picChg>
         <pc:cxnChg chg="mod">
-          <ac:chgData name="Zihao Viston Wang" userId="bb38f0bb24686ff5" providerId="LiveId" clId="{624A8E29-C0AB-51FB-8E4A-8A86974DAEAD}" dt="2026-05-31T06:39:33.374" v="44" actId="692"/>
+          <ac:chgData name="Zihao Viston Wang" userId="bb38f0bb24686ff5" providerId="LiveId" clId="{624A8E29-C0AB-51FB-8E4A-8A86974DAEAD}" dt="2026-06-07T10:30:12.463" v="524" actId="14100"/>
           <ac:cxnSpMkLst>
             <pc:docMk/>
             <pc:sldMk cId="1547542409" sldId="258"/>
@@ -571,7 +611,7 @@
           </ac:cxnSpMkLst>
         </pc:cxnChg>
         <pc:cxnChg chg="mod">
-          <ac:chgData name="Zihao Viston Wang" userId="bb38f0bb24686ff5" providerId="LiveId" clId="{624A8E29-C0AB-51FB-8E4A-8A86974DAEAD}" dt="2026-05-31T06:39:33.374" v="44" actId="692"/>
+          <ac:chgData name="Zihao Viston Wang" userId="bb38f0bb24686ff5" providerId="LiveId" clId="{624A8E29-C0AB-51FB-8E4A-8A86974DAEAD}" dt="2026-06-07T10:30:07.950" v="523" actId="14100"/>
           <ac:cxnSpMkLst>
             <pc:docMk/>
             <pc:sldMk cId="1547542409" sldId="258"/>
@@ -579,7 +619,7 @@
           </ac:cxnSpMkLst>
         </pc:cxnChg>
         <pc:cxnChg chg="mod">
-          <ac:chgData name="Zihao Viston Wang" userId="bb38f0bb24686ff5" providerId="LiveId" clId="{624A8E29-C0AB-51FB-8E4A-8A86974DAEAD}" dt="2026-05-31T06:39:33.374" v="44" actId="692"/>
+          <ac:chgData name="Zihao Viston Wang" userId="bb38f0bb24686ff5" providerId="LiveId" clId="{624A8E29-C0AB-51FB-8E4A-8A86974DAEAD}" dt="2026-06-07T10:29:51.006" v="522" actId="14100"/>
           <ac:cxnSpMkLst>
             <pc:docMk/>
             <pc:sldMk cId="1547542409" sldId="258"/>
@@ -595,7 +635,7 @@
           </ac:cxnSpMkLst>
         </pc:cxnChg>
         <pc:cxnChg chg="mod">
-          <ac:chgData name="Zihao Viston Wang" userId="bb38f0bb24686ff5" providerId="LiveId" clId="{624A8E29-C0AB-51FB-8E4A-8A86974DAEAD}" dt="2026-05-31T06:39:33.374" v="44" actId="692"/>
+          <ac:chgData name="Zihao Viston Wang" userId="bb38f0bb24686ff5" providerId="LiveId" clId="{624A8E29-C0AB-51FB-8E4A-8A86974DAEAD}" dt="2026-06-07T10:29:47.509" v="521" actId="14100"/>
           <ac:cxnSpMkLst>
             <pc:docMk/>
             <pc:sldMk cId="1547542409" sldId="258"/>
@@ -611,7 +651,7 @@
           </ac:cxnSpMkLst>
         </pc:cxnChg>
         <pc:cxnChg chg="mod">
-          <ac:chgData name="Zihao Viston Wang" userId="bb38f0bb24686ff5" providerId="LiveId" clId="{624A8E29-C0AB-51FB-8E4A-8A86974DAEAD}" dt="2026-05-31T06:39:33.374" v="44" actId="692"/>
+          <ac:chgData name="Zihao Viston Wang" userId="bb38f0bb24686ff5" providerId="LiveId" clId="{624A8E29-C0AB-51FB-8E4A-8A86974DAEAD}" dt="2026-06-07T10:22:34.544" v="281" actId="166"/>
           <ac:cxnSpMkLst>
             <pc:docMk/>
             <pc:sldMk cId="1547542409" sldId="258"/>
@@ -619,7 +659,7 @@
           </ac:cxnSpMkLst>
         </pc:cxnChg>
         <pc:cxnChg chg="mod">
-          <ac:chgData name="Zihao Viston Wang" userId="bb38f0bb24686ff5" providerId="LiveId" clId="{624A8E29-C0AB-51FB-8E4A-8A86974DAEAD}" dt="2026-05-31T06:39:33.374" v="44" actId="692"/>
+          <ac:chgData name="Zihao Viston Wang" userId="bb38f0bb24686ff5" providerId="LiveId" clId="{624A8E29-C0AB-51FB-8E4A-8A86974DAEAD}" dt="2026-06-07T10:22:34.544" v="281" actId="166"/>
           <ac:cxnSpMkLst>
             <pc:docMk/>
             <pc:sldMk cId="1547542409" sldId="258"/>
@@ -627,7 +667,7 @@
           </ac:cxnSpMkLst>
         </pc:cxnChg>
         <pc:cxnChg chg="mod">
-          <ac:chgData name="Zihao Viston Wang" userId="bb38f0bb24686ff5" providerId="LiveId" clId="{624A8E29-C0AB-51FB-8E4A-8A86974DAEAD}" dt="2026-05-31T06:39:54.006" v="45" actId="692"/>
+          <ac:chgData name="Zihao Viston Wang" userId="bb38f0bb24686ff5" providerId="LiveId" clId="{624A8E29-C0AB-51FB-8E4A-8A86974DAEAD}" dt="2026-06-07T10:27:38.537" v="399" actId="554"/>
           <ac:cxnSpMkLst>
             <pc:docMk/>
             <pc:sldMk cId="1547542409" sldId="258"/>
@@ -643,7 +683,7 @@
           </ac:cxnSpMkLst>
         </pc:cxnChg>
         <pc:cxnChg chg="mod">
-          <ac:chgData name="Zihao Viston Wang" userId="bb38f0bb24686ff5" providerId="LiveId" clId="{624A8E29-C0AB-51FB-8E4A-8A86974DAEAD}" dt="2026-05-31T06:39:54.006" v="45" actId="692"/>
+          <ac:chgData name="Zihao Viston Wang" userId="bb38f0bb24686ff5" providerId="LiveId" clId="{624A8E29-C0AB-51FB-8E4A-8A86974DAEAD}" dt="2026-06-07T10:27:38.537" v="399" actId="554"/>
           <ac:cxnSpMkLst>
             <pc:docMk/>
             <pc:sldMk cId="1547542409" sldId="258"/>
@@ -651,11 +691,19 @@
           </ac:cxnSpMkLst>
         </pc:cxnChg>
         <pc:cxnChg chg="mod">
-          <ac:chgData name="Zihao Viston Wang" userId="bb38f0bb24686ff5" providerId="LiveId" clId="{624A8E29-C0AB-51FB-8E4A-8A86974DAEAD}" dt="2026-05-31T06:39:54.006" v="45" actId="692"/>
+          <ac:chgData name="Zihao Viston Wang" userId="bb38f0bb24686ff5" providerId="LiveId" clId="{624A8E29-C0AB-51FB-8E4A-8A86974DAEAD}" dt="2026-06-07T10:31:00.556" v="561" actId="14100"/>
           <ac:cxnSpMkLst>
             <pc:docMk/>
             <pc:sldMk cId="1547542409" sldId="258"/>
             <ac:cxnSpMk id="110" creationId="{E9A3A1CC-0E03-23D0-1B6D-2A5996A5F20C}"/>
+          </ac:cxnSpMkLst>
+        </pc:cxnChg>
+        <pc:cxnChg chg="mod">
+          <ac:chgData name="Zihao Viston Wang" userId="bb38f0bb24686ff5" providerId="LiveId" clId="{624A8E29-C0AB-51FB-8E4A-8A86974DAEAD}" dt="2026-06-07T10:31:15.928" v="563" actId="14100"/>
+          <ac:cxnSpMkLst>
+            <pc:docMk/>
+            <pc:sldMk cId="1547542409" sldId="258"/>
+            <ac:cxnSpMk id="116" creationId="{B389B17F-A6A0-4AD7-CA18-110199B56404}"/>
           </ac:cxnSpMkLst>
         </pc:cxnChg>
         <pc:cxnChg chg="mod">
@@ -675,7 +723,7 @@
           </ac:cxnSpMkLst>
         </pc:cxnChg>
         <pc:cxnChg chg="mod">
-          <ac:chgData name="Zihao Viston Wang" userId="bb38f0bb24686ff5" providerId="LiveId" clId="{624A8E29-C0AB-51FB-8E4A-8A86974DAEAD}" dt="2026-05-31T06:39:54.006" v="45" actId="692"/>
+          <ac:chgData name="Zihao Viston Wang" userId="bb38f0bb24686ff5" providerId="LiveId" clId="{624A8E29-C0AB-51FB-8E4A-8A86974DAEAD}" dt="2026-06-07T10:31:08.689" v="562" actId="14100"/>
           <ac:cxnSpMkLst>
             <pc:docMk/>
             <pc:sldMk cId="1547542409" sldId="258"/>
@@ -683,11 +731,19 @@
           </ac:cxnSpMkLst>
         </pc:cxnChg>
         <pc:cxnChg chg="mod">
-          <ac:chgData name="Zihao Viston Wang" userId="bb38f0bb24686ff5" providerId="LiveId" clId="{624A8E29-C0AB-51FB-8E4A-8A86974DAEAD}" dt="2026-05-31T06:39:54.006" v="45" actId="692"/>
+          <ac:chgData name="Zihao Viston Wang" userId="bb38f0bb24686ff5" providerId="LiveId" clId="{624A8E29-C0AB-51FB-8E4A-8A86974DAEAD}" dt="2026-06-07T10:27:38.537" v="399" actId="554"/>
           <ac:cxnSpMkLst>
             <pc:docMk/>
             <pc:sldMk cId="1547542409" sldId="258"/>
             <ac:cxnSpMk id="133" creationId="{383399E7-0A8B-B5F3-8CAD-E4AB6C23D595}"/>
+          </ac:cxnSpMkLst>
+        </pc:cxnChg>
+        <pc:cxnChg chg="mod">
+          <ac:chgData name="Zihao Viston Wang" userId="bb38f0bb24686ff5" providerId="LiveId" clId="{624A8E29-C0AB-51FB-8E4A-8A86974DAEAD}" dt="2026-06-07T10:27:38.537" v="399" actId="554"/>
+          <ac:cxnSpMkLst>
+            <pc:docMk/>
+            <pc:sldMk cId="1547542409" sldId="258"/>
+            <ac:cxnSpMk id="138" creationId="{5B05E6EA-4C33-697C-3B34-833C7E2DB7CE}"/>
           </ac:cxnSpMkLst>
         </pc:cxnChg>
         <pc:cxnChg chg="mod">
@@ -794,7 +850,7 @@
           <a:p>
             <a:fld id="{23656DED-251E-404A-A174-6D96B007F581}" type="datetimeFigureOut">
               <a:rPr kumimoji="1" lang="zh-CN" altLang="en-US" smtClean="0"/>
-              <a:t>2026/5/31</a:t>
+              <a:t>2026/6/7</a:t>
             </a:fld>
             <a:endParaRPr kumimoji="1" lang="zh-CN" altLang="en-US"/>
           </a:p>
@@ -1292,7 +1348,7 @@
           <a:p>
             <a:fld id="{B9191346-5DF8-1F46-A428-6312BC22D0EA}" type="datetimeFigureOut">
               <a:rPr kumimoji="1" lang="zh-CN" altLang="en-US" smtClean="0"/>
-              <a:t>2026/5/31</a:t>
+              <a:t>2026/6/7</a:t>
             </a:fld>
             <a:endParaRPr kumimoji="1" lang="zh-CN" altLang="en-US"/>
           </a:p>
@@ -1490,7 +1546,7 @@
           <a:p>
             <a:fld id="{B9191346-5DF8-1F46-A428-6312BC22D0EA}" type="datetimeFigureOut">
               <a:rPr kumimoji="1" lang="zh-CN" altLang="en-US" smtClean="0"/>
-              <a:t>2026/5/31</a:t>
+              <a:t>2026/6/7</a:t>
             </a:fld>
             <a:endParaRPr kumimoji="1" lang="zh-CN" altLang="en-US"/>
           </a:p>
@@ -1698,7 +1754,7 @@
           <a:p>
             <a:fld id="{B9191346-5DF8-1F46-A428-6312BC22D0EA}" type="datetimeFigureOut">
               <a:rPr kumimoji="1" lang="zh-CN" altLang="en-US" smtClean="0"/>
-              <a:t>2026/5/31</a:t>
+              <a:t>2026/6/7</a:t>
             </a:fld>
             <a:endParaRPr kumimoji="1" lang="zh-CN" altLang="en-US"/>
           </a:p>
@@ -1896,7 +1952,7 @@
           <a:p>
             <a:fld id="{B9191346-5DF8-1F46-A428-6312BC22D0EA}" type="datetimeFigureOut">
               <a:rPr kumimoji="1" lang="zh-CN" altLang="en-US" smtClean="0"/>
-              <a:t>2026/5/31</a:t>
+              <a:t>2026/6/7</a:t>
             </a:fld>
             <a:endParaRPr kumimoji="1" lang="zh-CN" altLang="en-US"/>
           </a:p>
@@ -2171,7 +2227,7 @@
           <a:p>
             <a:fld id="{B9191346-5DF8-1F46-A428-6312BC22D0EA}" type="datetimeFigureOut">
               <a:rPr kumimoji="1" lang="zh-CN" altLang="en-US" smtClean="0"/>
-              <a:t>2026/5/31</a:t>
+              <a:t>2026/6/7</a:t>
             </a:fld>
             <a:endParaRPr kumimoji="1" lang="zh-CN" altLang="en-US"/>
           </a:p>
@@ -2436,7 +2492,7 @@
           <a:p>
             <a:fld id="{B9191346-5DF8-1F46-A428-6312BC22D0EA}" type="datetimeFigureOut">
               <a:rPr kumimoji="1" lang="zh-CN" altLang="en-US" smtClean="0"/>
-              <a:t>2026/5/31</a:t>
+              <a:t>2026/6/7</a:t>
             </a:fld>
             <a:endParaRPr kumimoji="1" lang="zh-CN" altLang="en-US"/>
           </a:p>
@@ -2848,7 +2904,7 @@
           <a:p>
             <a:fld id="{B9191346-5DF8-1F46-A428-6312BC22D0EA}" type="datetimeFigureOut">
               <a:rPr kumimoji="1" lang="zh-CN" altLang="en-US" smtClean="0"/>
-              <a:t>2026/5/31</a:t>
+              <a:t>2026/6/7</a:t>
             </a:fld>
             <a:endParaRPr kumimoji="1" lang="zh-CN" altLang="en-US"/>
           </a:p>
@@ -2989,7 +3045,7 @@
           <a:p>
             <a:fld id="{B9191346-5DF8-1F46-A428-6312BC22D0EA}" type="datetimeFigureOut">
               <a:rPr kumimoji="1" lang="zh-CN" altLang="en-US" smtClean="0"/>
-              <a:t>2026/5/31</a:t>
+              <a:t>2026/6/7</a:t>
             </a:fld>
             <a:endParaRPr kumimoji="1" lang="zh-CN" altLang="en-US"/>
           </a:p>
@@ -3102,7 +3158,7 @@
           <a:p>
             <a:fld id="{B9191346-5DF8-1F46-A428-6312BC22D0EA}" type="datetimeFigureOut">
               <a:rPr kumimoji="1" lang="zh-CN" altLang="en-US" smtClean="0"/>
-              <a:t>2026/5/31</a:t>
+              <a:t>2026/6/7</a:t>
             </a:fld>
             <a:endParaRPr kumimoji="1" lang="zh-CN" altLang="en-US"/>
           </a:p>
@@ -3413,7 +3469,7 @@
           <a:p>
             <a:fld id="{B9191346-5DF8-1F46-A428-6312BC22D0EA}" type="datetimeFigureOut">
               <a:rPr kumimoji="1" lang="zh-CN" altLang="en-US" smtClean="0"/>
-              <a:t>2026/5/31</a:t>
+              <a:t>2026/6/7</a:t>
             </a:fld>
             <a:endParaRPr kumimoji="1" lang="zh-CN" altLang="en-US"/>
           </a:p>
@@ -3701,7 +3757,7 @@
           <a:p>
             <a:fld id="{B9191346-5DF8-1F46-A428-6312BC22D0EA}" type="datetimeFigureOut">
               <a:rPr kumimoji="1" lang="zh-CN" altLang="en-US" smtClean="0"/>
-              <a:t>2026/5/31</a:t>
+              <a:t>2026/6/7</a:t>
             </a:fld>
             <a:endParaRPr kumimoji="1" lang="zh-CN" altLang="en-US"/>
           </a:p>
@@ -3942,7 +3998,7 @@
           <a:p>
             <a:fld id="{B9191346-5DF8-1F46-A428-6312BC22D0EA}" type="datetimeFigureOut">
               <a:rPr kumimoji="1" lang="zh-CN" altLang="en-US" smtClean="0"/>
-              <a:t>2026/5/31</a:t>
+              <a:t>2026/6/7</a:t>
             </a:fld>
             <a:endParaRPr kumimoji="1" lang="zh-CN" altLang="en-US"/>
           </a:p>
@@ -4361,10 +4417,10 @@
       </p:grpSpPr>
       <p:grpSp>
         <p:nvGrpSpPr>
-          <p:cNvPr id="2" name="组合 1">
+          <p:cNvPr id="9" name="组合 8">
             <a:extLst>
               <a:ext uri="{FF2B5EF4-FFF2-40B4-BE49-F238E27FC236}">
-                <a16:creationId xmlns:a16="http://schemas.microsoft.com/office/drawing/2014/main" id="{858AFEE3-F4E9-BE9C-0E4B-3257FEAEE28C}"/>
+                <a16:creationId xmlns:a16="http://schemas.microsoft.com/office/drawing/2014/main" id="{5B4C918B-C64C-0560-D796-04A1AF75EB0A}"/>
               </a:ext>
             </a:extLst>
           </p:cNvPr>
@@ -4381,10 +4437,10 @@
         </p:grpSpPr>
         <p:sp>
           <p:nvSpPr>
-            <p:cNvPr id="163" name="矩形 162">
+            <p:cNvPr id="3" name="矩形 2">
               <a:extLst>
                 <a:ext uri="{FF2B5EF4-FFF2-40B4-BE49-F238E27FC236}">
-                  <a16:creationId xmlns:a16="http://schemas.microsoft.com/office/drawing/2014/main" id="{0B26C5A9-9D90-3E00-BF36-6D4D5CB15F96}"/>
+                  <a16:creationId xmlns:a16="http://schemas.microsoft.com/office/drawing/2014/main" id="{AFEAB8E9-8454-1FFC-BBF3-33F4CFF89C5B}"/>
                 </a:ext>
               </a:extLst>
             </p:cNvPr>
@@ -4429,11 +4485,13 @@
               <a:pPr algn="ctr"/>
               <a:endParaRPr kumimoji="1" lang="zh-CN" altLang="en-US" b="1">
                 <a:solidFill>
-                  <a:schemeClr val="accent1">
-                    <a:lumMod val="60000"/>
-                    <a:lumOff val="40000"/>
+                  <a:schemeClr val="tx2">
+                    <a:lumMod val="50000"/>
+                    <a:lumOff val="50000"/>
                   </a:schemeClr>
                 </a:solidFill>
+                <a:latin typeface="Maple Mono NF CN" panose="020F0509060000000000" pitchFamily="49" charset="-128"/>
+                <a:ea typeface="Maple Mono NF CN" panose="020F0509060000000000" pitchFamily="49" charset="-128"/>
               </a:endParaRPr>
             </a:p>
           </p:txBody>
@@ -4654,151 +4712,54 @@
           </p:nvSpPr>
           <p:spPr>
             <a:xfrm>
-              <a:off x="869952" y="3408985"/>
-              <a:ext cx="1329210" cy="307777"/>
+              <a:off x="720398" y="3162555"/>
+              <a:ext cx="1613416" cy="553998"/>
             </a:xfrm>
             <a:prstGeom prst="rect">
               <a:avLst/>
             </a:prstGeom>
             <a:noFill/>
+            <a:effectLst/>
           </p:spPr>
           <p:txBody>
-            <a:bodyPr wrap="none" rtlCol="0">
+            <a:bodyPr wrap="square" rtlCol="0">
               <a:spAutoFit/>
             </a:bodyPr>
-            <a:lstStyle/>
+            <a:lstStyle>
+              <a:defPPr>
+                <a:defRPr lang="zh-CN"/>
+              </a:defPPr>
+              <a:lvl1pPr>
+                <a:defRPr sz="1000" b="1">
+                  <a:solidFill>
+                    <a:srgbClr val="0070C0"/>
+                  </a:solidFill>
+                  <a:latin typeface="Maple Mono" panose="020F0509060000000000" pitchFamily="49" charset="0"/>
+                  <a:ea typeface="Maple Mono" panose="020F0509060000000000" pitchFamily="49" charset="0"/>
+                </a:defRPr>
+              </a:lvl1pPr>
+            </a:lstStyle>
             <a:p>
               <a:r>
-                <a:rPr kumimoji="1" lang="en" altLang="zh-CN" sz="700" b="1" i="1" dirty="0">
-                  <a:ln w="3175">
-                    <a:noFill/>
-                  </a:ln>
-                  <a:solidFill>
-                    <a:schemeClr val="tx2">
-                      <a:lumMod val="50000"/>
-                      <a:lumOff val="50000"/>
-                    </a:schemeClr>
-                  </a:solidFill>
-                  <a:effectLst>
-                    <a:outerShdw blurRad="139700" dist="38100" dir="5400000" algn="t" rotWithShape="0">
-                      <a:prstClr val="black">
-                        <a:alpha val="25000"/>
-                      </a:prstClr>
-                    </a:outerShdw>
-                  </a:effectLst>
-                  <a:latin typeface="Maple Mono" panose="020F0509060000000000" pitchFamily="49" charset="0"/>
-                  <a:ea typeface="Maple Mono" panose="020F0509060000000000" pitchFamily="49" charset="0"/>
-                </a:rPr>
+                <a:rPr lang="en" altLang="zh-CN" dirty="0"/>
                 <a:t>Smart Outline </a:t>
               </a:r>
               <a:r>
-                <a:rPr kumimoji="1" lang="en-US" altLang="zh-CN" sz="700" b="1" i="1" dirty="0">
-                  <a:ln w="3175">
-                    <a:noFill/>
-                  </a:ln>
-                  <a:solidFill>
-                    <a:schemeClr val="tx2">
-                      <a:lumMod val="50000"/>
-                      <a:lumOff val="50000"/>
-                    </a:schemeClr>
-                  </a:solidFill>
-                  <a:effectLst>
-                    <a:outerShdw blurRad="139700" dist="38100" dir="5400000" algn="t" rotWithShape="0">
-                      <a:prstClr val="black">
-                        <a:alpha val="25000"/>
-                      </a:prstClr>
-                    </a:outerShdw>
-                  </a:effectLst>
-                  <a:latin typeface="Maple Mono" panose="020F0509060000000000" pitchFamily="49" charset="0"/>
-                  <a:ea typeface="Maple Mono" panose="020F0509060000000000" pitchFamily="49" charset="0"/>
-                </a:rPr>
+                <a:rPr lang="en-US" altLang="zh-CN" dirty="0"/>
                 <a:t>&amp;</a:t>
               </a:r>
               <a:r>
-                <a:rPr kumimoji="1" lang="zh-CN" altLang="en-US" sz="700" b="1" i="1" dirty="0">
-                  <a:ln w="3175">
-                    <a:noFill/>
-                  </a:ln>
-                  <a:solidFill>
-                    <a:schemeClr val="tx2">
-                      <a:lumMod val="50000"/>
-                      <a:lumOff val="50000"/>
-                    </a:schemeClr>
-                  </a:solidFill>
-                  <a:effectLst>
-                    <a:outerShdw blurRad="139700" dist="38100" dir="5400000" algn="t" rotWithShape="0">
-                      <a:prstClr val="black">
-                        <a:alpha val="25000"/>
-                      </a:prstClr>
-                    </a:outerShdw>
-                  </a:effectLst>
-                  <a:latin typeface="Maple Mono" panose="020F0509060000000000" pitchFamily="49" charset="0"/>
-                </a:rPr>
+                <a:rPr lang="zh-CN" altLang="en-US" dirty="0"/>
                 <a:t> </a:t>
               </a:r>
-              <a:endParaRPr kumimoji="1" lang="en-US" altLang="zh-CN" sz="700" b="1" i="1" dirty="0">
-                <a:ln w="3175">
-                  <a:noFill/>
-                </a:ln>
-                <a:solidFill>
-                  <a:schemeClr val="tx2">
-                    <a:lumMod val="50000"/>
-                    <a:lumOff val="50000"/>
-                  </a:schemeClr>
-                </a:solidFill>
-                <a:effectLst>
-                  <a:outerShdw blurRad="139700" dist="38100" dir="5400000" algn="t" rotWithShape="0">
-                    <a:prstClr val="black">
-                      <a:alpha val="25000"/>
-                    </a:prstClr>
-                  </a:outerShdw>
-                </a:effectLst>
-                <a:latin typeface="Maple Mono" panose="020F0509060000000000" pitchFamily="49" charset="0"/>
-              </a:endParaRPr>
+              <a:endParaRPr lang="en-US" altLang="zh-CN" dirty="0"/>
             </a:p>
             <a:p>
               <a:r>
-                <a:rPr kumimoji="1" lang="en" altLang="zh-CN" sz="700" b="1" i="1" dirty="0">
-                  <a:ln w="3175">
-                    <a:noFill/>
-                  </a:ln>
-                  <a:solidFill>
-                    <a:schemeClr val="tx2">
-                      <a:lumMod val="50000"/>
-                      <a:lumOff val="50000"/>
-                    </a:schemeClr>
-                  </a:solidFill>
-                  <a:effectLst>
-                    <a:outerShdw blurRad="139700" dist="38100" dir="5400000" algn="t" rotWithShape="0">
-                      <a:prstClr val="black">
-                        <a:alpha val="25000"/>
-                      </a:prstClr>
-                    </a:outerShdw>
-                  </a:effectLst>
-                  <a:latin typeface="Maple Mono" panose="020F0509060000000000" pitchFamily="49" charset="0"/>
-                  <a:ea typeface="Maple Mono" panose="020F0509060000000000" pitchFamily="49" charset="0"/>
-                </a:rPr>
+                <a:rPr lang="en" altLang="zh-CN" dirty="0"/>
                 <a:t>Structural Navigation</a:t>
               </a:r>
-              <a:endParaRPr kumimoji="1" lang="zh-CN" altLang="en-US" sz="700" b="1" i="1" dirty="0">
-                <a:ln w="3175">
-                  <a:noFill/>
-                </a:ln>
-                <a:solidFill>
-                  <a:schemeClr val="tx2">
-                    <a:lumMod val="50000"/>
-                    <a:lumOff val="50000"/>
-                  </a:schemeClr>
-                </a:solidFill>
-                <a:effectLst>
-                  <a:outerShdw blurRad="139700" dist="38100" dir="5400000" algn="t" rotWithShape="0">
-                    <a:prstClr val="black">
-                      <a:alpha val="25000"/>
-                    </a:prstClr>
-                  </a:outerShdw>
-                </a:effectLst>
-                <a:latin typeface="Maple Mono" panose="020F0509060000000000" pitchFamily="49" charset="0"/>
-              </a:endParaRPr>
+              <a:endParaRPr lang="zh-CN" altLang="en-US" dirty="0"/>
             </a:p>
           </p:txBody>
         </p:sp>
@@ -4910,87 +4871,45 @@
           </p:nvSpPr>
           <p:spPr>
             <a:xfrm>
-              <a:off x="869952" y="2724348"/>
-              <a:ext cx="1220206" cy="307777"/>
+              <a:off x="732845" y="2471433"/>
+              <a:ext cx="1479141" cy="553998"/>
             </a:xfrm>
             <a:prstGeom prst="rect">
               <a:avLst/>
             </a:prstGeom>
             <a:noFill/>
+            <a:effectLst/>
           </p:spPr>
           <p:txBody>
-            <a:bodyPr wrap="none" rtlCol="0">
+            <a:bodyPr wrap="square" rtlCol="0">
               <a:spAutoFit/>
             </a:bodyPr>
-            <a:lstStyle/>
+            <a:lstStyle>
+              <a:defPPr>
+                <a:defRPr lang="zh-CN"/>
+              </a:defPPr>
+              <a:lvl1pPr>
+                <a:defRPr sz="1000" b="1">
+                  <a:solidFill>
+                    <a:srgbClr val="0070C0"/>
+                  </a:solidFill>
+                  <a:latin typeface="Maple Mono" panose="020F0509060000000000" pitchFamily="49" charset="0"/>
+                  <a:ea typeface="Maple Mono" panose="020F0509060000000000" pitchFamily="49" charset="0"/>
+                </a:defRPr>
+              </a:lvl1pPr>
+            </a:lstStyle>
             <a:p>
               <a:r>
-                <a:rPr kumimoji="1" lang="en" altLang="zh-CN" sz="700" b="1" i="1" dirty="0">
-                  <a:ln w="3175">
-                    <a:noFill/>
-                  </a:ln>
-                  <a:solidFill>
-                    <a:schemeClr val="tx2">
-                      <a:lumMod val="50000"/>
-                      <a:lumOff val="50000"/>
-                    </a:schemeClr>
-                  </a:solidFill>
-                  <a:effectLst>
-                    <a:outerShdw blurRad="139700" dist="38100" dir="5400000" algn="t" rotWithShape="0">
-                      <a:prstClr val="black">
-                        <a:alpha val="25000"/>
-                      </a:prstClr>
-                    </a:outerShdw>
-                  </a:effectLst>
-                  <a:latin typeface="Maple Mono" panose="020F0509060000000000" pitchFamily="49" charset="0"/>
-                  <a:ea typeface="Maple Mono" panose="020F0509060000000000" pitchFamily="49" charset="0"/>
-                </a:rPr>
+                <a:rPr lang="en" altLang="zh-CN" dirty="0"/>
                 <a:t>Multi-level </a:t>
               </a:r>
             </a:p>
             <a:p>
               <a:r>
-                <a:rPr kumimoji="1" lang="en" altLang="zh-CN" sz="700" b="1" i="1" dirty="0">
-                  <a:ln w="3175">
-                    <a:noFill/>
-                  </a:ln>
-                  <a:solidFill>
-                    <a:schemeClr val="tx2">
-                      <a:lumMod val="50000"/>
-                      <a:lumOff val="50000"/>
-                    </a:schemeClr>
-                  </a:solidFill>
-                  <a:effectLst>
-                    <a:outerShdw blurRad="139700" dist="38100" dir="5400000" algn="t" rotWithShape="0">
-                      <a:prstClr val="black">
-                        <a:alpha val="25000"/>
-                      </a:prstClr>
-                    </a:outerShdw>
-                  </a:effectLst>
-                  <a:latin typeface="Maple Mono" panose="020F0509060000000000" pitchFamily="49" charset="0"/>
-                  <a:ea typeface="Maple Mono" panose="020F0509060000000000" pitchFamily="49" charset="0"/>
-                </a:rPr>
+                <a:rPr lang="en" altLang="zh-CN" dirty="0"/>
                 <a:t>Outline Recognition</a:t>
               </a:r>
-              <a:endParaRPr kumimoji="1" lang="zh-CN" altLang="en-US" sz="700" b="1" i="1" dirty="0">
-                <a:ln w="3175">
-                  <a:noFill/>
-                </a:ln>
-                <a:solidFill>
-                  <a:schemeClr val="tx2">
-                    <a:lumMod val="50000"/>
-                    <a:lumOff val="50000"/>
-                  </a:schemeClr>
-                </a:solidFill>
-                <a:effectLst>
-                  <a:outerShdw blurRad="139700" dist="38100" dir="5400000" algn="t" rotWithShape="0">
-                    <a:prstClr val="black">
-                      <a:alpha val="25000"/>
-                    </a:prstClr>
-                  </a:outerShdw>
-                </a:effectLst>
-                <a:latin typeface="Maple Mono" panose="020F0509060000000000" pitchFamily="49" charset="0"/>
-              </a:endParaRPr>
+              <a:endParaRPr lang="zh-CN" altLang="en-US" dirty="0"/>
             </a:p>
           </p:txBody>
         </p:sp>
@@ -5102,62 +5021,39 @@
           </p:nvSpPr>
           <p:spPr>
             <a:xfrm>
-              <a:off x="869952" y="2181195"/>
-              <a:ext cx="1220206" cy="200055"/>
+              <a:off x="732845" y="1980160"/>
+              <a:ext cx="1479141" cy="400110"/>
             </a:xfrm>
             <a:prstGeom prst="rect">
               <a:avLst/>
             </a:prstGeom>
             <a:noFill/>
+            <a:effectLst/>
           </p:spPr>
           <p:txBody>
-            <a:bodyPr wrap="none" rtlCol="0">
+            <a:bodyPr wrap="square" rtlCol="0">
               <a:spAutoFit/>
             </a:bodyPr>
-            <a:lstStyle/>
+            <a:lstStyle>
+              <a:defPPr>
+                <a:defRPr lang="zh-CN"/>
+              </a:defPPr>
+              <a:lvl1pPr>
+                <a:defRPr sz="1000" b="1">
+                  <a:solidFill>
+                    <a:srgbClr val="0070C0"/>
+                  </a:solidFill>
+                  <a:latin typeface="Maple Mono" panose="020F0509060000000000" pitchFamily="49" charset="0"/>
+                  <a:ea typeface="Maple Mono" panose="020F0509060000000000" pitchFamily="49" charset="0"/>
+                </a:defRPr>
+              </a:lvl1pPr>
+            </a:lstStyle>
             <a:p>
               <a:r>
-                <a:rPr kumimoji="1" lang="en" altLang="zh-CN" sz="700" b="1" i="1" dirty="0">
-                  <a:ln w="3175">
-                    <a:noFill/>
-                  </a:ln>
-                  <a:solidFill>
-                    <a:schemeClr val="tx2">
-                      <a:lumMod val="50000"/>
-                      <a:lumOff val="50000"/>
-                    </a:schemeClr>
-                  </a:solidFill>
-                  <a:effectLst>
-                    <a:outerShdw blurRad="139700" dist="38100" dir="5400000" algn="t" rotWithShape="0">
-                      <a:prstClr val="black">
-                        <a:alpha val="25000"/>
-                      </a:prstClr>
-                    </a:outerShdw>
-                  </a:effectLst>
-                  <a:latin typeface="Maple Mono" panose="020F0509060000000000" pitchFamily="49" charset="0"/>
-                  <a:ea typeface="Maple Mono" panose="020F0509060000000000" pitchFamily="49" charset="0"/>
-                </a:rPr>
+                <a:rPr lang="en" altLang="zh-CN" dirty="0"/>
                 <a:t>Syntax Highlighting</a:t>
               </a:r>
-              <a:endParaRPr kumimoji="1" lang="zh-CN" altLang="en-US" sz="700" b="1" i="1" dirty="0">
-                <a:ln w="3175">
-                  <a:noFill/>
-                </a:ln>
-                <a:solidFill>
-                  <a:schemeClr val="tx2">
-                    <a:lumMod val="50000"/>
-                    <a:lumOff val="50000"/>
-                  </a:schemeClr>
-                </a:solidFill>
-                <a:effectLst>
-                  <a:outerShdw blurRad="139700" dist="38100" dir="5400000" algn="t" rotWithShape="0">
-                    <a:prstClr val="black">
-                      <a:alpha val="25000"/>
-                    </a:prstClr>
-                  </a:outerShdw>
-                </a:effectLst>
-                <a:latin typeface="Maple Mono" panose="020F0509060000000000" pitchFamily="49" charset="0"/>
-              </a:endParaRPr>
+              <a:endParaRPr lang="zh-CN" altLang="en-US" dirty="0"/>
             </a:p>
           </p:txBody>
         </p:sp>
@@ -5222,38 +5118,26 @@
           </p:nvSpPr>
           <p:spPr>
             <a:xfrm>
-              <a:off x="869952" y="1264164"/>
-              <a:ext cx="1165704" cy="415498"/>
+              <a:off x="739068" y="972335"/>
+              <a:ext cx="1412004" cy="707886"/>
             </a:xfrm>
             <a:prstGeom prst="rect">
               <a:avLst/>
             </a:prstGeom>
             <a:noFill/>
+            <a:effectLst/>
           </p:spPr>
           <p:txBody>
-            <a:bodyPr wrap="none" rtlCol="0">
+            <a:bodyPr wrap="square" rtlCol="0">
               <a:spAutoFit/>
             </a:bodyPr>
             <a:lstStyle/>
             <a:p>
               <a:r>
-                <a:rPr kumimoji="1" lang="en" altLang="zh-CN" sz="700" b="1" i="1" dirty="0">
-                  <a:ln w="3175">
-                    <a:noFill/>
-                  </a:ln>
+                <a:rPr lang="en" altLang="zh-CN" sz="1000" b="1" dirty="0">
                   <a:solidFill>
-                    <a:schemeClr val="tx2">
-                      <a:lumMod val="50000"/>
-                      <a:lumOff val="50000"/>
-                    </a:schemeClr>
+                    <a:srgbClr val="0070C0"/>
                   </a:solidFill>
-                  <a:effectLst>
-                    <a:outerShdw blurRad="139700" dist="38100" dir="5400000" algn="t" rotWithShape="0">
-                      <a:prstClr val="black">
-                        <a:alpha val="25000"/>
-                      </a:prstClr>
-                    </a:outerShdw>
-                  </a:effectLst>
                   <a:latin typeface="Maple Mono" panose="020F0509060000000000" pitchFamily="49" charset="0"/>
                   <a:ea typeface="Maple Mono" panose="020F0509060000000000" pitchFamily="49" charset="0"/>
                 </a:rPr>
@@ -5262,69 +5146,30 @@
             </a:p>
             <a:p>
               <a:r>
-                <a:rPr kumimoji="1" lang="en" altLang="zh-CN" sz="700" b="1" i="1" dirty="0">
-                  <a:ln w="3175">
-                    <a:noFill/>
-                  </a:ln>
+                <a:rPr lang="en" altLang="zh-CN" sz="1000" b="1" dirty="0">
                   <a:solidFill>
-                    <a:schemeClr val="tx2">
-                      <a:lumMod val="50000"/>
-                      <a:lumOff val="50000"/>
-                    </a:schemeClr>
+                    <a:srgbClr val="0070C0"/>
                   </a:solidFill>
-                  <a:effectLst>
-                    <a:outerShdw blurRad="139700" dist="38100" dir="5400000" algn="t" rotWithShape="0">
-                      <a:prstClr val="black">
-                        <a:alpha val="25000"/>
-                      </a:prstClr>
-                    </a:outerShdw>
-                  </a:effectLst>
                   <a:latin typeface="Maple Mono" panose="020F0509060000000000" pitchFamily="49" charset="0"/>
                   <a:ea typeface="Maple Mono" panose="020F0509060000000000" pitchFamily="49" charset="0"/>
                 </a:rPr>
                 <a:t>the `</a:t>
               </a:r>
               <a:r>
-                <a:rPr kumimoji="1" lang="en" altLang="zh-CN" sz="700" b="1" dirty="0" err="1">
-                  <a:ln w="3175">
-                    <a:noFill/>
-                  </a:ln>
+                <a:rPr lang="en" altLang="zh-CN" sz="1000" b="1" dirty="0" err="1">
                   <a:solidFill>
-                    <a:schemeClr val="tx2">
-                      <a:lumMod val="50000"/>
-                      <a:lumOff val="50000"/>
-                    </a:schemeClr>
+                    <a:srgbClr val="0070C0"/>
                   </a:solidFill>
-                  <a:effectLst>
-                    <a:outerShdw blurRad="139700" dist="38100" dir="5400000" algn="t" rotWithShape="0">
-                      <a:prstClr val="black">
-                        <a:alpha val="25000"/>
-                      </a:prstClr>
-                    </a:outerShdw>
-                  </a:effectLst>
                   <a:latin typeface="Maple Mono" panose="020F0509060000000000" pitchFamily="49" charset="0"/>
                   <a:ea typeface="Maple Mono" panose="020F0509060000000000" pitchFamily="49" charset="0"/>
                 </a:rPr>
                 <a:t>dta</a:t>
               </a:r>
               <a:r>
-                <a:rPr kumimoji="1" lang="en" altLang="zh-CN" sz="700" b="1" i="1" dirty="0">
-                  <a:ln w="3175">
-                    <a:noFill/>
-                  </a:ln>
+                <a:rPr lang="en" altLang="zh-CN" sz="1000" b="1" dirty="0">
                   <a:solidFill>
-                    <a:schemeClr val="tx2">
-                      <a:lumMod val="50000"/>
-                      <a:lumOff val="50000"/>
-                    </a:schemeClr>
+                    <a:srgbClr val="0070C0"/>
                   </a:solidFill>
-                  <a:effectLst>
-                    <a:outerShdw blurRad="139700" dist="38100" dir="5400000" algn="t" rotWithShape="0">
-                      <a:prstClr val="black">
-                        <a:alpha val="25000"/>
-                      </a:prstClr>
-                    </a:outerShdw>
-                  </a:effectLst>
                   <a:latin typeface="Maple Mono" panose="020F0509060000000000" pitchFamily="49" charset="0"/>
                   <a:ea typeface="Maple Mono" panose="020F0509060000000000" pitchFamily="49" charset="0"/>
                 </a:rPr>
@@ -5333,45 +5178,19 @@
             </a:p>
             <a:p>
               <a:r>
-                <a:rPr kumimoji="1" lang="en" altLang="zh-CN" sz="700" b="1" i="1" dirty="0">
-                  <a:ln w="3175">
-                    <a:noFill/>
-                  </a:ln>
+                <a:rPr lang="en" altLang="zh-CN" sz="1000" b="1" dirty="0">
                   <a:solidFill>
-                    <a:schemeClr val="tx2">
-                      <a:lumMod val="50000"/>
-                      <a:lumOff val="50000"/>
-                    </a:schemeClr>
+                    <a:srgbClr val="0070C0"/>
                   </a:solidFill>
-                  <a:effectLst>
-                    <a:outerShdw blurRad="139700" dist="38100" dir="5400000" algn="t" rotWithShape="0">
-                      <a:prstClr val="black">
-                        <a:alpha val="25000"/>
-                      </a:prstClr>
-                    </a:outerShdw>
-                  </a:effectLst>
                   <a:latin typeface="Maple Mono" panose="020F0509060000000000" pitchFamily="49" charset="0"/>
                   <a:ea typeface="Maple Mono" panose="020F0509060000000000" pitchFamily="49" charset="0"/>
                 </a:rPr>
                 <a:t>in the Data Viewer</a:t>
               </a:r>
-              <a:endParaRPr kumimoji="1" lang="zh-CN" altLang="en-US" sz="700" b="1" i="1" dirty="0">
-                <a:ln w="3175">
-                  <a:noFill/>
-                </a:ln>
+              <a:endParaRPr lang="zh-CN" altLang="en-US" sz="1000" b="1" dirty="0">
                 <a:solidFill>
-                  <a:schemeClr val="tx2">
-                    <a:lumMod val="50000"/>
-                    <a:lumOff val="50000"/>
-                  </a:schemeClr>
+                  <a:srgbClr val="0070C0"/>
                 </a:solidFill>
-                <a:effectLst>
-                  <a:outerShdw blurRad="139700" dist="38100" dir="5400000" algn="t" rotWithShape="0">
-                    <a:prstClr val="black">
-                      <a:alpha val="25000"/>
-                    </a:prstClr>
-                  </a:outerShdw>
-                </a:effectLst>
                 <a:latin typeface="Maple Mono" panose="020F0509060000000000" pitchFamily="49" charset="0"/>
               </a:endParaRPr>
             </a:p>
@@ -5485,62 +5304,39 @@
           </p:nvSpPr>
           <p:spPr>
             <a:xfrm>
-              <a:off x="1962661" y="864389"/>
-              <a:ext cx="1220206" cy="200055"/>
+              <a:off x="1962661" y="818994"/>
+              <a:ext cx="1646605" cy="246221"/>
             </a:xfrm>
             <a:prstGeom prst="rect">
               <a:avLst/>
             </a:prstGeom>
             <a:noFill/>
+            <a:effectLst/>
           </p:spPr>
           <p:txBody>
-            <a:bodyPr wrap="none" rtlCol="0">
+            <a:bodyPr wrap="square" rtlCol="0">
               <a:spAutoFit/>
             </a:bodyPr>
-            <a:lstStyle/>
+            <a:lstStyle>
+              <a:defPPr>
+                <a:defRPr lang="zh-CN"/>
+              </a:defPPr>
+              <a:lvl1pPr>
+                <a:defRPr sz="1000" b="1">
+                  <a:solidFill>
+                    <a:srgbClr val="0070C0"/>
+                  </a:solidFill>
+                  <a:latin typeface="Maple Mono" panose="020F0509060000000000" pitchFamily="49" charset="0"/>
+                  <a:ea typeface="Maple Mono" panose="020F0509060000000000" pitchFamily="49" charset="0"/>
+                </a:defRPr>
+              </a:lvl1pPr>
+            </a:lstStyle>
             <a:p>
               <a:r>
-                <a:rPr kumimoji="1" lang="en" altLang="zh-CN" sz="700" b="1" i="1" dirty="0">
-                  <a:ln w="3175">
-                    <a:noFill/>
-                  </a:ln>
-                  <a:solidFill>
-                    <a:schemeClr val="tx2">
-                      <a:lumMod val="50000"/>
-                      <a:lumOff val="50000"/>
-                    </a:schemeClr>
-                  </a:solidFill>
-                  <a:effectLst>
-                    <a:outerShdw blurRad="139700" dist="38100" dir="5400000" algn="t" rotWithShape="0">
-                      <a:prstClr val="black">
-                        <a:alpha val="25000"/>
-                      </a:prstClr>
-                    </a:outerShdw>
-                  </a:effectLst>
-                  <a:latin typeface="Maple Mono" panose="020F0509060000000000" pitchFamily="49" charset="0"/>
-                  <a:ea typeface="Maple Mono" panose="020F0509060000000000" pitchFamily="49" charset="0"/>
-                </a:rPr>
+                <a:rPr lang="en" altLang="zh-CN" dirty="0"/>
                 <a:t>Enhanced Commenting</a:t>
               </a:r>
-              <a:endParaRPr kumimoji="1" lang="zh-CN" altLang="en-US" sz="700" b="1" i="1" dirty="0">
-                <a:ln w="3175">
-                  <a:noFill/>
-                </a:ln>
-                <a:solidFill>
-                  <a:schemeClr val="tx2">
-                    <a:lumMod val="50000"/>
-                    <a:lumOff val="50000"/>
-                  </a:schemeClr>
-                </a:solidFill>
-                <a:effectLst>
-                  <a:outerShdw blurRad="139700" dist="38100" dir="5400000" algn="t" rotWithShape="0">
-                    <a:prstClr val="black">
-                      <a:alpha val="25000"/>
-                    </a:prstClr>
-                  </a:outerShdw>
-                </a:effectLst>
-                <a:latin typeface="Maple Mono" panose="020F0509060000000000" pitchFamily="49" charset="0"/>
-              </a:endParaRPr>
+              <a:endParaRPr lang="zh-CN" altLang="en-US" dirty="0"/>
             </a:p>
           </p:txBody>
         </p:sp>
@@ -5788,41 +5584,36 @@
           </p:nvSpPr>
           <p:spPr>
             <a:xfrm>
-              <a:off x="3427080" y="5936466"/>
-              <a:ext cx="729687" cy="200055"/>
+              <a:off x="3498415" y="5878101"/>
+              <a:ext cx="954107" cy="246221"/>
             </a:xfrm>
             <a:prstGeom prst="rect">
               <a:avLst/>
             </a:prstGeom>
             <a:noFill/>
+            <a:effectLst/>
           </p:spPr>
           <p:txBody>
-            <a:bodyPr wrap="none" rtlCol="0">
+            <a:bodyPr wrap="square" rtlCol="0">
               <a:spAutoFit/>
             </a:bodyPr>
-            <a:lstStyle/>
+            <a:lstStyle>
+              <a:defPPr>
+                <a:defRPr lang="zh-CN"/>
+              </a:defPPr>
+              <a:lvl1pPr>
+                <a:defRPr sz="1000" b="1">
+                  <a:solidFill>
+                    <a:srgbClr val="0070C0"/>
+                  </a:solidFill>
+                  <a:latin typeface="Maple Mono" panose="020F0509060000000000" pitchFamily="49" charset="0"/>
+                  <a:ea typeface="Maple Mono" panose="020F0509060000000000" pitchFamily="49" charset="0"/>
+                </a:defRPr>
+              </a:lvl1pPr>
+            </a:lstStyle>
             <a:p>
               <a:r>
-                <a:rPr kumimoji="1" lang="en" altLang="zh-CN" sz="700" b="1" i="1" dirty="0">
-                  <a:ln w="3175">
-                    <a:noFill/>
-                  </a:ln>
-                  <a:solidFill>
-                    <a:schemeClr val="tx2">
-                      <a:lumMod val="50000"/>
-                      <a:lumOff val="50000"/>
-                    </a:schemeClr>
-                  </a:solidFill>
-                  <a:effectLst>
-                    <a:outerShdw blurRad="139700" dist="38100" dir="5400000" algn="t" rotWithShape="0">
-                      <a:prstClr val="black">
-                        <a:alpha val="25000"/>
-                      </a:prstClr>
-                    </a:outerShdw>
-                  </a:effectLst>
-                  <a:latin typeface="Maple Mono" panose="020F0509060000000000" pitchFamily="49" charset="0"/>
-                  <a:ea typeface="Maple Mono" panose="020F0509060000000000" pitchFamily="49" charset="0"/>
-                </a:rPr>
+                <a:rPr lang="en" altLang="zh-CN" dirty="0"/>
                 <a:t>Hover Help</a:t>
               </a:r>
             </a:p>
@@ -5889,200 +5680,63 @@
           </p:nvSpPr>
           <p:spPr>
             <a:xfrm>
-              <a:off x="4660763" y="866629"/>
-              <a:ext cx="1220206" cy="200055"/>
+              <a:off x="4187354" y="814749"/>
+              <a:ext cx="1646605" cy="246221"/>
             </a:xfrm>
             <a:prstGeom prst="rect">
               <a:avLst/>
             </a:prstGeom>
             <a:noFill/>
+            <a:effectLst/>
           </p:spPr>
           <p:txBody>
-            <a:bodyPr wrap="none" rtlCol="0">
+            <a:bodyPr wrap="square" rtlCol="0">
               <a:spAutoFit/>
             </a:bodyPr>
-            <a:lstStyle/>
+            <a:lstStyle>
+              <a:defPPr>
+                <a:defRPr lang="zh-CN"/>
+              </a:defPPr>
+              <a:lvl1pPr>
+                <a:defRPr sz="1000" b="1">
+                  <a:solidFill>
+                    <a:srgbClr val="0070C0"/>
+                  </a:solidFill>
+                  <a:latin typeface="Maple Mono" panose="020F0509060000000000" pitchFamily="49" charset="0"/>
+                  <a:ea typeface="Maple Mono" panose="020F0509060000000000" pitchFamily="49" charset="0"/>
+                </a:defRPr>
+              </a:lvl1pPr>
+            </a:lstStyle>
             <a:p>
               <a:r>
-                <a:rPr kumimoji="1" lang="en" altLang="zh-CN" sz="700" b="1" i="1" dirty="0">
-                  <a:ln w="3175">
-                    <a:noFill/>
-                  </a:ln>
-                  <a:solidFill>
-                    <a:schemeClr val="tx2">
-                      <a:lumMod val="50000"/>
-                      <a:lumOff val="50000"/>
-                    </a:schemeClr>
-                  </a:solidFill>
-                  <a:effectLst>
-                    <a:outerShdw blurRad="139700" dist="38100" dir="5400000" algn="t" rotWithShape="0">
-                      <a:prstClr val="black">
-                        <a:alpha val="25000"/>
-                      </a:prstClr>
-                    </a:outerShdw>
-                  </a:effectLst>
-                  <a:latin typeface="Maple Mono" panose="020F0509060000000000" pitchFamily="49" charset="0"/>
-                  <a:ea typeface="Maple Mono" panose="020F0509060000000000" pitchFamily="49" charset="0"/>
-                </a:rPr>
+                <a:rPr lang="en" altLang="zh-CN" dirty="0"/>
                 <a:t>Quickly</a:t>
               </a:r>
               <a:r>
-                <a:rPr kumimoji="1" lang="zh-CN" altLang="en-US" sz="700" b="1" i="1" dirty="0">
-                  <a:ln w="3175">
-                    <a:noFill/>
-                  </a:ln>
-                  <a:solidFill>
-                    <a:schemeClr val="tx2">
-                      <a:lumMod val="50000"/>
-                      <a:lumOff val="50000"/>
-                    </a:schemeClr>
-                  </a:solidFill>
-                  <a:effectLst>
-                    <a:outerShdw blurRad="139700" dist="38100" dir="5400000" algn="t" rotWithShape="0">
-                      <a:prstClr val="black">
-                        <a:alpha val="25000"/>
-                      </a:prstClr>
-                    </a:outerShdw>
-                  </a:effectLst>
-                  <a:latin typeface="Maple Mono" panose="020F0509060000000000" pitchFamily="49" charset="0"/>
-                  <a:ea typeface="Maple Mono" panose="020F0509060000000000" pitchFamily="49" charset="0"/>
-                </a:rPr>
+                <a:rPr lang="zh-CN" altLang="en-US" dirty="0"/>
                 <a:t> </a:t>
               </a:r>
               <a:r>
-                <a:rPr kumimoji="1" lang="en-US" altLang="zh-CN" sz="700" b="1" i="1" dirty="0">
-                  <a:ln w="3175">
-                    <a:noFill/>
-                  </a:ln>
-                  <a:solidFill>
-                    <a:schemeClr val="tx2">
-                      <a:lumMod val="50000"/>
-                      <a:lumOff val="50000"/>
-                    </a:schemeClr>
-                  </a:solidFill>
-                  <a:effectLst>
-                    <a:outerShdw blurRad="139700" dist="38100" dir="5400000" algn="t" rotWithShape="0">
-                      <a:prstClr val="black">
-                        <a:alpha val="25000"/>
-                      </a:prstClr>
-                    </a:outerShdw>
-                  </a:effectLst>
-                  <a:latin typeface="Maple Mono" panose="020F0509060000000000" pitchFamily="49" charset="0"/>
-                  <a:ea typeface="Maple Mono" panose="020F0509060000000000" pitchFamily="49" charset="0"/>
-                </a:rPr>
+                <a:rPr lang="en-US" altLang="zh-CN" dirty="0"/>
                 <a:t>Run</a:t>
               </a:r>
               <a:r>
-                <a:rPr kumimoji="1" lang="zh-CN" altLang="en-US" sz="700" b="1" i="1" dirty="0">
-                  <a:ln w="3175">
-                    <a:noFill/>
-                  </a:ln>
-                  <a:solidFill>
-                    <a:schemeClr val="tx2">
-                      <a:lumMod val="50000"/>
-                      <a:lumOff val="50000"/>
-                    </a:schemeClr>
-                  </a:solidFill>
-                  <a:effectLst>
-                    <a:outerShdw blurRad="139700" dist="38100" dir="5400000" algn="t" rotWithShape="0">
-                      <a:prstClr val="black">
-                        <a:alpha val="25000"/>
-                      </a:prstClr>
-                    </a:outerShdw>
-                  </a:effectLst>
-                  <a:latin typeface="Maple Mono" panose="020F0509060000000000" pitchFamily="49" charset="0"/>
-                  <a:ea typeface="Maple Mono" panose="020F0509060000000000" pitchFamily="49" charset="0"/>
-                </a:rPr>
+                <a:rPr lang="zh-CN" altLang="en-US" dirty="0"/>
                 <a:t> </a:t>
               </a:r>
               <a:r>
-                <a:rPr kumimoji="1" lang="en-US" altLang="zh-CN" sz="700" b="1" i="1" dirty="0">
-                  <a:ln w="3175">
-                    <a:noFill/>
-                  </a:ln>
-                  <a:solidFill>
-                    <a:schemeClr val="tx2">
-                      <a:lumMod val="50000"/>
-                      <a:lumOff val="50000"/>
-                    </a:schemeClr>
-                  </a:solidFill>
-                  <a:effectLst>
-                    <a:outerShdw blurRad="139700" dist="38100" dir="5400000" algn="t" rotWithShape="0">
-                      <a:prstClr val="black">
-                        <a:alpha val="25000"/>
-                      </a:prstClr>
-                    </a:outerShdw>
-                  </a:effectLst>
-                  <a:latin typeface="Maple Mono" panose="020F0509060000000000" pitchFamily="49" charset="0"/>
-                  <a:ea typeface="Maple Mono" panose="020F0509060000000000" pitchFamily="49" charset="0"/>
-                </a:rPr>
+                <a:rPr lang="en-US" altLang="zh-CN" dirty="0"/>
                 <a:t>&amp;</a:t>
               </a:r>
               <a:r>
-                <a:rPr kumimoji="1" lang="zh-CN" altLang="en-US" sz="700" b="1" i="1" dirty="0">
-                  <a:ln w="3175">
-                    <a:noFill/>
-                  </a:ln>
-                  <a:solidFill>
-                    <a:schemeClr val="tx2">
-                      <a:lumMod val="50000"/>
-                      <a:lumOff val="50000"/>
-                    </a:schemeClr>
-                  </a:solidFill>
-                  <a:effectLst>
-                    <a:outerShdw blurRad="139700" dist="38100" dir="5400000" algn="t" rotWithShape="0">
-                      <a:prstClr val="black">
-                        <a:alpha val="25000"/>
-                      </a:prstClr>
-                    </a:outerShdw>
-                  </a:effectLst>
-                  <a:latin typeface="Maple Mono" panose="020F0509060000000000" pitchFamily="49" charset="0"/>
-                  <a:ea typeface="Maple Mono" panose="020F0509060000000000" pitchFamily="49" charset="0"/>
-                </a:rPr>
+                <a:rPr lang="zh-CN" altLang="en-US" dirty="0"/>
                 <a:t> </a:t>
               </a:r>
               <a:r>
-                <a:rPr kumimoji="1" lang="en-US" altLang="zh-CN" sz="700" b="1" i="1" dirty="0">
-                  <a:ln w="3175">
-                    <a:noFill/>
-                  </a:ln>
-                  <a:solidFill>
-                    <a:schemeClr val="tx2">
-                      <a:lumMod val="50000"/>
-                      <a:lumOff val="50000"/>
-                    </a:schemeClr>
-                  </a:solidFill>
-                  <a:effectLst>
-                    <a:outerShdw blurRad="139700" dist="38100" dir="5400000" algn="t" rotWithShape="0">
-                      <a:prstClr val="black">
-                        <a:alpha val="25000"/>
-                      </a:prstClr>
-                    </a:outerShdw>
-                  </a:effectLst>
-                  <a:latin typeface="Maple Mono" panose="020F0509060000000000" pitchFamily="49" charset="0"/>
-                  <a:ea typeface="Maple Mono" panose="020F0509060000000000" pitchFamily="49" charset="0"/>
-                </a:rPr>
+                <a:rPr lang="en-US" altLang="zh-CN" dirty="0"/>
                 <a:t>Setup</a:t>
               </a:r>
-              <a:endParaRPr kumimoji="1" lang="zh-CN" altLang="en-US" sz="700" b="1" i="1" dirty="0">
-                <a:ln w="3175">
-                  <a:noFill/>
-                </a:ln>
-                <a:solidFill>
-                  <a:schemeClr val="tx2">
-                    <a:lumMod val="50000"/>
-                    <a:lumOff val="50000"/>
-                  </a:schemeClr>
-                </a:solidFill>
-                <a:effectLst>
-                  <a:outerShdw blurRad="139700" dist="38100" dir="5400000" algn="t" rotWithShape="0">
-                    <a:prstClr val="black">
-                      <a:alpha val="25000"/>
-                    </a:prstClr>
-                  </a:outerShdw>
-                </a:effectLst>
-                <a:latin typeface="Maple Mono" panose="020F0509060000000000" pitchFamily="49" charset="0"/>
-              </a:endParaRPr>
+              <a:endParaRPr lang="zh-CN" altLang="en-US" dirty="0"/>
             </a:p>
           </p:txBody>
         </p:sp>
@@ -6102,8 +5756,8 @@
           </p:nvCxnSpPr>
           <p:spPr>
             <a:xfrm>
-              <a:off x="4842027" y="1064444"/>
-              <a:ext cx="779301" cy="0"/>
+              <a:off x="4381187" y="1064444"/>
+              <a:ext cx="1240141" cy="0"/>
             </a:xfrm>
             <a:prstGeom prst="line">
               <a:avLst/>
@@ -6194,108 +5848,47 @@
           </p:nvSpPr>
           <p:spPr>
             <a:xfrm>
-              <a:off x="8870937" y="866629"/>
-              <a:ext cx="784189" cy="200055"/>
+              <a:off x="8870937" y="814749"/>
+              <a:ext cx="1031051" cy="246221"/>
             </a:xfrm>
             <a:prstGeom prst="rect">
               <a:avLst/>
             </a:prstGeom>
             <a:noFill/>
+            <a:effectLst/>
           </p:spPr>
           <p:txBody>
-            <a:bodyPr wrap="none" rtlCol="0">
+            <a:bodyPr wrap="square" rtlCol="0">
               <a:spAutoFit/>
             </a:bodyPr>
-            <a:lstStyle/>
+            <a:lstStyle>
+              <a:defPPr>
+                <a:defRPr lang="zh-CN"/>
+              </a:defPPr>
+              <a:lvl1pPr>
+                <a:defRPr sz="1000" b="1">
+                  <a:solidFill>
+                    <a:srgbClr val="0070C0"/>
+                  </a:solidFill>
+                  <a:latin typeface="Maple Mono" panose="020F0509060000000000" pitchFamily="49" charset="0"/>
+                  <a:ea typeface="Maple Mono" panose="020F0509060000000000" pitchFamily="49" charset="0"/>
+                </a:defRPr>
+              </a:lvl1pPr>
+            </a:lstStyle>
             <a:p>
               <a:r>
-                <a:rPr kumimoji="1" lang="en-US" altLang="zh-CN" sz="700" b="1" i="1" dirty="0">
-                  <a:ln w="3175">
-                    <a:noFill/>
-                  </a:ln>
-                  <a:solidFill>
-                    <a:schemeClr val="tx2">
-                      <a:lumMod val="50000"/>
-                      <a:lumOff val="50000"/>
-                    </a:schemeClr>
-                  </a:solidFill>
-                  <a:effectLst>
-                    <a:outerShdw blurRad="139700" dist="38100" dir="5400000" algn="t" rotWithShape="0">
-                      <a:prstClr val="black">
-                        <a:alpha val="25000"/>
-                      </a:prstClr>
-                    </a:outerShdw>
-                  </a:effectLst>
-                  <a:latin typeface="Maple Mono" panose="020F0509060000000000" pitchFamily="49" charset="0"/>
-                  <a:ea typeface="Maple Mono" panose="020F0509060000000000" pitchFamily="49" charset="0"/>
-                </a:rPr>
+                <a:rPr lang="en-US" altLang="zh-CN" dirty="0"/>
                 <a:t>Data</a:t>
               </a:r>
               <a:r>
-                <a:rPr kumimoji="1" lang="zh-CN" altLang="en-US" sz="700" b="1" i="1" dirty="0">
-                  <a:ln w="3175">
-                    <a:noFill/>
-                  </a:ln>
-                  <a:solidFill>
-                    <a:schemeClr val="tx2">
-                      <a:lumMod val="50000"/>
-                      <a:lumOff val="50000"/>
-                    </a:schemeClr>
-                  </a:solidFill>
-                  <a:effectLst>
-                    <a:outerShdw blurRad="139700" dist="38100" dir="5400000" algn="t" rotWithShape="0">
-                      <a:prstClr val="black">
-                        <a:alpha val="25000"/>
-                      </a:prstClr>
-                    </a:outerShdw>
-                  </a:effectLst>
-                  <a:latin typeface="Maple Mono" panose="020F0509060000000000" pitchFamily="49" charset="0"/>
-                  <a:ea typeface="Maple Mono" panose="020F0509060000000000" pitchFamily="49" charset="0"/>
-                </a:rPr>
+                <a:rPr lang="zh-CN" altLang="en-US" dirty="0"/>
                 <a:t> </a:t>
               </a:r>
               <a:r>
-                <a:rPr kumimoji="1" lang="en-US" altLang="zh-CN" sz="700" b="1" i="1" dirty="0">
-                  <a:ln w="3175">
-                    <a:noFill/>
-                  </a:ln>
-                  <a:solidFill>
-                    <a:schemeClr val="tx2">
-                      <a:lumMod val="50000"/>
-                      <a:lumOff val="50000"/>
-                    </a:schemeClr>
-                  </a:solidFill>
-                  <a:effectLst>
-                    <a:outerShdw blurRad="139700" dist="38100" dir="5400000" algn="t" rotWithShape="0">
-                      <a:prstClr val="black">
-                        <a:alpha val="25000"/>
-                      </a:prstClr>
-                    </a:outerShdw>
-                  </a:effectLst>
-                  <a:latin typeface="Maple Mono" panose="020F0509060000000000" pitchFamily="49" charset="0"/>
-                  <a:ea typeface="Maple Mono" panose="020F0509060000000000" pitchFamily="49" charset="0"/>
-                </a:rPr>
+                <a:rPr lang="en-US" altLang="zh-CN" dirty="0"/>
                 <a:t>Viewer</a:t>
               </a:r>
-              <a:endParaRPr kumimoji="1" lang="zh-CN" altLang="en-US" sz="700" b="1" i="1" dirty="0">
-                <a:ln w="3175">
-                  <a:noFill/>
-                </a:ln>
-                <a:solidFill>
-                  <a:schemeClr val="tx2">
-                    <a:lumMod val="50000"/>
-                    <a:lumOff val="50000"/>
-                  </a:schemeClr>
-                </a:solidFill>
-                <a:effectLst>
-                  <a:outerShdw blurRad="139700" dist="38100" dir="5400000" algn="t" rotWithShape="0">
-                    <a:prstClr val="black">
-                      <a:alpha val="25000"/>
-                    </a:prstClr>
-                  </a:outerShdw>
-                </a:effectLst>
-                <a:latin typeface="Maple Mono" panose="020F0509060000000000" pitchFamily="49" charset="0"/>
-              </a:endParaRPr>
+              <a:endParaRPr lang="zh-CN" altLang="en-US" dirty="0"/>
             </a:p>
           </p:txBody>
         </p:sp>
@@ -6316,7 +5909,7 @@
           <p:spPr>
             <a:xfrm>
               <a:off x="8814021" y="1064444"/>
-              <a:ext cx="631368" cy="0"/>
+              <a:ext cx="832295" cy="4549"/>
             </a:xfrm>
             <a:prstGeom prst="line">
               <a:avLst/>
@@ -6544,109 +6137,48 @@
           </p:nvSpPr>
           <p:spPr>
             <a:xfrm>
-              <a:off x="10121436" y="2191025"/>
-              <a:ext cx="1002197" cy="200055"/>
+              <a:off x="9952826" y="2145630"/>
+              <a:ext cx="1338828" cy="246221"/>
             </a:xfrm>
             <a:prstGeom prst="rect">
               <a:avLst/>
             </a:prstGeom>
             <a:noFill/>
+            <a:effectLst/>
           </p:spPr>
           <p:txBody>
-            <a:bodyPr wrap="none" rtlCol="0">
+            <a:bodyPr wrap="square" rtlCol="0">
               <a:spAutoFit/>
             </a:bodyPr>
-            <a:lstStyle/>
+            <a:lstStyle>
+              <a:defPPr>
+                <a:defRPr lang="zh-CN"/>
+              </a:defPPr>
+              <a:lvl1pPr>
+                <a:defRPr sz="1000" b="1">
+                  <a:solidFill>
+                    <a:srgbClr val="0070C0"/>
+                  </a:solidFill>
+                  <a:latin typeface="Maple Mono" panose="020F0509060000000000" pitchFamily="49" charset="0"/>
+                  <a:ea typeface="Maple Mono" panose="020F0509060000000000" pitchFamily="49" charset="0"/>
+                </a:defRPr>
+              </a:lvl1pPr>
+            </a:lstStyle>
             <a:p>
               <a:pPr algn="r"/>
               <a:r>
-                <a:rPr kumimoji="1" lang="en-US" altLang="zh-CN" sz="700" b="1" i="1" dirty="0">
-                  <a:ln w="3175">
-                    <a:noFill/>
-                  </a:ln>
-                  <a:solidFill>
-                    <a:schemeClr val="tx2">
-                      <a:lumMod val="50000"/>
-                      <a:lumOff val="50000"/>
-                    </a:schemeClr>
-                  </a:solidFill>
-                  <a:effectLst>
-                    <a:outerShdw blurRad="139700" dist="38100" dir="5400000" algn="t" rotWithShape="0">
-                      <a:prstClr val="black">
-                        <a:alpha val="25000"/>
-                      </a:prstClr>
-                    </a:outerShdw>
-                  </a:effectLst>
-                  <a:latin typeface="Maple Mono" panose="020F0509060000000000" pitchFamily="49" charset="0"/>
-                  <a:ea typeface="Maple Mono" panose="020F0509060000000000" pitchFamily="49" charset="0"/>
-                </a:rPr>
+                <a:rPr lang="en-US" altLang="zh-CN" dirty="0"/>
                 <a:t>Variables</a:t>
               </a:r>
               <a:r>
-                <a:rPr kumimoji="1" lang="zh-CN" altLang="en-US" sz="700" b="1" i="1" dirty="0">
-                  <a:ln w="3175">
-                    <a:noFill/>
-                  </a:ln>
-                  <a:solidFill>
-                    <a:schemeClr val="tx2">
-                      <a:lumMod val="50000"/>
-                      <a:lumOff val="50000"/>
-                    </a:schemeClr>
-                  </a:solidFill>
-                  <a:effectLst>
-                    <a:outerShdw blurRad="139700" dist="38100" dir="5400000" algn="t" rotWithShape="0">
-                      <a:prstClr val="black">
-                        <a:alpha val="25000"/>
-                      </a:prstClr>
-                    </a:outerShdw>
-                  </a:effectLst>
-                  <a:latin typeface="Maple Mono" panose="020F0509060000000000" pitchFamily="49" charset="0"/>
-                  <a:ea typeface="Maple Mono" panose="020F0509060000000000" pitchFamily="49" charset="0"/>
-                </a:rPr>
+                <a:rPr lang="zh-CN" altLang="en-US" dirty="0"/>
                 <a:t> </a:t>
               </a:r>
               <a:r>
-                <a:rPr kumimoji="1" lang="en" altLang="zh-CN" sz="700" b="1" i="1" dirty="0">
-                  <a:ln w="3175">
-                    <a:noFill/>
-                  </a:ln>
-                  <a:solidFill>
-                    <a:schemeClr val="tx2">
-                      <a:lumMod val="50000"/>
-                      <a:lumOff val="50000"/>
-                    </a:schemeClr>
-                  </a:solidFill>
-                  <a:effectLst>
-                    <a:outerShdw blurRad="139700" dist="38100" dir="5400000" algn="t" rotWithShape="0">
-                      <a:prstClr val="black">
-                        <a:alpha val="25000"/>
-                      </a:prstClr>
-                    </a:outerShdw>
-                  </a:effectLst>
-                  <a:latin typeface="Maple Mono" panose="020F0509060000000000" pitchFamily="49" charset="0"/>
-                  <a:ea typeface="Maple Mono" panose="020F0509060000000000" pitchFamily="49" charset="0"/>
-                </a:rPr>
+                <a:rPr lang="en" altLang="zh-CN" dirty="0"/>
                 <a:t>Table</a:t>
               </a:r>
-              <a:endParaRPr kumimoji="1" lang="zh-CN" altLang="en-US" sz="700" b="1" i="1" dirty="0">
-                <a:ln w="3175">
-                  <a:noFill/>
-                </a:ln>
-                <a:solidFill>
-                  <a:schemeClr val="tx2">
-                    <a:lumMod val="50000"/>
-                    <a:lumOff val="50000"/>
-                  </a:schemeClr>
-                </a:solidFill>
-                <a:effectLst>
-                  <a:outerShdw blurRad="139700" dist="38100" dir="5400000" algn="t" rotWithShape="0">
-                    <a:prstClr val="black">
-                      <a:alpha val="25000"/>
-                    </a:prstClr>
-                  </a:outerShdw>
-                </a:effectLst>
-                <a:latin typeface="Maple Mono" panose="020F0509060000000000" pitchFamily="49" charset="0"/>
-              </a:endParaRPr>
+              <a:endParaRPr lang="zh-CN" altLang="en-US" dirty="0"/>
             </a:p>
           </p:txBody>
         </p:sp>
@@ -6758,109 +6290,48 @@
           </p:nvSpPr>
           <p:spPr>
             <a:xfrm>
-              <a:off x="10393946" y="4901834"/>
-              <a:ext cx="729687" cy="200055"/>
+              <a:off x="10337547" y="4856439"/>
+              <a:ext cx="954107" cy="246221"/>
             </a:xfrm>
             <a:prstGeom prst="rect">
               <a:avLst/>
             </a:prstGeom>
             <a:noFill/>
+            <a:effectLst/>
           </p:spPr>
           <p:txBody>
-            <a:bodyPr wrap="none" rtlCol="0">
+            <a:bodyPr wrap="square" rtlCol="0">
               <a:spAutoFit/>
             </a:bodyPr>
-            <a:lstStyle/>
+            <a:lstStyle>
+              <a:defPPr>
+                <a:defRPr lang="zh-CN"/>
+              </a:defPPr>
+              <a:lvl1pPr>
+                <a:defRPr sz="1000" b="1">
+                  <a:solidFill>
+                    <a:srgbClr val="0070C0"/>
+                  </a:solidFill>
+                  <a:latin typeface="Maple Mono" panose="020F0509060000000000" pitchFamily="49" charset="0"/>
+                  <a:ea typeface="Maple Mono" panose="020F0509060000000000" pitchFamily="49" charset="0"/>
+                </a:defRPr>
+              </a:lvl1pPr>
+            </a:lstStyle>
             <a:p>
               <a:pPr algn="r"/>
               <a:r>
-                <a:rPr kumimoji="1" lang="en-US" altLang="zh-CN" sz="700" b="1" i="1" dirty="0">
-                  <a:ln w="3175">
-                    <a:noFill/>
-                  </a:ln>
-                  <a:solidFill>
-                    <a:schemeClr val="tx2">
-                      <a:lumMod val="50000"/>
-                      <a:lumOff val="50000"/>
-                    </a:schemeClr>
-                  </a:solidFill>
-                  <a:effectLst>
-                    <a:outerShdw blurRad="139700" dist="38100" dir="5400000" algn="t" rotWithShape="0">
-                      <a:prstClr val="black">
-                        <a:alpha val="25000"/>
-                      </a:prstClr>
-                    </a:outerShdw>
-                  </a:effectLst>
-                  <a:latin typeface="Maple Mono" panose="020F0509060000000000" pitchFamily="49" charset="0"/>
-                  <a:ea typeface="Maple Mono" panose="020F0509060000000000" pitchFamily="49" charset="0"/>
-                </a:rPr>
+                <a:rPr lang="en-US" altLang="zh-CN"/>
                 <a:t>Data</a:t>
               </a:r>
               <a:r>
-                <a:rPr kumimoji="1" lang="zh-CN" altLang="en-US" sz="700" b="1" i="1" dirty="0">
-                  <a:ln w="3175">
-                    <a:noFill/>
-                  </a:ln>
-                  <a:solidFill>
-                    <a:schemeClr val="tx2">
-                      <a:lumMod val="50000"/>
-                      <a:lumOff val="50000"/>
-                    </a:schemeClr>
-                  </a:solidFill>
-                  <a:effectLst>
-                    <a:outerShdw blurRad="139700" dist="38100" dir="5400000" algn="t" rotWithShape="0">
-                      <a:prstClr val="black">
-                        <a:alpha val="25000"/>
-                      </a:prstClr>
-                    </a:outerShdw>
-                  </a:effectLst>
-                  <a:latin typeface="Maple Mono" panose="020F0509060000000000" pitchFamily="49" charset="0"/>
-                  <a:ea typeface="Maple Mono" panose="020F0509060000000000" pitchFamily="49" charset="0"/>
-                </a:rPr>
+                <a:rPr lang="zh-CN" altLang="en-US"/>
                 <a:t> </a:t>
               </a:r>
               <a:r>
-                <a:rPr kumimoji="1" lang="en-US" altLang="zh-CN" sz="700" b="1" i="1" dirty="0">
-                  <a:ln w="3175">
-                    <a:noFill/>
-                  </a:ln>
-                  <a:solidFill>
-                    <a:schemeClr val="tx2">
-                      <a:lumMod val="50000"/>
-                      <a:lumOff val="50000"/>
-                    </a:schemeClr>
-                  </a:solidFill>
-                  <a:effectLst>
-                    <a:outerShdw blurRad="139700" dist="38100" dir="5400000" algn="t" rotWithShape="0">
-                      <a:prstClr val="black">
-                        <a:alpha val="25000"/>
-                      </a:prstClr>
-                    </a:outerShdw>
-                  </a:effectLst>
-                  <a:latin typeface="Maple Mono" panose="020F0509060000000000" pitchFamily="49" charset="0"/>
-                  <a:ea typeface="Maple Mono" panose="020F0509060000000000" pitchFamily="49" charset="0"/>
-                </a:rPr>
+                <a:rPr lang="en-US" altLang="zh-CN" dirty="0"/>
                 <a:t>Table</a:t>
               </a:r>
-              <a:endParaRPr kumimoji="1" lang="zh-CN" altLang="en-US" sz="700" b="1" i="1" dirty="0">
-                <a:ln w="3175">
-                  <a:noFill/>
-                </a:ln>
-                <a:solidFill>
-                  <a:schemeClr val="tx2">
-                    <a:lumMod val="50000"/>
-                    <a:lumOff val="50000"/>
-                  </a:schemeClr>
-                </a:solidFill>
-                <a:effectLst>
-                  <a:outerShdw blurRad="139700" dist="38100" dir="5400000" algn="t" rotWithShape="0">
-                    <a:prstClr val="black">
-                      <a:alpha val="25000"/>
-                    </a:prstClr>
-                  </a:outerShdw>
-                </a:effectLst>
-                <a:latin typeface="Maple Mono" panose="020F0509060000000000" pitchFamily="49" charset="0"/>
-              </a:endParaRPr>
+              <a:endParaRPr lang="zh-CN" altLang="en-US" dirty="0"/>
             </a:p>
           </p:txBody>
         </p:sp>
@@ -6972,68 +6443,44 @@
           </p:nvSpPr>
           <p:spPr>
             <a:xfrm>
-              <a:off x="10339444" y="2985742"/>
-              <a:ext cx="784189" cy="307777"/>
+              <a:off x="10260603" y="2940347"/>
+              <a:ext cx="1031051" cy="400110"/>
             </a:xfrm>
             <a:prstGeom prst="rect">
               <a:avLst/>
             </a:prstGeom>
             <a:noFill/>
+            <a:effectLst/>
           </p:spPr>
           <p:txBody>
-            <a:bodyPr wrap="none" rtlCol="0">
+            <a:bodyPr wrap="square" rtlCol="0">
               <a:spAutoFit/>
             </a:bodyPr>
-            <a:lstStyle/>
+            <a:lstStyle>
+              <a:defPPr>
+                <a:defRPr lang="zh-CN"/>
+              </a:defPPr>
+              <a:lvl1pPr>
+                <a:defRPr sz="1000" b="1">
+                  <a:solidFill>
+                    <a:srgbClr val="0070C0"/>
+                  </a:solidFill>
+                  <a:latin typeface="Maple Mono" panose="020F0509060000000000" pitchFamily="49" charset="0"/>
+                  <a:ea typeface="Maple Mono" panose="020F0509060000000000" pitchFamily="49" charset="0"/>
+                </a:defRPr>
+              </a:lvl1pPr>
+            </a:lstStyle>
             <a:p>
               <a:pPr algn="r"/>
               <a:r>
-                <a:rPr kumimoji="1" lang="en" altLang="zh-CN" sz="700" b="1" i="1" dirty="0">
-                  <a:ln w="3175">
-                    <a:noFill/>
-                  </a:ln>
-                  <a:solidFill>
-                    <a:schemeClr val="tx2">
-                      <a:lumMod val="50000"/>
-                      <a:lumOff val="50000"/>
-                    </a:schemeClr>
-                  </a:solidFill>
-                  <a:effectLst>
-                    <a:outerShdw blurRad="139700" dist="38100" dir="5400000" algn="t" rotWithShape="0">
-                      <a:prstClr val="black">
-                        <a:alpha val="25000"/>
-                      </a:prstClr>
-                    </a:outerShdw>
-                  </a:effectLst>
-                  <a:latin typeface="Maple Mono" panose="020F0509060000000000" pitchFamily="49" charset="0"/>
-                  <a:ea typeface="Maple Mono" panose="020F0509060000000000" pitchFamily="49" charset="0"/>
-                </a:rPr>
+                <a:rPr lang="en" altLang="zh-CN" dirty="0"/>
                 <a:t>Stata-style</a:t>
               </a:r>
             </a:p>
             <a:p>
               <a:pPr algn="r"/>
               <a:r>
-                <a:rPr kumimoji="1" lang="en" altLang="zh-CN" sz="700" b="1" i="1" dirty="0">
-                  <a:ln w="3175">
-                    <a:noFill/>
-                  </a:ln>
-                  <a:solidFill>
-                    <a:schemeClr val="tx2">
-                      <a:lumMod val="50000"/>
-                      <a:lumOff val="50000"/>
-                    </a:schemeClr>
-                  </a:solidFill>
-                  <a:effectLst>
-                    <a:outerShdw blurRad="139700" dist="38100" dir="5400000" algn="t" rotWithShape="0">
-                      <a:prstClr val="black">
-                        <a:alpha val="25000"/>
-                      </a:prstClr>
-                    </a:outerShdw>
-                  </a:effectLst>
-                  <a:latin typeface="Maple Mono" panose="020F0509060000000000" pitchFamily="49" charset="0"/>
-                  <a:ea typeface="Maple Mono" panose="020F0509060000000000" pitchFamily="49" charset="0"/>
-                </a:rPr>
+                <a:rPr lang="en" altLang="zh-CN" dirty="0"/>
                 <a:t>filtering</a:t>
               </a:r>
             </a:p>
@@ -7100,41 +6547,36 @@
           </p:nvSpPr>
           <p:spPr>
             <a:xfrm>
-              <a:off x="6059047" y="866629"/>
-              <a:ext cx="1056700" cy="200055"/>
+              <a:off x="5832072" y="814749"/>
+              <a:ext cx="1415772" cy="246221"/>
             </a:xfrm>
             <a:prstGeom prst="rect">
               <a:avLst/>
             </a:prstGeom>
             <a:noFill/>
+            <a:effectLst/>
           </p:spPr>
           <p:txBody>
-            <a:bodyPr wrap="none" rtlCol="0">
+            <a:bodyPr wrap="square" rtlCol="0">
               <a:spAutoFit/>
             </a:bodyPr>
-            <a:lstStyle/>
+            <a:lstStyle>
+              <a:defPPr>
+                <a:defRPr lang="zh-CN"/>
+              </a:defPPr>
+              <a:lvl1pPr>
+                <a:defRPr sz="1000" b="1">
+                  <a:solidFill>
+                    <a:srgbClr val="0070C0"/>
+                  </a:solidFill>
+                  <a:latin typeface="Maple Mono" panose="020F0509060000000000" pitchFamily="49" charset="0"/>
+                  <a:ea typeface="Maple Mono" panose="020F0509060000000000" pitchFamily="49" charset="0"/>
+                </a:defRPr>
+              </a:lvl1pPr>
+            </a:lstStyle>
             <a:p>
               <a:r>
-                <a:rPr kumimoji="1" lang="en-US" altLang="zh-CN" sz="700" b="1" i="1" dirty="0">
-                  <a:ln w="3175">
-                    <a:noFill/>
-                  </a:ln>
-                  <a:solidFill>
-                    <a:schemeClr val="tx2">
-                      <a:lumMod val="50000"/>
-                      <a:lumOff val="50000"/>
-                    </a:schemeClr>
-                  </a:solidFill>
-                  <a:effectLst>
-                    <a:outerShdw blurRad="139700" dist="38100" dir="5400000" algn="t" rotWithShape="0">
-                      <a:prstClr val="black">
-                        <a:alpha val="25000"/>
-                      </a:prstClr>
-                    </a:outerShdw>
-                  </a:effectLst>
-                  <a:latin typeface="Maple Mono" panose="020F0509060000000000" pitchFamily="49" charset="0"/>
-                  <a:ea typeface="Maple Mono" panose="020F0509060000000000" pitchFamily="49" charset="0"/>
-                </a:rPr>
+                <a:rPr lang="en-US" altLang="zh-CN" dirty="0"/>
                 <a:t>Embedded Console</a:t>
               </a:r>
             </a:p>
@@ -7156,8 +6598,8 @@
           </p:nvCxnSpPr>
           <p:spPr>
             <a:xfrm>
-              <a:off x="6220042" y="1064444"/>
-              <a:ext cx="672077" cy="0"/>
+              <a:off x="5998723" y="1060970"/>
+              <a:ext cx="1052510" cy="8023"/>
             </a:xfrm>
             <a:prstGeom prst="line">
               <a:avLst/>
@@ -7251,7 +6693,7 @@
           <p:spPr>
             <a:xfrm>
               <a:off x="7421594" y="1064444"/>
-              <a:ext cx="971912" cy="0"/>
+              <a:ext cx="1168178" cy="4549"/>
             </a:xfrm>
             <a:prstGeom prst="line">
               <a:avLst/>
@@ -7295,62 +6737,39 @@
           </p:nvSpPr>
           <p:spPr>
             <a:xfrm>
-              <a:off x="7204570" y="856694"/>
-              <a:ext cx="1507668" cy="200055"/>
+              <a:off x="7204570" y="817784"/>
+              <a:ext cx="1800493" cy="246221"/>
             </a:xfrm>
             <a:prstGeom prst="rect">
               <a:avLst/>
             </a:prstGeom>
             <a:noFill/>
+            <a:effectLst/>
           </p:spPr>
           <p:txBody>
-            <a:bodyPr wrap="square">
+            <a:bodyPr wrap="square" rtlCol="0">
               <a:spAutoFit/>
             </a:bodyPr>
-            <a:lstStyle/>
+            <a:lstStyle>
+              <a:defPPr>
+                <a:defRPr lang="zh-CN"/>
+              </a:defPPr>
+              <a:lvl1pPr>
+                <a:defRPr sz="1000" b="1">
+                  <a:solidFill>
+                    <a:srgbClr val="0070C0"/>
+                  </a:solidFill>
+                  <a:latin typeface="Maple Mono" panose="020F0509060000000000" pitchFamily="49" charset="0"/>
+                  <a:ea typeface="Maple Mono" panose="020F0509060000000000" pitchFamily="49" charset="0"/>
+                </a:defRPr>
+              </a:lvl1pPr>
+            </a:lstStyle>
             <a:p>
               <a:r>
-                <a:rPr kumimoji="1" lang="en-US" altLang="zh-CN" sz="700" b="1" i="1" dirty="0">
-                  <a:ln w="3175">
-                    <a:noFill/>
-                  </a:ln>
-                  <a:solidFill>
-                    <a:schemeClr val="tx2">
-                      <a:lumMod val="50000"/>
-                      <a:lumOff val="50000"/>
-                    </a:schemeClr>
-                  </a:solidFill>
-                  <a:effectLst>
-                    <a:outerShdw blurRad="139700" dist="38100" dir="5400000" algn="t" rotWithShape="0">
-                      <a:prstClr val="black">
-                        <a:alpha val="25000"/>
-                      </a:prstClr>
-                    </a:outerShdw>
-                  </a:effectLst>
-                  <a:latin typeface="Maple Mono" panose="020F0509060000000000" pitchFamily="49" charset="0"/>
-                  <a:ea typeface="Maple Mono" panose="020F0509060000000000" pitchFamily="49" charset="0"/>
-                </a:rPr>
+                <a:rPr lang="en-US" altLang="zh-CN" dirty="0"/>
                 <a:t>Display Stata Output </a:t>
               </a:r>
-              <a:endParaRPr kumimoji="1" lang="zh-CN" altLang="en-US" sz="700" b="1" i="1" dirty="0">
-                <a:ln w="3175">
-                  <a:noFill/>
-                </a:ln>
-                <a:solidFill>
-                  <a:schemeClr val="tx2">
-                    <a:lumMod val="50000"/>
-                    <a:lumOff val="50000"/>
-                  </a:schemeClr>
-                </a:solidFill>
-                <a:effectLst>
-                  <a:outerShdw blurRad="139700" dist="38100" dir="5400000" algn="t" rotWithShape="0">
-                    <a:prstClr val="black">
-                      <a:alpha val="25000"/>
-                    </a:prstClr>
-                  </a:outerShdw>
-                </a:effectLst>
-                <a:latin typeface="Maple Mono" panose="020F0509060000000000" pitchFamily="49" charset="0"/>
-              </a:endParaRPr>
+              <a:endParaRPr lang="zh-CN" altLang="en-US" dirty="0"/>
             </a:p>
           </p:txBody>
         </p:sp>
@@ -7462,63 +6881,39 @@
           </p:nvSpPr>
           <p:spPr>
             <a:xfrm>
-              <a:off x="9124377" y="5936466"/>
-              <a:ext cx="893194" cy="200055"/>
+              <a:off x="9195712" y="5878101"/>
+              <a:ext cx="1184940" cy="246221"/>
             </a:xfrm>
             <a:prstGeom prst="rect">
               <a:avLst/>
             </a:prstGeom>
             <a:noFill/>
+            <a:effectLst/>
           </p:spPr>
           <p:txBody>
-            <a:bodyPr wrap="none" rtlCol="0">
+            <a:bodyPr wrap="square" rtlCol="0">
               <a:spAutoFit/>
             </a:bodyPr>
-            <a:lstStyle/>
-            <a:p>
-              <a:pPr algn="r"/>
-              <a:r>
-                <a:rPr kumimoji="1" lang="en-US" altLang="zh-CN" sz="700" b="1" i="1" dirty="0">
-                  <a:ln w="3175">
-                    <a:noFill/>
-                  </a:ln>
+            <a:lstStyle>
+              <a:defPPr>
+                <a:defRPr lang="zh-CN"/>
+              </a:defPPr>
+              <a:lvl1pPr>
+                <a:defRPr sz="1000" b="1">
                   <a:solidFill>
-                    <a:schemeClr val="tx2">
-                      <a:lumMod val="50000"/>
-                      <a:lumOff val="50000"/>
-                    </a:schemeClr>
+                    <a:srgbClr val="0070C0"/>
                   </a:solidFill>
-                  <a:effectLst>
-                    <a:outerShdw blurRad="139700" dist="38100" dir="5400000" algn="t" rotWithShape="0">
-                      <a:prstClr val="black">
-                        <a:alpha val="25000"/>
-                      </a:prstClr>
-                    </a:outerShdw>
-                  </a:effectLst>
                   <a:latin typeface="Maple Mono" panose="020F0509060000000000" pitchFamily="49" charset="0"/>
                   <a:ea typeface="Maple Mono" panose="020F0509060000000000" pitchFamily="49" charset="0"/>
-                </a:rPr>
+                </a:defRPr>
+              </a:lvl1pPr>
+            </a:lstStyle>
+            <a:p>
+              <a:r>
+                <a:rPr lang="en-US" altLang="zh-CN" dirty="0"/>
                 <a:t>Graph Output </a:t>
               </a:r>
-              <a:endParaRPr kumimoji="1" lang="zh-CN" altLang="en-US" sz="700" b="1" i="1" dirty="0">
-                <a:ln w="3175">
-                  <a:noFill/>
-                </a:ln>
-                <a:solidFill>
-                  <a:schemeClr val="tx2">
-                    <a:lumMod val="50000"/>
-                    <a:lumOff val="50000"/>
-                  </a:schemeClr>
-                </a:solidFill>
-                <a:effectLst>
-                  <a:outerShdw blurRad="139700" dist="38100" dir="5400000" algn="t" rotWithShape="0">
-                    <a:prstClr val="black">
-                      <a:alpha val="25000"/>
-                    </a:prstClr>
-                  </a:outerShdw>
-                </a:effectLst>
-                <a:latin typeface="Maple Mono" panose="020F0509060000000000" pitchFamily="49" charset="0"/>
-              </a:endParaRPr>
+              <a:endParaRPr lang="zh-CN" altLang="en-US" dirty="0"/>
             </a:p>
           </p:txBody>
         </p:sp>
@@ -7630,109 +7025,47 @@
           </p:nvSpPr>
           <p:spPr>
             <a:xfrm>
-              <a:off x="7084149" y="5936466"/>
-              <a:ext cx="838691" cy="200055"/>
+              <a:off x="7155484" y="5878101"/>
+              <a:ext cx="1107996" cy="246221"/>
             </a:xfrm>
             <a:prstGeom prst="rect">
               <a:avLst/>
             </a:prstGeom>
             <a:noFill/>
+            <a:effectLst/>
           </p:spPr>
           <p:txBody>
-            <a:bodyPr wrap="none" rtlCol="0">
+            <a:bodyPr wrap="square" rtlCol="0">
               <a:spAutoFit/>
             </a:bodyPr>
-            <a:lstStyle/>
-            <a:p>
-              <a:pPr algn="r"/>
-              <a:r>
-                <a:rPr kumimoji="1" lang="en-US" altLang="zh-CN" sz="700" b="1" i="1" dirty="0">
-                  <a:ln w="3175">
-                    <a:noFill/>
-                  </a:ln>
+            <a:lstStyle>
+              <a:defPPr>
+                <a:defRPr lang="zh-CN"/>
+              </a:defPPr>
+              <a:lvl1pPr>
+                <a:defRPr sz="1000" b="1">
                   <a:solidFill>
-                    <a:schemeClr val="tx2">
-                      <a:lumMod val="50000"/>
-                      <a:lumOff val="50000"/>
-                    </a:schemeClr>
+                    <a:srgbClr val="0070C0"/>
                   </a:solidFill>
-                  <a:effectLst>
-                    <a:outerShdw blurRad="139700" dist="38100" dir="5400000" algn="t" rotWithShape="0">
-                      <a:prstClr val="black">
-                        <a:alpha val="25000"/>
-                      </a:prstClr>
-                    </a:outerShdw>
-                  </a:effectLst>
                   <a:latin typeface="Maple Mono" panose="020F0509060000000000" pitchFamily="49" charset="0"/>
                   <a:ea typeface="Maple Mono" panose="020F0509060000000000" pitchFamily="49" charset="0"/>
-                </a:rPr>
+                </a:defRPr>
+              </a:lvl1pPr>
+            </a:lstStyle>
+            <a:p>
+              <a:r>
+                <a:rPr lang="en-US" altLang="zh-CN"/>
                 <a:t>Command</a:t>
               </a:r>
               <a:r>
-                <a:rPr kumimoji="1" lang="zh-CN" altLang="en-US" sz="700" b="1" i="1" dirty="0">
-                  <a:ln w="3175">
-                    <a:noFill/>
-                  </a:ln>
-                  <a:solidFill>
-                    <a:schemeClr val="tx2">
-                      <a:lumMod val="50000"/>
-                      <a:lumOff val="50000"/>
-                    </a:schemeClr>
-                  </a:solidFill>
-                  <a:effectLst>
-                    <a:outerShdw blurRad="139700" dist="38100" dir="5400000" algn="t" rotWithShape="0">
-                      <a:prstClr val="black">
-                        <a:alpha val="25000"/>
-                      </a:prstClr>
-                    </a:outerShdw>
-                  </a:effectLst>
-                  <a:latin typeface="Maple Mono" panose="020F0509060000000000" pitchFamily="49" charset="0"/>
-                  <a:ea typeface="Maple Mono" panose="020F0509060000000000" pitchFamily="49" charset="0"/>
-                </a:rPr>
+                <a:rPr lang="zh-CN" altLang="en-US"/>
                 <a:t> </a:t>
               </a:r>
               <a:r>
-                <a:rPr kumimoji="1" lang="en-US" altLang="zh-CN" sz="700" b="1" i="1" dirty="0">
-                  <a:ln w="3175">
-                    <a:noFill/>
-                  </a:ln>
-                  <a:solidFill>
-                    <a:schemeClr val="tx2">
-                      <a:lumMod val="50000"/>
-                      <a:lumOff val="50000"/>
-                    </a:schemeClr>
-                  </a:solidFill>
-                  <a:effectLst>
-                    <a:outerShdw blurRad="139700" dist="38100" dir="5400000" algn="t" rotWithShape="0">
-                      <a:prstClr val="black">
-                        <a:alpha val="25000"/>
-                      </a:prstClr>
-                    </a:outerShdw>
-                  </a:effectLst>
-                  <a:latin typeface="Maple Mono" panose="020F0509060000000000" pitchFamily="49" charset="0"/>
-                  <a:ea typeface="Maple Mono" panose="020F0509060000000000" pitchFamily="49" charset="0"/>
-                </a:rPr>
+                <a:rPr lang="en-US" altLang="zh-CN" dirty="0"/>
                 <a:t>Line</a:t>
               </a:r>
-              <a:endParaRPr kumimoji="1" lang="zh-CN" altLang="en-US" sz="700" b="1" i="1" dirty="0">
-                <a:ln w="3175">
-                  <a:noFill/>
-                </a:ln>
-                <a:solidFill>
-                  <a:schemeClr val="tx2">
-                    <a:lumMod val="50000"/>
-                    <a:lumOff val="50000"/>
-                  </a:schemeClr>
-                </a:solidFill>
-                <a:effectLst>
-                  <a:outerShdw blurRad="139700" dist="38100" dir="5400000" algn="t" rotWithShape="0">
-                    <a:prstClr val="black">
-                      <a:alpha val="25000"/>
-                    </a:prstClr>
-                  </a:outerShdw>
-                </a:effectLst>
-                <a:latin typeface="Maple Mono" panose="020F0509060000000000" pitchFamily="49" charset="0"/>
-              </a:endParaRPr>
+              <a:endParaRPr lang="zh-CN" altLang="en-US" dirty="0"/>
             </a:p>
           </p:txBody>
         </p:sp>
@@ -7753,6 +7086,11 @@
 <file path=ppt/slides/slide2.xml><?xml version="1.0" encoding="utf-8"?>
 <p:sld xmlns:a="http://schemas.openxmlformats.org/drawingml/2006/main" xmlns:r="http://schemas.openxmlformats.org/officeDocument/2006/relationships" xmlns:p="http://schemas.openxmlformats.org/presentationml/2006/main">
   <p:cSld>
+    <p:bg>
+      <p:bgRef idx="1001">
+        <a:schemeClr val="bg1"/>
+      </p:bgRef>
+    </p:bg>
     <p:spTree>
       <p:nvGrpSpPr>
         <p:cNvPr id="1" name="">
@@ -7775,10 +7113,10 @@
       </p:grpSpPr>
       <p:grpSp>
         <p:nvGrpSpPr>
-          <p:cNvPr id="2" name="组合 1">
+          <p:cNvPr id="12" name="组合 11">
             <a:extLst>
               <a:ext uri="{FF2B5EF4-FFF2-40B4-BE49-F238E27FC236}">
-                <a16:creationId xmlns:a16="http://schemas.microsoft.com/office/drawing/2014/main" id="{D8674E0B-B4DE-1DF2-1A30-0462D7B6FFF7}"/>
+                <a16:creationId xmlns:a16="http://schemas.microsoft.com/office/drawing/2014/main" id="{7990F971-533A-8977-557B-E3B25FF0F1E4}"/>
               </a:ext>
             </a:extLst>
           </p:cNvPr>
@@ -7869,7 +7207,7 @@
             <p:nvPr/>
           </p:nvPicPr>
           <p:blipFill>
-            <a:blip r:embed="rId2"/>
+            <a:blip r:embed="rId3"/>
             <a:srcRect t="411"/>
             <a:stretch>
               <a:fillRect/>
@@ -8025,8 +7363,8 @@
           </p:nvCxnSpPr>
           <p:spPr>
             <a:xfrm>
-              <a:off x="1353368" y="3716762"/>
-              <a:ext cx="1389832" cy="0"/>
+              <a:off x="1044102" y="3716762"/>
+              <a:ext cx="1699098" cy="0"/>
             </a:xfrm>
             <a:prstGeom prst="line">
               <a:avLst/>
@@ -8070,8 +7408,8 @@
           </p:nvSpPr>
           <p:spPr>
             <a:xfrm>
-              <a:off x="1078293" y="3513740"/>
-              <a:ext cx="829073" cy="200055"/>
+              <a:off x="805923" y="3403495"/>
+              <a:ext cx="954107" cy="302840"/>
             </a:xfrm>
             <a:prstGeom prst="rect">
               <a:avLst/>
@@ -8082,26 +7420,26 @@
             <a:bodyPr wrap="none" rtlCol="0">
               <a:spAutoFit/>
             </a:bodyPr>
-            <a:lstStyle/>
+            <a:lstStyle>
+              <a:defPPr>
+                <a:defRPr lang="zh-CN"/>
+              </a:defPPr>
+              <a:lvl1pPr>
+                <a:lnSpc>
+                  <a:spcPct val="150000"/>
+                </a:lnSpc>
+                <a:defRPr sz="1000" b="1">
+                  <a:solidFill>
+                    <a:srgbClr val="0070C0"/>
+                  </a:solidFill>
+                  <a:latin typeface="Yuanti TC" panose="02010600040101010101" pitchFamily="2" charset="-120"/>
+                  <a:ea typeface="Yuanti TC" panose="02010600040101010101" pitchFamily="2" charset="-120"/>
+                </a:defRPr>
+              </a:lvl1pPr>
+            </a:lstStyle>
             <a:p>
               <a:r>
-                <a:rPr kumimoji="1" lang="zh-CN" altLang="en-US" sz="700" b="1" dirty="0">
-                  <a:solidFill>
-                    <a:schemeClr val="tx2">
-                      <a:lumMod val="50000"/>
-                      <a:lumOff val="50000"/>
-                    </a:schemeClr>
-                  </a:solidFill>
-                  <a:effectLst>
-                    <a:outerShdw blurRad="187198" dist="38100" dir="5400000" sx="99744" sy="99744" algn="t" rotWithShape="0">
-                      <a:prstClr val="black">
-                        <a:alpha val="40000"/>
-                      </a:prstClr>
-                    </a:outerShdw>
-                  </a:effectLst>
-                  <a:latin typeface="Maple Mono NF CN" panose="020F0509060000000000" pitchFamily="49" charset="-128"/>
-                  <a:ea typeface="Maple Mono NF CN" panose="020F0509060000000000" pitchFamily="49" charset="-128"/>
-                </a:rPr>
+                <a:rPr lang="zh-CN" altLang="en-US" dirty="0"/>
                 <a:t>智能大纲导航</a:t>
               </a:r>
             </a:p>
@@ -8170,8 +7508,8 @@
           </p:nvCxnSpPr>
           <p:spPr>
             <a:xfrm>
-              <a:off x="1353368" y="3032125"/>
-              <a:ext cx="1864969" cy="0"/>
+              <a:off x="1044102" y="3032125"/>
+              <a:ext cx="2174235" cy="0"/>
             </a:xfrm>
             <a:prstGeom prst="line">
               <a:avLst/>
@@ -8215,8 +7553,8 @@
           </p:nvSpPr>
           <p:spPr>
             <a:xfrm>
-              <a:off x="1078293" y="2832070"/>
-              <a:ext cx="936475" cy="200055"/>
+              <a:off x="805923" y="2721825"/>
+              <a:ext cx="1082348" cy="302840"/>
             </a:xfrm>
             <a:prstGeom prst="rect">
               <a:avLst/>
@@ -8227,26 +7565,26 @@
             <a:bodyPr wrap="none" rtlCol="0">
               <a:spAutoFit/>
             </a:bodyPr>
-            <a:lstStyle/>
+            <a:lstStyle>
+              <a:defPPr>
+                <a:defRPr lang="zh-CN"/>
+              </a:defPPr>
+              <a:lvl1pPr>
+                <a:lnSpc>
+                  <a:spcPct val="150000"/>
+                </a:lnSpc>
+                <a:defRPr sz="1000" b="1">
+                  <a:solidFill>
+                    <a:srgbClr val="0070C0"/>
+                  </a:solidFill>
+                  <a:latin typeface="Yuanti TC" panose="02010600040101010101" pitchFamily="2" charset="-120"/>
+                  <a:ea typeface="Yuanti TC" panose="02010600040101010101" pitchFamily="2" charset="-120"/>
+                </a:defRPr>
+              </a:lvl1pPr>
+            </a:lstStyle>
             <a:p>
               <a:r>
-                <a:rPr kumimoji="1" lang="zh-CN" altLang="en-US" sz="700" b="1" dirty="0">
-                  <a:solidFill>
-                    <a:schemeClr val="tx2">
-                      <a:lumMod val="50000"/>
-                      <a:lumOff val="50000"/>
-                    </a:schemeClr>
-                  </a:solidFill>
-                  <a:effectLst>
-                    <a:outerShdw blurRad="187198" dist="38100" dir="5400000" sx="99744" sy="99744" algn="t" rotWithShape="0">
-                      <a:prstClr val="black">
-                        <a:alpha val="40000"/>
-                      </a:prstClr>
-                    </a:outerShdw>
-                  </a:effectLst>
-                  <a:latin typeface="Maple Mono NF CN" panose="020F0509060000000000" pitchFamily="49" charset="-128"/>
-                  <a:ea typeface="Maple Mono NF CN" panose="020F0509060000000000" pitchFamily="49" charset="-128"/>
-                </a:rPr>
+                <a:rPr lang="zh-CN" altLang="en-US" dirty="0"/>
                 <a:t>多级别大纲识别</a:t>
               </a:r>
             </a:p>
@@ -8268,8 +7606,8 @@
           </p:nvCxnSpPr>
           <p:spPr>
             <a:xfrm>
-              <a:off x="1353368" y="2382284"/>
-              <a:ext cx="1864968" cy="0"/>
+              <a:off x="1044102" y="2382284"/>
+              <a:ext cx="2174234" cy="0"/>
             </a:xfrm>
             <a:prstGeom prst="line">
               <a:avLst/>
@@ -8360,8 +7698,8 @@
           </p:nvSpPr>
           <p:spPr>
             <a:xfrm>
-              <a:off x="1078293" y="2181195"/>
-              <a:ext cx="614271" cy="200055"/>
+              <a:off x="805923" y="2070950"/>
+              <a:ext cx="697627" cy="302840"/>
             </a:xfrm>
             <a:prstGeom prst="rect">
               <a:avLst/>
@@ -8372,26 +7710,26 @@
             <a:bodyPr wrap="none" rtlCol="0">
               <a:spAutoFit/>
             </a:bodyPr>
-            <a:lstStyle/>
+            <a:lstStyle>
+              <a:defPPr>
+                <a:defRPr lang="zh-CN"/>
+              </a:defPPr>
+              <a:lvl1pPr>
+                <a:lnSpc>
+                  <a:spcPct val="150000"/>
+                </a:lnSpc>
+                <a:defRPr sz="1000" b="1">
+                  <a:solidFill>
+                    <a:srgbClr val="0070C0"/>
+                  </a:solidFill>
+                  <a:latin typeface="Yuanti TC" panose="02010600040101010101" pitchFamily="2" charset="-120"/>
+                  <a:ea typeface="Yuanti TC" panose="02010600040101010101" pitchFamily="2" charset="-120"/>
+                </a:defRPr>
+              </a:lvl1pPr>
+            </a:lstStyle>
             <a:p>
               <a:r>
-                <a:rPr kumimoji="1" lang="zh-CN" altLang="en-US" sz="700" b="1" dirty="0">
-                  <a:solidFill>
-                    <a:schemeClr val="tx2">
-                      <a:lumMod val="50000"/>
-                      <a:lumOff val="50000"/>
-                    </a:schemeClr>
-                  </a:solidFill>
-                  <a:effectLst>
-                    <a:outerShdw blurRad="187198" dist="38100" dir="5400000" sx="99744" sy="99744" algn="t" rotWithShape="0">
-                      <a:prstClr val="black">
-                        <a:alpha val="40000"/>
-                      </a:prstClr>
-                    </a:outerShdw>
-                  </a:effectLst>
-                  <a:latin typeface="Maple Mono NF CN" panose="020F0509060000000000" pitchFamily="49" charset="-128"/>
-                  <a:ea typeface="Maple Mono NF CN" panose="020F0509060000000000" pitchFamily="49" charset="-128"/>
-                </a:rPr>
+                <a:rPr lang="zh-CN" altLang="en-US" dirty="0"/>
                 <a:t>代码高亮</a:t>
               </a:r>
             </a:p>
@@ -8413,8 +7751,8 @@
           </p:nvCxnSpPr>
           <p:spPr>
             <a:xfrm>
-              <a:off x="1353368" y="1679662"/>
-              <a:ext cx="1200362" cy="0"/>
+              <a:off x="1044102" y="1679662"/>
+              <a:ext cx="1509628" cy="0"/>
             </a:xfrm>
             <a:prstGeom prst="line">
               <a:avLst/>
@@ -8458,8 +7796,8 @@
           </p:nvSpPr>
           <p:spPr>
             <a:xfrm>
-              <a:off x="1078293" y="1372570"/>
-              <a:ext cx="1151277" cy="307777"/>
+              <a:off x="799438" y="1139110"/>
+              <a:ext cx="1338828" cy="533672"/>
             </a:xfrm>
             <a:prstGeom prst="rect">
               <a:avLst/>
@@ -8472,142 +7810,82 @@
             </a:bodyPr>
             <a:lstStyle/>
             <a:p>
+              <a:pPr>
+                <a:lnSpc>
+                  <a:spcPct val="150000"/>
+                </a:lnSpc>
+              </a:pPr>
               <a:r>
-                <a:rPr kumimoji="1" lang="zh-CN" altLang="en-US" sz="700" b="1" dirty="0">
+                <a:rPr lang="zh-CN" altLang="en-US" sz="1000" b="1" dirty="0">
                   <a:solidFill>
-                    <a:schemeClr val="tx2">
-                      <a:lumMod val="50000"/>
-                      <a:lumOff val="50000"/>
-                    </a:schemeClr>
+                    <a:srgbClr val="0070C0"/>
                   </a:solidFill>
-                  <a:effectLst>
-                    <a:outerShdw blurRad="187198" dist="38100" dir="5400000" sx="99744" sy="99744" algn="t" rotWithShape="0">
-                      <a:prstClr val="black">
-                        <a:alpha val="40000"/>
-                      </a:prstClr>
-                    </a:outerShdw>
-                  </a:effectLst>
-                  <a:latin typeface="Maple Mono NF CN" panose="020F0509060000000000" pitchFamily="49" charset="-128"/>
-                  <a:ea typeface="Maple Mono NF CN" panose="020F0509060000000000" pitchFamily="49" charset="-128"/>
+                  <a:latin typeface="Yuanti TC" panose="02010600040101010101" pitchFamily="2" charset="-120"/>
+                  <a:ea typeface="Yuanti TC" panose="02010600040101010101" pitchFamily="2" charset="-120"/>
                 </a:rPr>
                 <a:t>单击并在数据查看器</a:t>
               </a:r>
-              <a:endParaRPr kumimoji="1" lang="en-US" altLang="zh-CN" sz="700" b="1" dirty="0">
+              <a:endParaRPr lang="en-US" altLang="zh-CN" sz="1000" b="1" dirty="0">
                 <a:solidFill>
-                  <a:schemeClr val="tx2">
-                    <a:lumMod val="50000"/>
-                    <a:lumOff val="50000"/>
-                  </a:schemeClr>
+                  <a:srgbClr val="0070C0"/>
                 </a:solidFill>
-                <a:effectLst>
-                  <a:outerShdw blurRad="187198" dist="38100" dir="5400000" sx="99744" sy="99744" algn="t" rotWithShape="0">
-                    <a:prstClr val="black">
-                      <a:alpha val="40000"/>
-                    </a:prstClr>
-                  </a:outerShdw>
-                </a:effectLst>
-                <a:latin typeface="Maple Mono NF CN" panose="020F0509060000000000" pitchFamily="49" charset="-128"/>
-                <a:ea typeface="Maple Mono NF CN" panose="020F0509060000000000" pitchFamily="49" charset="-128"/>
+                <a:latin typeface="Yuanti TC" panose="02010600040101010101" pitchFamily="2" charset="-120"/>
+                <a:ea typeface="Yuanti TC" panose="02010600040101010101" pitchFamily="2" charset="-120"/>
               </a:endParaRPr>
             </a:p>
             <a:p>
+              <a:pPr>
+                <a:lnSpc>
+                  <a:spcPct val="150000"/>
+                </a:lnSpc>
+              </a:pPr>
               <a:r>
-                <a:rPr kumimoji="1" lang="zh-CN" altLang="en-US" sz="700" b="1" dirty="0">
+                <a:rPr lang="zh-CN" altLang="en-US" sz="1000" b="1" dirty="0">
                   <a:solidFill>
-                    <a:schemeClr val="tx2">
-                      <a:lumMod val="50000"/>
-                      <a:lumOff val="50000"/>
-                    </a:schemeClr>
+                    <a:srgbClr val="0070C0"/>
                   </a:solidFill>
-                  <a:effectLst>
-                    <a:outerShdw blurRad="187198" dist="38100" dir="5400000" sx="99744" sy="99744" algn="t" rotWithShape="0">
-                      <a:prstClr val="black">
-                        <a:alpha val="40000"/>
-                      </a:prstClr>
-                    </a:outerShdw>
-                  </a:effectLst>
-                  <a:latin typeface="Maple Mono NF CN" panose="020F0509060000000000" pitchFamily="49" charset="-128"/>
-                  <a:ea typeface="Maple Mono NF CN" panose="020F0509060000000000" pitchFamily="49" charset="-128"/>
+                  <a:latin typeface="Yuanti TC" panose="02010600040101010101" pitchFamily="2" charset="-120"/>
+                  <a:ea typeface="Yuanti TC" panose="02010600040101010101" pitchFamily="2" charset="-120"/>
                 </a:rPr>
                 <a:t>打开</a:t>
               </a:r>
               <a:r>
-                <a:rPr kumimoji="1" lang="en-US" altLang="zh-CN" sz="700" b="1" dirty="0">
+                <a:rPr lang="en-US" altLang="zh-CN" sz="1000" b="1" dirty="0">
                   <a:solidFill>
-                    <a:schemeClr val="tx2">
-                      <a:lumMod val="50000"/>
-                      <a:lumOff val="50000"/>
-                    </a:schemeClr>
+                    <a:srgbClr val="0070C0"/>
                   </a:solidFill>
-                  <a:effectLst>
-                    <a:outerShdw blurRad="187198" dist="38100" dir="5400000" sx="99744" sy="99744" algn="t" rotWithShape="0">
-                      <a:prstClr val="black">
-                        <a:alpha val="40000"/>
-                      </a:prstClr>
-                    </a:outerShdw>
-                  </a:effectLst>
-                  <a:latin typeface="Maple Mono NF CN" panose="020F0509060000000000" pitchFamily="49" charset="-128"/>
-                  <a:ea typeface="Maple Mono NF CN" panose="020F0509060000000000" pitchFamily="49" charset="-128"/>
+                  <a:latin typeface="Yuanti TC" panose="02010600040101010101" pitchFamily="2" charset="-120"/>
+                  <a:ea typeface="Yuanti TC" panose="02010600040101010101" pitchFamily="2" charset="-120"/>
                 </a:rPr>
                 <a:t>`</a:t>
               </a:r>
               <a:r>
-                <a:rPr kumimoji="1" lang="en" altLang="zh-CN" sz="700" b="1" dirty="0" err="1">
+                <a:rPr lang="en" altLang="zh-CN" sz="1000" b="1" dirty="0" err="1">
                   <a:solidFill>
-                    <a:schemeClr val="tx2">
-                      <a:lumMod val="50000"/>
-                      <a:lumOff val="50000"/>
-                    </a:schemeClr>
+                    <a:srgbClr val="0070C0"/>
                   </a:solidFill>
-                  <a:effectLst>
-                    <a:outerShdw blurRad="187198" dist="38100" dir="5400000" sx="99744" sy="99744" algn="t" rotWithShape="0">
-                      <a:prstClr val="black">
-                        <a:alpha val="40000"/>
-                      </a:prstClr>
-                    </a:outerShdw>
-                  </a:effectLst>
-                  <a:latin typeface="Maple Mono NF CN" panose="020F0509060000000000" pitchFamily="49" charset="-128"/>
-                  <a:ea typeface="Maple Mono NF CN" panose="020F0509060000000000" pitchFamily="49" charset="-128"/>
+                  <a:latin typeface="Yuanti TC" panose="02010600040101010101" pitchFamily="2" charset="-120"/>
+                  <a:ea typeface="Yuanti TC" panose="02010600040101010101" pitchFamily="2" charset="-120"/>
                 </a:rPr>
                 <a:t>dta</a:t>
               </a:r>
               <a:r>
-                <a:rPr kumimoji="1" lang="en-US" altLang="zh-CN" sz="700" b="1" dirty="0">
+                <a:rPr lang="en-US" altLang="zh-CN" sz="1000" b="1" dirty="0">
                   <a:solidFill>
-                    <a:schemeClr val="tx2">
-                      <a:lumMod val="50000"/>
-                      <a:lumOff val="50000"/>
-                    </a:schemeClr>
+                    <a:srgbClr val="0070C0"/>
                   </a:solidFill>
-                  <a:effectLst>
-                    <a:outerShdw blurRad="187198" dist="38100" dir="5400000" sx="99744" sy="99744" algn="t" rotWithShape="0">
-                      <a:prstClr val="black">
-                        <a:alpha val="40000"/>
-                      </a:prstClr>
-                    </a:outerShdw>
-                  </a:effectLst>
-                  <a:latin typeface="Maple Mono NF CN" panose="020F0509060000000000" pitchFamily="49" charset="-128"/>
-                  <a:ea typeface="Maple Mono NF CN" panose="020F0509060000000000" pitchFamily="49" charset="-128"/>
+                  <a:latin typeface="Yuanti TC" panose="02010600040101010101" pitchFamily="2" charset="-120"/>
+                  <a:ea typeface="Yuanti TC" panose="02010600040101010101" pitchFamily="2" charset="-120"/>
                 </a:rPr>
                 <a:t>`</a:t>
               </a:r>
               <a:r>
-                <a:rPr kumimoji="1" lang="zh-CN" altLang="en-US" sz="700" b="1" dirty="0">
+                <a:rPr lang="zh-CN" altLang="en-US" sz="1000" b="1" dirty="0">
                   <a:solidFill>
-                    <a:schemeClr val="tx2">
-                      <a:lumMod val="50000"/>
-                      <a:lumOff val="50000"/>
-                    </a:schemeClr>
+                    <a:srgbClr val="0070C0"/>
                   </a:solidFill>
-                  <a:effectLst>
-                    <a:outerShdw blurRad="187198" dist="38100" dir="5400000" sx="99744" sy="99744" algn="t" rotWithShape="0">
-                      <a:prstClr val="black">
-                        <a:alpha val="40000"/>
-                      </a:prstClr>
-                    </a:outerShdw>
-                  </a:effectLst>
-                  <a:latin typeface="Maple Mono NF CN" panose="020F0509060000000000" pitchFamily="49" charset="-128"/>
-                  <a:ea typeface="Maple Mono NF CN" panose="020F0509060000000000" pitchFamily="49" charset="-128"/>
+                  <a:latin typeface="Yuanti TC" panose="02010600040101010101" pitchFamily="2" charset="-120"/>
+                  <a:ea typeface="Yuanti TC" panose="02010600040101010101" pitchFamily="2" charset="-120"/>
                 </a:rPr>
                 <a:t>文件</a:t>
               </a:r>
@@ -8722,8 +8000,8 @@
           </p:nvSpPr>
           <p:spPr>
             <a:xfrm>
-              <a:off x="2509796" y="872083"/>
-              <a:ext cx="614271" cy="200055"/>
+              <a:off x="2509796" y="762536"/>
+              <a:ext cx="697627" cy="302840"/>
             </a:xfrm>
             <a:prstGeom prst="rect">
               <a:avLst/>
@@ -8734,346 +8012,28 @@
             <a:bodyPr wrap="none" rtlCol="0">
               <a:spAutoFit/>
             </a:bodyPr>
-            <a:lstStyle/>
+            <a:lstStyle>
+              <a:defPPr>
+                <a:defRPr lang="zh-CN"/>
+              </a:defPPr>
+              <a:lvl1pPr>
+                <a:lnSpc>
+                  <a:spcPct val="150000"/>
+                </a:lnSpc>
+                <a:defRPr sz="1000" b="1">
+                  <a:solidFill>
+                    <a:srgbClr val="0070C0"/>
+                  </a:solidFill>
+                  <a:latin typeface="Yuanti TC" panose="02010600040101010101" pitchFamily="2" charset="-120"/>
+                  <a:ea typeface="Yuanti TC" panose="02010600040101010101" pitchFamily="2" charset="-120"/>
+                </a:defRPr>
+              </a:lvl1pPr>
+            </a:lstStyle>
             <a:p>
               <a:r>
-                <a:rPr kumimoji="1" lang="zh-CN" altLang="en-US" sz="700" b="1" dirty="0">
-                  <a:solidFill>
-                    <a:schemeClr val="tx2">
-                      <a:lumMod val="50000"/>
-                      <a:lumOff val="50000"/>
-                    </a:schemeClr>
-                  </a:solidFill>
-                  <a:effectLst>
-                    <a:outerShdw blurRad="187198" dist="38100" dir="5400000" sx="99744" sy="99744" algn="t" rotWithShape="0">
-                      <a:prstClr val="black">
-                        <a:alpha val="40000"/>
-                      </a:prstClr>
-                    </a:outerShdw>
-                  </a:effectLst>
-                  <a:latin typeface="Maple Mono NF CN" panose="020F0509060000000000" pitchFamily="49" charset="-128"/>
-                  <a:ea typeface="Maple Mono NF CN" panose="020F0509060000000000" pitchFamily="49" charset="-128"/>
-                </a:rPr>
+                <a:rPr lang="zh-CN" altLang="en-US" dirty="0"/>
                 <a:t>注释增强</a:t>
               </a:r>
-            </a:p>
-          </p:txBody>
-        </p:sp>
-        <p:pic>
-          <p:nvPicPr>
-            <p:cNvPr id="70" name="图片 69">
-              <a:extLst>
-                <a:ext uri="{FF2B5EF4-FFF2-40B4-BE49-F238E27FC236}">
-                  <a16:creationId xmlns:a16="http://schemas.microsoft.com/office/drawing/2014/main" id="{200E670D-C701-E2FD-C685-601E4C695041}"/>
-                </a:ext>
-              </a:extLst>
-            </p:cNvPr>
-            <p:cNvPicPr>
-              <a:picLocks noChangeAspect="1"/>
-            </p:cNvPicPr>
-            <p:nvPr/>
-          </p:nvPicPr>
-          <p:blipFill>
-            <a:blip r:embed="rId3"/>
-            <a:srcRect/>
-            <a:stretch/>
-          </p:blipFill>
-          <p:spPr>
-            <a:xfrm>
-              <a:off x="1214608" y="4225539"/>
-              <a:ext cx="2161986" cy="2005595"/>
-            </a:xfrm>
-            <a:custGeom>
-              <a:avLst/>
-              <a:gdLst>
-                <a:gd name="csX0" fmla="*/ 37344 w 1893281"/>
-                <a:gd name="csY0" fmla="*/ 0 h 1869986"/>
-                <a:gd name="csX1" fmla="*/ 1855937 w 1893281"/>
-                <a:gd name="csY1" fmla="*/ 0 h 1869986"/>
-                <a:gd name="csX2" fmla="*/ 1893281 w 1893281"/>
-                <a:gd name="csY2" fmla="*/ 37344 h 1869986"/>
-                <a:gd name="csX3" fmla="*/ 1893281 w 1893281"/>
-                <a:gd name="csY3" fmla="*/ 1832642 h 1869986"/>
-                <a:gd name="csX4" fmla="*/ 1855937 w 1893281"/>
-                <a:gd name="csY4" fmla="*/ 1869986 h 1869986"/>
-                <a:gd name="csX5" fmla="*/ 37344 w 1893281"/>
-                <a:gd name="csY5" fmla="*/ 1869986 h 1869986"/>
-                <a:gd name="csX6" fmla="*/ 0 w 1893281"/>
-                <a:gd name="csY6" fmla="*/ 1832642 h 1869986"/>
-                <a:gd name="csX7" fmla="*/ 0 w 1893281"/>
-                <a:gd name="csY7" fmla="*/ 37344 h 1869986"/>
-                <a:gd name="csX8" fmla="*/ 37344 w 1893281"/>
-                <a:gd name="csY8" fmla="*/ 0 h 1869986"/>
-              </a:gdLst>
-              <a:ahLst/>
-              <a:cxnLst>
-                <a:cxn ang="0">
-                  <a:pos x="csX0" y="csY0"/>
-                </a:cxn>
-                <a:cxn ang="0">
-                  <a:pos x="csX1" y="csY1"/>
-                </a:cxn>
-                <a:cxn ang="0">
-                  <a:pos x="csX2" y="csY2"/>
-                </a:cxn>
-                <a:cxn ang="0">
-                  <a:pos x="csX3" y="csY3"/>
-                </a:cxn>
-                <a:cxn ang="0">
-                  <a:pos x="csX4" y="csY4"/>
-                </a:cxn>
-                <a:cxn ang="0">
-                  <a:pos x="csX5" y="csY5"/>
-                </a:cxn>
-                <a:cxn ang="0">
-                  <a:pos x="csX6" y="csY6"/>
-                </a:cxn>
-                <a:cxn ang="0">
-                  <a:pos x="csX7" y="csY7"/>
-                </a:cxn>
-                <a:cxn ang="0">
-                  <a:pos x="csX8" y="csY8"/>
-                </a:cxn>
-              </a:cxnLst>
-              <a:rect l="l" t="t" r="r" b="b"/>
-              <a:pathLst>
-                <a:path w="1893281" h="1869986">
-                  <a:moveTo>
-                    <a:pt x="37344" y="0"/>
-                  </a:moveTo>
-                  <a:lnTo>
-                    <a:pt x="1855937" y="0"/>
-                  </a:lnTo>
-                  <a:cubicBezTo>
-                    <a:pt x="1876562" y="0"/>
-                    <a:pt x="1893281" y="16719"/>
-                    <a:pt x="1893281" y="37344"/>
-                  </a:cubicBezTo>
-                  <a:lnTo>
-                    <a:pt x="1893281" y="1832642"/>
-                  </a:lnTo>
-                  <a:cubicBezTo>
-                    <a:pt x="1893281" y="1853267"/>
-                    <a:pt x="1876562" y="1869986"/>
-                    <a:pt x="1855937" y="1869986"/>
-                  </a:cubicBezTo>
-                  <a:lnTo>
-                    <a:pt x="37344" y="1869986"/>
-                  </a:lnTo>
-                  <a:cubicBezTo>
-                    <a:pt x="16719" y="1869986"/>
-                    <a:pt x="0" y="1853267"/>
-                    <a:pt x="0" y="1832642"/>
-                  </a:cubicBezTo>
-                  <a:lnTo>
-                    <a:pt x="0" y="37344"/>
-                  </a:lnTo>
-                  <a:cubicBezTo>
-                    <a:pt x="0" y="16719"/>
-                    <a:pt x="16719" y="0"/>
-                    <a:pt x="37344" y="0"/>
-                  </a:cubicBezTo>
-                  <a:close/>
-                </a:path>
-              </a:pathLst>
-            </a:custGeom>
-            <a:ln>
-              <a:solidFill>
-                <a:schemeClr val="tx2">
-                  <a:lumMod val="50000"/>
-                  <a:lumOff val="50000"/>
-                </a:schemeClr>
-              </a:solidFill>
-            </a:ln>
-            <a:effectLst>
-              <a:outerShdw blurRad="58657" dist="12700" dir="8100000" sx="101000" sy="101000" algn="tr" rotWithShape="0">
-                <a:srgbClr val="7030A0">
-                  <a:alpha val="40000"/>
-                </a:srgbClr>
-              </a:outerShdw>
-            </a:effectLst>
-          </p:spPr>
-        </p:pic>
-        <p:cxnSp>
-          <p:nvCxnSpPr>
-            <p:cNvPr id="71" name="直线连接符 70">
-              <a:extLst>
-                <a:ext uri="{FF2B5EF4-FFF2-40B4-BE49-F238E27FC236}">
-                  <a16:creationId xmlns:a16="http://schemas.microsoft.com/office/drawing/2014/main" id="{32863922-AA86-D90D-C617-AA0C70EA8C94}"/>
-                </a:ext>
-              </a:extLst>
-            </p:cNvPr>
-            <p:cNvCxnSpPr>
-              <a:cxnSpLocks/>
-            </p:cNvCxnSpPr>
-            <p:nvPr/>
-          </p:nvCxnSpPr>
-          <p:spPr>
-            <a:xfrm flipH="1" flipV="1">
-              <a:off x="3205709" y="5836653"/>
-              <a:ext cx="287873" cy="289827"/>
-            </a:xfrm>
-            <a:prstGeom prst="line">
-              <a:avLst/>
-            </a:prstGeom>
-            <a:ln w="9525">
-              <a:solidFill>
-                <a:schemeClr val="tx2">
-                  <a:lumMod val="50000"/>
-                  <a:lumOff val="50000"/>
-                </a:schemeClr>
-              </a:solidFill>
-              <a:tailEnd type="oval" w="sm" len="sm"/>
-            </a:ln>
-          </p:spPr>
-          <p:style>
-            <a:lnRef idx="2">
-              <a:schemeClr val="accent4"/>
-            </a:lnRef>
-            <a:fillRef idx="0">
-              <a:schemeClr val="accent4"/>
-            </a:fillRef>
-            <a:effectRef idx="1">
-              <a:schemeClr val="accent4"/>
-            </a:effectRef>
-            <a:fontRef idx="minor">
-              <a:schemeClr val="tx1"/>
-            </a:fontRef>
-          </p:style>
-        </p:cxnSp>
-        <p:cxnSp>
-          <p:nvCxnSpPr>
-            <p:cNvPr id="78" name="直线连接符 77">
-              <a:extLst>
-                <a:ext uri="{FF2B5EF4-FFF2-40B4-BE49-F238E27FC236}">
-                  <a16:creationId xmlns:a16="http://schemas.microsoft.com/office/drawing/2014/main" id="{DE1935D8-3055-6B05-FE2B-47988569AD20}"/>
-                </a:ext>
-              </a:extLst>
-            </p:cNvPr>
-            <p:cNvCxnSpPr>
-              <a:cxnSpLocks/>
-            </p:cNvCxnSpPr>
-            <p:nvPr/>
-          </p:nvCxnSpPr>
-          <p:spPr>
-            <a:xfrm>
-              <a:off x="1730829" y="6126480"/>
-              <a:ext cx="2220685" cy="0"/>
-            </a:xfrm>
-            <a:prstGeom prst="line">
-              <a:avLst/>
-            </a:prstGeom>
-            <a:ln w="9525">
-              <a:solidFill>
-                <a:schemeClr val="tx2">
-                  <a:lumMod val="50000"/>
-                  <a:lumOff val="50000"/>
-                </a:schemeClr>
-              </a:solidFill>
-              <a:headEnd type="oval" w="sm" len="sm"/>
-              <a:tailEnd type="none" w="med" len="med"/>
-            </a:ln>
-          </p:spPr>
-          <p:style>
-            <a:lnRef idx="2">
-              <a:schemeClr val="accent4"/>
-            </a:lnRef>
-            <a:fillRef idx="0">
-              <a:schemeClr val="accent4"/>
-            </a:fillRef>
-            <a:effectRef idx="1">
-              <a:schemeClr val="accent4"/>
-            </a:effectRef>
-            <a:fontRef idx="minor">
-              <a:schemeClr val="tx1"/>
-            </a:fontRef>
-          </p:style>
-        </p:cxnSp>
-        <p:sp>
-          <p:nvSpPr>
-            <p:cNvPr id="79" name="文本框 78">
-              <a:extLst>
-                <a:ext uri="{FF2B5EF4-FFF2-40B4-BE49-F238E27FC236}">
-                  <a16:creationId xmlns:a16="http://schemas.microsoft.com/office/drawing/2014/main" id="{911E7BB7-5502-050E-E833-CA3669D16C29}"/>
-                </a:ext>
-              </a:extLst>
-            </p:cNvPr>
-            <p:cNvSpPr txBox="1"/>
-            <p:nvPr/>
-          </p:nvSpPr>
-          <p:spPr>
-            <a:xfrm>
-              <a:off x="3427080" y="5936466"/>
-              <a:ext cx="829073" cy="200055"/>
-            </a:xfrm>
-            <a:prstGeom prst="rect">
-              <a:avLst/>
-            </a:prstGeom>
-            <a:noFill/>
-          </p:spPr>
-          <p:txBody>
-            <a:bodyPr wrap="none" rtlCol="0">
-              <a:spAutoFit/>
-            </a:bodyPr>
-            <a:lstStyle/>
-            <a:p>
-              <a:r>
-                <a:rPr kumimoji="1" lang="zh-CN" altLang="en" sz="700" b="1" dirty="0">
-                  <a:solidFill>
-                    <a:schemeClr val="tx2">
-                      <a:lumMod val="50000"/>
-                      <a:lumOff val="50000"/>
-                    </a:schemeClr>
-                  </a:solidFill>
-                  <a:effectLst>
-                    <a:outerShdw blurRad="187198" dist="38100" dir="5400000" sx="99744" sy="99744" algn="t" rotWithShape="0">
-                      <a:prstClr val="black">
-                        <a:alpha val="40000"/>
-                      </a:prstClr>
-                    </a:outerShdw>
-                  </a:effectLst>
-                  <a:latin typeface="Maple Mono NF CN" panose="020F0509060000000000" pitchFamily="49" charset="-128"/>
-                  <a:ea typeface="Maple Mono NF CN" panose="020F0509060000000000" pitchFamily="49" charset="-128"/>
-                </a:rPr>
-                <a:t>悬浮</a:t>
-              </a:r>
-              <a:r>
-                <a:rPr kumimoji="1" lang="zh-CN" altLang="en-US" sz="700" b="1" dirty="0">
-                  <a:solidFill>
-                    <a:schemeClr val="tx2">
-                      <a:lumMod val="50000"/>
-                      <a:lumOff val="50000"/>
-                    </a:schemeClr>
-                  </a:solidFill>
-                  <a:effectLst>
-                    <a:outerShdw blurRad="187198" dist="38100" dir="5400000" sx="99744" sy="99744" algn="t" rotWithShape="0">
-                      <a:prstClr val="black">
-                        <a:alpha val="40000"/>
-                      </a:prstClr>
-                    </a:outerShdw>
-                  </a:effectLst>
-                  <a:latin typeface="Maple Mono NF CN" panose="020F0509060000000000" pitchFamily="49" charset="-128"/>
-                  <a:ea typeface="Maple Mono NF CN" panose="020F0509060000000000" pitchFamily="49" charset="-128"/>
-                </a:rPr>
-                <a:t>帮助文档</a:t>
-              </a:r>
-              <a:endParaRPr kumimoji="1" lang="en" altLang="zh-CN" sz="700" b="1" dirty="0">
-                <a:solidFill>
-                  <a:schemeClr val="tx2">
-                    <a:lumMod val="50000"/>
-                    <a:lumOff val="50000"/>
-                  </a:schemeClr>
-                </a:solidFill>
-                <a:effectLst>
-                  <a:outerShdw blurRad="187198" dist="38100" dir="5400000" sx="99744" sy="99744" algn="t" rotWithShape="0">
-                    <a:prstClr val="black">
-                      <a:alpha val="40000"/>
-                    </a:prstClr>
-                  </a:outerShdw>
-                </a:effectLst>
-                <a:latin typeface="Maple Mono NF CN" panose="020F0509060000000000" pitchFamily="49" charset="-128"/>
-                <a:ea typeface="Maple Mono NF CN" panose="020F0509060000000000" pitchFamily="49" charset="-128"/>
-              </a:endParaRPr>
             </a:p>
           </p:txBody>
         </p:sp>
@@ -9138,8 +8098,8 @@
           </p:nvSpPr>
           <p:spPr>
             <a:xfrm>
-              <a:off x="4810029" y="872083"/>
-              <a:ext cx="936475" cy="200055"/>
+              <a:off x="4810029" y="762536"/>
+              <a:ext cx="1082348" cy="302840"/>
             </a:xfrm>
             <a:prstGeom prst="rect">
               <a:avLst/>
@@ -9150,26 +8110,26 @@
             <a:bodyPr wrap="none" rtlCol="0">
               <a:spAutoFit/>
             </a:bodyPr>
-            <a:lstStyle/>
+            <a:lstStyle>
+              <a:defPPr>
+                <a:defRPr lang="zh-CN"/>
+              </a:defPPr>
+              <a:lvl1pPr>
+                <a:lnSpc>
+                  <a:spcPct val="150000"/>
+                </a:lnSpc>
+                <a:defRPr sz="1000" b="1">
+                  <a:solidFill>
+                    <a:srgbClr val="0070C0"/>
+                  </a:solidFill>
+                  <a:latin typeface="Yuanti TC" panose="02010600040101010101" pitchFamily="2" charset="-120"/>
+                  <a:ea typeface="Yuanti TC" panose="02010600040101010101" pitchFamily="2" charset="-120"/>
+                </a:defRPr>
+              </a:lvl1pPr>
+            </a:lstStyle>
             <a:p>
               <a:r>
-                <a:rPr kumimoji="1" lang="zh-CN" altLang="en-US" sz="700" b="1" dirty="0">
-                  <a:solidFill>
-                    <a:schemeClr val="tx2">
-                      <a:lumMod val="50000"/>
-                      <a:lumOff val="50000"/>
-                    </a:schemeClr>
-                  </a:solidFill>
-                  <a:effectLst>
-                    <a:outerShdw blurRad="187198" dist="38100" dir="5400000" sx="99744" sy="99744" algn="t" rotWithShape="0">
-                      <a:prstClr val="black">
-                        <a:alpha val="40000"/>
-                      </a:prstClr>
-                    </a:outerShdw>
-                  </a:effectLst>
-                  <a:latin typeface="Maple Mono NF CN" panose="020F0509060000000000" pitchFamily="49" charset="-128"/>
-                  <a:ea typeface="Maple Mono NF CN" panose="020F0509060000000000" pitchFamily="49" charset="-128"/>
-                </a:rPr>
+                <a:rPr lang="zh-CN" altLang="en-US" dirty="0"/>
                 <a:t>便捷运行和配置</a:t>
               </a:r>
             </a:p>
@@ -9283,8 +8243,8 @@
           </p:nvSpPr>
           <p:spPr>
             <a:xfrm>
-              <a:off x="8900267" y="872083"/>
-              <a:ext cx="721672" cy="200055"/>
+              <a:off x="8900267" y="762536"/>
+              <a:ext cx="825867" cy="302840"/>
             </a:xfrm>
             <a:prstGeom prst="rect">
               <a:avLst/>
@@ -9295,26 +8255,26 @@
             <a:bodyPr wrap="none" rtlCol="0">
               <a:spAutoFit/>
             </a:bodyPr>
-            <a:lstStyle/>
+            <a:lstStyle>
+              <a:defPPr>
+                <a:defRPr lang="zh-CN"/>
+              </a:defPPr>
+              <a:lvl1pPr>
+                <a:lnSpc>
+                  <a:spcPct val="150000"/>
+                </a:lnSpc>
+                <a:defRPr sz="1000" b="1">
+                  <a:solidFill>
+                    <a:srgbClr val="0070C0"/>
+                  </a:solidFill>
+                  <a:latin typeface="Yuanti TC" panose="02010600040101010101" pitchFamily="2" charset="-120"/>
+                  <a:ea typeface="Yuanti TC" panose="02010600040101010101" pitchFamily="2" charset="-120"/>
+                </a:defRPr>
+              </a:lvl1pPr>
+            </a:lstStyle>
             <a:p>
               <a:r>
-                <a:rPr kumimoji="1" lang="zh-CN" altLang="en-US" sz="700" b="1" dirty="0">
-                  <a:solidFill>
-                    <a:schemeClr val="tx2">
-                      <a:lumMod val="50000"/>
-                      <a:lumOff val="50000"/>
-                    </a:schemeClr>
-                  </a:solidFill>
-                  <a:effectLst>
-                    <a:outerShdw blurRad="187198" dist="38100" dir="5400000" sx="99744" sy="99744" algn="t" rotWithShape="0">
-                      <a:prstClr val="black">
-                        <a:alpha val="40000"/>
-                      </a:prstClr>
-                    </a:outerShdw>
-                  </a:effectLst>
-                  <a:latin typeface="Maple Mono NF CN" panose="020F0509060000000000" pitchFamily="49" charset="-128"/>
-                  <a:ea typeface="Maple Mono NF CN" panose="020F0509060000000000" pitchFamily="49" charset="-128"/>
-                </a:rPr>
+                <a:rPr lang="zh-CN" altLang="en-US" dirty="0"/>
                 <a:t>数据查看器</a:t>
               </a:r>
             </a:p>
@@ -9521,7 +8481,7 @@
           <p:spPr>
             <a:xfrm flipH="1">
               <a:off x="9836331" y="2381250"/>
-              <a:ext cx="1031966" cy="0"/>
+              <a:ext cx="1162409" cy="0"/>
             </a:xfrm>
             <a:prstGeom prst="line">
               <a:avLst/>
@@ -9565,8 +8525,8 @@
           </p:nvSpPr>
           <p:spPr>
             <a:xfrm>
-              <a:off x="10616763" y="2191025"/>
-              <a:ext cx="506870" cy="200055"/>
+              <a:off x="10616763" y="2074295"/>
+              <a:ext cx="569387" cy="302840"/>
             </a:xfrm>
             <a:prstGeom prst="rect">
               <a:avLst/>
@@ -9577,27 +8537,27 @@
             <a:bodyPr wrap="none" rtlCol="0">
               <a:spAutoFit/>
             </a:bodyPr>
-            <a:lstStyle/>
+            <a:lstStyle>
+              <a:defPPr>
+                <a:defRPr lang="zh-CN"/>
+              </a:defPPr>
+              <a:lvl1pPr>
+                <a:lnSpc>
+                  <a:spcPct val="150000"/>
+                </a:lnSpc>
+                <a:defRPr sz="1000" b="1">
+                  <a:solidFill>
+                    <a:srgbClr val="0070C0"/>
+                  </a:solidFill>
+                  <a:latin typeface="Yuanti TC" panose="02010600040101010101" pitchFamily="2" charset="-120"/>
+                  <a:ea typeface="Yuanti TC" panose="02010600040101010101" pitchFamily="2" charset="-120"/>
+                </a:defRPr>
+              </a:lvl1pPr>
+            </a:lstStyle>
             <a:p>
               <a:pPr algn="r"/>
               <a:r>
-                <a:rPr kumimoji="1" lang="zh-CN" altLang="en-US" sz="700" b="1" dirty="0">
-                  <a:solidFill>
-                    <a:schemeClr val="tx2">
-                      <a:lumMod val="50000"/>
-                      <a:lumOff val="50000"/>
-                    </a:schemeClr>
-                  </a:solidFill>
-                  <a:effectLst>
-                    <a:outerShdw blurRad="187198" dist="38100" dir="5400000" sx="99744" sy="99744" algn="t" rotWithShape="0">
-                      <a:prstClr val="black">
-                        <a:alpha val="40000"/>
-                      </a:prstClr>
-                    </a:outerShdw>
-                  </a:effectLst>
-                  <a:latin typeface="Maple Mono NF CN" panose="020F0509060000000000" pitchFamily="49" charset="-128"/>
-                  <a:ea typeface="Maple Mono NF CN" panose="020F0509060000000000" pitchFamily="49" charset="-128"/>
-                </a:rPr>
+                <a:rPr lang="zh-CN" altLang="en-US" dirty="0"/>
                 <a:t>变量表</a:t>
               </a:r>
             </a:p>
@@ -9620,7 +8580,7 @@
           <p:spPr>
             <a:xfrm flipH="1">
               <a:off x="10156344" y="5102188"/>
-              <a:ext cx="711953" cy="0"/>
+              <a:ext cx="842396" cy="0"/>
             </a:xfrm>
             <a:prstGeom prst="line">
               <a:avLst/>
@@ -9711,8 +8671,8 @@
           </p:nvSpPr>
           <p:spPr>
             <a:xfrm>
-              <a:off x="10616763" y="4901834"/>
-              <a:ext cx="506870" cy="200055"/>
+              <a:off x="10616763" y="4804559"/>
+              <a:ext cx="569387" cy="302840"/>
             </a:xfrm>
             <a:prstGeom prst="rect">
               <a:avLst/>
@@ -9723,27 +8683,27 @@
             <a:bodyPr wrap="none" rtlCol="0">
               <a:spAutoFit/>
             </a:bodyPr>
-            <a:lstStyle/>
+            <a:lstStyle>
+              <a:defPPr>
+                <a:defRPr lang="zh-CN"/>
+              </a:defPPr>
+              <a:lvl1pPr>
+                <a:lnSpc>
+                  <a:spcPct val="150000"/>
+                </a:lnSpc>
+                <a:defRPr sz="1000" b="1">
+                  <a:solidFill>
+                    <a:srgbClr val="0070C0"/>
+                  </a:solidFill>
+                  <a:latin typeface="Yuanti TC" panose="02010600040101010101" pitchFamily="2" charset="-120"/>
+                  <a:ea typeface="Yuanti TC" panose="02010600040101010101" pitchFamily="2" charset="-120"/>
+                </a:defRPr>
+              </a:lvl1pPr>
+            </a:lstStyle>
             <a:p>
               <a:pPr algn="r"/>
               <a:r>
-                <a:rPr kumimoji="1" lang="zh-CN" altLang="en-US" sz="700" b="1" dirty="0">
-                  <a:solidFill>
-                    <a:schemeClr val="tx2">
-                      <a:lumMod val="50000"/>
-                      <a:lumOff val="50000"/>
-                    </a:schemeClr>
-                  </a:solidFill>
-                  <a:effectLst>
-                    <a:outerShdw blurRad="187198" dist="38100" dir="5400000" sx="99744" sy="99744" algn="t" rotWithShape="0">
-                      <a:prstClr val="black">
-                        <a:alpha val="40000"/>
-                      </a:prstClr>
-                    </a:outerShdw>
-                  </a:effectLst>
-                  <a:latin typeface="Maple Mono NF CN" panose="020F0509060000000000" pitchFamily="49" charset="-128"/>
-                  <a:ea typeface="Maple Mono NF CN" panose="020F0509060000000000" pitchFamily="49" charset="-128"/>
-                </a:rPr>
+                <a:rPr lang="zh-CN" altLang="en-US" dirty="0"/>
                 <a:t>数据表</a:t>
               </a:r>
             </a:p>
@@ -9813,7 +8773,7 @@
           <p:spPr>
             <a:xfrm flipH="1" flipV="1">
               <a:off x="9836331" y="3293519"/>
-              <a:ext cx="1031966" cy="543"/>
+              <a:ext cx="1162409" cy="543"/>
             </a:xfrm>
             <a:prstGeom prst="line">
               <a:avLst/>
@@ -9857,8 +8817,8 @@
           </p:nvSpPr>
           <p:spPr>
             <a:xfrm>
-              <a:off x="10288478" y="2995906"/>
-              <a:ext cx="829073" cy="307777"/>
+              <a:off x="10288478" y="2762446"/>
+              <a:ext cx="954107" cy="533672"/>
             </a:xfrm>
             <a:prstGeom prst="rect">
               <a:avLst/>
@@ -9869,89 +8829,41 @@
             <a:bodyPr wrap="none" rtlCol="0">
               <a:spAutoFit/>
             </a:bodyPr>
-            <a:lstStyle/>
+            <a:lstStyle>
+              <a:defPPr>
+                <a:defRPr lang="zh-CN"/>
+              </a:defPPr>
+              <a:lvl1pPr>
+                <a:lnSpc>
+                  <a:spcPct val="150000"/>
+                </a:lnSpc>
+                <a:defRPr sz="1000" b="1">
+                  <a:solidFill>
+                    <a:srgbClr val="0070C0"/>
+                  </a:solidFill>
+                  <a:latin typeface="Yuanti TC" panose="02010600040101010101" pitchFamily="2" charset="-120"/>
+                  <a:ea typeface="Yuanti TC" panose="02010600040101010101" pitchFamily="2" charset="-120"/>
+                </a:defRPr>
+              </a:lvl1pPr>
+            </a:lstStyle>
             <a:p>
               <a:pPr algn="r"/>
               <a:r>
-                <a:rPr kumimoji="1" lang="zh-CN" altLang="en" sz="700" b="1" dirty="0">
-                  <a:solidFill>
-                    <a:schemeClr val="tx2">
-                      <a:lumMod val="50000"/>
-                      <a:lumOff val="50000"/>
-                    </a:schemeClr>
-                  </a:solidFill>
-                  <a:effectLst>
-                    <a:outerShdw blurRad="187198" dist="38100" dir="5400000" sx="99744" sy="99744" algn="t" rotWithShape="0">
-                      <a:prstClr val="black">
-                        <a:alpha val="40000"/>
-                      </a:prstClr>
-                    </a:outerShdw>
-                  </a:effectLst>
-                  <a:latin typeface="Maple Mono NF CN" panose="020F0509060000000000" pitchFamily="49" charset="-128"/>
-                  <a:ea typeface="Maple Mono NF CN" panose="020F0509060000000000" pitchFamily="49" charset="-128"/>
-                </a:rPr>
+                <a:rPr lang="zh-CN" altLang="en" dirty="0"/>
                 <a:t>使用</a:t>
               </a:r>
               <a:r>
-                <a:rPr kumimoji="1" lang="en" altLang="zh-CN" sz="700" b="1" dirty="0">
-                  <a:solidFill>
-                    <a:schemeClr val="tx2">
-                      <a:lumMod val="50000"/>
-                      <a:lumOff val="50000"/>
-                    </a:schemeClr>
-                  </a:solidFill>
-                  <a:effectLst>
-                    <a:outerShdw blurRad="187198" dist="38100" dir="5400000" sx="99744" sy="99744" algn="t" rotWithShape="0">
-                      <a:prstClr val="black">
-                        <a:alpha val="40000"/>
-                      </a:prstClr>
-                    </a:outerShdw>
-                  </a:effectLst>
-                  <a:latin typeface="Maple Mono NF CN" panose="020F0509060000000000" pitchFamily="49" charset="-128"/>
-                  <a:ea typeface="Maple Mono NF CN" panose="020F0509060000000000" pitchFamily="49" charset="-128"/>
-                </a:rPr>
+                <a:rPr lang="en" altLang="zh-CN" dirty="0"/>
                 <a:t>Stata</a:t>
               </a:r>
             </a:p>
             <a:p>
               <a:pPr algn="r"/>
               <a:r>
-                <a:rPr kumimoji="1" lang="zh-CN" altLang="en-US" sz="700" b="1" dirty="0">
-                  <a:solidFill>
-                    <a:schemeClr val="tx2">
-                      <a:lumMod val="50000"/>
-                      <a:lumOff val="50000"/>
-                    </a:schemeClr>
-                  </a:solidFill>
-                  <a:effectLst>
-                    <a:outerShdw blurRad="187198" dist="38100" dir="5400000" sx="99744" sy="99744" algn="t" rotWithShape="0">
-                      <a:prstClr val="black">
-                        <a:alpha val="40000"/>
-                      </a:prstClr>
-                    </a:outerShdw>
-                  </a:effectLst>
-                  <a:latin typeface="Maple Mono NF CN" panose="020F0509060000000000" pitchFamily="49" charset="-128"/>
-                  <a:ea typeface="Maple Mono NF CN" panose="020F0509060000000000" pitchFamily="49" charset="-128"/>
-                </a:rPr>
+                <a:rPr lang="zh-CN" altLang="en-US" dirty="0"/>
                 <a:t>语法筛选数据</a:t>
               </a:r>
-              <a:endParaRPr kumimoji="1" lang="en" altLang="zh-CN" sz="700" b="1" dirty="0">
-                <a:solidFill>
-                  <a:schemeClr val="tx2">
-                    <a:lumMod val="50000"/>
-                    <a:lumOff val="50000"/>
-                  </a:schemeClr>
-                </a:solidFill>
-                <a:effectLst>
-                  <a:outerShdw blurRad="187198" dist="38100" dir="5400000" sx="99744" sy="99744" algn="t" rotWithShape="0">
-                    <a:prstClr val="black">
-                      <a:alpha val="40000"/>
-                    </a:prstClr>
-                  </a:outerShdw>
-                </a:effectLst>
-                <a:latin typeface="Maple Mono NF CN" panose="020F0509060000000000" pitchFamily="49" charset="-128"/>
-                <a:ea typeface="Maple Mono NF CN" panose="020F0509060000000000" pitchFamily="49" charset="-128"/>
-              </a:endParaRPr>
+              <a:endParaRPr lang="en" altLang="zh-CN" dirty="0"/>
             </a:p>
           </p:txBody>
         </p:sp>
@@ -10016,8 +8928,8 @@
           </p:nvSpPr>
           <p:spPr>
             <a:xfrm>
-              <a:off x="6101778" y="873959"/>
-              <a:ext cx="829073" cy="200055"/>
+              <a:off x="6101778" y="762536"/>
+              <a:ext cx="954107" cy="302840"/>
             </a:xfrm>
             <a:prstGeom prst="rect">
               <a:avLst/>
@@ -10028,45 +8940,29 @@
             <a:bodyPr wrap="none" rtlCol="0">
               <a:spAutoFit/>
             </a:bodyPr>
-            <a:lstStyle/>
+            <a:lstStyle>
+              <a:defPPr>
+                <a:defRPr lang="zh-CN"/>
+              </a:defPPr>
+              <a:lvl1pPr>
+                <a:lnSpc>
+                  <a:spcPct val="150000"/>
+                </a:lnSpc>
+                <a:defRPr sz="1000" b="1">
+                  <a:solidFill>
+                    <a:srgbClr val="0070C0"/>
+                  </a:solidFill>
+                  <a:latin typeface="Yuanti TC" panose="02010600040101010101" pitchFamily="2" charset="-120"/>
+                  <a:ea typeface="Yuanti TC" panose="02010600040101010101" pitchFamily="2" charset="-120"/>
+                </a:defRPr>
+              </a:lvl1pPr>
+            </a:lstStyle>
             <a:p>
               <a:r>
-                <a:rPr kumimoji="1" lang="zh-CN" altLang="en-US" sz="700" b="1" dirty="0">
-                  <a:solidFill>
-                    <a:schemeClr val="tx2">
-                      <a:lumMod val="50000"/>
-                      <a:lumOff val="50000"/>
-                    </a:schemeClr>
-                  </a:solidFill>
-                  <a:effectLst>
-                    <a:outerShdw blurRad="187198" dist="38100" dir="5400000" sx="99744" sy="99744" algn="t" rotWithShape="0">
-                      <a:prstClr val="black">
-                        <a:alpha val="40000"/>
-                      </a:prstClr>
-                    </a:outerShdw>
-                  </a:effectLst>
-                  <a:latin typeface="Maple Mono NF CN" panose="020F0509060000000000" pitchFamily="49" charset="-128"/>
-                  <a:ea typeface="Maple Mono NF CN" panose="020F0509060000000000" pitchFamily="49" charset="-128"/>
-                </a:rPr>
+                <a:rPr lang="zh-CN" altLang="en-US" dirty="0"/>
                 <a:t>嵌入式控制台</a:t>
               </a:r>
-              <a:endParaRPr kumimoji="1" lang="en-US" altLang="zh-CN" sz="700" b="1" dirty="0">
-                <a:solidFill>
-                  <a:schemeClr val="tx2">
-                    <a:lumMod val="50000"/>
-                    <a:lumOff val="50000"/>
-                  </a:schemeClr>
-                </a:solidFill>
-                <a:effectLst>
-                  <a:outerShdw blurRad="187198" dist="38100" dir="5400000" sx="99744" sy="99744" algn="t" rotWithShape="0">
-                    <a:prstClr val="black">
-                      <a:alpha val="40000"/>
-                    </a:prstClr>
-                  </a:outerShdw>
-                </a:effectLst>
-                <a:latin typeface="Maple Mono NF CN" panose="020F0509060000000000" pitchFamily="49" charset="-128"/>
-                <a:ea typeface="Maple Mono NF CN" panose="020F0509060000000000" pitchFamily="49" charset="-128"/>
-              </a:endParaRPr>
+              <a:endParaRPr lang="en-US" altLang="zh-CN" dirty="0"/>
             </a:p>
           </p:txBody>
         </p:sp>
@@ -10225,8 +9121,8 @@
           </p:nvSpPr>
           <p:spPr>
             <a:xfrm>
-              <a:off x="7362450" y="866296"/>
-              <a:ext cx="954788" cy="200055"/>
+              <a:off x="7362450" y="762536"/>
+              <a:ext cx="1005403" cy="302840"/>
             </a:xfrm>
             <a:prstGeom prst="rect">
               <a:avLst/>
@@ -10234,49 +9130,33 @@
             <a:noFill/>
           </p:spPr>
           <p:txBody>
-            <a:bodyPr wrap="square">
+            <a:bodyPr wrap="none" rtlCol="0">
               <a:spAutoFit/>
             </a:bodyPr>
-            <a:lstStyle/>
+            <a:lstStyle>
+              <a:defPPr>
+                <a:defRPr lang="zh-CN"/>
+              </a:defPPr>
+              <a:lvl1pPr>
+                <a:lnSpc>
+                  <a:spcPct val="150000"/>
+                </a:lnSpc>
+                <a:defRPr sz="1000" b="1">
+                  <a:solidFill>
+                    <a:srgbClr val="0070C0"/>
+                  </a:solidFill>
+                  <a:latin typeface="Yuanti TC" panose="02010600040101010101" pitchFamily="2" charset="-120"/>
+                  <a:ea typeface="Yuanti TC" panose="02010600040101010101" pitchFamily="2" charset="-120"/>
+                </a:defRPr>
+              </a:lvl1pPr>
+            </a:lstStyle>
             <a:p>
               <a:r>
-                <a:rPr kumimoji="1" lang="en-US" altLang="zh-CN" sz="700" b="1" dirty="0">
-                  <a:solidFill>
-                    <a:schemeClr val="tx2">
-                      <a:lumMod val="50000"/>
-                      <a:lumOff val="50000"/>
-                    </a:schemeClr>
-                  </a:solidFill>
-                  <a:effectLst>
-                    <a:outerShdw blurRad="187198" dist="38100" dir="5400000" sx="99744" sy="99744" algn="t" rotWithShape="0">
-                      <a:prstClr val="black">
-                        <a:alpha val="40000"/>
-                      </a:prstClr>
-                    </a:outerShdw>
-                  </a:effectLst>
-                  <a:latin typeface="Maple Mono NF CN" panose="020F0509060000000000" pitchFamily="49" charset="-128"/>
-                  <a:ea typeface="Maple Mono NF CN" panose="020F0509060000000000" pitchFamily="49" charset="-128"/>
-                </a:rPr>
+                <a:rPr lang="en-US" altLang="zh-CN" dirty="0"/>
                 <a:t>Stata</a:t>
               </a:r>
               <a:r>
-                <a:rPr kumimoji="1" lang="zh-CN" altLang="en-US" sz="700" b="1" dirty="0">
-                  <a:solidFill>
-                    <a:schemeClr val="tx2">
-                      <a:lumMod val="50000"/>
-                      <a:lumOff val="50000"/>
-                    </a:schemeClr>
-                  </a:solidFill>
-                  <a:effectLst>
-                    <a:outerShdw blurRad="187198" dist="38100" dir="5400000" sx="99744" sy="99744" algn="t" rotWithShape="0">
-                      <a:prstClr val="black">
-                        <a:alpha val="40000"/>
-                      </a:prstClr>
-                    </a:outerShdw>
-                  </a:effectLst>
-                  <a:latin typeface="Maple Mono NF CN" panose="020F0509060000000000" pitchFamily="49" charset="-128"/>
-                  <a:ea typeface="Maple Mono NF CN" panose="020F0509060000000000" pitchFamily="49" charset="-128"/>
-                </a:rPr>
+                <a:rPr lang="zh-CN" altLang="en-US" dirty="0"/>
                 <a:t>结果输出</a:t>
               </a:r>
             </a:p>
@@ -10390,8 +9270,8 @@
           </p:nvSpPr>
           <p:spPr>
             <a:xfrm>
-              <a:off x="9131300" y="5936466"/>
-              <a:ext cx="614272" cy="200055"/>
+              <a:off x="9170210" y="5826221"/>
+              <a:ext cx="697627" cy="302840"/>
             </a:xfrm>
             <a:prstGeom prst="rect">
               <a:avLst/>
@@ -10402,27 +9282,26 @@
             <a:bodyPr wrap="none" rtlCol="0">
               <a:spAutoFit/>
             </a:bodyPr>
-            <a:lstStyle/>
+            <a:lstStyle>
+              <a:defPPr>
+                <a:defRPr lang="zh-CN"/>
+              </a:defPPr>
+              <a:lvl1pPr>
+                <a:lnSpc>
+                  <a:spcPct val="150000"/>
+                </a:lnSpc>
+                <a:defRPr sz="1000" b="1">
+                  <a:solidFill>
+                    <a:srgbClr val="0070C0"/>
+                  </a:solidFill>
+                  <a:latin typeface="Yuanti TC" panose="02010600040101010101" pitchFamily="2" charset="-120"/>
+                  <a:ea typeface="Yuanti TC" panose="02010600040101010101" pitchFamily="2" charset="-120"/>
+                </a:defRPr>
+              </a:lvl1pPr>
+            </a:lstStyle>
             <a:p>
-              <a:pPr algn="r"/>
               <a:r>
-                <a:rPr kumimoji="1" lang="zh-CN" altLang="en-US" sz="700" b="1" dirty="0">
-                  <a:solidFill>
-                    <a:schemeClr val="tx2">
-                      <a:lumMod val="50000"/>
-                      <a:lumOff val="50000"/>
-                    </a:schemeClr>
-                  </a:solidFill>
-                  <a:effectLst>
-                    <a:outerShdw blurRad="187198" dist="38100" dir="5400000" sx="99744" sy="99744" algn="t" rotWithShape="0">
-                      <a:prstClr val="black">
-                        <a:alpha val="40000"/>
-                      </a:prstClr>
-                    </a:outerShdw>
-                  </a:effectLst>
-                  <a:latin typeface="Maple Mono NF CN" panose="020F0509060000000000" pitchFamily="49" charset="-128"/>
-                  <a:ea typeface="Maple Mono NF CN" panose="020F0509060000000000" pitchFamily="49" charset="-128"/>
-                </a:rPr>
+                <a:rPr lang="zh-CN" altLang="en-US" dirty="0"/>
                 <a:t>图片输出</a:t>
               </a:r>
             </a:p>
@@ -10536,8 +9415,8 @@
           </p:nvSpPr>
           <p:spPr>
             <a:xfrm>
-              <a:off x="7074584" y="5936466"/>
-              <a:ext cx="506870" cy="200055"/>
+              <a:off x="7113494" y="5826221"/>
+              <a:ext cx="569387" cy="302840"/>
             </a:xfrm>
             <a:prstGeom prst="rect">
               <a:avLst/>
@@ -10548,29 +9427,314 @@
             <a:bodyPr wrap="none" rtlCol="0">
               <a:spAutoFit/>
             </a:bodyPr>
-            <a:lstStyle/>
+            <a:lstStyle>
+              <a:defPPr>
+                <a:defRPr lang="zh-CN"/>
+              </a:defPPr>
+              <a:lvl1pPr>
+                <a:lnSpc>
+                  <a:spcPct val="150000"/>
+                </a:lnSpc>
+                <a:defRPr sz="1000" b="1">
+                  <a:solidFill>
+                    <a:srgbClr val="0070C0"/>
+                  </a:solidFill>
+                  <a:latin typeface="Yuanti TC" panose="02010600040101010101" pitchFamily="2" charset="-120"/>
+                  <a:ea typeface="Yuanti TC" panose="02010600040101010101" pitchFamily="2" charset="-120"/>
+                </a:defRPr>
+              </a:lvl1pPr>
+            </a:lstStyle>
             <a:p>
-              <a:pPr algn="r"/>
               <a:r>
-                <a:rPr kumimoji="1" lang="zh-CN" altLang="en-US" sz="700" b="1" dirty="0">
-                  <a:solidFill>
-                    <a:schemeClr val="tx2">
-                      <a:lumMod val="50000"/>
-                      <a:lumOff val="50000"/>
-                    </a:schemeClr>
-                  </a:solidFill>
-                  <a:effectLst>
-                    <a:outerShdw blurRad="187198" dist="38100" dir="5400000" sx="99744" sy="99744" algn="t" rotWithShape="0">
-                      <a:prstClr val="black">
-                        <a:alpha val="40000"/>
-                      </a:prstClr>
-                    </a:outerShdw>
-                  </a:effectLst>
-                  <a:latin typeface="Maple Mono NF CN" panose="020F0509060000000000" pitchFamily="49" charset="-128"/>
-                  <a:ea typeface="Maple Mono NF CN" panose="020F0509060000000000" pitchFamily="49" charset="-128"/>
-                </a:rPr>
+                <a:rPr lang="zh-CN" altLang="en-US" dirty="0"/>
                 <a:t>命令行</a:t>
               </a:r>
+            </a:p>
+          </p:txBody>
+        </p:sp>
+        <p:pic>
+          <p:nvPicPr>
+            <p:cNvPr id="3" name="图片 2">
+              <a:extLst>
+                <a:ext uri="{FF2B5EF4-FFF2-40B4-BE49-F238E27FC236}">
+                  <a16:creationId xmlns:a16="http://schemas.microsoft.com/office/drawing/2014/main" id="{EAAA91B4-518E-60CC-8033-ED0939B8D295}"/>
+                </a:ext>
+              </a:extLst>
+            </p:cNvPr>
+            <p:cNvPicPr>
+              <a:picLocks noChangeAspect="1"/>
+            </p:cNvPicPr>
+            <p:nvPr/>
+          </p:nvPicPr>
+          <p:blipFill>
+            <a:blip r:embed="rId5"/>
+            <a:srcRect/>
+            <a:stretch/>
+          </p:blipFill>
+          <p:spPr>
+            <a:xfrm>
+              <a:off x="1214608" y="4225539"/>
+              <a:ext cx="2161986" cy="2005595"/>
+            </a:xfrm>
+            <a:custGeom>
+              <a:avLst/>
+              <a:gdLst>
+                <a:gd name="csX0" fmla="*/ 37344 w 1893281"/>
+                <a:gd name="csY0" fmla="*/ 0 h 1869986"/>
+                <a:gd name="csX1" fmla="*/ 1855937 w 1893281"/>
+                <a:gd name="csY1" fmla="*/ 0 h 1869986"/>
+                <a:gd name="csX2" fmla="*/ 1893281 w 1893281"/>
+                <a:gd name="csY2" fmla="*/ 37344 h 1869986"/>
+                <a:gd name="csX3" fmla="*/ 1893281 w 1893281"/>
+                <a:gd name="csY3" fmla="*/ 1832642 h 1869986"/>
+                <a:gd name="csX4" fmla="*/ 1855937 w 1893281"/>
+                <a:gd name="csY4" fmla="*/ 1869986 h 1869986"/>
+                <a:gd name="csX5" fmla="*/ 37344 w 1893281"/>
+                <a:gd name="csY5" fmla="*/ 1869986 h 1869986"/>
+                <a:gd name="csX6" fmla="*/ 0 w 1893281"/>
+                <a:gd name="csY6" fmla="*/ 1832642 h 1869986"/>
+                <a:gd name="csX7" fmla="*/ 0 w 1893281"/>
+                <a:gd name="csY7" fmla="*/ 37344 h 1869986"/>
+                <a:gd name="csX8" fmla="*/ 37344 w 1893281"/>
+                <a:gd name="csY8" fmla="*/ 0 h 1869986"/>
+              </a:gdLst>
+              <a:ahLst/>
+              <a:cxnLst>
+                <a:cxn ang="0">
+                  <a:pos x="csX0" y="csY0"/>
+                </a:cxn>
+                <a:cxn ang="0">
+                  <a:pos x="csX1" y="csY1"/>
+                </a:cxn>
+                <a:cxn ang="0">
+                  <a:pos x="csX2" y="csY2"/>
+                </a:cxn>
+                <a:cxn ang="0">
+                  <a:pos x="csX3" y="csY3"/>
+                </a:cxn>
+                <a:cxn ang="0">
+                  <a:pos x="csX4" y="csY4"/>
+                </a:cxn>
+                <a:cxn ang="0">
+                  <a:pos x="csX5" y="csY5"/>
+                </a:cxn>
+                <a:cxn ang="0">
+                  <a:pos x="csX6" y="csY6"/>
+                </a:cxn>
+                <a:cxn ang="0">
+                  <a:pos x="csX7" y="csY7"/>
+                </a:cxn>
+                <a:cxn ang="0">
+                  <a:pos x="csX8" y="csY8"/>
+                </a:cxn>
+              </a:cxnLst>
+              <a:rect l="l" t="t" r="r" b="b"/>
+              <a:pathLst>
+                <a:path w="1893281" h="1869986">
+                  <a:moveTo>
+                    <a:pt x="37344" y="0"/>
+                  </a:moveTo>
+                  <a:lnTo>
+                    <a:pt x="1855937" y="0"/>
+                  </a:lnTo>
+                  <a:cubicBezTo>
+                    <a:pt x="1876562" y="0"/>
+                    <a:pt x="1893281" y="16719"/>
+                    <a:pt x="1893281" y="37344"/>
+                  </a:cubicBezTo>
+                  <a:lnTo>
+                    <a:pt x="1893281" y="1832642"/>
+                  </a:lnTo>
+                  <a:cubicBezTo>
+                    <a:pt x="1893281" y="1853267"/>
+                    <a:pt x="1876562" y="1869986"/>
+                    <a:pt x="1855937" y="1869986"/>
+                  </a:cubicBezTo>
+                  <a:lnTo>
+                    <a:pt x="37344" y="1869986"/>
+                  </a:lnTo>
+                  <a:cubicBezTo>
+                    <a:pt x="16719" y="1869986"/>
+                    <a:pt x="0" y="1853267"/>
+                    <a:pt x="0" y="1832642"/>
+                  </a:cubicBezTo>
+                  <a:lnTo>
+                    <a:pt x="0" y="37344"/>
+                  </a:lnTo>
+                  <a:cubicBezTo>
+                    <a:pt x="0" y="16719"/>
+                    <a:pt x="16719" y="0"/>
+                    <a:pt x="37344" y="0"/>
+                  </a:cubicBezTo>
+                  <a:close/>
+                </a:path>
+              </a:pathLst>
+            </a:custGeom>
+            <a:ln>
+              <a:solidFill>
+                <a:schemeClr val="accent5">
+                  <a:lumMod val="20000"/>
+                  <a:lumOff val="80000"/>
+                </a:schemeClr>
+              </a:solidFill>
+            </a:ln>
+            <a:effectLst>
+              <a:outerShdw blurRad="58657" dist="12700" dir="8100000" sx="101000" sy="101000" algn="tr" rotWithShape="0">
+                <a:srgbClr val="7030A0">
+                  <a:alpha val="40000"/>
+                </a:srgbClr>
+              </a:outerShdw>
+            </a:effectLst>
+          </p:spPr>
+        </p:pic>
+        <p:cxnSp>
+          <p:nvCxnSpPr>
+            <p:cNvPr id="71" name="直线连接符 70">
+              <a:extLst>
+                <a:ext uri="{FF2B5EF4-FFF2-40B4-BE49-F238E27FC236}">
+                  <a16:creationId xmlns:a16="http://schemas.microsoft.com/office/drawing/2014/main" id="{32863922-AA86-D90D-C617-AA0C70EA8C94}"/>
+                </a:ext>
+              </a:extLst>
+            </p:cNvPr>
+            <p:cNvCxnSpPr>
+              <a:cxnSpLocks/>
+            </p:cNvCxnSpPr>
+            <p:nvPr/>
+          </p:nvCxnSpPr>
+          <p:spPr>
+            <a:xfrm flipH="1" flipV="1">
+              <a:off x="3205709" y="5836653"/>
+              <a:ext cx="287873" cy="289827"/>
+            </a:xfrm>
+            <a:prstGeom prst="line">
+              <a:avLst/>
+            </a:prstGeom>
+            <a:ln w="9525">
+              <a:solidFill>
+                <a:schemeClr val="tx2">
+                  <a:lumMod val="50000"/>
+                  <a:lumOff val="50000"/>
+                </a:schemeClr>
+              </a:solidFill>
+              <a:tailEnd type="oval" w="sm" len="sm"/>
+            </a:ln>
+          </p:spPr>
+          <p:style>
+            <a:lnRef idx="2">
+              <a:schemeClr val="accent4"/>
+            </a:lnRef>
+            <a:fillRef idx="0">
+              <a:schemeClr val="accent4"/>
+            </a:fillRef>
+            <a:effectRef idx="1">
+              <a:schemeClr val="accent4"/>
+            </a:effectRef>
+            <a:fontRef idx="minor">
+              <a:schemeClr val="tx1"/>
+            </a:fontRef>
+          </p:style>
+        </p:cxnSp>
+        <p:cxnSp>
+          <p:nvCxnSpPr>
+            <p:cNvPr id="78" name="直线连接符 77">
+              <a:extLst>
+                <a:ext uri="{FF2B5EF4-FFF2-40B4-BE49-F238E27FC236}">
+                  <a16:creationId xmlns:a16="http://schemas.microsoft.com/office/drawing/2014/main" id="{DE1935D8-3055-6B05-FE2B-47988569AD20}"/>
+                </a:ext>
+              </a:extLst>
+            </p:cNvPr>
+            <p:cNvCxnSpPr>
+              <a:cxnSpLocks/>
+            </p:cNvCxnSpPr>
+            <p:nvPr/>
+          </p:nvCxnSpPr>
+          <p:spPr>
+            <a:xfrm>
+              <a:off x="1730829" y="6126480"/>
+              <a:ext cx="2220685" cy="0"/>
+            </a:xfrm>
+            <a:prstGeom prst="line">
+              <a:avLst/>
+            </a:prstGeom>
+            <a:ln w="9525">
+              <a:solidFill>
+                <a:schemeClr val="tx2">
+                  <a:lumMod val="50000"/>
+                  <a:lumOff val="50000"/>
+                </a:schemeClr>
+              </a:solidFill>
+              <a:headEnd type="oval" w="sm" len="sm"/>
+              <a:tailEnd type="none" w="med" len="med"/>
+            </a:ln>
+          </p:spPr>
+          <p:style>
+            <a:lnRef idx="2">
+              <a:schemeClr val="accent4"/>
+            </a:lnRef>
+            <a:fillRef idx="0">
+              <a:schemeClr val="accent4"/>
+            </a:fillRef>
+            <a:effectRef idx="1">
+              <a:schemeClr val="accent4"/>
+            </a:effectRef>
+            <a:fontRef idx="minor">
+              <a:schemeClr val="tx1"/>
+            </a:fontRef>
+          </p:style>
+        </p:cxnSp>
+        <p:sp>
+          <p:nvSpPr>
+            <p:cNvPr id="79" name="文本框 78">
+              <a:extLst>
+                <a:ext uri="{FF2B5EF4-FFF2-40B4-BE49-F238E27FC236}">
+                  <a16:creationId xmlns:a16="http://schemas.microsoft.com/office/drawing/2014/main" id="{911E7BB7-5502-050E-E833-CA3669D16C29}"/>
+                </a:ext>
+              </a:extLst>
+            </p:cNvPr>
+            <p:cNvSpPr txBox="1"/>
+            <p:nvPr/>
+          </p:nvSpPr>
+          <p:spPr>
+            <a:xfrm>
+              <a:off x="3465990" y="5826221"/>
+              <a:ext cx="954107" cy="302840"/>
+            </a:xfrm>
+            <a:prstGeom prst="rect">
+              <a:avLst/>
+            </a:prstGeom>
+            <a:noFill/>
+          </p:spPr>
+          <p:txBody>
+            <a:bodyPr wrap="none" rtlCol="0">
+              <a:spAutoFit/>
+            </a:bodyPr>
+            <a:lstStyle>
+              <a:defPPr>
+                <a:defRPr lang="zh-CN"/>
+              </a:defPPr>
+              <a:lvl1pPr>
+                <a:lnSpc>
+                  <a:spcPct val="150000"/>
+                </a:lnSpc>
+                <a:defRPr sz="1000" b="1">
+                  <a:solidFill>
+                    <a:srgbClr val="0070C0"/>
+                  </a:solidFill>
+                  <a:latin typeface="Yuanti TC" panose="02010600040101010101" pitchFamily="2" charset="-120"/>
+                  <a:ea typeface="Yuanti TC" panose="02010600040101010101" pitchFamily="2" charset="-120"/>
+                </a:defRPr>
+              </a:lvl1pPr>
+            </a:lstStyle>
+            <a:p>
+              <a:r>
+                <a:rPr lang="zh-CN" altLang="en" dirty="0"/>
+                <a:t>悬浮</a:t>
+              </a:r>
+              <a:r>
+                <a:rPr lang="zh-CN" altLang="en-US" dirty="0"/>
+                <a:t>帮助文档</a:t>
+              </a:r>
+              <a:endParaRPr lang="en" altLang="zh-CN" dirty="0"/>
             </a:p>
           </p:txBody>
         </p:sp>
@@ -10583,7 +9747,7 @@
     </p:extLst>
   </p:cSld>
   <p:clrMapOvr>
-    <a:masterClrMapping/>
+    <a:overrideClrMapping bg1="lt1" tx1="dk1" bg2="lt2" tx2="dk2" accent1="accent1" accent2="accent2" accent3="accent3" accent4="accent4" accent5="accent5" accent6="accent6" hlink="hlink" folHlink="folHlink"/>
   </p:clrMapOvr>
 </p:sld>
 </file>
@@ -11216,4 +10380,47 @@
     </a:ext>
   </a:extLst>
 </a:theme>
+</file>
+
+<file path=ppt/theme/themeOverride1.xml><?xml version="1.0" encoding="utf-8"?>
+<a:themeOverride xmlns:a="http://schemas.openxmlformats.org/drawingml/2006/main">
+  <a:clrScheme name="Office">
+    <a:dk1>
+      <a:sysClr val="windowText" lastClr="000000"/>
+    </a:dk1>
+    <a:lt1>
+      <a:sysClr val="window" lastClr="FFFFFF"/>
+    </a:lt1>
+    <a:dk2>
+      <a:srgbClr val="0E2841"/>
+    </a:dk2>
+    <a:lt2>
+      <a:srgbClr val="E8E8E8"/>
+    </a:lt2>
+    <a:accent1>
+      <a:srgbClr val="156082"/>
+    </a:accent1>
+    <a:accent2>
+      <a:srgbClr val="E97132"/>
+    </a:accent2>
+    <a:accent3>
+      <a:srgbClr val="196B24"/>
+    </a:accent3>
+    <a:accent4>
+      <a:srgbClr val="0F9ED5"/>
+    </a:accent4>
+    <a:accent5>
+      <a:srgbClr val="A02B93"/>
+    </a:accent5>
+    <a:accent6>
+      <a:srgbClr val="4EA72E"/>
+    </a:accent6>
+    <a:hlink>
+      <a:srgbClr val="467886"/>
+    </a:hlink>
+    <a:folHlink>
+      <a:srgbClr val="96607D"/>
+    </a:folHlink>
+  </a:clrScheme>
+</a:themeOverride>
 </file>
</xml_diff>

<commit_message>
release: prepare v0.3.0 stable release
- 更新版本号到 0.3.0，并同步中英文 README 与 CHANGELOG。
- 移除预览版弹窗、回退按钮和无关调试命令，仅保留 update notice。
- 更新 0.3.0 更新提示链接、正式版展示图片和赞助致谢。
</commit_message>
<xml_diff>
--- a/img/example-marked.pptx
+++ b/img/example-marked.pptx
@@ -119,7 +119,7 @@
 <file path=ppt/revisionInfo.xml><?xml version="1.0" encoding="utf-8"?>
 <p1510:revInfo xmlns:a="http://schemas.openxmlformats.org/drawingml/2006/main" xmlns:r="http://schemas.openxmlformats.org/officeDocument/2006/relationships" xmlns:p1510="http://schemas.microsoft.com/office/powerpoint/2015/10/main">
   <p1510:revLst>
-    <p1510:client id="{21B15FB9-1BA0-F247-8406-2C9EAB55C849}" v="209" dt="2026-06-07T10:36:10.071"/>
+    <p1510:client id="{21B15FB9-1BA0-F247-8406-2C9EAB55C849}" v="221" dt="2026-07-06T09:08:41.543"/>
   </p1510:revLst>
 </p1510:revInfo>
 </file>
@@ -128,13 +128,13 @@
 <pc:chgInfo xmlns:a="http://schemas.openxmlformats.org/drawingml/2006/main" xmlns:r="http://schemas.openxmlformats.org/officeDocument/2006/relationships" xmlns:ac="http://schemas.microsoft.com/office/drawing/2013/main/command" xmlns:pc="http://schemas.microsoft.com/office/powerpoint/2013/main/command">
   <pc:docChgLst>
     <pc:chgData name="Zihao Viston Wang" userId="bb38f0bb24686ff5" providerId="LiveId" clId="{624A8E29-C0AB-51FB-8E4A-8A86974DAEAD}"/>
-    <pc:docChg chg="undo custSel modSld">
-      <pc:chgData name="Zihao Viston Wang" userId="bb38f0bb24686ff5" providerId="LiveId" clId="{624A8E29-C0AB-51FB-8E4A-8A86974DAEAD}" dt="2026-06-07T10:36:10.071" v="832" actId="164"/>
+    <pc:docChg chg="undo redo custSel modSld">
+      <pc:chgData name="Zihao Viston Wang" userId="bb38f0bb24686ff5" providerId="LiveId" clId="{624A8E29-C0AB-51FB-8E4A-8A86974DAEAD}" dt="2026-07-06T09:08:41.541" v="938" actId="164"/>
       <pc:docMkLst>
         <pc:docMk/>
       </pc:docMkLst>
       <pc:sldChg chg="addSp delSp modSp mod">
-        <pc:chgData name="Zihao Viston Wang" userId="bb38f0bb24686ff5" providerId="LiveId" clId="{624A8E29-C0AB-51FB-8E4A-8A86974DAEAD}" dt="2026-06-07T10:35:34.008" v="831" actId="164"/>
+        <pc:chgData name="Zihao Viston Wang" userId="bb38f0bb24686ff5" providerId="LiveId" clId="{624A8E29-C0AB-51FB-8E4A-8A86974DAEAD}" dt="2026-07-06T09:07:42.829" v="937" actId="164"/>
         <pc:sldMkLst>
           <pc:docMk/>
           <pc:sldMk cId="333356922" sldId="256"/>
@@ -180,7 +180,7 @@
           </ac:spMkLst>
         </pc:spChg>
         <pc:spChg chg="mod">
-          <ac:chgData name="Zihao Viston Wang" userId="bb38f0bb24686ff5" providerId="LiveId" clId="{624A8E29-C0AB-51FB-8E4A-8A86974DAEAD}" dt="2026-06-07T10:35:34.008" v="831" actId="164"/>
+          <ac:chgData name="Zihao Viston Wang" userId="bb38f0bb24686ff5" providerId="LiveId" clId="{624A8E29-C0AB-51FB-8E4A-8A86974DAEAD}" dt="2026-07-06T09:05:32.057" v="923" actId="1037"/>
           <ac:spMkLst>
             <pc:docMk/>
             <pc:sldMk cId="333356922" sldId="256"/>
@@ -188,7 +188,7 @@
           </ac:spMkLst>
         </pc:spChg>
         <pc:spChg chg="mod topLvl">
-          <ac:chgData name="Zihao Viston Wang" userId="bb38f0bb24686ff5" providerId="LiveId" clId="{624A8E29-C0AB-51FB-8E4A-8A86974DAEAD}" dt="2026-06-07T10:35:17.753" v="830" actId="1037"/>
+          <ac:chgData name="Zihao Viston Wang" userId="bb38f0bb24686ff5" providerId="LiveId" clId="{624A8E29-C0AB-51FB-8E4A-8A86974DAEAD}" dt="2026-07-06T09:07:42.829" v="937" actId="164"/>
           <ac:spMkLst>
             <pc:docMk/>
             <pc:sldMk cId="333356922" sldId="256"/>
@@ -196,7 +196,7 @@
           </ac:spMkLst>
         </pc:spChg>
         <pc:spChg chg="mod topLvl">
-          <ac:chgData name="Zihao Viston Wang" userId="bb38f0bb24686ff5" providerId="LiveId" clId="{624A8E29-C0AB-51FB-8E4A-8A86974DAEAD}" dt="2026-06-07T10:33:33.568" v="724" actId="1037"/>
+          <ac:chgData name="Zihao Viston Wang" userId="bb38f0bb24686ff5" providerId="LiveId" clId="{624A8E29-C0AB-51FB-8E4A-8A86974DAEAD}" dt="2026-07-06T09:07:42.829" v="937" actId="164"/>
           <ac:spMkLst>
             <pc:docMk/>
             <pc:sldMk cId="333356922" sldId="256"/>
@@ -204,7 +204,7 @@
           </ac:spMkLst>
         </pc:spChg>
         <pc:spChg chg="mod topLvl">
-          <ac:chgData name="Zihao Viston Wang" userId="bb38f0bb24686ff5" providerId="LiveId" clId="{624A8E29-C0AB-51FB-8E4A-8A86974DAEAD}" dt="2026-06-07T10:35:34.008" v="831" actId="164"/>
+          <ac:chgData name="Zihao Viston Wang" userId="bb38f0bb24686ff5" providerId="LiveId" clId="{624A8E29-C0AB-51FB-8E4A-8A86974DAEAD}" dt="2026-07-06T09:07:42.829" v="937" actId="164"/>
           <ac:spMkLst>
             <pc:docMk/>
             <pc:sldMk cId="333356922" sldId="256"/>
@@ -212,15 +212,15 @@
           </ac:spMkLst>
         </pc:spChg>
         <pc:spChg chg="mod topLvl">
-          <ac:chgData name="Zihao Viston Wang" userId="bb38f0bb24686ff5" providerId="LiveId" clId="{624A8E29-C0AB-51FB-8E4A-8A86974DAEAD}" dt="2026-06-07T10:34:59.461" v="811" actId="1037"/>
+          <ac:chgData name="Zihao Viston Wang" userId="bb38f0bb24686ff5" providerId="LiveId" clId="{624A8E29-C0AB-51FB-8E4A-8A86974DAEAD}" dt="2026-07-06T09:07:42.829" v="937" actId="164"/>
           <ac:spMkLst>
             <pc:docMk/>
             <pc:sldMk cId="333356922" sldId="256"/>
             <ac:spMk id="114" creationId="{303CAF3C-365B-A0E6-FF95-D77E75F0614D}"/>
           </ac:spMkLst>
         </pc:spChg>
-        <pc:spChg chg="mod">
-          <ac:chgData name="Zihao Viston Wang" userId="bb38f0bb24686ff5" providerId="LiveId" clId="{624A8E29-C0AB-51FB-8E4A-8A86974DAEAD}" dt="2026-06-07T10:34:59.461" v="811" actId="1037"/>
+        <pc:spChg chg="mod topLvl">
+          <ac:chgData name="Zihao Viston Wang" userId="bb38f0bb24686ff5" providerId="LiveId" clId="{624A8E29-C0AB-51FB-8E4A-8A86974DAEAD}" dt="2026-07-06T09:07:42.829" v="937" actId="164"/>
           <ac:spMkLst>
             <pc:docMk/>
             <pc:sldMk cId="333356922" sldId="256"/>
@@ -228,7 +228,7 @@
           </ac:spMkLst>
         </pc:spChg>
         <pc:spChg chg="mod topLvl">
-          <ac:chgData name="Zihao Viston Wang" userId="bb38f0bb24686ff5" providerId="LiveId" clId="{624A8E29-C0AB-51FB-8E4A-8A86974DAEAD}" dt="2026-06-07T10:35:34.008" v="831" actId="164"/>
+          <ac:chgData name="Zihao Viston Wang" userId="bb38f0bb24686ff5" providerId="LiveId" clId="{624A8E29-C0AB-51FB-8E4A-8A86974DAEAD}" dt="2026-07-06T09:07:42.829" v="937" actId="164"/>
           <ac:spMkLst>
             <pc:docMk/>
             <pc:sldMk cId="333356922" sldId="256"/>
@@ -236,7 +236,7 @@
           </ac:spMkLst>
         </pc:spChg>
         <pc:spChg chg="mod topLvl">
-          <ac:chgData name="Zihao Viston Wang" userId="bb38f0bb24686ff5" providerId="LiveId" clId="{624A8E29-C0AB-51FB-8E4A-8A86974DAEAD}" dt="2026-06-07T10:35:34.008" v="831" actId="164"/>
+          <ac:chgData name="Zihao Viston Wang" userId="bb38f0bb24686ff5" providerId="LiveId" clId="{624A8E29-C0AB-51FB-8E4A-8A86974DAEAD}" dt="2026-07-06T09:07:42.829" v="937" actId="164"/>
           <ac:spMkLst>
             <pc:docMk/>
             <pc:sldMk cId="333356922" sldId="256"/>
@@ -244,7 +244,7 @@
           </ac:spMkLst>
         </pc:spChg>
         <pc:spChg chg="mod topLvl">
-          <ac:chgData name="Zihao Viston Wang" userId="bb38f0bb24686ff5" providerId="LiveId" clId="{624A8E29-C0AB-51FB-8E4A-8A86974DAEAD}" dt="2026-06-07T10:35:34.008" v="831" actId="164"/>
+          <ac:chgData name="Zihao Viston Wang" userId="bb38f0bb24686ff5" providerId="LiveId" clId="{624A8E29-C0AB-51FB-8E4A-8A86974DAEAD}" dt="2026-07-06T09:07:42.829" v="937" actId="164"/>
           <ac:spMkLst>
             <pc:docMk/>
             <pc:sldMk cId="333356922" sldId="256"/>
@@ -252,7 +252,7 @@
           </ac:spMkLst>
         </pc:spChg>
         <pc:spChg chg="mod topLvl">
-          <ac:chgData name="Zihao Viston Wang" userId="bb38f0bb24686ff5" providerId="LiveId" clId="{624A8E29-C0AB-51FB-8E4A-8A86974DAEAD}" dt="2026-06-07T10:35:34.008" v="831" actId="164"/>
+          <ac:chgData name="Zihao Viston Wang" userId="bb38f0bb24686ff5" providerId="LiveId" clId="{624A8E29-C0AB-51FB-8E4A-8A86974DAEAD}" dt="2026-07-06T09:07:42.829" v="937" actId="164"/>
           <ac:spMkLst>
             <pc:docMk/>
             <pc:sldMk cId="333356922" sldId="256"/>
@@ -260,103 +260,47 @@
           </ac:spMkLst>
         </pc:spChg>
         <pc:spChg chg="mod topLvl">
-          <ac:chgData name="Zihao Viston Wang" userId="bb38f0bb24686ff5" providerId="LiveId" clId="{624A8E29-C0AB-51FB-8E4A-8A86974DAEAD}" dt="2026-06-07T10:35:34.008" v="831" actId="164"/>
+          <ac:chgData name="Zihao Viston Wang" userId="bb38f0bb24686ff5" providerId="LiveId" clId="{624A8E29-C0AB-51FB-8E4A-8A86974DAEAD}" dt="2026-07-06T09:07:42.829" v="937" actId="164"/>
           <ac:spMkLst>
             <pc:docMk/>
             <pc:sldMk cId="333356922" sldId="256"/>
             <ac:spMk id="162" creationId="{6778955A-4814-046A-650F-24AC5D48E585}"/>
           </ac:spMkLst>
         </pc:spChg>
-        <pc:spChg chg="del mod topLvl">
-          <ac:chgData name="Zihao Viston Wang" userId="bb38f0bb24686ff5" providerId="LiveId" clId="{624A8E29-C0AB-51FB-8E4A-8A86974DAEAD}" dt="2026-06-07T10:21:25.332" v="270" actId="478"/>
-          <ac:spMkLst>
+        <pc:picChg chg="add del mod">
+          <ac:chgData name="Zihao Viston Wang" userId="bb38f0bb24686ff5" providerId="LiveId" clId="{624A8E29-C0AB-51FB-8E4A-8A86974DAEAD}" dt="2026-07-06T09:02:28.811" v="855" actId="478"/>
+          <ac:picMkLst>
             <pc:docMk/>
             <pc:sldMk cId="333356922" sldId="256"/>
-            <ac:spMk id="163" creationId="{0B26C5A9-9D90-3E00-BF36-6D4D5CB15F96}"/>
-          </ac:spMkLst>
-        </pc:spChg>
-        <pc:cxnChg chg="mod">
-          <ac:chgData name="Zihao Viston Wang" userId="bb38f0bb24686ff5" providerId="LiveId" clId="{624A8E29-C0AB-51FB-8E4A-8A86974DAEAD}" dt="2026-05-31T06:36:57.141" v="10" actId="692"/>
-          <ac:cxnSpMkLst>
+            <ac:picMk id="2" creationId="{B28AC28F-24EF-959B-66A1-B9EA9638D025}"/>
+          </ac:picMkLst>
+        </pc:picChg>
+        <pc:picChg chg="add del mod modCrop">
+          <ac:chgData name="Zihao Viston Wang" userId="bb38f0bb24686ff5" providerId="LiveId" clId="{624A8E29-C0AB-51FB-8E4A-8A86974DAEAD}" dt="2026-07-06T09:02:33.827" v="856" actId="478"/>
+          <ac:picMkLst>
             <pc:docMk/>
             <pc:sldMk cId="333356922" sldId="256"/>
-            <ac:cxnSpMk id="16" creationId="{702AFE14-0768-5BC0-CDBE-0B7982C4AF19}"/>
-          </ac:cxnSpMkLst>
-        </pc:cxnChg>
-        <pc:cxnChg chg="mod">
-          <ac:chgData name="Zihao Viston Wang" userId="bb38f0bb24686ff5" providerId="LiveId" clId="{624A8E29-C0AB-51FB-8E4A-8A86974DAEAD}" dt="2026-05-31T06:36:57.141" v="10" actId="692"/>
-          <ac:cxnSpMkLst>
+            <ac:picMk id="4" creationId="{41FF5429-6DE1-A45F-6C85-875EB5FC3C61}"/>
+          </ac:picMkLst>
+        </pc:picChg>
+        <pc:picChg chg="add mod">
+          <ac:chgData name="Zihao Viston Wang" userId="bb38f0bb24686ff5" providerId="LiveId" clId="{624A8E29-C0AB-51FB-8E4A-8A86974DAEAD}" dt="2026-07-06T09:03:54.429" v="886" actId="14100"/>
+          <ac:picMkLst>
             <pc:docMk/>
             <pc:sldMk cId="333356922" sldId="256"/>
-            <ac:cxnSpMk id="23" creationId="{7EFDCBCB-DF99-BE85-BEB3-4F7167972C43}"/>
-          </ac:cxnSpMkLst>
-        </pc:cxnChg>
-        <pc:cxnChg chg="mod">
-          <ac:chgData name="Zihao Viston Wang" userId="bb38f0bb24686ff5" providerId="LiveId" clId="{624A8E29-C0AB-51FB-8E4A-8A86974DAEAD}" dt="2026-05-31T06:36:57.141" v="10" actId="692"/>
-          <ac:cxnSpMkLst>
+            <ac:picMk id="5" creationId="{2DF35F2C-6704-3E6F-E7E5-265794FF71B1}"/>
+          </ac:picMkLst>
+        </pc:picChg>
+        <pc:picChg chg="mod">
+          <ac:chgData name="Zihao Viston Wang" userId="bb38f0bb24686ff5" providerId="LiveId" clId="{624A8E29-C0AB-51FB-8E4A-8A86974DAEAD}" dt="2026-07-06T09:01:50.146" v="852" actId="108"/>
+          <ac:picMkLst>
             <pc:docMk/>
             <pc:sldMk cId="333356922" sldId="256"/>
-            <ac:cxnSpMk id="34" creationId="{A2F30F7E-AE9D-14BB-D04B-32B336129E65}"/>
-          </ac:cxnSpMkLst>
-        </pc:cxnChg>
+            <ac:picMk id="107" creationId="{94A8FACC-7544-0856-FA63-58799CE76F94}"/>
+          </ac:picMkLst>
+        </pc:picChg>
         <pc:cxnChg chg="mod">
-          <ac:chgData name="Zihao Viston Wang" userId="bb38f0bb24686ff5" providerId="LiveId" clId="{624A8E29-C0AB-51FB-8E4A-8A86974DAEAD}" dt="2026-05-31T06:36:57.141" v="10" actId="692"/>
-          <ac:cxnSpMkLst>
-            <pc:docMk/>
-            <pc:sldMk cId="333356922" sldId="256"/>
-            <ac:cxnSpMk id="42" creationId="{2797FA0A-7840-BC28-A620-2BD60455E1F9}"/>
-          </ac:cxnSpMkLst>
-        </pc:cxnChg>
-        <pc:cxnChg chg="mod">
-          <ac:chgData name="Zihao Viston Wang" userId="bb38f0bb24686ff5" providerId="LiveId" clId="{624A8E29-C0AB-51FB-8E4A-8A86974DAEAD}" dt="2026-05-31T06:36:57.141" v="10" actId="692"/>
-          <ac:cxnSpMkLst>
-            <pc:docMk/>
-            <pc:sldMk cId="333356922" sldId="256"/>
-            <ac:cxnSpMk id="43" creationId="{9FA1B514-38FC-12B3-6103-1471C709E323}"/>
-          </ac:cxnSpMkLst>
-        </pc:cxnChg>
-        <pc:cxnChg chg="mod">
-          <ac:chgData name="Zihao Viston Wang" userId="bb38f0bb24686ff5" providerId="LiveId" clId="{624A8E29-C0AB-51FB-8E4A-8A86974DAEAD}" dt="2026-05-31T06:36:57.141" v="10" actId="692"/>
-          <ac:cxnSpMkLst>
-            <pc:docMk/>
-            <pc:sldMk cId="333356922" sldId="256"/>
-            <ac:cxnSpMk id="45" creationId="{6CFD0B21-EF17-0850-A16A-324451C208E9}"/>
-          </ac:cxnSpMkLst>
-        </pc:cxnChg>
-        <pc:cxnChg chg="mod">
-          <ac:chgData name="Zihao Viston Wang" userId="bb38f0bb24686ff5" providerId="LiveId" clId="{624A8E29-C0AB-51FB-8E4A-8A86974DAEAD}" dt="2026-05-31T06:36:57.141" v="10" actId="692"/>
-          <ac:cxnSpMkLst>
-            <pc:docMk/>
-            <pc:sldMk cId="333356922" sldId="256"/>
-            <ac:cxnSpMk id="49" creationId="{048963D1-C6DC-E7DF-EE81-AAFB21AFA728}"/>
-          </ac:cxnSpMkLst>
-        </pc:cxnChg>
-        <pc:cxnChg chg="mod">
-          <ac:chgData name="Zihao Viston Wang" userId="bb38f0bb24686ff5" providerId="LiveId" clId="{624A8E29-C0AB-51FB-8E4A-8A86974DAEAD}" dt="2026-05-31T06:36:57.141" v="10" actId="692"/>
-          <ac:cxnSpMkLst>
-            <pc:docMk/>
-            <pc:sldMk cId="333356922" sldId="256"/>
-            <ac:cxnSpMk id="50" creationId="{1F21ECC4-80A6-2A27-F117-AA80B885A977}"/>
-          </ac:cxnSpMkLst>
-        </pc:cxnChg>
-        <pc:cxnChg chg="mod">
-          <ac:chgData name="Zihao Viston Wang" userId="bb38f0bb24686ff5" providerId="LiveId" clId="{624A8E29-C0AB-51FB-8E4A-8A86974DAEAD}" dt="2026-05-31T06:36:57.141" v="10" actId="692"/>
-          <ac:cxnSpMkLst>
-            <pc:docMk/>
-            <pc:sldMk cId="333356922" sldId="256"/>
-            <ac:cxnSpMk id="71" creationId="{BDAADD49-104B-2EAB-FCA5-82DFB6326C8D}"/>
-          </ac:cxnSpMkLst>
-        </pc:cxnChg>
-        <pc:cxnChg chg="mod">
-          <ac:chgData name="Zihao Viston Wang" userId="bb38f0bb24686ff5" providerId="LiveId" clId="{624A8E29-C0AB-51FB-8E4A-8A86974DAEAD}" dt="2026-05-31T06:36:57.141" v="10" actId="692"/>
-          <ac:cxnSpMkLst>
-            <pc:docMk/>
-            <pc:sldMk cId="333356922" sldId="256"/>
-            <ac:cxnSpMk id="78" creationId="{32A2565B-36A2-B0EF-2FF4-BD8FD75511D3}"/>
-          </ac:cxnSpMkLst>
-        </pc:cxnChg>
-        <pc:cxnChg chg="mod">
-          <ac:chgData name="Zihao Viston Wang" userId="bb38f0bb24686ff5" providerId="LiveId" clId="{624A8E29-C0AB-51FB-8E4A-8A86974DAEAD}" dt="2026-05-31T06:37:57.269" v="16" actId="692"/>
+          <ac:chgData name="Zihao Viston Wang" userId="bb38f0bb24686ff5" providerId="LiveId" clId="{624A8E29-C0AB-51FB-8E4A-8A86974DAEAD}" dt="2026-07-06T09:03:08.254" v="863" actId="166"/>
           <ac:cxnSpMkLst>
             <pc:docMk/>
             <pc:sldMk cId="333356922" sldId="256"/>
@@ -380,38 +324,6 @@
           </ac:cxnSpMkLst>
         </pc:cxnChg>
         <pc:cxnChg chg="mod">
-          <ac:chgData name="Zihao Viston Wang" userId="bb38f0bb24686ff5" providerId="LiveId" clId="{624A8E29-C0AB-51FB-8E4A-8A86974DAEAD}" dt="2026-05-31T06:37:57.269" v="16" actId="692"/>
-          <ac:cxnSpMkLst>
-            <pc:docMk/>
-            <pc:sldMk cId="333356922" sldId="256"/>
-            <ac:cxnSpMk id="110" creationId="{FCDAB1CE-EFBB-AC0B-0DAF-18A0090F8B8D}"/>
-          </ac:cxnSpMkLst>
-        </pc:cxnChg>
-        <pc:cxnChg chg="mod">
-          <ac:chgData name="Zihao Viston Wang" userId="bb38f0bb24686ff5" providerId="LiveId" clId="{624A8E29-C0AB-51FB-8E4A-8A86974DAEAD}" dt="2026-05-31T06:37:57.269" v="16" actId="692"/>
-          <ac:cxnSpMkLst>
-            <pc:docMk/>
-            <pc:sldMk cId="333356922" sldId="256"/>
-            <ac:cxnSpMk id="116" creationId="{5CD7A262-30C5-F972-761C-1853E8EAD21B}"/>
-          </ac:cxnSpMkLst>
-        </pc:cxnChg>
-        <pc:cxnChg chg="mod">
-          <ac:chgData name="Zihao Viston Wang" userId="bb38f0bb24686ff5" providerId="LiveId" clId="{624A8E29-C0AB-51FB-8E4A-8A86974DAEAD}" dt="2026-05-31T06:37:57.269" v="16" actId="692"/>
-          <ac:cxnSpMkLst>
-            <pc:docMk/>
-            <pc:sldMk cId="333356922" sldId="256"/>
-            <ac:cxnSpMk id="123" creationId="{721BFE38-F56F-4ECB-C0E7-3AB53482FF50}"/>
-          </ac:cxnSpMkLst>
-        </pc:cxnChg>
-        <pc:cxnChg chg="mod">
-          <ac:chgData name="Zihao Viston Wang" userId="bb38f0bb24686ff5" providerId="LiveId" clId="{624A8E29-C0AB-51FB-8E4A-8A86974DAEAD}" dt="2026-05-31T06:37:57.269" v="16" actId="692"/>
-          <ac:cxnSpMkLst>
-            <pc:docMk/>
-            <pc:sldMk cId="333356922" sldId="256"/>
-            <ac:cxnSpMk id="131" creationId="{1F5057BC-2AFC-9E58-3C1E-B132DC0F3C77}"/>
-          </ac:cxnSpMkLst>
-        </pc:cxnChg>
-        <pc:cxnChg chg="mod">
           <ac:chgData name="Zihao Viston Wang" userId="bb38f0bb24686ff5" providerId="LiveId" clId="{624A8E29-C0AB-51FB-8E4A-8A86974DAEAD}" dt="2026-06-07T10:34:08.332" v="761" actId="14100"/>
           <ac:cxnSpMkLst>
             <pc:docMk/>
@@ -427,25 +339,9 @@
             <ac:cxnSpMk id="138" creationId="{A2CB1E6F-2323-694D-A086-DBF6AB34038D}"/>
           </ac:cxnSpMkLst>
         </pc:cxnChg>
-        <pc:cxnChg chg="mod">
-          <ac:chgData name="Zihao Viston Wang" userId="bb38f0bb24686ff5" providerId="LiveId" clId="{624A8E29-C0AB-51FB-8E4A-8A86974DAEAD}" dt="2026-05-31T06:37:57.269" v="16" actId="692"/>
-          <ac:cxnSpMkLst>
-            <pc:docMk/>
-            <pc:sldMk cId="333356922" sldId="256"/>
-            <ac:cxnSpMk id="150" creationId="{45959344-B3E4-8FB8-7E82-C77C6E203DAD}"/>
-          </ac:cxnSpMkLst>
-        </pc:cxnChg>
-        <pc:cxnChg chg="mod">
-          <ac:chgData name="Zihao Viston Wang" userId="bb38f0bb24686ff5" providerId="LiveId" clId="{624A8E29-C0AB-51FB-8E4A-8A86974DAEAD}" dt="2026-05-31T06:37:57.269" v="16" actId="692"/>
-          <ac:cxnSpMkLst>
-            <pc:docMk/>
-            <pc:sldMk cId="333356922" sldId="256"/>
-            <ac:cxnSpMk id="155" creationId="{7FE0FC47-DEAE-C128-81F0-01167734F819}"/>
-          </ac:cxnSpMkLst>
-        </pc:cxnChg>
       </pc:sldChg>
       <pc:sldChg chg="addSp delSp modSp mod setBg">
-        <pc:chgData name="Zihao Viston Wang" userId="bb38f0bb24686ff5" providerId="LiveId" clId="{624A8E29-C0AB-51FB-8E4A-8A86974DAEAD}" dt="2026-06-07T10:36:10.071" v="832" actId="164"/>
+        <pc:chgData name="Zihao Viston Wang" userId="bb38f0bb24686ff5" providerId="LiveId" clId="{624A8E29-C0AB-51FB-8E4A-8A86974DAEAD}" dt="2026-07-06T09:08:41.541" v="938" actId="164"/>
         <pc:sldMkLst>
           <pc:docMk/>
           <pc:sldMk cId="1547542409" sldId="258"/>
@@ -499,7 +395,7 @@
           </ac:spMkLst>
         </pc:spChg>
         <pc:spChg chg="mod topLvl">
-          <ac:chgData name="Zihao Viston Wang" userId="bb38f0bb24686ff5" providerId="LiveId" clId="{624A8E29-C0AB-51FB-8E4A-8A86974DAEAD}" dt="2026-06-07T10:30:24.076" v="532" actId="1035"/>
+          <ac:chgData name="Zihao Viston Wang" userId="bb38f0bb24686ff5" providerId="LiveId" clId="{624A8E29-C0AB-51FB-8E4A-8A86974DAEAD}" dt="2026-07-06T09:08:41.541" v="938" actId="164"/>
           <ac:spMkLst>
             <pc:docMk/>
             <pc:sldMk cId="1547542409" sldId="258"/>
@@ -507,15 +403,15 @@
           </ac:spMkLst>
         </pc:spChg>
         <pc:spChg chg="mod topLvl">
-          <ac:chgData name="Zihao Viston Wang" userId="bb38f0bb24686ff5" providerId="LiveId" clId="{624A8E29-C0AB-51FB-8E4A-8A86974DAEAD}" dt="2026-06-07T10:36:10.071" v="832" actId="164"/>
+          <ac:chgData name="Zihao Viston Wang" userId="bb38f0bb24686ff5" providerId="LiveId" clId="{624A8E29-C0AB-51FB-8E4A-8A86974DAEAD}" dt="2026-07-06T09:08:41.541" v="938" actId="164"/>
           <ac:spMkLst>
             <pc:docMk/>
             <pc:sldMk cId="1547542409" sldId="258"/>
             <ac:spMk id="100" creationId="{9F35ECDB-3798-53CC-0B3B-6251C1F733A6}"/>
           </ac:spMkLst>
         </pc:spChg>
-        <pc:spChg chg="mod">
-          <ac:chgData name="Zihao Viston Wang" userId="bb38f0bb24686ff5" providerId="LiveId" clId="{624A8E29-C0AB-51FB-8E4A-8A86974DAEAD}" dt="2026-06-07T10:30:33.400" v="539" actId="1035"/>
+        <pc:spChg chg="mod topLvl">
+          <ac:chgData name="Zihao Viston Wang" userId="bb38f0bb24686ff5" providerId="LiveId" clId="{624A8E29-C0AB-51FB-8E4A-8A86974DAEAD}" dt="2026-07-06T09:08:41.541" v="938" actId="164"/>
           <ac:spMkLst>
             <pc:docMk/>
             <pc:sldMk cId="1547542409" sldId="258"/>
@@ -523,7 +419,7 @@
           </ac:spMkLst>
         </pc:spChg>
         <pc:spChg chg="mod topLvl">
-          <ac:chgData name="Zihao Viston Wang" userId="bb38f0bb24686ff5" providerId="LiveId" clId="{624A8E29-C0AB-51FB-8E4A-8A86974DAEAD}" dt="2026-06-07T10:30:33.400" v="539" actId="1035"/>
+          <ac:chgData name="Zihao Viston Wang" userId="bb38f0bb24686ff5" providerId="LiveId" clId="{624A8E29-C0AB-51FB-8E4A-8A86974DAEAD}" dt="2026-07-06T09:08:41.541" v="938" actId="164"/>
           <ac:spMkLst>
             <pc:docMk/>
             <pc:sldMk cId="1547542409" sldId="258"/>
@@ -531,7 +427,7 @@
           </ac:spMkLst>
         </pc:spChg>
         <pc:spChg chg="mod topLvl">
-          <ac:chgData name="Zihao Viston Wang" userId="bb38f0bb24686ff5" providerId="LiveId" clId="{624A8E29-C0AB-51FB-8E4A-8A86974DAEAD}" dt="2026-06-07T10:36:10.071" v="832" actId="164"/>
+          <ac:chgData name="Zihao Viston Wang" userId="bb38f0bb24686ff5" providerId="LiveId" clId="{624A8E29-C0AB-51FB-8E4A-8A86974DAEAD}" dt="2026-07-06T09:08:41.541" v="938" actId="164"/>
           <ac:spMkLst>
             <pc:docMk/>
             <pc:sldMk cId="1547542409" sldId="258"/>
@@ -539,7 +435,7 @@
           </ac:spMkLst>
         </pc:spChg>
         <pc:spChg chg="mod topLvl">
-          <ac:chgData name="Zihao Viston Wang" userId="bb38f0bb24686ff5" providerId="LiveId" clId="{624A8E29-C0AB-51FB-8E4A-8A86974DAEAD}" dt="2026-06-07T10:36:10.071" v="832" actId="164"/>
+          <ac:chgData name="Zihao Viston Wang" userId="bb38f0bb24686ff5" providerId="LiveId" clId="{624A8E29-C0AB-51FB-8E4A-8A86974DAEAD}" dt="2026-07-06T09:08:41.541" v="938" actId="164"/>
           <ac:spMkLst>
             <pc:docMk/>
             <pc:sldMk cId="1547542409" sldId="258"/>
@@ -547,7 +443,7 @@
           </ac:spMkLst>
         </pc:spChg>
         <pc:spChg chg="mod topLvl">
-          <ac:chgData name="Zihao Viston Wang" userId="bb38f0bb24686ff5" providerId="LiveId" clId="{624A8E29-C0AB-51FB-8E4A-8A86974DAEAD}" dt="2026-06-07T10:36:10.071" v="832" actId="164"/>
+          <ac:chgData name="Zihao Viston Wang" userId="bb38f0bb24686ff5" providerId="LiveId" clId="{624A8E29-C0AB-51FB-8E4A-8A86974DAEAD}" dt="2026-07-06T09:08:41.541" v="938" actId="164"/>
           <ac:spMkLst>
             <pc:docMk/>
             <pc:sldMk cId="1547542409" sldId="258"/>
@@ -555,7 +451,7 @@
           </ac:spMkLst>
         </pc:spChg>
         <pc:spChg chg="mod topLvl">
-          <ac:chgData name="Zihao Viston Wang" userId="bb38f0bb24686ff5" providerId="LiveId" clId="{624A8E29-C0AB-51FB-8E4A-8A86974DAEAD}" dt="2026-06-07T10:30:53.862" v="560" actId="1038"/>
+          <ac:chgData name="Zihao Viston Wang" userId="bb38f0bb24686ff5" providerId="LiveId" clId="{624A8E29-C0AB-51FB-8E4A-8A86974DAEAD}" dt="2026-07-06T09:08:41.541" v="938" actId="164"/>
           <ac:spMkLst>
             <pc:docMk/>
             <pc:sldMk cId="1547542409" sldId="258"/>
@@ -563,7 +459,7 @@
           </ac:spMkLst>
         </pc:spChg>
         <pc:spChg chg="mod topLvl">
-          <ac:chgData name="Zihao Viston Wang" userId="bb38f0bb24686ff5" providerId="LiveId" clId="{624A8E29-C0AB-51FB-8E4A-8A86974DAEAD}" dt="2026-06-07T10:30:53.862" v="560" actId="1038"/>
+          <ac:chgData name="Zihao Viston Wang" userId="bb38f0bb24686ff5" providerId="LiveId" clId="{624A8E29-C0AB-51FB-8E4A-8A86974DAEAD}" dt="2026-07-06T09:08:41.541" v="938" actId="164"/>
           <ac:spMkLst>
             <pc:docMk/>
             <pc:sldMk cId="1547542409" sldId="258"/>
@@ -571,13 +467,21 @@
           </ac:spMkLst>
         </pc:spChg>
         <pc:spChg chg="mod topLvl">
-          <ac:chgData name="Zihao Viston Wang" userId="bb38f0bb24686ff5" providerId="LiveId" clId="{624A8E29-C0AB-51FB-8E4A-8A86974DAEAD}" dt="2026-06-07T10:36:10.071" v="832" actId="164"/>
+          <ac:chgData name="Zihao Viston Wang" userId="bb38f0bb24686ff5" providerId="LiveId" clId="{624A8E29-C0AB-51FB-8E4A-8A86974DAEAD}" dt="2026-07-06T09:08:41.541" v="938" actId="164"/>
           <ac:spMkLst>
             <pc:docMk/>
             <pc:sldMk cId="1547542409" sldId="258"/>
             <ac:spMk id="163" creationId="{66129CBA-1CCC-9DA7-573E-0AC281B7519C}"/>
           </ac:spMkLst>
         </pc:spChg>
+        <pc:picChg chg="add mod">
+          <ac:chgData name="Zihao Viston Wang" userId="bb38f0bb24686ff5" providerId="LiveId" clId="{624A8E29-C0AB-51FB-8E4A-8A86974DAEAD}" dt="2026-07-06T09:04:05.962" v="887"/>
+          <ac:picMkLst>
+            <pc:docMk/>
+            <pc:sldMk cId="1547542409" sldId="258"/>
+            <ac:picMk id="2" creationId="{6358BA2D-DC20-E93D-C7DD-B501F04DAA72}"/>
+          </ac:picMkLst>
+        </pc:picChg>
         <pc:picChg chg="add mod">
           <ac:chgData name="Zihao Viston Wang" userId="bb38f0bb24686ff5" providerId="LiveId" clId="{624A8E29-C0AB-51FB-8E4A-8A86974DAEAD}" dt="2026-06-07T10:22:22.569" v="280"/>
           <ac:picMkLst>
@@ -586,28 +490,12 @@
             <ac:picMk id="3" creationId="{EAAA91B4-518E-60CC-8033-ED0939B8D295}"/>
           </ac:picMkLst>
         </pc:picChg>
-        <pc:picChg chg="del mod">
-          <ac:chgData name="Zihao Viston Wang" userId="bb38f0bb24686ff5" providerId="LiveId" clId="{624A8E29-C0AB-51FB-8E4A-8A86974DAEAD}" dt="2026-06-07T10:22:22.062" v="279" actId="478"/>
-          <ac:picMkLst>
-            <pc:docMk/>
-            <pc:sldMk cId="1547542409" sldId="258"/>
-            <ac:picMk id="70" creationId="{200E670D-C701-E2FD-C685-601E4C695041}"/>
-          </ac:picMkLst>
-        </pc:picChg>
         <pc:cxnChg chg="mod">
           <ac:chgData name="Zihao Viston Wang" userId="bb38f0bb24686ff5" providerId="LiveId" clId="{624A8E29-C0AB-51FB-8E4A-8A86974DAEAD}" dt="2026-06-07T10:30:12.463" v="524" actId="14100"/>
           <ac:cxnSpMkLst>
             <pc:docMk/>
             <pc:sldMk cId="1547542409" sldId="258"/>
             <ac:cxnSpMk id="16" creationId="{33A52804-A982-32B9-98E1-23DCCAC42C93}"/>
-          </ac:cxnSpMkLst>
-        </pc:cxnChg>
-        <pc:cxnChg chg="mod">
-          <ac:chgData name="Zihao Viston Wang" userId="bb38f0bb24686ff5" providerId="LiveId" clId="{624A8E29-C0AB-51FB-8E4A-8A86974DAEAD}" dt="2026-05-31T06:39:33.374" v="44" actId="692"/>
-          <ac:cxnSpMkLst>
-            <pc:docMk/>
-            <pc:sldMk cId="1547542409" sldId="258"/>
-            <ac:cxnSpMk id="23" creationId="{09092759-02D4-0C63-6752-67DB83CA9452}"/>
           </ac:cxnSpMkLst>
         </pc:cxnChg>
         <pc:cxnChg chg="mod">
@@ -627,27 +515,11 @@
           </ac:cxnSpMkLst>
         </pc:cxnChg>
         <pc:cxnChg chg="mod">
-          <ac:chgData name="Zihao Viston Wang" userId="bb38f0bb24686ff5" providerId="LiveId" clId="{624A8E29-C0AB-51FB-8E4A-8A86974DAEAD}" dt="2026-05-31T06:39:33.374" v="44" actId="692"/>
-          <ac:cxnSpMkLst>
-            <pc:docMk/>
-            <pc:sldMk cId="1547542409" sldId="258"/>
-            <ac:cxnSpMk id="43" creationId="{E0011866-623F-0918-9882-4F1FD08AC2AB}"/>
-          </ac:cxnSpMkLst>
-        </pc:cxnChg>
-        <pc:cxnChg chg="mod">
           <ac:chgData name="Zihao Viston Wang" userId="bb38f0bb24686ff5" providerId="LiveId" clId="{624A8E29-C0AB-51FB-8E4A-8A86974DAEAD}" dt="2026-06-07T10:29:47.509" v="521" actId="14100"/>
           <ac:cxnSpMkLst>
             <pc:docMk/>
             <pc:sldMk cId="1547542409" sldId="258"/>
             <ac:cxnSpMk id="45" creationId="{C5648FE9-4F55-25B9-46FA-9F816C596E62}"/>
-          </ac:cxnSpMkLst>
-        </pc:cxnChg>
-        <pc:cxnChg chg="mod">
-          <ac:chgData name="Zihao Viston Wang" userId="bb38f0bb24686ff5" providerId="LiveId" clId="{624A8E29-C0AB-51FB-8E4A-8A86974DAEAD}" dt="2026-05-31T06:39:33.374" v="44" actId="692"/>
-          <ac:cxnSpMkLst>
-            <pc:docMk/>
-            <pc:sldMk cId="1547542409" sldId="258"/>
-            <ac:cxnSpMk id="50" creationId="{4877BB6D-056A-9C7F-54A3-571E4D88E199}"/>
           </ac:cxnSpMkLst>
         </pc:cxnChg>
         <pc:cxnChg chg="mod">
@@ -667,19 +539,19 @@
           </ac:cxnSpMkLst>
         </pc:cxnChg>
         <pc:cxnChg chg="mod">
+          <ac:chgData name="Zihao Viston Wang" userId="bb38f0bb24686ff5" providerId="LiveId" clId="{624A8E29-C0AB-51FB-8E4A-8A86974DAEAD}" dt="2026-07-06T09:04:34.875" v="891" actId="166"/>
+          <ac:cxnSpMkLst>
+            <pc:docMk/>
+            <pc:sldMk cId="1547542409" sldId="258"/>
+            <ac:cxnSpMk id="91" creationId="{9B7824B4-D3E4-597B-37ED-BBAA321E16DF}"/>
+          </ac:cxnSpMkLst>
+        </pc:cxnChg>
+        <pc:cxnChg chg="mod">
           <ac:chgData name="Zihao Viston Wang" userId="bb38f0bb24686ff5" providerId="LiveId" clId="{624A8E29-C0AB-51FB-8E4A-8A86974DAEAD}" dt="2026-06-07T10:27:38.537" v="399" actId="554"/>
           <ac:cxnSpMkLst>
             <pc:docMk/>
             <pc:sldMk cId="1547542409" sldId="258"/>
             <ac:cxnSpMk id="96" creationId="{2AEBE6DE-E151-02D5-F89C-8E0E9C9044F5}"/>
-          </ac:cxnSpMkLst>
-        </pc:cxnChg>
-        <pc:cxnChg chg="mod">
-          <ac:chgData name="Zihao Viston Wang" userId="bb38f0bb24686ff5" providerId="LiveId" clId="{624A8E29-C0AB-51FB-8E4A-8A86974DAEAD}" dt="2026-05-31T06:39:54.006" v="45" actId="692"/>
-          <ac:cxnSpMkLst>
-            <pc:docMk/>
-            <pc:sldMk cId="1547542409" sldId="258"/>
-            <ac:cxnSpMk id="99" creationId="{B07DE192-5861-4AA0-5922-4C2C30397BB4}"/>
           </ac:cxnSpMkLst>
         </pc:cxnChg>
         <pc:cxnChg chg="mod">
@@ -707,22 +579,6 @@
           </ac:cxnSpMkLst>
         </pc:cxnChg>
         <pc:cxnChg chg="mod">
-          <ac:chgData name="Zihao Viston Wang" userId="bb38f0bb24686ff5" providerId="LiveId" clId="{624A8E29-C0AB-51FB-8E4A-8A86974DAEAD}" dt="2026-05-31T06:39:54.006" v="45" actId="692"/>
-          <ac:cxnSpMkLst>
-            <pc:docMk/>
-            <pc:sldMk cId="1547542409" sldId="258"/>
-            <ac:cxnSpMk id="117" creationId="{3D39A993-E931-2AC7-FA2C-448F52995C16}"/>
-          </ac:cxnSpMkLst>
-        </pc:cxnChg>
-        <pc:cxnChg chg="mod">
-          <ac:chgData name="Zihao Viston Wang" userId="bb38f0bb24686ff5" providerId="LiveId" clId="{624A8E29-C0AB-51FB-8E4A-8A86974DAEAD}" dt="2026-05-31T06:39:54.006" v="45" actId="692"/>
-          <ac:cxnSpMkLst>
-            <pc:docMk/>
-            <pc:sldMk cId="1547542409" sldId="258"/>
-            <ac:cxnSpMk id="123" creationId="{0AC23D31-00F6-8C3C-CCE5-B1CD5ADAC9DE}"/>
-          </ac:cxnSpMkLst>
-        </pc:cxnChg>
-        <pc:cxnChg chg="mod">
           <ac:chgData name="Zihao Viston Wang" userId="bb38f0bb24686ff5" providerId="LiveId" clId="{624A8E29-C0AB-51FB-8E4A-8A86974DAEAD}" dt="2026-06-07T10:31:08.689" v="562" actId="14100"/>
           <ac:cxnSpMkLst>
             <pc:docMk/>
@@ -744,22 +600,6 @@
             <pc:docMk/>
             <pc:sldMk cId="1547542409" sldId="258"/>
             <ac:cxnSpMk id="138" creationId="{5B05E6EA-4C33-697C-3B34-833C7E2DB7CE}"/>
-          </ac:cxnSpMkLst>
-        </pc:cxnChg>
-        <pc:cxnChg chg="mod">
-          <ac:chgData name="Zihao Viston Wang" userId="bb38f0bb24686ff5" providerId="LiveId" clId="{624A8E29-C0AB-51FB-8E4A-8A86974DAEAD}" dt="2026-05-31T06:39:54.006" v="45" actId="692"/>
-          <ac:cxnSpMkLst>
-            <pc:docMk/>
-            <pc:sldMk cId="1547542409" sldId="258"/>
-            <ac:cxnSpMk id="155" creationId="{A117E8C1-02A9-5451-1830-01148D627210}"/>
-          </ac:cxnSpMkLst>
-        </pc:cxnChg>
-        <pc:cxnChg chg="mod">
-          <ac:chgData name="Zihao Viston Wang" userId="bb38f0bb24686ff5" providerId="LiveId" clId="{624A8E29-C0AB-51FB-8E4A-8A86974DAEAD}" dt="2026-05-31T06:39:54.006" v="45" actId="692"/>
-          <ac:cxnSpMkLst>
-            <pc:docMk/>
-            <pc:sldMk cId="1547542409" sldId="258"/>
-            <ac:cxnSpMk id="157" creationId="{A631FC9A-ECFB-9E48-30E2-99B11F5E6136}"/>
           </ac:cxnSpMkLst>
         </pc:cxnChg>
       </pc:sldChg>
@@ -850,7 +690,7 @@
           <a:p>
             <a:fld id="{23656DED-251E-404A-A174-6D96B007F581}" type="datetimeFigureOut">
               <a:rPr kumimoji="1" lang="zh-CN" altLang="en-US" smtClean="0"/>
-              <a:t>2026/6/7</a:t>
+              <a:t>2026/7/6</a:t>
             </a:fld>
             <a:endParaRPr kumimoji="1" lang="zh-CN" altLang="en-US"/>
           </a:p>
@@ -1348,7 +1188,7 @@
           <a:p>
             <a:fld id="{B9191346-5DF8-1F46-A428-6312BC22D0EA}" type="datetimeFigureOut">
               <a:rPr kumimoji="1" lang="zh-CN" altLang="en-US" smtClean="0"/>
-              <a:t>2026/6/7</a:t>
+              <a:t>2026/7/6</a:t>
             </a:fld>
             <a:endParaRPr kumimoji="1" lang="zh-CN" altLang="en-US"/>
           </a:p>
@@ -1546,7 +1386,7 @@
           <a:p>
             <a:fld id="{B9191346-5DF8-1F46-A428-6312BC22D0EA}" type="datetimeFigureOut">
               <a:rPr kumimoji="1" lang="zh-CN" altLang="en-US" smtClean="0"/>
-              <a:t>2026/6/7</a:t>
+              <a:t>2026/7/6</a:t>
             </a:fld>
             <a:endParaRPr kumimoji="1" lang="zh-CN" altLang="en-US"/>
           </a:p>
@@ -1754,7 +1594,7 @@
           <a:p>
             <a:fld id="{B9191346-5DF8-1F46-A428-6312BC22D0EA}" type="datetimeFigureOut">
               <a:rPr kumimoji="1" lang="zh-CN" altLang="en-US" smtClean="0"/>
-              <a:t>2026/6/7</a:t>
+              <a:t>2026/7/6</a:t>
             </a:fld>
             <a:endParaRPr kumimoji="1" lang="zh-CN" altLang="en-US"/>
           </a:p>
@@ -1952,7 +1792,7 @@
           <a:p>
             <a:fld id="{B9191346-5DF8-1F46-A428-6312BC22D0EA}" type="datetimeFigureOut">
               <a:rPr kumimoji="1" lang="zh-CN" altLang="en-US" smtClean="0"/>
-              <a:t>2026/6/7</a:t>
+              <a:t>2026/7/6</a:t>
             </a:fld>
             <a:endParaRPr kumimoji="1" lang="zh-CN" altLang="en-US"/>
           </a:p>
@@ -2227,7 +2067,7 @@
           <a:p>
             <a:fld id="{B9191346-5DF8-1F46-A428-6312BC22D0EA}" type="datetimeFigureOut">
               <a:rPr kumimoji="1" lang="zh-CN" altLang="en-US" smtClean="0"/>
-              <a:t>2026/6/7</a:t>
+              <a:t>2026/7/6</a:t>
             </a:fld>
             <a:endParaRPr kumimoji="1" lang="zh-CN" altLang="en-US"/>
           </a:p>
@@ -2492,7 +2332,7 @@
           <a:p>
             <a:fld id="{B9191346-5DF8-1F46-A428-6312BC22D0EA}" type="datetimeFigureOut">
               <a:rPr kumimoji="1" lang="zh-CN" altLang="en-US" smtClean="0"/>
-              <a:t>2026/6/7</a:t>
+              <a:t>2026/7/6</a:t>
             </a:fld>
             <a:endParaRPr kumimoji="1" lang="zh-CN" altLang="en-US"/>
           </a:p>
@@ -2904,7 +2744,7 @@
           <a:p>
             <a:fld id="{B9191346-5DF8-1F46-A428-6312BC22D0EA}" type="datetimeFigureOut">
               <a:rPr kumimoji="1" lang="zh-CN" altLang="en-US" smtClean="0"/>
-              <a:t>2026/6/7</a:t>
+              <a:t>2026/7/6</a:t>
             </a:fld>
             <a:endParaRPr kumimoji="1" lang="zh-CN" altLang="en-US"/>
           </a:p>
@@ -3045,7 +2885,7 @@
           <a:p>
             <a:fld id="{B9191346-5DF8-1F46-A428-6312BC22D0EA}" type="datetimeFigureOut">
               <a:rPr kumimoji="1" lang="zh-CN" altLang="en-US" smtClean="0"/>
-              <a:t>2026/6/7</a:t>
+              <a:t>2026/7/6</a:t>
             </a:fld>
             <a:endParaRPr kumimoji="1" lang="zh-CN" altLang="en-US"/>
           </a:p>
@@ -3158,7 +2998,7 @@
           <a:p>
             <a:fld id="{B9191346-5DF8-1F46-A428-6312BC22D0EA}" type="datetimeFigureOut">
               <a:rPr kumimoji="1" lang="zh-CN" altLang="en-US" smtClean="0"/>
-              <a:t>2026/6/7</a:t>
+              <a:t>2026/7/6</a:t>
             </a:fld>
             <a:endParaRPr kumimoji="1" lang="zh-CN" altLang="en-US"/>
           </a:p>
@@ -3469,7 +3309,7 @@
           <a:p>
             <a:fld id="{B9191346-5DF8-1F46-A428-6312BC22D0EA}" type="datetimeFigureOut">
               <a:rPr kumimoji="1" lang="zh-CN" altLang="en-US" smtClean="0"/>
-              <a:t>2026/6/7</a:t>
+              <a:t>2026/7/6</a:t>
             </a:fld>
             <a:endParaRPr kumimoji="1" lang="zh-CN" altLang="en-US"/>
           </a:p>
@@ -3757,7 +3597,7 @@
           <a:p>
             <a:fld id="{B9191346-5DF8-1F46-A428-6312BC22D0EA}" type="datetimeFigureOut">
               <a:rPr kumimoji="1" lang="zh-CN" altLang="en-US" smtClean="0"/>
-              <a:t>2026/6/7</a:t>
+              <a:t>2026/7/6</a:t>
             </a:fld>
             <a:endParaRPr kumimoji="1" lang="zh-CN" altLang="en-US"/>
           </a:p>
@@ -3998,7 +3838,7 @@
           <a:p>
             <a:fld id="{B9191346-5DF8-1F46-A428-6312BC22D0EA}" type="datetimeFigureOut">
               <a:rPr kumimoji="1" lang="zh-CN" altLang="en-US" smtClean="0"/>
-              <a:t>2026/6/7</a:t>
+              <a:t>2026/7/6</a:t>
             </a:fld>
             <a:endParaRPr kumimoji="1" lang="zh-CN" altLang="en-US"/>
           </a:p>
@@ -4417,10 +4257,10 @@
       </p:grpSpPr>
       <p:grpSp>
         <p:nvGrpSpPr>
-          <p:cNvPr id="9" name="组合 8">
+          <p:cNvPr id="6" name="组合 5">
             <a:extLst>
               <a:ext uri="{FF2B5EF4-FFF2-40B4-BE49-F238E27FC236}">
-                <a16:creationId xmlns:a16="http://schemas.microsoft.com/office/drawing/2014/main" id="{5B4C918B-C64C-0560-D796-04A1AF75EB0A}"/>
+                <a16:creationId xmlns:a16="http://schemas.microsoft.com/office/drawing/2014/main" id="{00A02D6E-0AF4-31B9-E1DF-3D5CF85984F0}"/>
               </a:ext>
             </a:extLst>
           </p:cNvPr>
@@ -5304,7 +5144,7 @@
           </p:nvSpPr>
           <p:spPr>
             <a:xfrm>
-              <a:off x="1962661" y="818994"/>
+              <a:off x="1849927" y="818994"/>
               <a:ext cx="1646605" cy="246221"/>
             </a:xfrm>
             <a:prstGeom prst="rect">
@@ -5619,53 +5459,6 @@
             </a:p>
           </p:txBody>
         </p:sp>
-        <p:cxnSp>
-          <p:nvCxnSpPr>
-            <p:cNvPr id="91" name="直线连接符 90">
-              <a:extLst>
-                <a:ext uri="{FF2B5EF4-FFF2-40B4-BE49-F238E27FC236}">
-                  <a16:creationId xmlns:a16="http://schemas.microsoft.com/office/drawing/2014/main" id="{EF169605-6BCA-1228-A209-34E7F0B7503B}"/>
-                </a:ext>
-              </a:extLst>
-            </p:cNvPr>
-            <p:cNvCxnSpPr>
-              <a:cxnSpLocks/>
-            </p:cNvCxnSpPr>
-            <p:nvPr/>
-          </p:nvCxnSpPr>
-          <p:spPr>
-            <a:xfrm>
-              <a:off x="5231678" y="1064444"/>
-              <a:ext cx="0" cy="254905"/>
-            </a:xfrm>
-            <a:prstGeom prst="line">
-              <a:avLst/>
-            </a:prstGeom>
-            <a:ln w="9525" cap="rnd">
-              <a:solidFill>
-                <a:schemeClr val="tx2">
-                  <a:lumMod val="50000"/>
-                  <a:lumOff val="50000"/>
-                </a:schemeClr>
-              </a:solidFill>
-              <a:tailEnd type="oval" w="sm" len="sm"/>
-            </a:ln>
-          </p:spPr>
-          <p:style>
-            <a:lnRef idx="2">
-              <a:schemeClr val="accent4"/>
-            </a:lnRef>
-            <a:fillRef idx="0">
-              <a:schemeClr val="accent4"/>
-            </a:fillRef>
-            <a:effectRef idx="1">
-              <a:schemeClr val="accent4"/>
-            </a:effectRef>
-            <a:fontRef idx="minor">
-              <a:schemeClr val="tx1"/>
-            </a:fontRef>
-          </p:style>
-        </p:cxnSp>
         <p:sp>
           <p:nvSpPr>
             <p:cNvPr id="95" name="文本框 94">
@@ -5680,8 +5473,8 @@
           </p:nvSpPr>
           <p:spPr>
             <a:xfrm>
-              <a:off x="4187354" y="814749"/>
-              <a:ext cx="1646605" cy="246221"/>
+              <a:off x="3432756" y="821012"/>
+              <a:ext cx="2401203" cy="246221"/>
             </a:xfrm>
             <a:prstGeom prst="rect">
               <a:avLst/>
@@ -5708,6 +5501,22 @@
               </a:lvl1pPr>
             </a:lstStyle>
             <a:p>
+              <a:r>
+                <a:rPr lang="en-US" altLang="zh-CN" dirty="0"/>
+                <a:t>AI</a:t>
+              </a:r>
+              <a:r>
+                <a:rPr lang="zh-CN" altLang="en-US" dirty="0"/>
+                <a:t> </a:t>
+              </a:r>
+              <a:r>
+                <a:rPr lang="en-US" altLang="zh-CN" dirty="0"/>
+                <a:t>Skill,</a:t>
+              </a:r>
+              <a:r>
+                <a:rPr lang="zh-CN" altLang="en-US" dirty="0"/>
+                <a:t> </a:t>
+              </a:r>
               <a:r>
                 <a:rPr lang="en" altLang="zh-CN" dirty="0"/>
                 <a:t>Quickly</a:t>
@@ -7069,6 +6878,83 @@
             </a:p>
           </p:txBody>
         </p:sp>
+        <p:pic>
+          <p:nvPicPr>
+            <p:cNvPr id="5" name="图片 4">
+              <a:extLst>
+                <a:ext uri="{FF2B5EF4-FFF2-40B4-BE49-F238E27FC236}">
+                  <a16:creationId xmlns:a16="http://schemas.microsoft.com/office/drawing/2014/main" id="{2DF35F2C-6704-3E6F-E7E5-265794FF71B1}"/>
+                </a:ext>
+              </a:extLst>
+            </p:cNvPr>
+            <p:cNvPicPr>
+              <a:picLocks noChangeAspect="1"/>
+            </p:cNvPicPr>
+            <p:nvPr/>
+          </p:nvPicPr>
+          <p:blipFill>
+            <a:blip r:embed="rId6"/>
+            <a:stretch>
+              <a:fillRect/>
+            </a:stretch>
+          </p:blipFill>
+          <p:spPr>
+            <a:xfrm>
+              <a:off x="3966069" y="1320227"/>
+              <a:ext cx="1267201" cy="97200"/>
+            </a:xfrm>
+            <a:prstGeom prst="rect">
+              <a:avLst/>
+            </a:prstGeom>
+          </p:spPr>
+        </p:pic>
+        <p:cxnSp>
+          <p:nvCxnSpPr>
+            <p:cNvPr id="91" name="直线连接符 90">
+              <a:extLst>
+                <a:ext uri="{FF2B5EF4-FFF2-40B4-BE49-F238E27FC236}">
+                  <a16:creationId xmlns:a16="http://schemas.microsoft.com/office/drawing/2014/main" id="{EF169605-6BCA-1228-A209-34E7F0B7503B}"/>
+                </a:ext>
+              </a:extLst>
+            </p:cNvPr>
+            <p:cNvCxnSpPr>
+              <a:cxnSpLocks/>
+            </p:cNvCxnSpPr>
+            <p:nvPr/>
+          </p:nvCxnSpPr>
+          <p:spPr>
+            <a:xfrm>
+              <a:off x="5231678" y="1064444"/>
+              <a:ext cx="0" cy="254905"/>
+            </a:xfrm>
+            <a:prstGeom prst="line">
+              <a:avLst/>
+            </a:prstGeom>
+            <a:ln w="9525" cap="rnd">
+              <a:solidFill>
+                <a:schemeClr val="tx2">
+                  <a:lumMod val="50000"/>
+                  <a:lumOff val="50000"/>
+                </a:schemeClr>
+              </a:solidFill>
+              <a:tailEnd type="oval" w="sm" len="sm"/>
+            </a:ln>
+          </p:spPr>
+          <p:style>
+            <a:lnRef idx="2">
+              <a:schemeClr val="accent4"/>
+            </a:lnRef>
+            <a:fillRef idx="0">
+              <a:schemeClr val="accent4"/>
+            </a:fillRef>
+            <a:effectRef idx="1">
+              <a:schemeClr val="accent4"/>
+            </a:effectRef>
+            <a:fontRef idx="minor">
+              <a:schemeClr val="tx1"/>
+            </a:fontRef>
+          </p:style>
+        </p:cxnSp>
       </p:grpSp>
     </p:spTree>
     <p:extLst>
@@ -7113,10 +6999,10 @@
       </p:grpSpPr>
       <p:grpSp>
         <p:nvGrpSpPr>
-          <p:cNvPr id="12" name="组合 11">
+          <p:cNvPr id="4" name="组合 3">
             <a:extLst>
               <a:ext uri="{FF2B5EF4-FFF2-40B4-BE49-F238E27FC236}">
-                <a16:creationId xmlns:a16="http://schemas.microsoft.com/office/drawing/2014/main" id="{7990F971-533A-8977-557B-E3B25FF0F1E4}"/>
+                <a16:creationId xmlns:a16="http://schemas.microsoft.com/office/drawing/2014/main" id="{C2721B16-AD1E-F1CD-E3D2-97EAA2497F4D}"/>
               </a:ext>
             </a:extLst>
           </p:cNvPr>
@@ -8037,53 +7923,6 @@
             </a:p>
           </p:txBody>
         </p:sp>
-        <p:cxnSp>
-          <p:nvCxnSpPr>
-            <p:cNvPr id="91" name="直线连接符 90">
-              <a:extLst>
-                <a:ext uri="{FF2B5EF4-FFF2-40B4-BE49-F238E27FC236}">
-                  <a16:creationId xmlns:a16="http://schemas.microsoft.com/office/drawing/2014/main" id="{9B7824B4-D3E4-597B-37ED-BBAA321E16DF}"/>
-                </a:ext>
-              </a:extLst>
-            </p:cNvPr>
-            <p:cNvCxnSpPr>
-              <a:cxnSpLocks/>
-            </p:cNvCxnSpPr>
-            <p:nvPr/>
-          </p:nvCxnSpPr>
-          <p:spPr>
-            <a:xfrm>
-              <a:off x="5231678" y="1064444"/>
-              <a:ext cx="0" cy="254905"/>
-            </a:xfrm>
-            <a:prstGeom prst="line">
-              <a:avLst/>
-            </a:prstGeom>
-            <a:ln w="9525" cap="rnd">
-              <a:solidFill>
-                <a:schemeClr val="tx2">
-                  <a:lumMod val="50000"/>
-                  <a:lumOff val="50000"/>
-                </a:schemeClr>
-              </a:solidFill>
-              <a:tailEnd type="oval" w="sm" len="sm"/>
-            </a:ln>
-          </p:spPr>
-          <p:style>
-            <a:lnRef idx="2">
-              <a:schemeClr val="accent4"/>
-            </a:lnRef>
-            <a:fillRef idx="0">
-              <a:schemeClr val="accent4"/>
-            </a:fillRef>
-            <a:effectRef idx="1">
-              <a:schemeClr val="accent4"/>
-            </a:effectRef>
-            <a:fontRef idx="minor">
-              <a:schemeClr val="tx1"/>
-            </a:fontRef>
-          </p:style>
-        </p:cxnSp>
         <p:sp>
           <p:nvSpPr>
             <p:cNvPr id="95" name="文本框 94">
@@ -8098,8 +7937,8 @@
           </p:nvSpPr>
           <p:spPr>
             <a:xfrm>
-              <a:off x="4810029" y="762536"/>
-              <a:ext cx="1082348" cy="302840"/>
+              <a:off x="4051375" y="762536"/>
+              <a:ext cx="2326712" cy="302840"/>
             </a:xfrm>
             <a:prstGeom prst="rect">
               <a:avLst/>
@@ -8107,7 +7946,7 @@
             <a:noFill/>
           </p:spPr>
           <p:txBody>
-            <a:bodyPr wrap="none" rtlCol="0">
+            <a:bodyPr wrap="square" rtlCol="0">
               <a:spAutoFit/>
             </a:bodyPr>
             <a:lstStyle>
@@ -8129,8 +7968,20 @@
             </a:lstStyle>
             <a:p>
               <a:r>
+                <a:rPr lang="en-US" altLang="zh-CN" dirty="0"/>
+                <a:t>AI</a:t>
+              </a:r>
+              <a:r>
                 <a:rPr lang="zh-CN" altLang="en-US" dirty="0"/>
-                <a:t>便捷运行和配置</a:t>
+                <a:t> </a:t>
+              </a:r>
+              <a:r>
+                <a:rPr lang="en-US" altLang="zh-CN" dirty="0"/>
+                <a:t>Skill</a:t>
+              </a:r>
+              <a:r>
+                <a:rPr lang="zh-CN" altLang="en-US" dirty="0"/>
+                <a:t>、便捷运行和配置</a:t>
               </a:r>
             </a:p>
           </p:txBody>
@@ -9738,6 +9589,83 @@
             </a:p>
           </p:txBody>
         </p:sp>
+        <p:pic>
+          <p:nvPicPr>
+            <p:cNvPr id="2" name="图片 1">
+              <a:extLst>
+                <a:ext uri="{FF2B5EF4-FFF2-40B4-BE49-F238E27FC236}">
+                  <a16:creationId xmlns:a16="http://schemas.microsoft.com/office/drawing/2014/main" id="{6358BA2D-DC20-E93D-C7DD-B501F04DAA72}"/>
+                </a:ext>
+              </a:extLst>
+            </p:cNvPr>
+            <p:cNvPicPr>
+              <a:picLocks noChangeAspect="1"/>
+            </p:cNvPicPr>
+            <p:nvPr/>
+          </p:nvPicPr>
+          <p:blipFill>
+            <a:blip r:embed="rId6"/>
+            <a:stretch>
+              <a:fillRect/>
+            </a:stretch>
+          </p:blipFill>
+          <p:spPr>
+            <a:xfrm>
+              <a:off x="3966069" y="1320227"/>
+              <a:ext cx="1267201" cy="97200"/>
+            </a:xfrm>
+            <a:prstGeom prst="rect">
+              <a:avLst/>
+            </a:prstGeom>
+          </p:spPr>
+        </p:pic>
+        <p:cxnSp>
+          <p:nvCxnSpPr>
+            <p:cNvPr id="91" name="直线连接符 90">
+              <a:extLst>
+                <a:ext uri="{FF2B5EF4-FFF2-40B4-BE49-F238E27FC236}">
+                  <a16:creationId xmlns:a16="http://schemas.microsoft.com/office/drawing/2014/main" id="{9B7824B4-D3E4-597B-37ED-BBAA321E16DF}"/>
+                </a:ext>
+              </a:extLst>
+            </p:cNvPr>
+            <p:cNvCxnSpPr>
+              <a:cxnSpLocks/>
+            </p:cNvCxnSpPr>
+            <p:nvPr/>
+          </p:nvCxnSpPr>
+          <p:spPr>
+            <a:xfrm>
+              <a:off x="5231678" y="1064444"/>
+              <a:ext cx="0" cy="254905"/>
+            </a:xfrm>
+            <a:prstGeom prst="line">
+              <a:avLst/>
+            </a:prstGeom>
+            <a:ln w="9525" cap="rnd">
+              <a:solidFill>
+                <a:schemeClr val="tx2">
+                  <a:lumMod val="50000"/>
+                  <a:lumOff val="50000"/>
+                </a:schemeClr>
+              </a:solidFill>
+              <a:tailEnd type="oval" w="sm" len="sm"/>
+            </a:ln>
+          </p:spPr>
+          <p:style>
+            <a:lnRef idx="2">
+              <a:schemeClr val="accent4"/>
+            </a:lnRef>
+            <a:fillRef idx="0">
+              <a:schemeClr val="accent4"/>
+            </a:fillRef>
+            <a:effectRef idx="1">
+              <a:schemeClr val="accent4"/>
+            </a:effectRef>
+            <a:fontRef idx="minor">
+              <a:schemeClr val="tx1"/>
+            </a:fontRef>
+          </p:style>
+        </p:cxnSp>
       </p:grpSp>
     </p:spTree>
     <p:extLst>

</xml_diff>